<commit_message>
DESIGN/slides: add NoSQL (DynamoDB) alternative appendix
Co-Authored-By: Claude Opus 4.8 <noreply@anthropic.com>
</commit_message>
<xml_diff>
--- a/QR Code Generator/QR_Code_Generator.pptx
+++ b/QR Code Generator/QR_Code_Generator.pptx
@@ -22,6 +22,7 @@
     <p:sldId id="270" r:id="rId21"/>
     <p:sldId id="271" r:id="rId22"/>
     <p:sldId id="272" r:id="rId23"/>
+    <p:sldId id="273" r:id="rId24"/>
   </p:sldIdLst>
   <p:sldSz cx="12191695" cy="6858000" type="screen4x3"/>
   <p:notesSz cx="6858000" cy="9144000"/>
@@ -7124,6 +7125,938 @@
 </file>
 
 <file path=ppt/slides/slide17.xml><?xml version="1.0" encoding="utf-8"?>
+<p:sld xmlns:a="http://schemas.openxmlformats.org/drawingml/2006/main" xmlns:p="http://schemas.openxmlformats.org/presentationml/2006/main" xmlns:r="http://schemas.openxmlformats.org/officeDocument/2006/relationships">
+  <p:cSld>
+    <p:spTree>
+      <p:nvGrpSpPr>
+        <p:cNvPr id="1" name=""/>
+        <p:cNvGrpSpPr/>
+        <p:nvPr/>
+      </p:nvGrpSpPr>
+      <p:grpSpPr/>
+      <p:sp>
+        <p:nvSpPr>
+          <p:cNvPr id="2" name="Rectangle 1"/>
+          <p:cNvSpPr/>
+          <p:nvPr/>
+        </p:nvSpPr>
+        <p:spPr>
+          <a:xfrm>
+            <a:off x="0" y="0"/>
+            <a:ext cx="164592" cy="6858000"/>
+          </a:xfrm>
+          <a:prstGeom prst="rect">
+            <a:avLst/>
+          </a:prstGeom>
+          <a:solidFill>
+            <a:srgbClr val="2563EB"/>
+          </a:solidFill>
+          <a:ln>
+            <a:noFill/>
+          </a:ln>
+          <a:effectLst/>
+        </p:spPr>
+        <p:style>
+          <a:lnRef idx="1">
+            <a:schemeClr val="accent1"/>
+          </a:lnRef>
+          <a:fillRef idx="3">
+            <a:schemeClr val="accent1"/>
+          </a:fillRef>
+          <a:effectRef idx="2">
+            <a:schemeClr val="accent1"/>
+          </a:effectRef>
+          <a:fontRef idx="minor">
+            <a:schemeClr val="lt1"/>
+          </a:fontRef>
+        </p:style>
+        <p:txBody>
+          <a:bodyPr rtlCol="0" anchor="ctr"/>
+          <a:lstStyle/>
+          <a:p>
+            <a:pPr algn="ctr"/>
+          </a:p>
+        </p:txBody>
+      </p:sp>
+      <p:sp>
+        <p:nvSpPr>
+          <p:cNvPr id="3" name="TextBox 2"/>
+          <p:cNvSpPr txBox="1"/>
+          <p:nvPr/>
+        </p:nvSpPr>
+        <p:spPr>
+          <a:xfrm>
+            <a:off x="502920" y="320040"/>
+            <a:ext cx="10972800" cy="1005840"/>
+          </a:xfrm>
+          <a:prstGeom prst="rect">
+            <a:avLst/>
+          </a:prstGeom>
+          <a:noFill/>
+        </p:spPr>
+        <p:txBody>
+          <a:bodyPr wrap="square" anchor="t">
+            <a:spAutoFit/>
+          </a:bodyPr>
+          <a:lstStyle/>
+          <a:p>
+            <a:pPr algn="l">
+              <a:spcAft>
+                <a:spcPts val="200"/>
+              </a:spcAft>
+            </a:pPr>
+            <a:r>
+              <a:rPr sz="1300" b="1">
+                <a:solidFill>
+                  <a:srgbClr val="2563EB"/>
+                </a:solidFill>
+                <a:latin typeface="PingFang TC"/>
+                <a:ea typeface="PingFang TC"/>
+              </a:rPr>
+              <a:t>附錄 · NOSQL</a:t>
+            </a:r>
+          </a:p>
+          <a:p>
+            <a:pPr algn="l">
+              <a:spcAft>
+                <a:spcPts val="400"/>
+              </a:spcAft>
+            </a:pPr>
+            <a:r>
+              <a:rPr sz="3000" b="1">
+                <a:solidFill>
+                  <a:srgbClr val="0F172A"/>
+                </a:solidFill>
+                <a:latin typeface="PingFang TC"/>
+                <a:ea typeface="PingFang TC"/>
+              </a:rPr>
+              <a:t>替代方案 — DynamoDB 風格 key 設計</a:t>
+            </a:r>
+          </a:p>
+        </p:txBody>
+      </p:sp>
+      <p:sp>
+        <p:nvSpPr>
+          <p:cNvPr id="4" name="Rounded Rectangle 3"/>
+          <p:cNvSpPr/>
+          <p:nvPr/>
+        </p:nvSpPr>
+        <p:spPr>
+          <a:xfrm>
+            <a:off x="548640" y="1508760"/>
+            <a:ext cx="5486400" cy="548640"/>
+          </a:xfrm>
+          <a:prstGeom prst="roundRect">
+            <a:avLst/>
+          </a:prstGeom>
+          <a:solidFill>
+            <a:srgbClr val="D97706"/>
+          </a:solidFill>
+          <a:ln>
+            <a:solidFill>
+              <a:srgbClr val="D97706"/>
+            </a:solidFill>
+          </a:ln>
+          <a:effectLst/>
+        </p:spPr>
+        <p:style>
+          <a:lnRef idx="1">
+            <a:schemeClr val="accent1"/>
+          </a:lnRef>
+          <a:fillRef idx="3">
+            <a:schemeClr val="accent1"/>
+          </a:fillRef>
+          <a:effectRef idx="2">
+            <a:schemeClr val="accent1"/>
+          </a:effectRef>
+          <a:fontRef idx="minor">
+            <a:schemeClr val="lt1"/>
+          </a:fontRef>
+        </p:style>
+        <p:txBody>
+          <a:bodyPr rtlCol="0" anchor="ctr" wrap="square" tIns="25400" bIns="25400"/>
+          <a:lstStyle/>
+          <a:p>
+            <a:pPr algn="ctr"/>
+            <a:r>
+              <a:rPr sz="1200" b="1">
+                <a:solidFill>
+                  <a:srgbClr val="FFFFFF"/>
+                </a:solidFill>
+                <a:latin typeface="PingFang TC"/>
+                <a:ea typeface="PingFang TC"/>
+              </a:rPr>
+              <a:t>直覺方案  PK=user_id · SK=created_at#qr_token</a:t>
+            </a:r>
+          </a:p>
+        </p:txBody>
+      </p:sp>
+      <p:sp>
+        <p:nvSpPr>
+          <p:cNvPr id="5" name="Rounded Rectangle 4"/>
+          <p:cNvSpPr/>
+          <p:nvPr/>
+        </p:nvSpPr>
+        <p:spPr>
+          <a:xfrm>
+            <a:off x="548640" y="2103120"/>
+            <a:ext cx="5486400" cy="1737360"/>
+          </a:xfrm>
+          <a:prstGeom prst="roundRect">
+            <a:avLst/>
+          </a:prstGeom>
+          <a:solidFill>
+            <a:srgbClr val="F1F5F9"/>
+          </a:solidFill>
+          <a:ln>
+            <a:solidFill>
+              <a:srgbClr val="F1F5F9"/>
+            </a:solidFill>
+          </a:ln>
+          <a:effectLst/>
+        </p:spPr>
+        <p:style>
+          <a:lnRef idx="1">
+            <a:schemeClr val="accent1"/>
+          </a:lnRef>
+          <a:fillRef idx="3">
+            <a:schemeClr val="accent1"/>
+          </a:fillRef>
+          <a:effectRef idx="2">
+            <a:schemeClr val="accent1"/>
+          </a:effectRef>
+          <a:fontRef idx="minor">
+            <a:schemeClr val="lt1"/>
+          </a:fontRef>
+        </p:style>
+        <p:txBody>
+          <a:bodyPr rtlCol="0" anchor="ctr"/>
+          <a:lstStyle/>
+          <a:p>
+            <a:pPr algn="ctr"/>
+          </a:p>
+        </p:txBody>
+      </p:sp>
+      <p:sp>
+        <p:nvSpPr>
+          <p:cNvPr id="6" name="TextBox 5"/>
+          <p:cNvSpPr txBox="1"/>
+          <p:nvPr/>
+        </p:nvSpPr>
+        <p:spPr>
+          <a:xfrm>
+            <a:off x="731520" y="2240280"/>
+            <a:ext cx="5120640" cy="1554480"/>
+          </a:xfrm>
+          <a:prstGeom prst="rect">
+            <a:avLst/>
+          </a:prstGeom>
+          <a:noFill/>
+        </p:spPr>
+        <p:txBody>
+          <a:bodyPr wrap="square">
+            <a:spAutoFit/>
+          </a:bodyPr>
+          <a:lstStyle/>
+          <a:p>
+            <a:pPr>
+              <a:spcAft>
+                <a:spcPts val="600"/>
+              </a:spcAft>
+            </a:pPr>
+            <a:r>
+              <a:rPr sz="1300" b="0">
+                <a:solidFill>
+                  <a:srgbClr val="0F172A"/>
+                </a:solidFill>
+                <a:latin typeface="PingFang TC"/>
+                <a:ea typeface="PingFang TC"/>
+              </a:rPr>
+              <a:t>•  ✅ 列出我的 QR：Query PK=user_id 天生最佳</a:t>
+            </a:r>
+          </a:p>
+          <a:p>
+            <a:pPr>
+              <a:spcAft>
+                <a:spcPts val="600"/>
+              </a:spcAft>
+            </a:pPr>
+            <a:r>
+              <a:rPr sz="1300" b="0">
+                <a:solidFill>
+                  <a:srgbClr val="0F172A"/>
+                </a:solidFill>
+                <a:latin typeface="PingFang TC"/>
+                <a:ea typeface="PingFang TC"/>
+              </a:rPr>
+              <a:t>•  ❌ redirect 只有 token、沒 user_id → 定位不到分區</a:t>
+            </a:r>
+          </a:p>
+          <a:p>
+            <a:pPr lvl="1">
+              <a:spcAft>
+                <a:spcPts val="600"/>
+              </a:spcAft>
+            </a:pPr>
+            <a:r>
+              <a:rPr sz="1200" b="0">
+                <a:solidFill>
+                  <a:srgbClr val="64748B"/>
+                </a:solidFill>
+                <a:latin typeface="PingFang TC"/>
+                <a:ea typeface="PingFang TC"/>
+              </a:rPr>
+              <a:t>–  → 退化成 Scan O(n)，違反 &lt;100ms（致命）</a:t>
+            </a:r>
+          </a:p>
+        </p:txBody>
+      </p:sp>
+      <p:sp>
+        <p:nvSpPr>
+          <p:cNvPr id="7" name="Rounded Rectangle 6"/>
+          <p:cNvSpPr/>
+          <p:nvPr/>
+        </p:nvSpPr>
+        <p:spPr>
+          <a:xfrm>
+            <a:off x="6263640" y="1508760"/>
+            <a:ext cx="5394960" cy="548640"/>
+          </a:xfrm>
+          <a:prstGeom prst="roundRect">
+            <a:avLst/>
+          </a:prstGeom>
+          <a:solidFill>
+            <a:srgbClr val="059669"/>
+          </a:solidFill>
+          <a:ln>
+            <a:solidFill>
+              <a:srgbClr val="059669"/>
+            </a:solidFill>
+          </a:ln>
+          <a:effectLst/>
+        </p:spPr>
+        <p:style>
+          <a:lnRef idx="1">
+            <a:schemeClr val="accent1"/>
+          </a:lnRef>
+          <a:fillRef idx="3">
+            <a:schemeClr val="accent1"/>
+          </a:fillRef>
+          <a:effectRef idx="2">
+            <a:schemeClr val="accent1"/>
+          </a:effectRef>
+          <a:fontRef idx="minor">
+            <a:schemeClr val="lt1"/>
+          </a:fontRef>
+        </p:style>
+        <p:txBody>
+          <a:bodyPr rtlCol="0" anchor="ctr" wrap="square" tIns="25400" bIns="25400"/>
+          <a:lstStyle/>
+          <a:p>
+            <a:pPr algn="ctr"/>
+            <a:r>
+              <a:rPr sz="1200" b="1">
+                <a:solidFill>
+                  <a:srgbClr val="FFFFFF"/>
+                </a:solidFill>
+                <a:latin typeface="PingFang TC"/>
+                <a:ea typeface="PingFang TC"/>
+              </a:rPr>
+              <a:t>建議  base PK=qr_token + GSI(user_id, created_at)</a:t>
+            </a:r>
+          </a:p>
+        </p:txBody>
+      </p:sp>
+      <p:sp>
+        <p:nvSpPr>
+          <p:cNvPr id="8" name="Rounded Rectangle 7"/>
+          <p:cNvSpPr/>
+          <p:nvPr/>
+        </p:nvSpPr>
+        <p:spPr>
+          <a:xfrm>
+            <a:off x="6263640" y="2103120"/>
+            <a:ext cx="5394960" cy="1737360"/>
+          </a:xfrm>
+          <a:prstGeom prst="roundRect">
+            <a:avLst/>
+          </a:prstGeom>
+          <a:solidFill>
+            <a:srgbClr val="F1F5F9"/>
+          </a:solidFill>
+          <a:ln>
+            <a:solidFill>
+              <a:srgbClr val="F1F5F9"/>
+            </a:solidFill>
+          </a:ln>
+          <a:effectLst/>
+        </p:spPr>
+        <p:style>
+          <a:lnRef idx="1">
+            <a:schemeClr val="accent1"/>
+          </a:lnRef>
+          <a:fillRef idx="3">
+            <a:schemeClr val="accent1"/>
+          </a:fillRef>
+          <a:effectRef idx="2">
+            <a:schemeClr val="accent1"/>
+          </a:effectRef>
+          <a:fontRef idx="minor">
+            <a:schemeClr val="lt1"/>
+          </a:fontRef>
+        </p:style>
+        <p:txBody>
+          <a:bodyPr rtlCol="0" anchor="ctr"/>
+          <a:lstStyle/>
+          <a:p>
+            <a:pPr algn="ctr"/>
+          </a:p>
+        </p:txBody>
+      </p:sp>
+      <p:sp>
+        <p:nvSpPr>
+          <p:cNvPr id="9" name="TextBox 8"/>
+          <p:cNvSpPr txBox="1"/>
+          <p:nvPr/>
+        </p:nvSpPr>
+        <p:spPr>
+          <a:xfrm>
+            <a:off x="6446520" y="2240280"/>
+            <a:ext cx="5029200" cy="1554480"/>
+          </a:xfrm>
+          <a:prstGeom prst="rect">
+            <a:avLst/>
+          </a:prstGeom>
+          <a:noFill/>
+        </p:spPr>
+        <p:txBody>
+          <a:bodyPr wrap="square">
+            <a:spAutoFit/>
+          </a:bodyPr>
+          <a:lstStyle/>
+          <a:p>
+            <a:pPr>
+              <a:spcAft>
+                <a:spcPts val="500"/>
+              </a:spcAft>
+            </a:pPr>
+            <a:r>
+              <a:rPr sz="1300" b="0">
+                <a:solidFill>
+                  <a:srgbClr val="0F172A"/>
+                </a:solidFill>
+                <a:latin typeface="PingFang TC"/>
+                <a:ea typeface="PingFang TC"/>
+              </a:rPr>
+              <a:t>•  ✅ redirect：GetItem(PK=qr_token) O(1)、強一致</a:t>
+            </a:r>
+          </a:p>
+          <a:p>
+            <a:pPr>
+              <a:spcAft>
+                <a:spcPts val="500"/>
+              </a:spcAft>
+            </a:pPr>
+            <a:r>
+              <a:rPr sz="1300" b="0">
+                <a:solidFill>
+                  <a:srgbClr val="0F172A"/>
+                </a:solidFill>
+                <a:latin typeface="PingFang TC"/>
+                <a:ea typeface="PingFang TC"/>
+              </a:rPr>
+              <a:t>•  ✅ 列我的 QR：走 GSI(PK=user_id)</a:t>
+            </a:r>
+          </a:p>
+          <a:p>
+            <a:pPr>
+              <a:spcAft>
+                <a:spcPts val="500"/>
+              </a:spcAft>
+            </a:pPr>
+            <a:r>
+              <a:rPr sz="1300" b="0">
+                <a:solidFill>
+                  <a:srgbClr val="0F172A"/>
+                </a:solidFill>
+                <a:latin typeface="PingFang TC"/>
+                <a:ea typeface="PingFang TC"/>
+              </a:rPr>
+              <a:t>•  qr_token 高亂度 → 均勻分區，避免 hot partition</a:t>
+            </a:r>
+          </a:p>
+          <a:p>
+            <a:pPr>
+              <a:spcAft>
+                <a:spcPts val="500"/>
+              </a:spcAft>
+            </a:pPr>
+            <a:r>
+              <a:rPr sz="1300" b="0">
+                <a:solidFill>
+                  <a:srgbClr val="0F172A"/>
+                </a:solidFill>
+                <a:latin typeface="PingFang TC"/>
+                <a:ea typeface="PingFang TC"/>
+              </a:rPr>
+              <a:t>•  唯一性：條件寫入 attribute_not_exists</a:t>
+            </a:r>
+          </a:p>
+        </p:txBody>
+      </p:sp>
+      <p:graphicFrame>
+        <p:nvGraphicFramePr>
+          <p:cNvPr id="10" name="Table 9"/>
+          <p:cNvGraphicFramePr>
+            <a:graphicFrameLocks noGrp="1"/>
+          </p:cNvGraphicFramePr>
+          <p:nvPr/>
+        </p:nvGraphicFramePr>
+        <p:xfrm>
+          <a:off x="548640" y="4114800"/>
+          <a:ext cx="11109960" cy="1920240"/>
+        </p:xfrm>
+        <a:graphic>
+          <a:graphicData uri="http://schemas.openxmlformats.org/drawingml/2006/table">
+            <a:tbl>
+              <a:tblPr firstRow="1" bandRow="1">
+                <a:tableStyleId>{5C22544A-7EE6-4342-B048-85BDC9FD1C3A}</a:tableStyleId>
+              </a:tblPr>
+              <a:tblGrid>
+                <a:gridCol w="2743200"/>
+                <a:gridCol w="2788920"/>
+                <a:gridCol w="2788920"/>
+                <a:gridCol w="2788920"/>
+              </a:tblGrid>
+              <a:tr h="480060">
+                <a:tc>
+                  <a:txBody>
+                    <a:bodyPr/>
+                    <a:lstStyle/>
+                    <a:p>
+                      <a:r>
+                        <a:rPr sz="1100" b="1">
+                          <a:solidFill>
+                            <a:srgbClr val="FFFFFF"/>
+                          </a:solidFill>
+                          <a:latin typeface="PingFang TC"/>
+                          <a:ea typeface="PingFang TC"/>
+                        </a:rPr>
+                        <a:t>存取模式</a:t>
+                      </a:r>
+                    </a:p>
+                  </a:txBody>
+                  <a:tcPr marT="25400" marB="25400" marL="101600" anchor="ctr">
+                    <a:solidFill>
+                      <a:srgbClr val="2563EB"/>
+                    </a:solidFill>
+                  </a:tcPr>
+                </a:tc>
+                <a:tc>
+                  <a:txBody>
+                    <a:bodyPr/>
+                    <a:lstStyle/>
+                    <a:p>
+                      <a:r>
+                        <a:rPr sz="1100" b="1">
+                          <a:solidFill>
+                            <a:srgbClr val="FFFFFF"/>
+                          </a:solidFill>
+                          <a:latin typeface="PingFang TC"/>
+                          <a:ea typeface="PingFang TC"/>
+                        </a:rPr>
+                        <a:t>SQL（現況）</a:t>
+                      </a:r>
+                    </a:p>
+                  </a:txBody>
+                  <a:tcPr marT="25400" marB="25400" marL="101600" anchor="ctr">
+                    <a:solidFill>
+                      <a:srgbClr val="2563EB"/>
+                    </a:solidFill>
+                  </a:tcPr>
+                </a:tc>
+                <a:tc>
+                  <a:txBody>
+                    <a:bodyPr/>
+                    <a:lstStyle/>
+                    <a:p>
+                      <a:r>
+                        <a:rPr sz="1100" b="1">
+                          <a:solidFill>
+                            <a:srgbClr val="FFFFFF"/>
+                          </a:solidFill>
+                          <a:latin typeface="PingFang TC"/>
+                          <a:ea typeface="PingFang TC"/>
+                        </a:rPr>
+                        <a:t>NoSQL PK=user_id</a:t>
+                      </a:r>
+                    </a:p>
+                  </a:txBody>
+                  <a:tcPr marT="25400" marB="25400" marL="101600" anchor="ctr">
+                    <a:solidFill>
+                      <a:srgbClr val="2563EB"/>
+                    </a:solidFill>
+                  </a:tcPr>
+                </a:tc>
+                <a:tc>
+                  <a:txBody>
+                    <a:bodyPr/>
+                    <a:lstStyle/>
+                    <a:p>
+                      <a:r>
+                        <a:rPr sz="1100" b="1">
+                          <a:solidFill>
+                            <a:srgbClr val="FFFFFF"/>
+                          </a:solidFill>
+                          <a:latin typeface="PingFang TC"/>
+                          <a:ea typeface="PingFang TC"/>
+                        </a:rPr>
+                        <a:t>NoSQL PK=qr_token</a:t>
+                      </a:r>
+                    </a:p>
+                  </a:txBody>
+                  <a:tcPr marT="25400" marB="25400" marL="101600" anchor="ctr">
+                    <a:solidFill>
+                      <a:srgbClr val="2563EB"/>
+                    </a:solidFill>
+                  </a:tcPr>
+                </a:tc>
+              </a:tr>
+              <a:tr h="480060">
+                <a:tc>
+                  <a:txBody>
+                    <a:bodyPr/>
+                    <a:lstStyle/>
+                    <a:p>
+                      <a:r>
+                        <a:rPr sz="1100" b="1">
+                          <a:solidFill>
+                            <a:srgbClr val="0F172A"/>
+                          </a:solidFill>
+                          <a:latin typeface="PingFang TC"/>
+                          <a:ea typeface="PingFang TC"/>
+                        </a:rPr>
+                        <a:t>redirect 查 token</a:t>
+                      </a:r>
+                    </a:p>
+                  </a:txBody>
+                  <a:tcPr marT="25400" marB="25400" marL="101600" anchor="ctr">
+                    <a:solidFill>
+                      <a:srgbClr val="FFFFFF"/>
+                    </a:solidFill>
+                  </a:tcPr>
+                </a:tc>
+                <a:tc>
+                  <a:txBody>
+                    <a:bodyPr/>
+                    <a:lstStyle/>
+                    <a:p>
+                      <a:r>
+                        <a:rPr sz="1100" b="0">
+                          <a:solidFill>
+                            <a:srgbClr val="64748B"/>
+                          </a:solidFill>
+                          <a:latin typeface="PingFang TC"/>
+                          <a:ea typeface="PingFang TC"/>
+                        </a:rPr>
+                        <a:t>B-tree O(log n) ✅</a:t>
+                      </a:r>
+                    </a:p>
+                  </a:txBody>
+                  <a:tcPr marT="25400" marB="25400" marL="101600" anchor="ctr">
+                    <a:solidFill>
+                      <a:srgbClr val="FFFFFF"/>
+                    </a:solidFill>
+                  </a:tcPr>
+                </a:tc>
+                <a:tc>
+                  <a:txBody>
+                    <a:bodyPr/>
+                    <a:lstStyle/>
+                    <a:p>
+                      <a:r>
+                        <a:rPr sz="1100" b="0">
+                          <a:solidFill>
+                            <a:srgbClr val="64748B"/>
+                          </a:solidFill>
+                          <a:latin typeface="PingFang TC"/>
+                          <a:ea typeface="PingFang TC"/>
+                        </a:rPr>
+                        <a:t>Scan O(n) ❌</a:t>
+                      </a:r>
+                    </a:p>
+                  </a:txBody>
+                  <a:tcPr marT="25400" marB="25400" marL="101600" anchor="ctr">
+                    <a:solidFill>
+                      <a:srgbClr val="FFFFFF"/>
+                    </a:solidFill>
+                  </a:tcPr>
+                </a:tc>
+                <a:tc>
+                  <a:txBody>
+                    <a:bodyPr/>
+                    <a:lstStyle/>
+                    <a:p>
+                      <a:r>
+                        <a:rPr sz="1100" b="0">
+                          <a:solidFill>
+                            <a:srgbClr val="64748B"/>
+                          </a:solidFill>
+                          <a:latin typeface="PingFang TC"/>
+                          <a:ea typeface="PingFang TC"/>
+                        </a:rPr>
+                        <a:t>GetItem O(1) ✅</a:t>
+                      </a:r>
+                    </a:p>
+                  </a:txBody>
+                  <a:tcPr marT="25400" marB="25400" marL="101600" anchor="ctr">
+                    <a:solidFill>
+                      <a:srgbClr val="FFFFFF"/>
+                    </a:solidFill>
+                  </a:tcPr>
+                </a:tc>
+              </a:tr>
+              <a:tr h="480060">
+                <a:tc>
+                  <a:txBody>
+                    <a:bodyPr/>
+                    <a:lstStyle/>
+                    <a:p>
+                      <a:r>
+                        <a:rPr sz="1100" b="1">
+                          <a:solidFill>
+                            <a:srgbClr val="0F172A"/>
+                          </a:solidFill>
+                          <a:latin typeface="PingFang TC"/>
+                          <a:ea typeface="PingFang TC"/>
+                        </a:rPr>
+                        <a:t>列出我的 QR</a:t>
+                      </a:r>
+                    </a:p>
+                  </a:txBody>
+                  <a:tcPr marT="25400" marB="25400" marL="101600" anchor="ctr">
+                    <a:solidFill>
+                      <a:srgbClr val="F1F5F9"/>
+                    </a:solidFill>
+                  </a:tcPr>
+                </a:tc>
+                <a:tc>
+                  <a:txBody>
+                    <a:bodyPr/>
+                    <a:lstStyle/>
+                    <a:p>
+                      <a:r>
+                        <a:rPr sz="1100" b="0">
+                          <a:solidFill>
+                            <a:srgbClr val="64748B"/>
+                          </a:solidFill>
+                          <a:latin typeface="PingFang TC"/>
+                          <a:ea typeface="PingFang TC"/>
+                        </a:rPr>
+                        <a:t>WHERE user_id ✅</a:t>
+                      </a:r>
+                    </a:p>
+                  </a:txBody>
+                  <a:tcPr marT="25400" marB="25400" marL="101600" anchor="ctr">
+                    <a:solidFill>
+                      <a:srgbClr val="F1F5F9"/>
+                    </a:solidFill>
+                  </a:tcPr>
+                </a:tc>
+                <a:tc>
+                  <a:txBody>
+                    <a:bodyPr/>
+                    <a:lstStyle/>
+                    <a:p>
+                      <a:r>
+                        <a:rPr sz="1100" b="0">
+                          <a:solidFill>
+                            <a:srgbClr val="64748B"/>
+                          </a:solidFill>
+                          <a:latin typeface="PingFang TC"/>
+                          <a:ea typeface="PingFang TC"/>
+                        </a:rPr>
+                        <a:t>天生最佳 ✅</a:t>
+                      </a:r>
+                    </a:p>
+                  </a:txBody>
+                  <a:tcPr marT="25400" marB="25400" marL="101600" anchor="ctr">
+                    <a:solidFill>
+                      <a:srgbClr val="F1F5F9"/>
+                    </a:solidFill>
+                  </a:tcPr>
+                </a:tc>
+                <a:tc>
+                  <a:txBody>
+                    <a:bodyPr/>
+                    <a:lstStyle/>
+                    <a:p>
+                      <a:r>
+                        <a:rPr sz="1100" b="0">
+                          <a:solidFill>
+                            <a:srgbClr val="64748B"/>
+                          </a:solidFill>
+                          <a:latin typeface="PingFang TC"/>
+                          <a:ea typeface="PingFang TC"/>
+                        </a:rPr>
+                        <a:t>GSI 查 ✅</a:t>
+                      </a:r>
+                    </a:p>
+                  </a:txBody>
+                  <a:tcPr marT="25400" marB="25400" marL="101600" anchor="ctr">
+                    <a:solidFill>
+                      <a:srgbClr val="F1F5F9"/>
+                    </a:solidFill>
+                  </a:tcPr>
+                </a:tc>
+              </a:tr>
+              <a:tr h="480060">
+                <a:tc>
+                  <a:txBody>
+                    <a:bodyPr/>
+                    <a:lstStyle/>
+                    <a:p>
+                      <a:r>
+                        <a:rPr sz="1100" b="1">
+                          <a:solidFill>
+                            <a:srgbClr val="0F172A"/>
+                          </a:solidFill>
+                          <a:latin typeface="PingFang TC"/>
+                          <a:ea typeface="PingFang TC"/>
+                        </a:rPr>
+                        <a:t>token 唯一</a:t>
+                      </a:r>
+                    </a:p>
+                  </a:txBody>
+                  <a:tcPr marT="25400" marB="25400" marL="101600" anchor="ctr">
+                    <a:solidFill>
+                      <a:srgbClr val="FFFFFF"/>
+                    </a:solidFill>
+                  </a:tcPr>
+                </a:tc>
+                <a:tc>
+                  <a:txBody>
+                    <a:bodyPr/>
+                    <a:lstStyle/>
+                    <a:p>
+                      <a:r>
+                        <a:rPr sz="1100" b="0">
+                          <a:solidFill>
+                            <a:srgbClr val="64748B"/>
+                          </a:solidFill>
+                          <a:latin typeface="PingFang TC"/>
+                          <a:ea typeface="PingFang TC"/>
+                        </a:rPr>
+                        <a:t>UNIQUE ✅</a:t>
+                      </a:r>
+                    </a:p>
+                  </a:txBody>
+                  <a:tcPr marT="25400" marB="25400" marL="101600" anchor="ctr">
+                    <a:solidFill>
+                      <a:srgbClr val="FFFFFF"/>
+                    </a:solidFill>
+                  </a:tcPr>
+                </a:tc>
+                <a:tc>
+                  <a:txBody>
+                    <a:bodyPr/>
+                    <a:lstStyle/>
+                    <a:p>
+                      <a:r>
+                        <a:rPr sz="1100" b="0">
+                          <a:solidFill>
+                            <a:srgbClr val="64748B"/>
+                          </a:solidFill>
+                          <a:latin typeface="PingFang TC"/>
+                          <a:ea typeface="PingFang TC"/>
+                        </a:rPr>
+                        <a:t>需額外處理</a:t>
+                      </a:r>
+                    </a:p>
+                  </a:txBody>
+                  <a:tcPr marT="25400" marB="25400" marL="101600" anchor="ctr">
+                    <a:solidFill>
+                      <a:srgbClr val="FFFFFF"/>
+                    </a:solidFill>
+                  </a:tcPr>
+                </a:tc>
+                <a:tc>
+                  <a:txBody>
+                    <a:bodyPr/>
+                    <a:lstStyle/>
+                    <a:p>
+                      <a:r>
+                        <a:rPr sz="1100" b="0">
+                          <a:solidFill>
+                            <a:srgbClr val="64748B"/>
+                          </a:solidFill>
+                          <a:latin typeface="PingFang TC"/>
+                          <a:ea typeface="PingFang TC"/>
+                        </a:rPr>
+                        <a:t>條件寫入 ✅</a:t>
+                      </a:r>
+                    </a:p>
+                  </a:txBody>
+                  <a:tcPr marT="25400" marB="25400" marL="101600" anchor="ctr">
+                    <a:solidFill>
+                      <a:srgbClr val="FFFFFF"/>
+                    </a:solidFill>
+                  </a:tcPr>
+                </a:tc>
+              </a:tr>
+            </a:tbl>
+          </a:graphicData>
+        </a:graphic>
+      </p:graphicFrame>
+      <p:sp>
+        <p:nvSpPr>
+          <p:cNvPr id="11" name="TextBox 10"/>
+          <p:cNvSpPr txBox="1"/>
+          <p:nvPr/>
+        </p:nvSpPr>
+        <p:spPr>
+          <a:xfrm>
+            <a:off x="548640" y="6172200"/>
+            <a:ext cx="11155680" cy="548640"/>
+          </a:xfrm>
+          <a:prstGeom prst="rect">
+            <a:avLst/>
+          </a:prstGeom>
+          <a:noFill/>
+        </p:spPr>
+        <p:txBody>
+          <a:bodyPr wrap="square" anchor="t">
+            <a:spAutoFit/>
+          </a:bodyPr>
+          <a:lstStyle/>
+          <a:p>
+            <a:pPr algn="l">
+              <a:spcAft>
+                <a:spcPts val="400"/>
+              </a:spcAft>
+            </a:pPr>
+            <a:r>
+              <a:rPr sz="1200" b="0">
+                <a:solidFill>
+                  <a:srgbClr val="64748B"/>
+                </a:solidFill>
+                <a:latin typeface="PingFang TC"/>
+                <a:ea typeface="PingFang TC"/>
+              </a:rPr>
+              <a:t>NoSQL 先列存取模式、再決定 key；redirect（token→URL）是這個系統的第一公民。</a:t>
+            </a:r>
+          </a:p>
+        </p:txBody>
+      </p:sp>
+    </p:spTree>
+  </p:cSld>
+  <p:clrMapOvr>
+    <a:masterClrMapping/>
+  </p:clrMapOvr>
+</p:sld>
+</file>
+
+<file path=ppt/slides/slide18.xml><?xml version="1.0" encoding="utf-8"?>
 <p:sld xmlns:a="http://schemas.openxmlformats.org/drawingml/2006/main" xmlns:p="http://schemas.openxmlformats.org/presentationml/2006/main" xmlns:r="http://schemas.openxmlformats.org/officeDocument/2006/relationships">
   <p:cSld>
     <p:spTree>

</xml_diff>

<commit_message>
DESIGN/slides: clarify 302-vs-CDN tradeoff; add read-heavy read-replica section
Co-Authored-By: Claude Opus 4.8 <noreply@anthropic.com>
</commit_message>
<xml_diff>
--- a/QR Code Generator/QR_Code_Generator.pptx
+++ b/QR Code Generator/QR_Code_Generator.pptx
@@ -23,6 +23,8 @@
     <p:sldId id="271" r:id="rId22"/>
     <p:sldId id="272" r:id="rId23"/>
     <p:sldId id="273" r:id="rId24"/>
+    <p:sldId id="274" r:id="rId25"/>
+    <p:sldId id="275" r:id="rId26"/>
   </p:sldIdLst>
   <p:sldSz cx="12191695" cy="6858000" type="screen4x3"/>
   <p:notesSz cx="6858000" cy="9144000"/>
@@ -6299,7 +6301,7 @@
                 <a:latin typeface="PingFang TC"/>
                 <a:ea typeface="PingFang TC"/>
               </a:rPr>
-              <a:t>12 · IMPROVEMENTS</a:t>
+              <a:t>11b · READ REPLICA</a:t>
             </a:r>
           </a:p>
           <a:p>
@@ -6316,21 +6318,146 @@
                 <a:latin typeface="PingFang TC"/>
                 <a:ea typeface="PingFang TC"/>
               </a:rPr>
-              <a:t>對參考 repo 的關鍵改良</a:t>
-            </a:r>
-          </a:p>
-        </p:txBody>
-      </p:sp>
-      <p:sp>
-        <p:nvSpPr>
-          <p:cNvPr id="4" name="Rounded Rectangle 3"/>
+              <a:t>Read-heavy → 讀寫分離 + Read Replica</a:t>
+            </a:r>
+          </a:p>
+        </p:txBody>
+      </p:sp>
+      <p:sp>
+        <p:nvSpPr>
+          <p:cNvPr id="4" name="TextBox 3"/>
+          <p:cNvSpPr txBox="1"/>
+          <p:nvPr/>
+        </p:nvSpPr>
+        <p:spPr>
+          <a:xfrm>
+            <a:off x="548640" y="1645920"/>
+            <a:ext cx="5486400" cy="2926080"/>
+          </a:xfrm>
+          <a:prstGeom prst="rect">
+            <a:avLst/>
+          </a:prstGeom>
+          <a:noFill/>
+        </p:spPr>
+        <p:txBody>
+          <a:bodyPr wrap="square" anchor="t">
+            <a:spAutoFit/>
+          </a:bodyPr>
+          <a:lstStyle/>
+          <a:p>
+            <a:pPr algn="l">
+              <a:spcAft>
+                <a:spcPts val="800"/>
+              </a:spcAft>
+            </a:pPr>
+            <a:r>
+              <a:rPr sz="1500" b="0">
+                <a:solidFill>
+                  <a:srgbClr val="0F172A"/>
+                </a:solidFill>
+                <a:latin typeface="PingFang TC"/>
+                <a:ea typeface="PingFang TC"/>
+              </a:rPr>
+              <a:t>容量：1B × 200B = 200GB（單機放得下）</a:t>
+            </a:r>
+          </a:p>
+          <a:p>
+            <a:pPr algn="l">
+              <a:spcAft>
+                <a:spcPts val="400"/>
+              </a:spcAft>
+            </a:pPr>
+            <a:r>
+              <a:rPr sz="1500" b="0">
+                <a:solidFill>
+                  <a:srgbClr val="0F172A"/>
+                </a:solidFill>
+                <a:latin typeface="PingFang TC"/>
+                <a:ea typeface="PingFang TC"/>
+              </a:rPr>
+              <a:t>讀流量：1 億 users × 5/日 = 5 億 redirects/日</a:t>
+            </a:r>
+          </a:p>
+          <a:p>
+            <a:pPr algn="l">
+              <a:spcAft>
+                <a:spcPts val="800"/>
+              </a:spcAft>
+            </a:pPr>
+            <a:r>
+              <a:rPr sz="1600" b="1">
+                <a:solidFill>
+                  <a:srgbClr val="2563EB"/>
+                </a:solidFill>
+                <a:latin typeface="PingFang TC"/>
+                <a:ea typeface="PingFang TC"/>
+              </a:rPr>
+              <a:t>            5 億 ÷ 86,400s ≈ 5,787 redirects/秒</a:t>
+            </a:r>
+          </a:p>
+          <a:p>
+            <a:pPr algn="l">
+              <a:spcAft>
+                <a:spcPts val="1200"/>
+              </a:spcAft>
+            </a:pPr>
+            <a:r>
+              <a:rPr sz="1500" b="0">
+                <a:solidFill>
+                  <a:srgbClr val="0F172A"/>
+                </a:solidFill>
+                <a:latin typeface="PingFang TC"/>
+                <a:ea typeface="PingFang TC"/>
+              </a:rPr>
+              <a:t>讀寫比：≈ 100:1（讀 ≫ 寫）</a:t>
+            </a:r>
+          </a:p>
+          <a:p>
+            <a:pPr algn="l">
+              <a:spcAft>
+                <a:spcPts val="400"/>
+              </a:spcAft>
+            </a:pPr>
+            <a:r>
+              <a:rPr sz="1500" b="1">
+                <a:solidFill>
+                  <a:srgbClr val="0F172A"/>
+                </a:solidFill>
+                <a:latin typeface="PingFang TC"/>
+                <a:ea typeface="PingFang TC"/>
+              </a:rPr>
+              <a:t>→ 瓶頸是「讀吞吐」、不是容量</a:t>
+            </a:r>
+          </a:p>
+          <a:p>
+            <a:pPr algn="l">
+              <a:spcAft>
+                <a:spcPts val="400"/>
+              </a:spcAft>
+            </a:pPr>
+            <a:r>
+              <a:rPr sz="1600" b="1">
+                <a:solidFill>
+                  <a:srgbClr val="059669"/>
+                </a:solidFill>
+                <a:latin typeface="PingFang TC"/>
+                <a:ea typeface="PingFang TC"/>
+              </a:rPr>
+              <a:t>→ 讀寫分離 + 多個 read replica</a:t>
+            </a:r>
+          </a:p>
+        </p:txBody>
+      </p:sp>
+      <p:sp>
+        <p:nvSpPr>
+          <p:cNvPr id="5" name="Rounded Rectangle 4"/>
           <p:cNvSpPr/>
           <p:nvPr/>
         </p:nvSpPr>
         <p:spPr>
           <a:xfrm>
-            <a:off x="640080" y="1691640"/>
-            <a:ext cx="640080" cy="731520"/>
+            <a:off x="6126480" y="2286000"/>
+            <a:ext cx="1645920" cy="914400"/>
           </a:xfrm>
           <a:prstGeom prst="roundRect">
             <a:avLst/>
@@ -6365,6 +6492,792 @@
           <a:p>
             <a:pPr algn="ctr"/>
             <a:r>
+              <a:rPr sz="1300" b="1">
+                <a:solidFill>
+                  <a:srgbClr val="FFFFFF"/>
+                </a:solidFill>
+                <a:latin typeface="PingFang TC"/>
+                <a:ea typeface="PingFang TC"/>
+              </a:rPr>
+              <a:t>App</a:t>
+            </a:r>
+          </a:p>
+          <a:p>
+            <a:pPr algn="ctr"/>
+            <a:r>
+              <a:rPr sz="1300" b="0">
+                <a:solidFill>
+                  <a:srgbClr val="FFFFFF"/>
+                </a:solidFill>
+                <a:latin typeface="PingFang TC"/>
+                <a:ea typeface="PingFang TC"/>
+              </a:rPr>
+              <a:t>(stateless)</a:t>
+            </a:r>
+          </a:p>
+        </p:txBody>
+      </p:sp>
+      <p:sp>
+        <p:nvSpPr>
+          <p:cNvPr id="6" name="Rounded Rectangle 5"/>
+          <p:cNvSpPr/>
+          <p:nvPr/>
+        </p:nvSpPr>
+        <p:spPr>
+          <a:xfrm>
+            <a:off x="8595360" y="1737360"/>
+            <a:ext cx="3017520" cy="731520"/>
+          </a:xfrm>
+          <a:prstGeom prst="roundRect">
+            <a:avLst/>
+          </a:prstGeom>
+          <a:solidFill>
+            <a:srgbClr val="059669"/>
+          </a:solidFill>
+          <a:ln>
+            <a:solidFill>
+              <a:srgbClr val="059669"/>
+            </a:solidFill>
+          </a:ln>
+          <a:effectLst/>
+        </p:spPr>
+        <p:style>
+          <a:lnRef idx="1">
+            <a:schemeClr val="accent1"/>
+          </a:lnRef>
+          <a:fillRef idx="3">
+            <a:schemeClr val="accent1"/>
+          </a:fillRef>
+          <a:effectRef idx="2">
+            <a:schemeClr val="accent1"/>
+          </a:effectRef>
+          <a:fontRef idx="minor">
+            <a:schemeClr val="lt1"/>
+          </a:fontRef>
+        </p:style>
+        <p:txBody>
+          <a:bodyPr rtlCol="0" anchor="ctr" wrap="square" tIns="25400" bIns="25400"/>
+          <a:lstStyle/>
+          <a:p>
+            <a:pPr algn="ctr"/>
+            <a:r>
+              <a:rPr sz="1300" b="1">
+                <a:solidFill>
+                  <a:srgbClr val="FFFFFF"/>
+                </a:solidFill>
+                <a:latin typeface="PingFang TC"/>
+                <a:ea typeface="PingFang TC"/>
+              </a:rPr>
+              <a:t>Primary (Write)</a:t>
+            </a:r>
+          </a:p>
+        </p:txBody>
+      </p:sp>
+      <p:sp>
+        <p:nvSpPr>
+          <p:cNvPr id="7" name="Rounded Rectangle 6"/>
+          <p:cNvSpPr/>
+          <p:nvPr/>
+        </p:nvSpPr>
+        <p:spPr>
+          <a:xfrm>
+            <a:off x="8595360" y="2697480"/>
+            <a:ext cx="3017520" cy="594360"/>
+          </a:xfrm>
+          <a:prstGeom prst="roundRect">
+            <a:avLst/>
+          </a:prstGeom>
+          <a:solidFill>
+            <a:srgbClr val="0EA5E9"/>
+          </a:solidFill>
+          <a:ln>
+            <a:solidFill>
+              <a:srgbClr val="0EA5E9"/>
+            </a:solidFill>
+          </a:ln>
+          <a:effectLst/>
+        </p:spPr>
+        <p:style>
+          <a:lnRef idx="1">
+            <a:schemeClr val="accent1"/>
+          </a:lnRef>
+          <a:fillRef idx="3">
+            <a:schemeClr val="accent1"/>
+          </a:fillRef>
+          <a:effectRef idx="2">
+            <a:schemeClr val="accent1"/>
+          </a:effectRef>
+          <a:fontRef idx="minor">
+            <a:schemeClr val="lt1"/>
+          </a:fontRef>
+        </p:style>
+        <p:txBody>
+          <a:bodyPr rtlCol="0" anchor="ctr" wrap="square" tIns="25400" bIns="25400"/>
+          <a:lstStyle/>
+          <a:p>
+            <a:pPr algn="ctr"/>
+            <a:r>
+              <a:rPr sz="1200" b="1">
+                <a:solidFill>
+                  <a:srgbClr val="FFFFFF"/>
+                </a:solidFill>
+                <a:latin typeface="PingFang TC"/>
+                <a:ea typeface="PingFang TC"/>
+              </a:rPr>
+              <a:t>Read Replica 1</a:t>
+            </a:r>
+          </a:p>
+        </p:txBody>
+      </p:sp>
+      <p:sp>
+        <p:nvSpPr>
+          <p:cNvPr id="8" name="Rounded Rectangle 7"/>
+          <p:cNvSpPr/>
+          <p:nvPr/>
+        </p:nvSpPr>
+        <p:spPr>
+          <a:xfrm>
+            <a:off x="8595360" y="3429000"/>
+            <a:ext cx="3017520" cy="594360"/>
+          </a:xfrm>
+          <a:prstGeom prst="roundRect">
+            <a:avLst/>
+          </a:prstGeom>
+          <a:solidFill>
+            <a:srgbClr val="0EA5E9"/>
+          </a:solidFill>
+          <a:ln>
+            <a:solidFill>
+              <a:srgbClr val="0EA5E9"/>
+            </a:solidFill>
+          </a:ln>
+          <a:effectLst/>
+        </p:spPr>
+        <p:style>
+          <a:lnRef idx="1">
+            <a:schemeClr val="accent1"/>
+          </a:lnRef>
+          <a:fillRef idx="3">
+            <a:schemeClr val="accent1"/>
+          </a:fillRef>
+          <a:effectRef idx="2">
+            <a:schemeClr val="accent1"/>
+          </a:effectRef>
+          <a:fontRef idx="minor">
+            <a:schemeClr val="lt1"/>
+          </a:fontRef>
+        </p:style>
+        <p:txBody>
+          <a:bodyPr rtlCol="0" anchor="ctr" wrap="square" tIns="25400" bIns="25400"/>
+          <a:lstStyle/>
+          <a:p>
+            <a:pPr algn="ctr"/>
+            <a:r>
+              <a:rPr sz="1200" b="1">
+                <a:solidFill>
+                  <a:srgbClr val="FFFFFF"/>
+                </a:solidFill>
+                <a:latin typeface="PingFang TC"/>
+                <a:ea typeface="PingFang TC"/>
+              </a:rPr>
+              <a:t>Read Replica 2</a:t>
+            </a:r>
+          </a:p>
+        </p:txBody>
+      </p:sp>
+      <p:sp>
+        <p:nvSpPr>
+          <p:cNvPr id="9" name="Rounded Rectangle 8"/>
+          <p:cNvSpPr/>
+          <p:nvPr/>
+        </p:nvSpPr>
+        <p:spPr>
+          <a:xfrm>
+            <a:off x="8595360" y="4160520"/>
+            <a:ext cx="3017520" cy="594360"/>
+          </a:xfrm>
+          <a:prstGeom prst="roundRect">
+            <a:avLst/>
+          </a:prstGeom>
+          <a:solidFill>
+            <a:srgbClr val="0EA5E9"/>
+          </a:solidFill>
+          <a:ln>
+            <a:solidFill>
+              <a:srgbClr val="0EA5E9"/>
+            </a:solidFill>
+          </a:ln>
+          <a:effectLst/>
+        </p:spPr>
+        <p:style>
+          <a:lnRef idx="1">
+            <a:schemeClr val="accent1"/>
+          </a:lnRef>
+          <a:fillRef idx="3">
+            <a:schemeClr val="accent1"/>
+          </a:fillRef>
+          <a:effectRef idx="2">
+            <a:schemeClr val="accent1"/>
+          </a:effectRef>
+          <a:fontRef idx="minor">
+            <a:schemeClr val="lt1"/>
+          </a:fontRef>
+        </p:style>
+        <p:txBody>
+          <a:bodyPr rtlCol="0" anchor="ctr" wrap="square" tIns="25400" bIns="25400"/>
+          <a:lstStyle/>
+          <a:p>
+            <a:pPr algn="ctr"/>
+            <a:r>
+              <a:rPr sz="1200" b="1">
+                <a:solidFill>
+                  <a:srgbClr val="FFFFFF"/>
+                </a:solidFill>
+                <a:latin typeface="PingFang TC"/>
+                <a:ea typeface="PingFang TC"/>
+              </a:rPr>
+              <a:t>Read Replica N</a:t>
+            </a:r>
+          </a:p>
+        </p:txBody>
+      </p:sp>
+      <p:cxnSp>
+        <p:nvCxnSpPr>
+          <p:cNvPr id="10" name="Connector 9"/>
+          <p:cNvCxnSpPr/>
+          <p:nvPr/>
+        </p:nvCxnSpPr>
+        <p:spPr>
+          <a:xfrm flipV="1">
+            <a:off x="7772400" y="2103120"/>
+            <a:ext cx="822960" cy="457200"/>
+          </a:xfrm>
+          <a:prstGeom prst="line">
+            <a:avLst/>
+          </a:prstGeom>
+          <a:ln w="20320">
+            <a:solidFill>
+              <a:srgbClr val="DC2626"/>
+            </a:solidFill>
+            <a:tailEnd type="triangle" w="med" len="med"/>
+          </a:ln>
+        </p:spPr>
+        <p:style>
+          <a:lnRef idx="2">
+            <a:schemeClr val="accent1"/>
+          </a:lnRef>
+          <a:fillRef idx="0">
+            <a:schemeClr val="accent1"/>
+          </a:fillRef>
+          <a:effectRef idx="1">
+            <a:schemeClr val="accent1"/>
+          </a:effectRef>
+          <a:fontRef idx="minor">
+            <a:schemeClr val="tx1"/>
+          </a:fontRef>
+        </p:style>
+      </p:cxnSp>
+      <p:cxnSp>
+        <p:nvCxnSpPr>
+          <p:cNvPr id="11" name="Connector 10"/>
+          <p:cNvCxnSpPr/>
+          <p:nvPr/>
+        </p:nvCxnSpPr>
+        <p:spPr>
+          <a:xfrm>
+            <a:off x="7772400" y="2880360"/>
+            <a:ext cx="822960" cy="109728"/>
+          </a:xfrm>
+          <a:prstGeom prst="line">
+            <a:avLst/>
+          </a:prstGeom>
+          <a:ln w="17780">
+            <a:solidFill>
+              <a:srgbClr val="059669"/>
+            </a:solidFill>
+            <a:tailEnd type="triangle" w="med" len="med"/>
+          </a:ln>
+        </p:spPr>
+        <p:style>
+          <a:lnRef idx="2">
+            <a:schemeClr val="accent1"/>
+          </a:lnRef>
+          <a:fillRef idx="0">
+            <a:schemeClr val="accent1"/>
+          </a:fillRef>
+          <a:effectRef idx="1">
+            <a:schemeClr val="accent1"/>
+          </a:effectRef>
+          <a:fontRef idx="minor">
+            <a:schemeClr val="tx1"/>
+          </a:fontRef>
+        </p:style>
+      </p:cxnSp>
+      <p:cxnSp>
+        <p:nvCxnSpPr>
+          <p:cNvPr id="12" name="Connector 11"/>
+          <p:cNvCxnSpPr/>
+          <p:nvPr/>
+        </p:nvCxnSpPr>
+        <p:spPr>
+          <a:xfrm>
+            <a:off x="7772400" y="3017520"/>
+            <a:ext cx="822960" cy="704088"/>
+          </a:xfrm>
+          <a:prstGeom prst="line">
+            <a:avLst/>
+          </a:prstGeom>
+          <a:ln w="17780">
+            <a:solidFill>
+              <a:srgbClr val="059669"/>
+            </a:solidFill>
+            <a:tailEnd type="triangle" w="med" len="med"/>
+          </a:ln>
+        </p:spPr>
+        <p:style>
+          <a:lnRef idx="2">
+            <a:schemeClr val="accent1"/>
+          </a:lnRef>
+          <a:fillRef idx="0">
+            <a:schemeClr val="accent1"/>
+          </a:fillRef>
+          <a:effectRef idx="1">
+            <a:schemeClr val="accent1"/>
+          </a:effectRef>
+          <a:fontRef idx="minor">
+            <a:schemeClr val="tx1"/>
+          </a:fontRef>
+        </p:style>
+      </p:cxnSp>
+      <p:cxnSp>
+        <p:nvCxnSpPr>
+          <p:cNvPr id="13" name="Connector 12"/>
+          <p:cNvCxnSpPr/>
+          <p:nvPr/>
+        </p:nvCxnSpPr>
+        <p:spPr>
+          <a:xfrm>
+            <a:off x="7772400" y="3108960"/>
+            <a:ext cx="822960" cy="1344168"/>
+          </a:xfrm>
+          <a:prstGeom prst="line">
+            <a:avLst/>
+          </a:prstGeom>
+          <a:ln w="17780">
+            <a:solidFill>
+              <a:srgbClr val="059669"/>
+            </a:solidFill>
+            <a:tailEnd type="triangle" w="med" len="med"/>
+          </a:ln>
+        </p:spPr>
+        <p:style>
+          <a:lnRef idx="2">
+            <a:schemeClr val="accent1"/>
+          </a:lnRef>
+          <a:fillRef idx="0">
+            <a:schemeClr val="accent1"/>
+          </a:fillRef>
+          <a:effectRef idx="1">
+            <a:schemeClr val="accent1"/>
+          </a:effectRef>
+          <a:fontRef idx="minor">
+            <a:schemeClr val="tx1"/>
+          </a:fontRef>
+        </p:style>
+      </p:cxnSp>
+      <p:sp>
+        <p:nvSpPr>
+          <p:cNvPr id="14" name="TextBox 13"/>
+          <p:cNvSpPr txBox="1"/>
+          <p:nvPr/>
+        </p:nvSpPr>
+        <p:spPr>
+          <a:xfrm>
+            <a:off x="7635240" y="2057400"/>
+            <a:ext cx="914400" cy="274320"/>
+          </a:xfrm>
+          <a:prstGeom prst="rect">
+            <a:avLst/>
+          </a:prstGeom>
+          <a:noFill/>
+        </p:spPr>
+        <p:txBody>
+          <a:bodyPr wrap="square" anchor="t">
+            <a:spAutoFit/>
+          </a:bodyPr>
+          <a:lstStyle/>
+          <a:p>
+            <a:pPr algn="l">
+              <a:spcAft>
+                <a:spcPts val="400"/>
+              </a:spcAft>
+            </a:pPr>
+            <a:r>
+              <a:rPr sz="1200" b="1">
+                <a:solidFill>
+                  <a:srgbClr val="DC2626"/>
+                </a:solidFill>
+                <a:latin typeface="PingFang TC"/>
+                <a:ea typeface="PingFang TC"/>
+              </a:rPr>
+              <a:t>寫</a:t>
+            </a:r>
+          </a:p>
+        </p:txBody>
+      </p:sp>
+      <p:sp>
+        <p:nvSpPr>
+          <p:cNvPr id="15" name="TextBox 14"/>
+          <p:cNvSpPr txBox="1"/>
+          <p:nvPr/>
+        </p:nvSpPr>
+        <p:spPr>
+          <a:xfrm>
+            <a:off x="7589520" y="3200400"/>
+            <a:ext cx="914400" cy="274320"/>
+          </a:xfrm>
+          <a:prstGeom prst="rect">
+            <a:avLst/>
+          </a:prstGeom>
+          <a:noFill/>
+        </p:spPr>
+        <p:txBody>
+          <a:bodyPr wrap="square" anchor="t">
+            <a:spAutoFit/>
+          </a:bodyPr>
+          <a:lstStyle/>
+          <a:p>
+            <a:pPr algn="l">
+              <a:spcAft>
+                <a:spcPts val="400"/>
+              </a:spcAft>
+            </a:pPr>
+            <a:r>
+              <a:rPr sz="1200" b="1">
+                <a:solidFill>
+                  <a:srgbClr val="059669"/>
+                </a:solidFill>
+                <a:latin typeface="PingFang TC"/>
+                <a:ea typeface="PingFang TC"/>
+              </a:rPr>
+              <a:t>讀</a:t>
+            </a:r>
+          </a:p>
+        </p:txBody>
+      </p:sp>
+      <p:cxnSp>
+        <p:nvCxnSpPr>
+          <p:cNvPr id="16" name="Connector 15"/>
+          <p:cNvCxnSpPr/>
+          <p:nvPr/>
+        </p:nvCxnSpPr>
+        <p:spPr>
+          <a:xfrm>
+            <a:off x="10104120" y="2468880"/>
+            <a:ext cx="0" cy="228600"/>
+          </a:xfrm>
+          <a:prstGeom prst="line">
+            <a:avLst/>
+          </a:prstGeom>
+          <a:ln w="13970">
+            <a:solidFill>
+              <a:srgbClr val="64748B"/>
+            </a:solidFill>
+            <a:tailEnd type="triangle" w="med" len="med"/>
+          </a:ln>
+        </p:spPr>
+        <p:style>
+          <a:lnRef idx="2">
+            <a:schemeClr val="accent1"/>
+          </a:lnRef>
+          <a:fillRef idx="0">
+            <a:schemeClr val="accent1"/>
+          </a:fillRef>
+          <a:effectRef idx="1">
+            <a:schemeClr val="accent1"/>
+          </a:effectRef>
+          <a:fontRef idx="minor">
+            <a:schemeClr val="tx1"/>
+          </a:fontRef>
+        </p:style>
+      </p:cxnSp>
+      <p:sp>
+        <p:nvSpPr>
+          <p:cNvPr id="17" name="TextBox 16"/>
+          <p:cNvSpPr txBox="1"/>
+          <p:nvPr/>
+        </p:nvSpPr>
+        <p:spPr>
+          <a:xfrm>
+            <a:off x="10241280" y="2395728"/>
+            <a:ext cx="1463040" cy="274320"/>
+          </a:xfrm>
+          <a:prstGeom prst="rect">
+            <a:avLst/>
+          </a:prstGeom>
+          <a:noFill/>
+        </p:spPr>
+        <p:txBody>
+          <a:bodyPr wrap="square" anchor="t">
+            <a:spAutoFit/>
+          </a:bodyPr>
+          <a:lstStyle/>
+          <a:p>
+            <a:pPr algn="l">
+              <a:spcAft>
+                <a:spcPts val="400"/>
+              </a:spcAft>
+            </a:pPr>
+            <a:r>
+              <a:rPr sz="1000" b="0">
+                <a:solidFill>
+                  <a:srgbClr val="64748B"/>
+                </a:solidFill>
+                <a:latin typeface="PingFang TC"/>
+                <a:ea typeface="PingFang TC"/>
+              </a:rPr>
+              <a:t>非同步複寫</a:t>
+            </a:r>
+          </a:p>
+        </p:txBody>
+      </p:sp>
+      <p:sp>
+        <p:nvSpPr>
+          <p:cNvPr id="18" name="TextBox 17"/>
+          <p:cNvSpPr txBox="1"/>
+          <p:nvPr/>
+        </p:nvSpPr>
+        <p:spPr>
+          <a:xfrm>
+            <a:off x="548640" y="5029200"/>
+            <a:ext cx="11247120" cy="1554480"/>
+          </a:xfrm>
+          <a:prstGeom prst="rect">
+            <a:avLst/>
+          </a:prstGeom>
+          <a:noFill/>
+        </p:spPr>
+        <p:txBody>
+          <a:bodyPr wrap="square">
+            <a:spAutoFit/>
+          </a:bodyPr>
+          <a:lstStyle/>
+          <a:p>
+            <a:pPr>
+              <a:spcAft>
+                <a:spcPts val="600"/>
+              </a:spcAft>
+            </a:pPr>
+            <a:r>
+              <a:rPr sz="1300" b="0">
+                <a:solidFill>
+                  <a:srgbClr val="0F172A"/>
+                </a:solidFill>
+                <a:latin typeface="PingFang TC"/>
+                <a:ea typeface="PingFang TC"/>
+              </a:rPr>
+              <a:t>•  寫走 primary、讀走 replica（load-balanced）；讀不夠就加 replica 水平擴讀</a:t>
+            </a:r>
+          </a:p>
+          <a:p>
+            <a:pPr>
+              <a:spcAft>
+                <a:spcPts val="600"/>
+              </a:spcAft>
+            </a:pPr>
+            <a:r>
+              <a:rPr sz="1300" b="0">
+                <a:solidFill>
+                  <a:srgbClr val="0F172A"/>
+                </a:solidFill>
+                <a:latin typeface="PingFang TC"/>
+                <a:ea typeface="PingFang TC"/>
+              </a:rPr>
+              <a:t>•  配合 Redis cache，真正打到 DB 的讀已先被擋掉一大半</a:t>
+            </a:r>
+          </a:p>
+          <a:p>
+            <a:pPr>
+              <a:spcAft>
+                <a:spcPts val="600"/>
+              </a:spcAft>
+            </a:pPr>
+            <a:r>
+              <a:rPr sz="1300" b="0">
+                <a:solidFill>
+                  <a:srgbClr val="0F172A"/>
+                </a:solidFill>
+                <a:latin typeface="PingFang TC"/>
+                <a:ea typeface="PingFang TC"/>
+              </a:rPr>
+              <a:t>•  failover：primary 掛 → 升一台 read replica 為新 primary；複寫延遲靠 create 後暖 cache 緩解</a:t>
+            </a:r>
+          </a:p>
+        </p:txBody>
+      </p:sp>
+    </p:spTree>
+  </p:cSld>
+  <p:clrMapOvr>
+    <a:masterClrMapping/>
+  </p:clrMapOvr>
+</p:sld>
+</file>
+
+<file path=ppt/slides/slide17.xml><?xml version="1.0" encoding="utf-8"?>
+<p:sld xmlns:a="http://schemas.openxmlformats.org/drawingml/2006/main" xmlns:p="http://schemas.openxmlformats.org/presentationml/2006/main" xmlns:r="http://schemas.openxmlformats.org/officeDocument/2006/relationships">
+  <p:cSld>
+    <p:spTree>
+      <p:nvGrpSpPr>
+        <p:cNvPr id="1" name=""/>
+        <p:cNvGrpSpPr/>
+        <p:nvPr/>
+      </p:nvGrpSpPr>
+      <p:grpSpPr/>
+      <p:sp>
+        <p:nvSpPr>
+          <p:cNvPr id="2" name="Rectangle 1"/>
+          <p:cNvSpPr/>
+          <p:nvPr/>
+        </p:nvSpPr>
+        <p:spPr>
+          <a:xfrm>
+            <a:off x="0" y="0"/>
+            <a:ext cx="164592" cy="6858000"/>
+          </a:xfrm>
+          <a:prstGeom prst="rect">
+            <a:avLst/>
+          </a:prstGeom>
+          <a:solidFill>
+            <a:srgbClr val="2563EB"/>
+          </a:solidFill>
+          <a:ln>
+            <a:noFill/>
+          </a:ln>
+          <a:effectLst/>
+        </p:spPr>
+        <p:style>
+          <a:lnRef idx="1">
+            <a:schemeClr val="accent1"/>
+          </a:lnRef>
+          <a:fillRef idx="3">
+            <a:schemeClr val="accent1"/>
+          </a:fillRef>
+          <a:effectRef idx="2">
+            <a:schemeClr val="accent1"/>
+          </a:effectRef>
+          <a:fontRef idx="minor">
+            <a:schemeClr val="lt1"/>
+          </a:fontRef>
+        </p:style>
+        <p:txBody>
+          <a:bodyPr rtlCol="0" anchor="ctr"/>
+          <a:lstStyle/>
+          <a:p>
+            <a:pPr algn="ctr"/>
+          </a:p>
+        </p:txBody>
+      </p:sp>
+      <p:sp>
+        <p:nvSpPr>
+          <p:cNvPr id="3" name="TextBox 2"/>
+          <p:cNvSpPr txBox="1"/>
+          <p:nvPr/>
+        </p:nvSpPr>
+        <p:spPr>
+          <a:xfrm>
+            <a:off x="502920" y="320040"/>
+            <a:ext cx="10972800" cy="1005840"/>
+          </a:xfrm>
+          <a:prstGeom prst="rect">
+            <a:avLst/>
+          </a:prstGeom>
+          <a:noFill/>
+        </p:spPr>
+        <p:txBody>
+          <a:bodyPr wrap="square" anchor="t">
+            <a:spAutoFit/>
+          </a:bodyPr>
+          <a:lstStyle/>
+          <a:p>
+            <a:pPr algn="l">
+              <a:spcAft>
+                <a:spcPts val="200"/>
+              </a:spcAft>
+            </a:pPr>
+            <a:r>
+              <a:rPr sz="1300" b="1">
+                <a:solidFill>
+                  <a:srgbClr val="2563EB"/>
+                </a:solidFill>
+                <a:latin typeface="PingFang TC"/>
+                <a:ea typeface="PingFang TC"/>
+              </a:rPr>
+              <a:t>12 · IMPROVEMENTS</a:t>
+            </a:r>
+          </a:p>
+          <a:p>
+            <a:pPr algn="l">
+              <a:spcAft>
+                <a:spcPts val="400"/>
+              </a:spcAft>
+            </a:pPr>
+            <a:r>
+              <a:rPr sz="3000" b="1">
+                <a:solidFill>
+                  <a:srgbClr val="0F172A"/>
+                </a:solidFill>
+                <a:latin typeface="PingFang TC"/>
+                <a:ea typeface="PingFang TC"/>
+              </a:rPr>
+              <a:t>對參考 repo 的關鍵改良</a:t>
+            </a:r>
+          </a:p>
+        </p:txBody>
+      </p:sp>
+      <p:sp>
+        <p:nvSpPr>
+          <p:cNvPr id="4" name="Rounded Rectangle 3"/>
+          <p:cNvSpPr/>
+          <p:nvPr/>
+        </p:nvSpPr>
+        <p:spPr>
+          <a:xfrm>
+            <a:off x="640080" y="1691640"/>
+            <a:ext cx="640080" cy="731520"/>
+          </a:xfrm>
+          <a:prstGeom prst="roundRect">
+            <a:avLst/>
+          </a:prstGeom>
+          <a:solidFill>
+            <a:srgbClr val="2563EB"/>
+          </a:solidFill>
+          <a:ln>
+            <a:solidFill>
+              <a:srgbClr val="2563EB"/>
+            </a:solidFill>
+          </a:ln>
+          <a:effectLst/>
+        </p:spPr>
+        <p:style>
+          <a:lnRef idx="1">
+            <a:schemeClr val="accent1"/>
+          </a:lnRef>
+          <a:fillRef idx="3">
+            <a:schemeClr val="accent1"/>
+          </a:fillRef>
+          <a:effectRef idx="2">
+            <a:schemeClr val="accent1"/>
+          </a:effectRef>
+          <a:fontRef idx="minor">
+            <a:schemeClr val="lt1"/>
+          </a:fontRef>
+        </p:style>
+        <p:txBody>
+          <a:bodyPr rtlCol="0" anchor="ctr" wrap="square" tIns="25400" bIns="25400"/>
+          <a:lstStyle/>
+          <a:p>
+            <a:pPr algn="ctr"/>
+            <a:r>
               <a:rPr sz="1800" b="1">
                 <a:solidFill>
                   <a:srgbClr val="FFFFFF"/>
@@ -7124,7 +8037,7 @@
 </p:sld>
 </file>
 
-<file path=ppt/slides/slide17.xml><?xml version="1.0" encoding="utf-8"?>
+<file path=ppt/slides/slide18.xml><?xml version="1.0" encoding="utf-8"?>
 <p:sld xmlns:a="http://schemas.openxmlformats.org/drawingml/2006/main" xmlns:p="http://schemas.openxmlformats.org/presentationml/2006/main" xmlns:r="http://schemas.openxmlformats.org/officeDocument/2006/relationships">
   <p:cSld>
     <p:spTree>
@@ -8056,7 +8969,7 @@
 </p:sld>
 </file>
 
-<file path=ppt/slides/slide18.xml><?xml version="1.0" encoding="utf-8"?>
+<file path=ppt/slides/slide19.xml><?xml version="1.0" encoding="utf-8"?>
 <p:sld xmlns:a="http://schemas.openxmlformats.org/drawingml/2006/main" xmlns:p="http://schemas.openxmlformats.org/presentationml/2006/main" xmlns:r="http://schemas.openxmlformats.org/officeDocument/2006/relationships">
   <p:cSld>
     <p:spTree>
@@ -8075,13 +8988,13 @@
         <p:spPr>
           <a:xfrm>
             <a:off x="0" y="0"/>
-            <a:ext cx="12191695" cy="6858000"/>
+            <a:ext cx="164592" cy="6858000"/>
           </a:xfrm>
           <a:prstGeom prst="rect">
             <a:avLst/>
           </a:prstGeom>
           <a:solidFill>
-            <a:srgbClr val="0F172A"/>
+            <a:srgbClr val="2563EB"/>
           </a:solidFill>
           <a:ln>
             <a:noFill/>
@@ -8118,8 +9031,8 @@
         </p:nvSpPr>
         <p:spPr>
           <a:xfrm>
-            <a:off x="822960" y="1097280"/>
-            <a:ext cx="10515600" cy="1097280"/>
+            <a:off x="502920" y="320040"/>
+            <a:ext cx="10972800" cy="1005840"/>
           </a:xfrm>
           <a:prstGeom prst="rect">
             <a:avLst/>
@@ -8134,35 +9047,35 @@
           <a:p>
             <a:pPr algn="l">
               <a:spcAft>
+                <a:spcPts val="200"/>
+              </a:spcAft>
+            </a:pPr>
+            <a:r>
+              <a:rPr sz="1300" b="1">
+                <a:solidFill>
+                  <a:srgbClr val="2563EB"/>
+                </a:solidFill>
+                <a:latin typeface="PingFang TC"/>
+                <a:ea typeface="PingFang TC"/>
+              </a:rPr>
+              <a:t>附錄 · CDN EDGE</a:t>
+            </a:r>
+          </a:p>
+          <a:p>
+            <a:pPr algn="l">
+              <a:spcAft>
                 <a:spcPts val="400"/>
               </a:spcAft>
             </a:pPr>
             <a:r>
-              <a:rPr sz="1600" b="1">
-                <a:solidFill>
-                  <a:srgbClr val="2563EB"/>
-                </a:solidFill>
-                <a:latin typeface="PingFang TC"/>
-                <a:ea typeface="PingFang TC"/>
-              </a:rPr>
-              <a:t>原型狀態</a:t>
-            </a:r>
-          </a:p>
-          <a:p>
-            <a:pPr algn="l">
-              <a:spcAft>
-                <a:spcPts val="400"/>
-              </a:spcAft>
-            </a:pPr>
-            <a:r>
               <a:rPr sz="3000" b="1">
                 <a:solidFill>
-                  <a:srgbClr val="FFFFFF"/>
-                </a:solidFill>
-                <a:latin typeface="PingFang TC"/>
-                <a:ea typeface="PingFang TC"/>
-              </a:rPr>
-              <a:t>可跑的 FastAPI 實作 + 管理頁前端</a:t>
+                  <a:srgbClr val="0F172A"/>
+                </a:solidFill>
+                <a:latin typeface="PingFang TC"/>
+                <a:ea typeface="PingFang TC"/>
+              </a:rPr>
+              <a:t>CDN 邊緣 redirect 變體（可選最佳化）</a:t>
             </a:r>
           </a:p>
         </p:txBody>
@@ -8175,8 +9088,8 @@
         </p:nvSpPr>
         <p:spPr>
           <a:xfrm>
-            <a:off x="822960" y="2743200"/>
-            <a:ext cx="10515600" cy="2743200"/>
+            <a:off x="548640" y="1371600"/>
+            <a:ext cx="11155680" cy="548640"/>
           </a:xfrm>
           <a:prstGeom prst="rect">
             <a:avLst/>
@@ -8184,76 +9097,790 @@
           <a:noFill/>
         </p:spPr>
         <p:txBody>
-          <a:bodyPr wrap="square">
+          <a:bodyPr wrap="square" anchor="t">
             <a:spAutoFit/>
           </a:bodyPr>
           <a:lstStyle/>
           <a:p>
-            <a:pPr>
-              <a:spcAft>
-                <a:spcPts val="1200"/>
-              </a:spcAft>
-            </a:pPr>
-            <a:r>
-              <a:rPr sz="1600" b="0">
-                <a:solidFill>
-                  <a:srgbClr val="E2E8F0"/>
-                </a:solidFill>
-                <a:latin typeface="PingFang TC"/>
-                <a:ea typeface="PingFang TC"/>
-              </a:rPr>
-              <a:t>✓  7 個 API 端點 + 管理頁前端（建立/清單/編輯/刪除/分析）</a:t>
-            </a:r>
-          </a:p>
-          <a:p>
-            <a:pPr>
-              <a:spcAft>
-                <a:spcPts val="1200"/>
-              </a:spcAft>
-            </a:pPr>
-            <a:r>
-              <a:rPr sz="1600" b="0">
-                <a:solidFill>
-                  <a:srgbClr val="E2E8F0"/>
-                </a:solidFill>
-                <a:latin typeface="PingFang TC"/>
-                <a:ea typeface="PingFang TC"/>
-              </a:rPr>
-              <a:t>✓  全部 curl 驗證通過：302 / 404 / 410 / 8 碼 token / 正規化 / SSRF / 過期</a:t>
-            </a:r>
-          </a:p>
-          <a:p>
-            <a:pPr>
-              <a:spcAft>
-                <a:spcPts val="1200"/>
-              </a:spcAft>
-            </a:pPr>
-            <a:r>
-              <a:rPr sz="1600" b="0">
-                <a:solidFill>
-                  <a:srgbClr val="E2E8F0"/>
-                </a:solidFill>
-                <a:latin typeface="PingFang TC"/>
-                <a:ea typeface="PingFang TC"/>
-              </a:rPr>
-              <a:t>✓  production 替換點已在程式註解標明（Redis / 佇列 / CDN / 預聚合 / PostgreSQL）</a:t>
-            </a:r>
-          </a:p>
-          <a:p>
-            <a:pPr>
-              <a:spcAft>
-                <a:spcPts val="1200"/>
-              </a:spcAft>
-            </a:pPr>
-            <a:r>
-              <a:rPr sz="1600" b="0">
-                <a:solidFill>
-                  <a:srgbClr val="E2E8F0"/>
-                </a:solidFill>
-                <a:latin typeface="PingFang TC"/>
-                <a:ea typeface="PingFang TC"/>
-              </a:rPr>
-              <a:t>✓  設計依據：DESIGN.md（16 題決策 + 優劣分析）</a:t>
+            <a:pPr algn="l">
+              <a:spcAft>
+                <a:spcPts val="200"/>
+              </a:spcAft>
+            </a:pPr>
+            <a:r>
+              <a:rPr sz="1200" b="0">
+                <a:solidFill>
+                  <a:srgbClr val="64748B"/>
+                </a:solidFill>
+                <a:latin typeface="PingFang TC"/>
+                <a:ea typeface="PingFang TC"/>
+              </a:rPr>
+              <a:t>主設計選擇不快取 redirect（回源保即時改/刪 + 分析）。302 與 CDN 無因果——302 仍可設短 TTL 讓 CDN 快取；</a:t>
+            </a:r>
+          </a:p>
+          <a:p>
+            <a:pPr algn="l">
+              <a:spcAft>
+                <a:spcPts val="400"/>
+              </a:spcAft>
+            </a:pPr>
+            <a:r>
+              <a:rPr sz="1200" b="0">
+                <a:solidFill>
+                  <a:srgbClr val="64748B"/>
+                </a:solidFill>
+                <a:latin typeface="PingFang TC"/>
+                <a:ea typeface="PingFang TC"/>
+              </a:rPr>
+              <a:t>真正取捨是「快取 redirect vs 即時性/分析」。本變體：熱門 token 的 302 設短 TTL、邊緣直接跳，換更低延遲。</a:t>
+            </a:r>
+          </a:p>
+        </p:txBody>
+      </p:sp>
+      <p:sp>
+        <p:nvSpPr>
+          <p:cNvPr id="5" name="Rounded Rectangle 4"/>
+          <p:cNvSpPr/>
+          <p:nvPr/>
+        </p:nvSpPr>
+        <p:spPr>
+          <a:xfrm>
+            <a:off x="548640" y="2011680"/>
+            <a:ext cx="2011680" cy="868680"/>
+          </a:xfrm>
+          <a:prstGeom prst="roundRect">
+            <a:avLst/>
+          </a:prstGeom>
+          <a:solidFill>
+            <a:srgbClr val="64748B"/>
+          </a:solidFill>
+          <a:ln>
+            <a:solidFill>
+              <a:srgbClr val="64748B"/>
+            </a:solidFill>
+          </a:ln>
+          <a:effectLst/>
+        </p:spPr>
+        <p:style>
+          <a:lnRef idx="1">
+            <a:schemeClr val="accent1"/>
+          </a:lnRef>
+          <a:fillRef idx="3">
+            <a:schemeClr val="accent1"/>
+          </a:fillRef>
+          <a:effectRef idx="2">
+            <a:schemeClr val="accent1"/>
+          </a:effectRef>
+          <a:fontRef idx="minor">
+            <a:schemeClr val="lt1"/>
+          </a:fontRef>
+        </p:style>
+        <p:txBody>
+          <a:bodyPr rtlCol="0" anchor="ctr" wrap="square" tIns="25400" bIns="25400"/>
+          <a:lstStyle/>
+          <a:p>
+            <a:pPr algn="ctr"/>
+            <a:r>
+              <a:rPr sz="1200" b="1">
+                <a:solidFill>
+                  <a:srgbClr val="FFFFFF"/>
+                </a:solidFill>
+                <a:latin typeface="PingFang TC"/>
+                <a:ea typeface="PingFang TC"/>
+              </a:rPr>
+              <a:t>掃描者</a:t>
+            </a:r>
+          </a:p>
+          <a:p>
+            <a:pPr algn="ctr"/>
+            <a:r>
+              <a:rPr sz="1200" b="0">
+                <a:solidFill>
+                  <a:srgbClr val="FFFFFF"/>
+                </a:solidFill>
+                <a:latin typeface="PingFang TC"/>
+                <a:ea typeface="PingFang TC"/>
+              </a:rPr>
+              <a:t>GET /r/{token}</a:t>
+            </a:r>
+          </a:p>
+        </p:txBody>
+      </p:sp>
+      <p:sp>
+        <p:nvSpPr>
+          <p:cNvPr id="6" name="Rounded Rectangle 5"/>
+          <p:cNvSpPr/>
+          <p:nvPr/>
+        </p:nvSpPr>
+        <p:spPr>
+          <a:xfrm>
+            <a:off x="3017520" y="1920240"/>
+            <a:ext cx="3291840" cy="1051560"/>
+          </a:xfrm>
+          <a:prstGeom prst="roundRect">
+            <a:avLst/>
+          </a:prstGeom>
+          <a:solidFill>
+            <a:srgbClr val="7C3AED"/>
+          </a:solidFill>
+          <a:ln>
+            <a:solidFill>
+              <a:srgbClr val="7C3AED"/>
+            </a:solidFill>
+          </a:ln>
+          <a:effectLst/>
+        </p:spPr>
+        <p:style>
+          <a:lnRef idx="1">
+            <a:schemeClr val="accent1"/>
+          </a:lnRef>
+          <a:fillRef idx="3">
+            <a:schemeClr val="accent1"/>
+          </a:fillRef>
+          <a:effectRef idx="2">
+            <a:schemeClr val="accent1"/>
+          </a:effectRef>
+          <a:fontRef idx="minor">
+            <a:schemeClr val="lt1"/>
+          </a:fontRef>
+        </p:style>
+        <p:txBody>
+          <a:bodyPr rtlCol="0" anchor="ctr" wrap="square" tIns="25400" bIns="25400"/>
+          <a:lstStyle/>
+          <a:p>
+            <a:pPr algn="ctr"/>
+            <a:r>
+              <a:rPr sz="1200" b="1">
+                <a:solidFill>
+                  <a:srgbClr val="FFFFFF"/>
+                </a:solidFill>
+                <a:latin typeface="PingFang TC"/>
+                <a:ea typeface="PingFang TC"/>
+              </a:rPr>
+              <a:t>CDN Edge（近使用者）</a:t>
+            </a:r>
+          </a:p>
+          <a:p>
+            <a:pPr algn="ctr"/>
+            <a:r>
+              <a:rPr sz="1200" b="0">
+                <a:solidFill>
+                  <a:srgbClr val="FFFFFF"/>
+                </a:solidFill>
+                <a:latin typeface="PingFang TC"/>
+                <a:ea typeface="PingFang TC"/>
+              </a:rPr>
+              <a:t>edge cache: token→URL</a:t>
+            </a:r>
+          </a:p>
+          <a:p>
+            <a:pPr algn="ctr"/>
+            <a:r>
+              <a:rPr sz="1200" b="0">
+                <a:solidFill>
+                  <a:srgbClr val="FFFFFF"/>
+                </a:solidFill>
+                <a:latin typeface="PingFang TC"/>
+                <a:ea typeface="PingFang TC"/>
+              </a:rPr>
+              <a:t>短 TTL（例 60s）</a:t>
+            </a:r>
+          </a:p>
+        </p:txBody>
+      </p:sp>
+      <p:cxnSp>
+        <p:nvCxnSpPr>
+          <p:cNvPr id="7" name="Connector 6"/>
+          <p:cNvCxnSpPr/>
+          <p:nvPr/>
+        </p:nvCxnSpPr>
+        <p:spPr>
+          <a:xfrm>
+            <a:off x="2560320" y="2423160"/>
+            <a:ext cx="457200" cy="0"/>
+          </a:xfrm>
+          <a:prstGeom prst="line">
+            <a:avLst/>
+          </a:prstGeom>
+          <a:ln w="22225">
+            <a:solidFill>
+              <a:srgbClr val="64748B"/>
+            </a:solidFill>
+            <a:tailEnd type="triangle" w="med" len="med"/>
+          </a:ln>
+        </p:spPr>
+        <p:style>
+          <a:lnRef idx="2">
+            <a:schemeClr val="accent1"/>
+          </a:lnRef>
+          <a:fillRef idx="0">
+            <a:schemeClr val="accent1"/>
+          </a:fillRef>
+          <a:effectRef idx="1">
+            <a:schemeClr val="accent1"/>
+          </a:effectRef>
+          <a:fontRef idx="minor">
+            <a:schemeClr val="tx1"/>
+          </a:fontRef>
+        </p:style>
+      </p:cxnSp>
+      <p:sp>
+        <p:nvSpPr>
+          <p:cNvPr id="8" name="Rounded Rectangle 7"/>
+          <p:cNvSpPr/>
+          <p:nvPr/>
+        </p:nvSpPr>
+        <p:spPr>
+          <a:xfrm>
+            <a:off x="3017520" y="3337560"/>
+            <a:ext cx="3291840" cy="777240"/>
+          </a:xfrm>
+          <a:prstGeom prst="roundRect">
+            <a:avLst/>
+          </a:prstGeom>
+          <a:solidFill>
+            <a:srgbClr val="059669"/>
+          </a:solidFill>
+          <a:ln>
+            <a:solidFill>
+              <a:srgbClr val="059669"/>
+            </a:solidFill>
+          </a:ln>
+          <a:effectLst/>
+        </p:spPr>
+        <p:style>
+          <a:lnRef idx="1">
+            <a:schemeClr val="accent1"/>
+          </a:lnRef>
+          <a:fillRef idx="3">
+            <a:schemeClr val="accent1"/>
+          </a:fillRef>
+          <a:effectRef idx="2">
+            <a:schemeClr val="accent1"/>
+          </a:effectRef>
+          <a:fontRef idx="minor">
+            <a:schemeClr val="lt1"/>
+          </a:fontRef>
+        </p:style>
+        <p:txBody>
+          <a:bodyPr rtlCol="0" anchor="ctr" wrap="square" tIns="25400" bIns="25400"/>
+          <a:lstStyle/>
+          <a:p>
+            <a:pPr algn="ctr"/>
+            <a:r>
+              <a:rPr sz="1200" b="1">
+                <a:solidFill>
+                  <a:srgbClr val="FFFFFF"/>
+                </a:solidFill>
+                <a:latin typeface="PingFang TC"/>
+                <a:ea typeface="PingFang TC"/>
+              </a:rPr>
+              <a:t>命中 → CDN 直接回 302</a:t>
+            </a:r>
+          </a:p>
+          <a:p>
+            <a:pPr algn="ctr"/>
+            <a:r>
+              <a:rPr sz="1200" b="0">
+                <a:solidFill>
+                  <a:srgbClr val="FFFFFF"/>
+                </a:solidFill>
+                <a:latin typeface="PingFang TC"/>
+                <a:ea typeface="PingFang TC"/>
+              </a:rPr>
+              <a:t>不回源 · 最低延遲</a:t>
+            </a:r>
+          </a:p>
+        </p:txBody>
+      </p:sp>
+      <p:cxnSp>
+        <p:nvCxnSpPr>
+          <p:cNvPr id="9" name="Connector 8"/>
+          <p:cNvCxnSpPr/>
+          <p:nvPr/>
+        </p:nvCxnSpPr>
+        <p:spPr>
+          <a:xfrm>
+            <a:off x="4663440" y="2971800"/>
+            <a:ext cx="0" cy="365760"/>
+          </a:xfrm>
+          <a:prstGeom prst="line">
+            <a:avLst/>
+          </a:prstGeom>
+          <a:ln w="16510">
+            <a:solidFill>
+              <a:srgbClr val="059669"/>
+            </a:solidFill>
+            <a:tailEnd type="triangle" w="med" len="med"/>
+          </a:ln>
+        </p:spPr>
+        <p:style>
+          <a:lnRef idx="2">
+            <a:schemeClr val="accent1"/>
+          </a:lnRef>
+          <a:fillRef idx="0">
+            <a:schemeClr val="accent1"/>
+          </a:fillRef>
+          <a:effectRef idx="1">
+            <a:schemeClr val="accent1"/>
+          </a:effectRef>
+          <a:fontRef idx="minor">
+            <a:schemeClr val="tx1"/>
+          </a:fontRef>
+        </p:style>
+      </p:cxnSp>
+      <p:sp>
+        <p:nvSpPr>
+          <p:cNvPr id="10" name="Rounded Rectangle 9"/>
+          <p:cNvSpPr/>
+          <p:nvPr/>
+        </p:nvSpPr>
+        <p:spPr>
+          <a:xfrm>
+            <a:off x="6675120" y="2057400"/>
+            <a:ext cx="4937760" cy="868680"/>
+          </a:xfrm>
+          <a:prstGeom prst="roundRect">
+            <a:avLst/>
+          </a:prstGeom>
+          <a:solidFill>
+            <a:srgbClr val="059669"/>
+          </a:solidFill>
+          <a:ln>
+            <a:solidFill>
+              <a:srgbClr val="059669"/>
+            </a:solidFill>
+          </a:ln>
+          <a:effectLst/>
+        </p:spPr>
+        <p:style>
+          <a:lnRef idx="1">
+            <a:schemeClr val="accent1"/>
+          </a:lnRef>
+          <a:fillRef idx="3">
+            <a:schemeClr val="accent1"/>
+          </a:fillRef>
+          <a:effectRef idx="2">
+            <a:schemeClr val="accent1"/>
+          </a:effectRef>
+          <a:fontRef idx="minor">
+            <a:schemeClr val="lt1"/>
+          </a:fontRef>
+        </p:style>
+        <p:txBody>
+          <a:bodyPr rtlCol="0" anchor="ctr" wrap="square" tIns="25400" bIns="25400"/>
+          <a:lstStyle/>
+          <a:p>
+            <a:pPr algn="ctr"/>
+            <a:r>
+              <a:rPr sz="1200" b="1">
+                <a:solidFill>
+                  <a:srgbClr val="FFFFFF"/>
+                </a:solidFill>
+                <a:latin typeface="PingFang TC"/>
+                <a:ea typeface="PingFang TC"/>
+              </a:rPr>
+              <a:t>miss → 回源 Service</a:t>
+            </a:r>
+          </a:p>
+          <a:p>
+            <a:pPr algn="ctr"/>
+            <a:r>
+              <a:rPr sz="1200" b="0">
+                <a:solidFill>
+                  <a:srgbClr val="FFFFFF"/>
+                </a:solidFill>
+                <a:latin typeface="PingFang TC"/>
+                <a:ea typeface="PingFang TC"/>
+              </a:rPr>
+              <a:t>→ Cache/DB → 回 302（CDN 記短 TTL）</a:t>
+            </a:r>
+          </a:p>
+        </p:txBody>
+      </p:sp>
+      <p:cxnSp>
+        <p:nvCxnSpPr>
+          <p:cNvPr id="11" name="Connector 10"/>
+          <p:cNvCxnSpPr/>
+          <p:nvPr/>
+        </p:nvCxnSpPr>
+        <p:spPr>
+          <a:xfrm>
+            <a:off x="6309360" y="2423160"/>
+            <a:ext cx="365760" cy="0"/>
+          </a:xfrm>
+          <a:prstGeom prst="line">
+            <a:avLst/>
+          </a:prstGeom>
+          <a:ln w="22225">
+            <a:solidFill>
+              <a:srgbClr val="64748B"/>
+            </a:solidFill>
+            <a:tailEnd type="triangle" w="med" len="med"/>
+          </a:ln>
+        </p:spPr>
+        <p:style>
+          <a:lnRef idx="2">
+            <a:schemeClr val="accent1"/>
+          </a:lnRef>
+          <a:fillRef idx="0">
+            <a:schemeClr val="accent1"/>
+          </a:fillRef>
+          <a:effectRef idx="1">
+            <a:schemeClr val="accent1"/>
+          </a:effectRef>
+          <a:fontRef idx="minor">
+            <a:schemeClr val="tx1"/>
+          </a:fontRef>
+        </p:style>
+      </p:cxnSp>
+      <p:graphicFrame>
+        <p:nvGraphicFramePr>
+          <p:cNvPr id="12" name="Table 11"/>
+          <p:cNvGraphicFramePr>
+            <a:graphicFrameLocks noGrp="1"/>
+          </p:cNvGraphicFramePr>
+          <p:nvPr/>
+        </p:nvGraphicFramePr>
+        <p:xfrm>
+          <a:off x="548640" y="4343400"/>
+          <a:ext cx="11109960" cy="1828800"/>
+        </p:xfrm>
+        <a:graphic>
+          <a:graphicData uri="http://schemas.openxmlformats.org/drawingml/2006/table">
+            <a:tbl>
+              <a:tblPr firstRow="1" bandRow="1">
+                <a:tableStyleId>{5C22544A-7EE6-4342-B048-85BDC9FD1C3A}</a:tableStyleId>
+              </a:tblPr>
+              <a:tblGrid>
+                <a:gridCol w="2743200"/>
+                <a:gridCol w="4160520"/>
+                <a:gridCol w="4206240"/>
+              </a:tblGrid>
+              <a:tr h="457200">
+                <a:tc>
+                  <a:txBody>
+                    <a:bodyPr/>
+                    <a:lstStyle/>
+                    <a:p>
+                      <a:r>
+                        <a:rPr sz="1200" b="1">
+                          <a:solidFill>
+                            <a:srgbClr val="FFFFFF"/>
+                          </a:solidFill>
+                          <a:latin typeface="PingFang TC"/>
+                          <a:ea typeface="PingFang TC"/>
+                        </a:rPr>
+                        <a:t>面向</a:t>
+                      </a:r>
+                    </a:p>
+                  </a:txBody>
+                  <a:tcPr marT="25400" marB="25400" marL="101600" anchor="ctr">
+                    <a:solidFill>
+                      <a:srgbClr val="2563EB"/>
+                    </a:solidFill>
+                  </a:tcPr>
+                </a:tc>
+                <a:tc>
+                  <a:txBody>
+                    <a:bodyPr/>
+                    <a:lstStyle/>
+                    <a:p>
+                      <a:r>
+                        <a:rPr sz="1200" b="1">
+                          <a:solidFill>
+                            <a:srgbClr val="FFFFFF"/>
+                          </a:solidFill>
+                          <a:latin typeface="PingFang TC"/>
+                          <a:ea typeface="PingFang TC"/>
+                        </a:rPr>
+                        <a:t>主設計（回源 + Redis）</a:t>
+                      </a:r>
+                    </a:p>
+                  </a:txBody>
+                  <a:tcPr marT="25400" marB="25400" marL="101600" anchor="ctr">
+                    <a:solidFill>
+                      <a:srgbClr val="2563EB"/>
+                    </a:solidFill>
+                  </a:tcPr>
+                </a:tc>
+                <a:tc>
+                  <a:txBody>
+                    <a:bodyPr/>
+                    <a:lstStyle/>
+                    <a:p>
+                      <a:r>
+                        <a:rPr sz="1200" b="1">
+                          <a:solidFill>
+                            <a:srgbClr val="FFFFFF"/>
+                          </a:solidFill>
+                          <a:latin typeface="PingFang TC"/>
+                          <a:ea typeface="PingFang TC"/>
+                        </a:rPr>
+                        <a:t>CDN 邊緣變體</a:t>
+                      </a:r>
+                    </a:p>
+                  </a:txBody>
+                  <a:tcPr marT="25400" marB="25400" marL="101600" anchor="ctr">
+                    <a:solidFill>
+                      <a:srgbClr val="2563EB"/>
+                    </a:solidFill>
+                  </a:tcPr>
+                </a:tc>
+              </a:tr>
+              <a:tr h="457200">
+                <a:tc>
+                  <a:txBody>
+                    <a:bodyPr/>
+                    <a:lstStyle/>
+                    <a:p>
+                      <a:r>
+                        <a:rPr sz="1200" b="1">
+                          <a:solidFill>
+                            <a:srgbClr val="0F172A"/>
+                          </a:solidFill>
+                          <a:latin typeface="PingFang TC"/>
+                          <a:ea typeface="PingFang TC"/>
+                        </a:rPr>
+                        <a:t>延遲</a:t>
+                      </a:r>
+                    </a:p>
+                  </a:txBody>
+                  <a:tcPr marT="25400" marB="25400" marL="101600" anchor="ctr">
+                    <a:solidFill>
+                      <a:srgbClr val="FFFFFF"/>
+                    </a:solidFill>
+                  </a:tcPr>
+                </a:tc>
+                <a:tc>
+                  <a:txBody>
+                    <a:bodyPr/>
+                    <a:lstStyle/>
+                    <a:p>
+                      <a:r>
+                        <a:rPr sz="1200" b="0">
+                          <a:solidFill>
+                            <a:srgbClr val="64748B"/>
+                          </a:solidFill>
+                          <a:latin typeface="PingFang TC"/>
+                          <a:ea typeface="PingFang TC"/>
+                        </a:rPr>
+                        <a:t>低（回源 + Redis）</a:t>
+                      </a:r>
+                    </a:p>
+                  </a:txBody>
+                  <a:tcPr marT="25400" marB="25400" marL="101600" anchor="ctr">
+                    <a:solidFill>
+                      <a:srgbClr val="FFFFFF"/>
+                    </a:solidFill>
+                  </a:tcPr>
+                </a:tc>
+                <a:tc>
+                  <a:txBody>
+                    <a:bodyPr/>
+                    <a:lstStyle/>
+                    <a:p>
+                      <a:r>
+                        <a:rPr sz="1200" b="0">
+                          <a:solidFill>
+                            <a:srgbClr val="64748B"/>
+                          </a:solidFill>
+                          <a:latin typeface="PingFang TC"/>
+                          <a:ea typeface="PingFang TC"/>
+                        </a:rPr>
+                        <a:t>最低（邊緣直接跳）</a:t>
+                      </a:r>
+                    </a:p>
+                  </a:txBody>
+                  <a:tcPr marT="25400" marB="25400" marL="101600" anchor="ctr">
+                    <a:solidFill>
+                      <a:srgbClr val="FFFFFF"/>
+                    </a:solidFill>
+                  </a:tcPr>
+                </a:tc>
+              </a:tr>
+              <a:tr h="457200">
+                <a:tc>
+                  <a:txBody>
+                    <a:bodyPr/>
+                    <a:lstStyle/>
+                    <a:p>
+                      <a:r>
+                        <a:rPr sz="1200" b="1">
+                          <a:solidFill>
+                            <a:srgbClr val="0F172A"/>
+                          </a:solidFill>
+                          <a:latin typeface="PingFang TC"/>
+                          <a:ea typeface="PingFang TC"/>
+                        </a:rPr>
+                        <a:t>改 / 刪即時性</a:t>
+                      </a:r>
+                    </a:p>
+                  </a:txBody>
+                  <a:tcPr marT="25400" marB="25400" marL="101600" anchor="ctr">
+                    <a:solidFill>
+                      <a:srgbClr val="F1F5F9"/>
+                    </a:solidFill>
+                  </a:tcPr>
+                </a:tc>
+                <a:tc>
+                  <a:txBody>
+                    <a:bodyPr/>
+                    <a:lstStyle/>
+                    <a:p>
+                      <a:r>
+                        <a:rPr sz="1200" b="0">
+                          <a:solidFill>
+                            <a:srgbClr val="64748B"/>
+                          </a:solidFill>
+                          <a:latin typeface="PingFang TC"/>
+                          <a:ea typeface="PingFang TC"/>
+                        </a:rPr>
+                        <a:t>立即生效</a:t>
+                      </a:r>
+                    </a:p>
+                  </a:txBody>
+                  <a:tcPr marT="25400" marB="25400" marL="101600" anchor="ctr">
+                    <a:solidFill>
+                      <a:srgbClr val="F1F5F9"/>
+                    </a:solidFill>
+                  </a:tcPr>
+                </a:tc>
+                <a:tc>
+                  <a:txBody>
+                    <a:bodyPr/>
+                    <a:lstStyle/>
+                    <a:p>
+                      <a:r>
+                        <a:rPr sz="1200" b="0">
+                          <a:solidFill>
+                            <a:srgbClr val="64748B"/>
+                          </a:solidFill>
+                          <a:latin typeface="PingFang TC"/>
+                          <a:ea typeface="PingFang TC"/>
+                        </a:rPr>
+                        <a:t>TTL 內延遲</a:t>
+                      </a:r>
+                    </a:p>
+                  </a:txBody>
+                  <a:tcPr marT="25400" marB="25400" marL="101600" anchor="ctr">
+                    <a:solidFill>
+                      <a:srgbClr val="F1F5F9"/>
+                    </a:solidFill>
+                  </a:tcPr>
+                </a:tc>
+              </a:tr>
+              <a:tr h="457200">
+                <a:tc>
+                  <a:txBody>
+                    <a:bodyPr/>
+                    <a:lstStyle/>
+                    <a:p>
+                      <a:r>
+                        <a:rPr sz="1200" b="1">
+                          <a:solidFill>
+                            <a:srgbClr val="0F172A"/>
+                          </a:solidFill>
+                          <a:latin typeface="PingFang TC"/>
+                          <a:ea typeface="PingFang TC"/>
+                        </a:rPr>
+                        <a:t>掃描分析</a:t>
+                      </a:r>
+                    </a:p>
+                  </a:txBody>
+                  <a:tcPr marT="25400" marB="25400" marL="101600" anchor="ctr">
+                    <a:solidFill>
+                      <a:srgbClr val="FFFFFF"/>
+                    </a:solidFill>
+                  </a:tcPr>
+                </a:tc>
+                <a:tc>
+                  <a:txBody>
+                    <a:bodyPr/>
+                    <a:lstStyle/>
+                    <a:p>
+                      <a:r>
+                        <a:rPr sz="1200" b="0">
+                          <a:solidFill>
+                            <a:srgbClr val="64748B"/>
+                          </a:solidFill>
+                          <a:latin typeface="PingFang TC"/>
+                          <a:ea typeface="PingFang TC"/>
+                        </a:rPr>
+                        <a:t>每次都記</a:t>
+                      </a:r>
+                    </a:p>
+                  </a:txBody>
+                  <a:tcPr marT="25400" marB="25400" marL="101600" anchor="ctr">
+                    <a:solidFill>
+                      <a:srgbClr val="FFFFFF"/>
+                    </a:solidFill>
+                  </a:tcPr>
+                </a:tc>
+                <a:tc>
+                  <a:txBody>
+                    <a:bodyPr/>
+                    <a:lstStyle/>
+                    <a:p>
+                      <a:r>
+                        <a:rPr sz="1200" b="0">
+                          <a:solidFill>
+                            <a:srgbClr val="64748B"/>
+                          </a:solidFill>
+                          <a:latin typeface="PingFang TC"/>
+                          <a:ea typeface="PingFang TC"/>
+                        </a:rPr>
+                        <a:t>TTL 內漏記</a:t>
+                      </a:r>
+                    </a:p>
+                  </a:txBody>
+                  <a:tcPr marT="25400" marB="25400" marL="101600" anchor="ctr">
+                    <a:solidFill>
+                      <a:srgbClr val="FFFFFF"/>
+                    </a:solidFill>
+                  </a:tcPr>
+                </a:tc>
+              </a:tr>
+            </a:tbl>
+          </a:graphicData>
+        </a:graphic>
+      </p:graphicFrame>
+      <p:sp>
+        <p:nvSpPr>
+          <p:cNvPr id="13" name="TextBox 12"/>
+          <p:cNvSpPr txBox="1"/>
+          <p:nvPr/>
+        </p:nvSpPr>
+        <p:spPr>
+          <a:xfrm>
+            <a:off x="548640" y="6263640"/>
+            <a:ext cx="11155680" cy="457200"/>
+          </a:xfrm>
+          <a:prstGeom prst="rect">
+            <a:avLst/>
+          </a:prstGeom>
+          <a:noFill/>
+        </p:spPr>
+        <p:txBody>
+          <a:bodyPr wrap="square" anchor="t">
+            <a:spAutoFit/>
+          </a:bodyPr>
+          <a:lstStyle/>
+          <a:p>
+            <a:pPr algn="l">
+              <a:spcAft>
+                <a:spcPts val="400"/>
+              </a:spcAft>
+            </a:pPr>
+            <a:r>
+              <a:rPr sz="1200" b="0">
+                <a:solidFill>
+                  <a:srgbClr val="64748B"/>
+                </a:solidFill>
+                <a:latin typeface="PingFang TC"/>
+                <a:ea typeface="PingFang TC"/>
+              </a:rPr>
+              <a:t>預設不採用；列為超高流量、目標穩定的熱門 QR 之可選最佳化（短 TTL 控制誤差）。</a:t>
             </a:r>
           </a:p>
         </p:txBody>
@@ -8969,6 +10596,216 @@
                 <a:ea typeface="PingFang TC"/>
               </a:rPr>
               <a:t>•  圖片 + redirect 為主流量</a:t>
+            </a:r>
+          </a:p>
+        </p:txBody>
+      </p:sp>
+    </p:spTree>
+  </p:cSld>
+  <p:clrMapOvr>
+    <a:masterClrMapping/>
+  </p:clrMapOvr>
+</p:sld>
+</file>
+
+<file path=ppt/slides/slide20.xml><?xml version="1.0" encoding="utf-8"?>
+<p:sld xmlns:a="http://schemas.openxmlformats.org/drawingml/2006/main" xmlns:p="http://schemas.openxmlformats.org/presentationml/2006/main" xmlns:r="http://schemas.openxmlformats.org/officeDocument/2006/relationships">
+  <p:cSld>
+    <p:spTree>
+      <p:nvGrpSpPr>
+        <p:cNvPr id="1" name=""/>
+        <p:cNvGrpSpPr/>
+        <p:nvPr/>
+      </p:nvGrpSpPr>
+      <p:grpSpPr/>
+      <p:sp>
+        <p:nvSpPr>
+          <p:cNvPr id="2" name="Rectangle 1"/>
+          <p:cNvSpPr/>
+          <p:nvPr/>
+        </p:nvSpPr>
+        <p:spPr>
+          <a:xfrm>
+            <a:off x="0" y="0"/>
+            <a:ext cx="12191695" cy="6858000"/>
+          </a:xfrm>
+          <a:prstGeom prst="rect">
+            <a:avLst/>
+          </a:prstGeom>
+          <a:solidFill>
+            <a:srgbClr val="0F172A"/>
+          </a:solidFill>
+          <a:ln>
+            <a:noFill/>
+          </a:ln>
+          <a:effectLst/>
+        </p:spPr>
+        <p:style>
+          <a:lnRef idx="1">
+            <a:schemeClr val="accent1"/>
+          </a:lnRef>
+          <a:fillRef idx="3">
+            <a:schemeClr val="accent1"/>
+          </a:fillRef>
+          <a:effectRef idx="2">
+            <a:schemeClr val="accent1"/>
+          </a:effectRef>
+          <a:fontRef idx="minor">
+            <a:schemeClr val="lt1"/>
+          </a:fontRef>
+        </p:style>
+        <p:txBody>
+          <a:bodyPr rtlCol="0" anchor="ctr"/>
+          <a:lstStyle/>
+          <a:p>
+            <a:pPr algn="ctr"/>
+          </a:p>
+        </p:txBody>
+      </p:sp>
+      <p:sp>
+        <p:nvSpPr>
+          <p:cNvPr id="3" name="TextBox 2"/>
+          <p:cNvSpPr txBox="1"/>
+          <p:nvPr/>
+        </p:nvSpPr>
+        <p:spPr>
+          <a:xfrm>
+            <a:off x="822960" y="1097280"/>
+            <a:ext cx="10515600" cy="1097280"/>
+          </a:xfrm>
+          <a:prstGeom prst="rect">
+            <a:avLst/>
+          </a:prstGeom>
+          <a:noFill/>
+        </p:spPr>
+        <p:txBody>
+          <a:bodyPr wrap="square" anchor="t">
+            <a:spAutoFit/>
+          </a:bodyPr>
+          <a:lstStyle/>
+          <a:p>
+            <a:pPr algn="l">
+              <a:spcAft>
+                <a:spcPts val="400"/>
+              </a:spcAft>
+            </a:pPr>
+            <a:r>
+              <a:rPr sz="1600" b="1">
+                <a:solidFill>
+                  <a:srgbClr val="2563EB"/>
+                </a:solidFill>
+                <a:latin typeface="PingFang TC"/>
+                <a:ea typeface="PingFang TC"/>
+              </a:rPr>
+              <a:t>原型狀態</a:t>
+            </a:r>
+          </a:p>
+          <a:p>
+            <a:pPr algn="l">
+              <a:spcAft>
+                <a:spcPts val="400"/>
+              </a:spcAft>
+            </a:pPr>
+            <a:r>
+              <a:rPr sz="3000" b="1">
+                <a:solidFill>
+                  <a:srgbClr val="FFFFFF"/>
+                </a:solidFill>
+                <a:latin typeface="PingFang TC"/>
+                <a:ea typeface="PingFang TC"/>
+              </a:rPr>
+              <a:t>可跑的 FastAPI 實作 + 管理頁前端</a:t>
+            </a:r>
+          </a:p>
+        </p:txBody>
+      </p:sp>
+      <p:sp>
+        <p:nvSpPr>
+          <p:cNvPr id="4" name="TextBox 3"/>
+          <p:cNvSpPr txBox="1"/>
+          <p:nvPr/>
+        </p:nvSpPr>
+        <p:spPr>
+          <a:xfrm>
+            <a:off x="822960" y="2743200"/>
+            <a:ext cx="10515600" cy="2743200"/>
+          </a:xfrm>
+          <a:prstGeom prst="rect">
+            <a:avLst/>
+          </a:prstGeom>
+          <a:noFill/>
+        </p:spPr>
+        <p:txBody>
+          <a:bodyPr wrap="square">
+            <a:spAutoFit/>
+          </a:bodyPr>
+          <a:lstStyle/>
+          <a:p>
+            <a:pPr>
+              <a:spcAft>
+                <a:spcPts val="1200"/>
+              </a:spcAft>
+            </a:pPr>
+            <a:r>
+              <a:rPr sz="1600" b="0">
+                <a:solidFill>
+                  <a:srgbClr val="E2E8F0"/>
+                </a:solidFill>
+                <a:latin typeface="PingFang TC"/>
+                <a:ea typeface="PingFang TC"/>
+              </a:rPr>
+              <a:t>✓  7 個 API 端點 + 管理頁前端（建立/清單/編輯/刪除/分析）</a:t>
+            </a:r>
+          </a:p>
+          <a:p>
+            <a:pPr>
+              <a:spcAft>
+                <a:spcPts val="1200"/>
+              </a:spcAft>
+            </a:pPr>
+            <a:r>
+              <a:rPr sz="1600" b="0">
+                <a:solidFill>
+                  <a:srgbClr val="E2E8F0"/>
+                </a:solidFill>
+                <a:latin typeface="PingFang TC"/>
+                <a:ea typeface="PingFang TC"/>
+              </a:rPr>
+              <a:t>✓  全部 curl 驗證通過：302 / 404 / 410 / 8 碼 token / 正規化 / SSRF / 過期</a:t>
+            </a:r>
+          </a:p>
+          <a:p>
+            <a:pPr>
+              <a:spcAft>
+                <a:spcPts val="1200"/>
+              </a:spcAft>
+            </a:pPr>
+            <a:r>
+              <a:rPr sz="1600" b="0">
+                <a:solidFill>
+                  <a:srgbClr val="E2E8F0"/>
+                </a:solidFill>
+                <a:latin typeface="PingFang TC"/>
+                <a:ea typeface="PingFang TC"/>
+              </a:rPr>
+              <a:t>✓  production 替換點已在程式註解標明（Redis / 佇列 / CDN / 預聚合 / PostgreSQL）</a:t>
+            </a:r>
+          </a:p>
+          <a:p>
+            <a:pPr>
+              <a:spcAft>
+                <a:spcPts val="1200"/>
+              </a:spcAft>
+            </a:pPr>
+            <a:r>
+              <a:rPr sz="1600" b="0">
+                <a:solidFill>
+                  <a:srgbClr val="E2E8F0"/>
+                </a:solidFill>
+                <a:latin typeface="PingFang TC"/>
+                <a:ea typeface="PingFang TC"/>
+              </a:rPr>
+              <a:t>✓  設計依據：DESIGN.md（16 題決策 + 優劣分析）</a:t>
             </a:r>
           </a:p>
         </p:txBody>

</xml_diff>

<commit_message>
Add rate limiting (WAF per-IP + API GW throttle) + sync DESIGN/slides/README
- infra/edge: WAF web ACL (CLOUDFRONT/us-east-1) with per-IP rate-based rules
  (/api/* 300/5min, global 2000/5min) + API Gateway stage throttling
- DESIGN appendix C/D updated + new appendix E (Rate Limiting)
- PPT: AWS arch +WAF, PROD GAP row, new Rate Limiting slide (28 pages)
- README: rate limiting note
- not applied (infra currently destroyed); takes effect on next terraform apply

Co-Authored-By: Claude Opus 4.8 <noreply@anthropic.com>
</commit_message>
<xml_diff>
--- a/QR Code Generator/QR_Code_Generator.pptx
+++ b/QR Code Generator/QR_Code_Generator.pptx
@@ -30,6 +30,9 @@
     <p:sldId id="278" r:id="rId29"/>
     <p:sldId id="279" r:id="rId30"/>
     <p:sldId id="280" r:id="rId31"/>
+    <p:sldId id="281" r:id="rId32"/>
+    <p:sldId id="282" r:id="rId33"/>
+    <p:sldId id="283" r:id="rId34"/>
   </p:sldIdLst>
   <p:sldSz cx="12191695" cy="6858000" type="screen4x3"/>
   <p:notesSz cx="6858000" cy="9144000"/>
@@ -12680,13 +12683,13 @@
                           <a:latin typeface="PingFang TC"/>
                           <a:ea typeface="PingFang TC"/>
                         </a:rPr>
-                        <a:t>無</a:t>
+                        <a:t>✅ 已實作</a:t>
                       </a:r>
                     </a:p>
                   </a:txBody>
                   <a:tcPr marT="25400" marB="25400" marL="101600" anchor="ctr">
                     <a:solidFill>
-                      <a:srgbClr val="FEE2E2"/>
+                      <a:srgbClr val="F1F5F9"/>
                     </a:solidFill>
                   </a:tcPr>
                 </a:tc>
@@ -12703,7 +12706,7 @@
                           <a:latin typeface="PingFang TC"/>
                           <a:ea typeface="PingFang TC"/>
                         </a:rPr>
-                        <a:t>端點限流，防 script 灌爆</a:t>
+                        <a:t>WAF per-IP + API GW 節流</a:t>
                       </a:r>
                     </a:p>
                   </a:txBody>
@@ -13281,7 +13284,7 @@
                 <a:latin typeface="PingFang TC"/>
                 <a:ea typeface="PingFang TC"/>
               </a:rPr>
-              <a:t>(CDN)</a:t>
+              <a:t>(CDN + WAF)</a:t>
             </a:r>
           </a:p>
         </p:txBody>
@@ -13419,7 +13422,7 @@
                 <a:latin typeface="PingFang TC"/>
                 <a:ea typeface="PingFang TC"/>
               </a:rPr>
-              <a:t>(HTTP API)</a:t>
+              <a:t>(HTTP API · 節流)</a:t>
             </a:r>
           </a:p>
         </p:txBody>
@@ -14001,7 +14004,7 @@
                 <a:latin typeface="PingFang TC"/>
                 <a:ea typeface="PingFang TC"/>
               </a:rPr>
-              <a:t>/qr-img/* → S3 長快取;/, /r/*, /api/* → API Gateway,redirect 不快取(第 6 題每次回源)。</a:t>
+              <a:t>WAF(per-IP rate limit)掛在 CloudFront 邊緣;/qr-img/* → S3 長快取;/, /r/*, /api/* → API Gateway,redirect 不快取。</a:t>
             </a:r>
           </a:p>
           <a:p>
@@ -14120,7 +14123,7 @@
                 <a:latin typeface="PingFang TC"/>
                 <a:ea typeface="PingFang TC"/>
               </a:rPr>
-              <a:t>部署 · CI/CD</a:t>
+              <a:t>安全 · RATE LIMITING</a:t>
             </a:r>
           </a:p>
           <a:p>
@@ -14137,7 +14140,7 @@
                 <a:latin typeface="PingFang TC"/>
                 <a:ea typeface="PingFang TC"/>
               </a:rPr>
-              <a:t>CI/CD 流程（GitHub Actions + OIDC）</a:t>
+              <a:t>防灌爆：WAF per-IP + API Gateway 節流（縱深）</a:t>
             </a:r>
           </a:p>
         </p:txBody>
@@ -14150,8 +14153,8 @@
         </p:nvSpPr>
         <p:spPr>
           <a:xfrm>
-            <a:off x="457200" y="2286000"/>
-            <a:ext cx="1481328" cy="1280160"/>
+            <a:off x="457200" y="1828800"/>
+            <a:ext cx="1645920" cy="822960"/>
           </a:xfrm>
           <a:prstGeom prst="roundRect">
             <a:avLst/>
@@ -14186,67 +14189,87 @@
           <a:p>
             <a:pPr algn="ctr"/>
             <a:r>
-              <a:rPr sz="1100" b="1">
+              <a:rPr sz="1200" b="1">
                 <a:solidFill>
                   <a:srgbClr val="FFFFFF"/>
                 </a:solidFill>
                 <a:latin typeface="PingFang TC"/>
                 <a:ea typeface="PingFang TC"/>
               </a:rPr>
-              <a:t>git push</a:t>
-            </a:r>
-          </a:p>
-          <a:p>
-            <a:pPr algn="ctr"/>
-            <a:r>
-              <a:rPr sz="1100" b="0">
-                <a:solidFill>
-                  <a:srgbClr val="FFFFFF"/>
-                </a:solidFill>
-                <a:latin typeface="PingFang TC"/>
-                <a:ea typeface="PingFang TC"/>
-              </a:rPr>
-              <a:t>QR Code Generator/**</a:t>
-            </a:r>
-          </a:p>
-        </p:txBody>
-      </p:sp>
-      <p:cxnSp>
-        <p:nvCxnSpPr>
-          <p:cNvPr id="5" name="Connector 4"/>
-          <p:cNvCxnSpPr/>
-          <p:nvPr/>
-        </p:nvCxnSpPr>
-        <p:spPr>
-          <a:xfrm>
-            <a:off x="1938528" y="2926080"/>
-            <a:ext cx="118872" cy="0"/>
-          </a:xfrm>
-          <a:prstGeom prst="line">
-            <a:avLst/>
-          </a:prstGeom>
-          <a:ln w="22225">
+              <a:t>掃描者 / Script</a:t>
+            </a:r>
+          </a:p>
+        </p:txBody>
+      </p:sp>
+      <p:sp>
+        <p:nvSpPr>
+          <p:cNvPr id="5" name="Rounded Rectangle 4"/>
+          <p:cNvSpPr/>
+          <p:nvPr/>
+        </p:nvSpPr>
+        <p:spPr>
+          <a:xfrm>
+            <a:off x="2423160" y="1828800"/>
+            <a:ext cx="2286000" cy="822960"/>
+          </a:xfrm>
+          <a:prstGeom prst="roundRect">
+            <a:avLst/>
+          </a:prstGeom>
+          <a:solidFill>
+            <a:srgbClr val="DC2626"/>
+          </a:solidFill>
+          <a:ln>
             <a:solidFill>
-              <a:srgbClr val="64748B"/>
+              <a:srgbClr val="DC2626"/>
             </a:solidFill>
-            <a:tailEnd type="triangle" w="med" len="med"/>
           </a:ln>
+          <a:effectLst/>
         </p:spPr>
         <p:style>
-          <a:lnRef idx="2">
+          <a:lnRef idx="1">
             <a:schemeClr val="accent1"/>
           </a:lnRef>
-          <a:fillRef idx="0">
+          <a:fillRef idx="3">
             <a:schemeClr val="accent1"/>
           </a:fillRef>
-          <a:effectRef idx="1">
+          <a:effectRef idx="2">
             <a:schemeClr val="accent1"/>
           </a:effectRef>
           <a:fontRef idx="minor">
-            <a:schemeClr val="tx1"/>
+            <a:schemeClr val="lt1"/>
           </a:fontRef>
         </p:style>
-      </p:cxnSp>
+        <p:txBody>
+          <a:bodyPr rtlCol="0" anchor="ctr" wrap="square" tIns="25400" bIns="25400"/>
+          <a:lstStyle/>
+          <a:p>
+            <a:pPr algn="ctr"/>
+            <a:r>
+              <a:rPr sz="1200" b="1">
+                <a:solidFill>
+                  <a:srgbClr val="FFFFFF"/>
+                </a:solidFill>
+                <a:latin typeface="PingFang TC"/>
+                <a:ea typeface="PingFang TC"/>
+              </a:rPr>
+              <a:t>WAF (per-IP)</a:t>
+            </a:r>
+          </a:p>
+          <a:p>
+            <a:pPr algn="ctr"/>
+            <a:r>
+              <a:rPr sz="1200" b="0">
+                <a:solidFill>
+                  <a:srgbClr val="FFFFFF"/>
+                </a:solidFill>
+                <a:latin typeface="PingFang TC"/>
+                <a:ea typeface="PingFang TC"/>
+              </a:rPr>
+              <a:t>超量 → 403</a:t>
+            </a:r>
+          </a:p>
+        </p:txBody>
+      </p:sp>
       <p:sp>
         <p:nvSpPr>
           <p:cNvPr id="6" name="Rounded Rectangle 5"/>
@@ -14255,8 +14278,64 @@
         </p:nvSpPr>
         <p:spPr>
           <a:xfrm>
-            <a:off x="2057400" y="2286000"/>
-            <a:ext cx="1481328" cy="1280160"/>
+            <a:off x="5074920" y="1828800"/>
+            <a:ext cx="1737360" cy="822960"/>
+          </a:xfrm>
+          <a:prstGeom prst="roundRect">
+            <a:avLst/>
+          </a:prstGeom>
+          <a:solidFill>
+            <a:srgbClr val="7C3AED"/>
+          </a:solidFill>
+          <a:ln>
+            <a:solidFill>
+              <a:srgbClr val="7C3AED"/>
+            </a:solidFill>
+          </a:ln>
+          <a:effectLst/>
+        </p:spPr>
+        <p:style>
+          <a:lnRef idx="1">
+            <a:schemeClr val="accent1"/>
+          </a:lnRef>
+          <a:fillRef idx="3">
+            <a:schemeClr val="accent1"/>
+          </a:fillRef>
+          <a:effectRef idx="2">
+            <a:schemeClr val="accent1"/>
+          </a:effectRef>
+          <a:fontRef idx="minor">
+            <a:schemeClr val="lt1"/>
+          </a:fontRef>
+        </p:style>
+        <p:txBody>
+          <a:bodyPr rtlCol="0" anchor="ctr" wrap="square" tIns="25400" bIns="25400"/>
+          <a:lstStyle/>
+          <a:p>
+            <a:pPr algn="ctr"/>
+            <a:r>
+              <a:rPr sz="1200" b="1">
+                <a:solidFill>
+                  <a:srgbClr val="FFFFFF"/>
+                </a:solidFill>
+                <a:latin typeface="PingFang TC"/>
+                <a:ea typeface="PingFang TC"/>
+              </a:rPr>
+              <a:t>CloudFront</a:t>
+            </a:r>
+          </a:p>
+        </p:txBody>
+      </p:sp>
+      <p:sp>
+        <p:nvSpPr>
+          <p:cNvPr id="7" name="Rounded Rectangle 6"/>
+          <p:cNvSpPr/>
+          <p:nvPr/>
+        </p:nvSpPr>
+        <p:spPr>
+          <a:xfrm>
+            <a:off x="7178040" y="1828800"/>
+            <a:ext cx="2468880" cy="822960"/>
           </a:xfrm>
           <a:prstGeom prst="roundRect">
             <a:avLst/>
@@ -14291,80 +14370,31 @@
           <a:p>
             <a:pPr algn="ctr"/>
             <a:r>
-              <a:rPr sz="1100" b="1">
+              <a:rPr sz="1200" b="1">
                 <a:solidFill>
                   <a:srgbClr val="FFFFFF"/>
                 </a:solidFill>
                 <a:latin typeface="PingFang TC"/>
                 <a:ea typeface="PingFang TC"/>
               </a:rPr>
-              <a:t>GitHub Actions</a:t>
+              <a:t>API GW 整體節流</a:t>
             </a:r>
           </a:p>
           <a:p>
             <a:pPr algn="ctr"/>
             <a:r>
-              <a:rPr sz="1100" b="0">
+              <a:rPr sz="1200" b="0">
                 <a:solidFill>
                   <a:srgbClr val="FFFFFF"/>
                 </a:solidFill>
                 <a:latin typeface="PingFang TC"/>
                 <a:ea typeface="PingFang TC"/>
               </a:rPr>
-              <a:t>OIDC assume role</a:t>
-            </a:r>
-          </a:p>
-          <a:p>
-            <a:pPr algn="ctr"/>
-            <a:r>
-              <a:rPr sz="1100" b="0">
-                <a:solidFill>
-                  <a:srgbClr val="FFFFFF"/>
-                </a:solidFill>
-                <a:latin typeface="PingFang TC"/>
-                <a:ea typeface="PingFang TC"/>
-              </a:rPr>
-              <a:t>(無長期金鑰)</a:t>
-            </a:r>
-          </a:p>
-        </p:txBody>
-      </p:sp>
-      <p:cxnSp>
-        <p:nvCxnSpPr>
-          <p:cNvPr id="7" name="Connector 6"/>
-          <p:cNvCxnSpPr/>
-          <p:nvPr/>
-        </p:nvCxnSpPr>
-        <p:spPr>
-          <a:xfrm>
-            <a:off x="3538728" y="2926080"/>
-            <a:ext cx="118872" cy="0"/>
-          </a:xfrm>
-          <a:prstGeom prst="line">
-            <a:avLst/>
-          </a:prstGeom>
-          <a:ln w="22225">
-            <a:solidFill>
-              <a:srgbClr val="64748B"/>
-            </a:solidFill>
-            <a:tailEnd type="triangle" w="med" len="med"/>
-          </a:ln>
-        </p:spPr>
-        <p:style>
-          <a:lnRef idx="2">
-            <a:schemeClr val="accent1"/>
-          </a:lnRef>
-          <a:fillRef idx="0">
-            <a:schemeClr val="accent1"/>
-          </a:fillRef>
-          <a:effectRef idx="1">
-            <a:schemeClr val="accent1"/>
-          </a:effectRef>
-          <a:fontRef idx="minor">
-            <a:schemeClr val="tx1"/>
-          </a:fontRef>
-        </p:style>
-      </p:cxnSp>
+              <a:t>超量 → 429</a:t>
+            </a:r>
+          </a:p>
+        </p:txBody>
+      </p:sp>
       <p:sp>
         <p:nvSpPr>
           <p:cNvPr id="8" name="Rounded Rectangle 7"/>
@@ -14373,8 +14403,8 @@
         </p:nvSpPr>
         <p:spPr>
           <a:xfrm>
-            <a:off x="3657600" y="2286000"/>
-            <a:ext cx="1481328" cy="1280160"/>
+            <a:off x="10012680" y="1828800"/>
+            <a:ext cx="1691640" cy="822960"/>
           </a:xfrm>
           <a:prstGeom prst="roundRect">
             <a:avLst/>
@@ -14416,33 +14446,7 @@
                 <a:latin typeface="PingFang TC"/>
                 <a:ea typeface="PingFang TC"/>
               </a:rPr>
-              <a:t>buildx</a:t>
-            </a:r>
-          </a:p>
-          <a:p>
-            <a:pPr algn="ctr"/>
-            <a:r>
-              <a:rPr sz="1100" b="0">
-                <a:solidFill>
-                  <a:srgbClr val="FFFFFF"/>
-                </a:solidFill>
-                <a:latin typeface="PingFang TC"/>
-                <a:ea typeface="PingFang TC"/>
-              </a:rPr>
-              <a:t>--platform</a:t>
-            </a:r>
-          </a:p>
-          <a:p>
-            <a:pPr algn="ctr"/>
-            <a:r>
-              <a:rPr sz="1100" b="0">
-                <a:solidFill>
-                  <a:srgbClr val="FFFFFF"/>
-                </a:solidFill>
-                <a:latin typeface="PingFang TC"/>
-                <a:ea typeface="PingFang TC"/>
-              </a:rPr>
-              <a:t>linux/arm64</a:t>
+              <a:t>ALB → EC2</a:t>
             </a:r>
           </a:p>
         </p:txBody>
@@ -14455,8 +14459,8 @@
         </p:nvCxnSpPr>
         <p:spPr>
           <a:xfrm>
-            <a:off x="5138928" y="2926080"/>
-            <a:ext cx="118872" cy="0"/>
+            <a:off x="2103120" y="2240280"/>
+            <a:ext cx="320040" cy="0"/>
           </a:xfrm>
           <a:prstGeom prst="line">
             <a:avLst/>
@@ -14483,98 +14487,16 @@
           </a:fontRef>
         </p:style>
       </p:cxnSp>
-      <p:sp>
-        <p:nvSpPr>
-          <p:cNvPr id="10" name="Rounded Rectangle 9"/>
-          <p:cNvSpPr/>
-          <p:nvPr/>
-        </p:nvSpPr>
-        <p:spPr>
-          <a:xfrm>
-            <a:off x="5257800" y="2286000"/>
-            <a:ext cx="1481328" cy="1280160"/>
-          </a:xfrm>
-          <a:prstGeom prst="roundRect">
-            <a:avLst/>
-          </a:prstGeom>
-          <a:solidFill>
-            <a:srgbClr val="059669"/>
-          </a:solidFill>
-          <a:ln>
-            <a:solidFill>
-              <a:srgbClr val="059669"/>
-            </a:solidFill>
-          </a:ln>
-          <a:effectLst/>
-        </p:spPr>
-        <p:style>
-          <a:lnRef idx="1">
-            <a:schemeClr val="accent1"/>
-          </a:lnRef>
-          <a:fillRef idx="3">
-            <a:schemeClr val="accent1"/>
-          </a:fillRef>
-          <a:effectRef idx="2">
-            <a:schemeClr val="accent1"/>
-          </a:effectRef>
-          <a:fontRef idx="minor">
-            <a:schemeClr val="lt1"/>
-          </a:fontRef>
-        </p:style>
-        <p:txBody>
-          <a:bodyPr rtlCol="0" anchor="ctr" wrap="square" tIns="25400" bIns="25400"/>
-          <a:lstStyle/>
-          <a:p>
-            <a:pPr algn="ctr"/>
-            <a:r>
-              <a:rPr sz="1100" b="1">
-                <a:solidFill>
-                  <a:srgbClr val="FFFFFF"/>
-                </a:solidFill>
-                <a:latin typeface="PingFang TC"/>
-                <a:ea typeface="PingFang TC"/>
-              </a:rPr>
-              <a:t>ECR push</a:t>
-            </a:r>
-          </a:p>
-          <a:p>
-            <a:pPr algn="ctr"/>
-            <a:r>
-              <a:rPr sz="1100" b="0">
-                <a:solidFill>
-                  <a:srgbClr val="FFFFFF"/>
-                </a:solidFill>
-                <a:latin typeface="PingFang TC"/>
-                <a:ea typeface="PingFang TC"/>
-              </a:rPr>
-              <a:t>tag = SHA</a:t>
-            </a:r>
-          </a:p>
-          <a:p>
-            <a:pPr algn="ctr"/>
-            <a:r>
-              <a:rPr sz="1100" b="0">
-                <a:solidFill>
-                  <a:srgbClr val="FFFFFF"/>
-                </a:solidFill>
-                <a:latin typeface="PingFang TC"/>
-                <a:ea typeface="PingFang TC"/>
-              </a:rPr>
-              <a:t>+ latest</a:t>
-            </a:r>
-          </a:p>
-        </p:txBody>
-      </p:sp>
       <p:cxnSp>
         <p:nvCxnSpPr>
-          <p:cNvPr id="11" name="Connector 10"/>
+          <p:cNvPr id="10" name="Connector 9"/>
           <p:cNvCxnSpPr/>
           <p:nvPr/>
         </p:nvCxnSpPr>
         <p:spPr>
           <a:xfrm>
-            <a:off x="6739128" y="2926080"/>
-            <a:ext cx="118872" cy="0"/>
+            <a:off x="4709160" y="2240280"/>
+            <a:ext cx="365760" cy="0"/>
           </a:xfrm>
           <a:prstGeom prst="line">
             <a:avLst/>
@@ -14601,98 +14523,16 @@
           </a:fontRef>
         </p:style>
       </p:cxnSp>
-      <p:sp>
-        <p:nvSpPr>
-          <p:cNvPr id="12" name="Rounded Rectangle 11"/>
-          <p:cNvSpPr/>
-          <p:nvPr/>
-        </p:nvSpPr>
-        <p:spPr>
-          <a:xfrm>
-            <a:off x="6858000" y="2286000"/>
-            <a:ext cx="1481328" cy="1280160"/>
-          </a:xfrm>
-          <a:prstGeom prst="roundRect">
-            <a:avLst/>
-          </a:prstGeom>
-          <a:solidFill>
-            <a:srgbClr val="7C3AED"/>
-          </a:solidFill>
-          <a:ln>
-            <a:solidFill>
-              <a:srgbClr val="7C3AED"/>
-            </a:solidFill>
-          </a:ln>
-          <a:effectLst/>
-        </p:spPr>
-        <p:style>
-          <a:lnRef idx="1">
-            <a:schemeClr val="accent1"/>
-          </a:lnRef>
-          <a:fillRef idx="3">
-            <a:schemeClr val="accent1"/>
-          </a:fillRef>
-          <a:effectRef idx="2">
-            <a:schemeClr val="accent1"/>
-          </a:effectRef>
-          <a:fontRef idx="minor">
-            <a:schemeClr val="lt1"/>
-          </a:fontRef>
-        </p:style>
-        <p:txBody>
-          <a:bodyPr rtlCol="0" anchor="ctr" wrap="square" tIns="25400" bIns="25400"/>
-          <a:lstStyle/>
-          <a:p>
-            <a:pPr algn="ctr"/>
-            <a:r>
-              <a:rPr sz="1100" b="1">
-                <a:solidFill>
-                  <a:srgbClr val="FFFFFF"/>
-                </a:solidFill>
-                <a:latin typeface="PingFang TC"/>
-                <a:ea typeface="PingFang TC"/>
-              </a:rPr>
-              <a:t>SSM 更新</a:t>
-            </a:r>
-          </a:p>
-          <a:p>
-            <a:pPr algn="ctr"/>
-            <a:r>
-              <a:rPr sz="1100" b="0">
-                <a:solidFill>
-                  <a:srgbClr val="FFFFFF"/>
-                </a:solidFill>
-                <a:latin typeface="PingFang TC"/>
-                <a:ea typeface="PingFang TC"/>
-              </a:rPr>
-              <a:t>/qrcode/</a:t>
-            </a:r>
-          </a:p>
-          <a:p>
-            <a:pPr algn="ctr"/>
-            <a:r>
-              <a:rPr sz="1100" b="0">
-                <a:solidFill>
-                  <a:srgbClr val="FFFFFF"/>
-                </a:solidFill>
-                <a:latin typeface="PingFang TC"/>
-                <a:ea typeface="PingFang TC"/>
-              </a:rPr>
-              <a:t>IMAGE_URI</a:t>
-            </a:r>
-          </a:p>
-        </p:txBody>
-      </p:sp>
       <p:cxnSp>
         <p:nvCxnSpPr>
-          <p:cNvPr id="13" name="Connector 12"/>
+          <p:cNvPr id="11" name="Connector 10"/>
           <p:cNvCxnSpPr/>
           <p:nvPr/>
         </p:nvCxnSpPr>
         <p:spPr>
           <a:xfrm>
-            <a:off x="8339328" y="2926080"/>
-            <a:ext cx="118872" cy="0"/>
+            <a:off x="6812280" y="2240280"/>
+            <a:ext cx="365760" cy="0"/>
           </a:xfrm>
           <a:prstGeom prst="line">
             <a:avLst/>
@@ -14719,98 +14559,16 @@
           </a:fontRef>
         </p:style>
       </p:cxnSp>
-      <p:sp>
-        <p:nvSpPr>
-          <p:cNvPr id="14" name="Rounded Rectangle 13"/>
-          <p:cNvSpPr/>
-          <p:nvPr/>
-        </p:nvSpPr>
-        <p:spPr>
-          <a:xfrm>
-            <a:off x="8458200" y="2286000"/>
-            <a:ext cx="1481328" cy="1280160"/>
-          </a:xfrm>
-          <a:prstGeom prst="roundRect">
-            <a:avLst/>
-          </a:prstGeom>
-          <a:solidFill>
-            <a:srgbClr val="D97706"/>
-          </a:solidFill>
-          <a:ln>
-            <a:solidFill>
-              <a:srgbClr val="D97706"/>
-            </a:solidFill>
-          </a:ln>
-          <a:effectLst/>
-        </p:spPr>
-        <p:style>
-          <a:lnRef idx="1">
-            <a:schemeClr val="accent1"/>
-          </a:lnRef>
-          <a:fillRef idx="3">
-            <a:schemeClr val="accent1"/>
-          </a:fillRef>
-          <a:effectRef idx="2">
-            <a:schemeClr val="accent1"/>
-          </a:effectRef>
-          <a:fontRef idx="minor">
-            <a:schemeClr val="lt1"/>
-          </a:fontRef>
-        </p:style>
-        <p:txBody>
-          <a:bodyPr rtlCol="0" anchor="ctr" wrap="square" tIns="25400" bIns="25400"/>
-          <a:lstStyle/>
-          <a:p>
-            <a:pPr algn="ctr"/>
-            <a:r>
-              <a:rPr sz="1100" b="1">
-                <a:solidFill>
-                  <a:srgbClr val="FFFFFF"/>
-                </a:solidFill>
-                <a:latin typeface="PingFang TC"/>
-                <a:ea typeface="PingFang TC"/>
-              </a:rPr>
-              <a:t>SSM 部署</a:t>
-            </a:r>
-          </a:p>
-          <a:p>
-            <a:pPr algn="ctr"/>
-            <a:r>
-              <a:rPr sz="1100" b="0">
-                <a:solidFill>
-                  <a:srgbClr val="FFFFFF"/>
-                </a:solidFill>
-                <a:latin typeface="PingFang TC"/>
-                <a:ea typeface="PingFang TC"/>
-              </a:rPr>
-              <a:t>→ EC2</a:t>
-            </a:r>
-          </a:p>
-          <a:p>
-            <a:pPr algn="ctr"/>
-            <a:r>
-              <a:rPr sz="1100" b="0">
-                <a:solidFill>
-                  <a:srgbClr val="FFFFFF"/>
-                </a:solidFill>
-                <a:latin typeface="PingFang TC"/>
-                <a:ea typeface="PingFang TC"/>
-              </a:rPr>
-              <a:t>deploy-app.sh</a:t>
-            </a:r>
-          </a:p>
-        </p:txBody>
-      </p:sp>
       <p:cxnSp>
         <p:nvCxnSpPr>
-          <p:cNvPr id="15" name="Connector 14"/>
+          <p:cNvPr id="12" name="Connector 11"/>
           <p:cNvCxnSpPr/>
           <p:nvPr/>
         </p:nvCxnSpPr>
         <p:spPr>
           <a:xfrm>
-            <a:off x="9939528" y="2926080"/>
-            <a:ext cx="118872" cy="0"/>
+            <a:off x="9646920" y="2240280"/>
+            <a:ext cx="365760" cy="0"/>
           </a:xfrm>
           <a:prstGeom prst="line">
             <a:avLst/>
@@ -14837,98 +14595,420 @@
           </a:fontRef>
         </p:style>
       </p:cxnSp>
-      <p:sp>
-        <p:nvSpPr>
-          <p:cNvPr id="16" name="Rounded Rectangle 15"/>
-          <p:cNvSpPr/>
-          <p:nvPr/>
-        </p:nvSpPr>
-        <p:spPr>
-          <a:xfrm>
-            <a:off x="10058400" y="2286000"/>
-            <a:ext cx="1481328" cy="1280160"/>
-          </a:xfrm>
-          <a:prstGeom prst="roundRect">
-            <a:avLst/>
-          </a:prstGeom>
-          <a:solidFill>
-            <a:srgbClr val="059669"/>
-          </a:solidFill>
-          <a:ln>
-            <a:solidFill>
-              <a:srgbClr val="059669"/>
-            </a:solidFill>
-          </a:ln>
-          <a:effectLst/>
-        </p:spPr>
-        <p:style>
-          <a:lnRef idx="1">
-            <a:schemeClr val="accent1"/>
-          </a:lnRef>
-          <a:fillRef idx="3">
-            <a:schemeClr val="accent1"/>
-          </a:fillRef>
-          <a:effectRef idx="2">
-            <a:schemeClr val="accent1"/>
-          </a:effectRef>
-          <a:fontRef idx="minor">
-            <a:schemeClr val="lt1"/>
-          </a:fontRef>
-        </p:style>
-        <p:txBody>
-          <a:bodyPr rtlCol="0" anchor="ctr" wrap="square" tIns="25400" bIns="25400"/>
-          <a:lstStyle/>
-          <a:p>
-            <a:pPr algn="ctr"/>
-            <a:r>
-              <a:rPr sz="1100" b="1">
-                <a:solidFill>
-                  <a:srgbClr val="FFFFFF"/>
-                </a:solidFill>
-                <a:latin typeface="PingFang TC"/>
-                <a:ea typeface="PingFang TC"/>
-              </a:rPr>
-              <a:t>上線</a:t>
-            </a:r>
-          </a:p>
-          <a:p>
-            <a:pPr algn="ctr"/>
-            <a:r>
-              <a:rPr sz="1100" b="0">
-                <a:solidFill>
-                  <a:srgbClr val="FFFFFF"/>
-                </a:solidFill>
-                <a:latin typeface="PingFang TC"/>
-                <a:ea typeface="PingFang TC"/>
-              </a:rPr>
-              <a:t>ALB /health</a:t>
-            </a:r>
-          </a:p>
-          <a:p>
-            <a:pPr algn="ctr"/>
-            <a:r>
-              <a:rPr sz="1100" b="0">
-                <a:solidFill>
-                  <a:srgbClr val="FFFFFF"/>
-                </a:solidFill>
-                <a:latin typeface="PingFang TC"/>
-                <a:ea typeface="PingFang TC"/>
-              </a:rPr>
-              <a:t>通過</a:t>
-            </a:r>
-          </a:p>
-        </p:txBody>
-      </p:sp>
-      <p:sp>
-        <p:nvSpPr>
-          <p:cNvPr id="17" name="TextBox 16"/>
+      <p:graphicFrame>
+        <p:nvGraphicFramePr>
+          <p:cNvPr id="13" name="Table 12"/>
+          <p:cNvGraphicFramePr>
+            <a:graphicFrameLocks noGrp="1"/>
+          </p:cNvGraphicFramePr>
+          <p:nvPr/>
+        </p:nvGraphicFramePr>
+        <p:xfrm>
+          <a:off x="548640" y="3017520"/>
+          <a:ext cx="11109960" cy="1828800"/>
+        </p:xfrm>
+        <a:graphic>
+          <a:graphicData uri="http://schemas.openxmlformats.org/drawingml/2006/table">
+            <a:tbl>
+              <a:tblPr firstRow="1" bandRow="1">
+                <a:tableStyleId>{5C22544A-7EE6-4342-B048-85BDC9FD1C3A}</a:tableStyleId>
+              </a:tblPr>
+              <a:tblGrid>
+                <a:gridCol w="2743200"/>
+                <a:gridCol w="2743200"/>
+                <a:gridCol w="3794760"/>
+                <a:gridCol w="1828800"/>
+              </a:tblGrid>
+              <a:tr h="457200">
+                <a:tc>
+                  <a:txBody>
+                    <a:bodyPr/>
+                    <a:lstStyle/>
+                    <a:p>
+                      <a:r>
+                        <a:rPr sz="1200" b="1">
+                          <a:solidFill>
+                            <a:srgbClr val="FFFFFF"/>
+                          </a:solidFill>
+                          <a:latin typeface="PingFang TC"/>
+                          <a:ea typeface="PingFang TC"/>
+                        </a:rPr>
+                        <a:t>層</a:t>
+                      </a:r>
+                    </a:p>
+                  </a:txBody>
+                  <a:tcPr marT="25400" marB="25400" marL="101600" anchor="ctr">
+                    <a:solidFill>
+                      <a:srgbClr val="2563EB"/>
+                    </a:solidFill>
+                  </a:tcPr>
+                </a:tc>
+                <a:tc>
+                  <a:txBody>
+                    <a:bodyPr/>
+                    <a:lstStyle/>
+                    <a:p>
+                      <a:r>
+                        <a:rPr sz="1200" b="1">
+                          <a:solidFill>
+                            <a:srgbClr val="FFFFFF"/>
+                          </a:solidFill>
+                          <a:latin typeface="PingFang TC"/>
+                          <a:ea typeface="PingFang TC"/>
+                        </a:rPr>
+                        <a:t>機制</a:t>
+                      </a:r>
+                    </a:p>
+                  </a:txBody>
+                  <a:tcPr marT="25400" marB="25400" marL="101600" anchor="ctr">
+                    <a:solidFill>
+                      <a:srgbClr val="2563EB"/>
+                    </a:solidFill>
+                  </a:tcPr>
+                </a:tc>
+                <a:tc>
+                  <a:txBody>
+                    <a:bodyPr/>
+                    <a:lstStyle/>
+                    <a:p>
+                      <a:r>
+                        <a:rPr sz="1200" b="1">
+                          <a:solidFill>
+                            <a:srgbClr val="FFFFFF"/>
+                          </a:solidFill>
+                          <a:latin typeface="PingFang TC"/>
+                          <a:ea typeface="PingFang TC"/>
+                        </a:rPr>
+                        <a:t>上限</a:t>
+                      </a:r>
+                    </a:p>
+                  </a:txBody>
+                  <a:tcPr marT="25400" marB="25400" marL="101600" anchor="ctr">
+                    <a:solidFill>
+                      <a:srgbClr val="2563EB"/>
+                    </a:solidFill>
+                  </a:tcPr>
+                </a:tc>
+                <a:tc>
+                  <a:txBody>
+                    <a:bodyPr/>
+                    <a:lstStyle/>
+                    <a:p>
+                      <a:r>
+                        <a:rPr sz="1200" b="1">
+                          <a:solidFill>
+                            <a:srgbClr val="FFFFFF"/>
+                          </a:solidFill>
+                          <a:latin typeface="PingFang TC"/>
+                          <a:ea typeface="PingFang TC"/>
+                        </a:rPr>
+                        <a:t>超量</a:t>
+                      </a:r>
+                    </a:p>
+                  </a:txBody>
+                  <a:tcPr marT="25400" marB="25400" marL="101600" anchor="ctr">
+                    <a:solidFill>
+                      <a:srgbClr val="2563EB"/>
+                    </a:solidFill>
+                  </a:tcPr>
+                </a:tc>
+              </a:tr>
+              <a:tr h="457200">
+                <a:tc>
+                  <a:txBody>
+                    <a:bodyPr/>
+                    <a:lstStyle/>
+                    <a:p>
+                      <a:r>
+                        <a:rPr sz="1200" b="1">
+                          <a:solidFill>
+                            <a:srgbClr val="0F172A"/>
+                          </a:solidFill>
+                          <a:latin typeface="PingFang TC"/>
+                          <a:ea typeface="PingFang TC"/>
+                        </a:rPr>
+                        <a:t>CloudFront WAF</a:t>
+                      </a:r>
+                    </a:p>
+                  </a:txBody>
+                  <a:tcPr marT="25400" marB="25400" marL="101600" anchor="ctr">
+                    <a:solidFill>
+                      <a:srgbClr val="FFFFFF"/>
+                    </a:solidFill>
+                  </a:tcPr>
+                </a:tc>
+                <a:tc>
+                  <a:txBody>
+                    <a:bodyPr/>
+                    <a:lstStyle/>
+                    <a:p>
+                      <a:r>
+                        <a:rPr sz="1200" b="0">
+                          <a:solidFill>
+                            <a:srgbClr val="0F172A"/>
+                          </a:solidFill>
+                          <a:latin typeface="PingFang TC"/>
+                          <a:ea typeface="PingFang TC"/>
+                        </a:rPr>
+                        <a:t>per-IP · /api/*</a:t>
+                      </a:r>
+                    </a:p>
+                  </a:txBody>
+                  <a:tcPr marT="25400" marB="25400" marL="101600" anchor="ctr">
+                    <a:solidFill>
+                      <a:srgbClr val="FFFFFF"/>
+                    </a:solidFill>
+                  </a:tcPr>
+                </a:tc>
+                <a:tc>
+                  <a:txBody>
+                    <a:bodyPr/>
+                    <a:lstStyle/>
+                    <a:p>
+                      <a:r>
+                        <a:rPr sz="1200" b="0">
+                          <a:solidFill>
+                            <a:srgbClr val="0F172A"/>
+                          </a:solidFill>
+                          <a:latin typeface="PingFang TC"/>
+                          <a:ea typeface="PingFang TC"/>
+                        </a:rPr>
+                        <a:t>300 / 5 分 / IP</a:t>
+                      </a:r>
+                    </a:p>
+                  </a:txBody>
+                  <a:tcPr marT="25400" marB="25400" marL="101600" anchor="ctr">
+                    <a:solidFill>
+                      <a:srgbClr val="FFFFFF"/>
+                    </a:solidFill>
+                  </a:tcPr>
+                </a:tc>
+                <a:tc>
+                  <a:txBody>
+                    <a:bodyPr/>
+                    <a:lstStyle/>
+                    <a:p>
+                      <a:r>
+                        <a:rPr sz="1200" b="0">
+                          <a:solidFill>
+                            <a:srgbClr val="0F172A"/>
+                          </a:solidFill>
+                          <a:latin typeface="PingFang TC"/>
+                          <a:ea typeface="PingFang TC"/>
+                        </a:rPr>
+                        <a:t>403</a:t>
+                      </a:r>
+                    </a:p>
+                  </a:txBody>
+                  <a:tcPr marT="25400" marB="25400" marL="101600" anchor="ctr">
+                    <a:solidFill>
+                      <a:srgbClr val="FFFFFF"/>
+                    </a:solidFill>
+                  </a:tcPr>
+                </a:tc>
+              </a:tr>
+              <a:tr h="457200">
+                <a:tc>
+                  <a:txBody>
+                    <a:bodyPr/>
+                    <a:lstStyle/>
+                    <a:p>
+                      <a:r>
+                        <a:rPr sz="1200" b="1">
+                          <a:solidFill>
+                            <a:srgbClr val="0F172A"/>
+                          </a:solidFill>
+                          <a:latin typeface="PingFang TC"/>
+                          <a:ea typeface="PingFang TC"/>
+                        </a:rPr>
+                        <a:t>CloudFront WAF</a:t>
+                      </a:r>
+                    </a:p>
+                  </a:txBody>
+                  <a:tcPr marT="25400" marB="25400" marL="101600" anchor="ctr">
+                    <a:solidFill>
+                      <a:srgbClr val="F1F5F9"/>
+                    </a:solidFill>
+                  </a:tcPr>
+                </a:tc>
+                <a:tc>
+                  <a:txBody>
+                    <a:bodyPr/>
+                    <a:lstStyle/>
+                    <a:p>
+                      <a:r>
+                        <a:rPr sz="1200" b="0">
+                          <a:solidFill>
+                            <a:srgbClr val="0F172A"/>
+                          </a:solidFill>
+                          <a:latin typeface="PingFang TC"/>
+                          <a:ea typeface="PingFang TC"/>
+                        </a:rPr>
+                        <a:t>per-IP · 全域</a:t>
+                      </a:r>
+                    </a:p>
+                  </a:txBody>
+                  <a:tcPr marT="25400" marB="25400" marL="101600" anchor="ctr">
+                    <a:solidFill>
+                      <a:srgbClr val="F1F5F9"/>
+                    </a:solidFill>
+                  </a:tcPr>
+                </a:tc>
+                <a:tc>
+                  <a:txBody>
+                    <a:bodyPr/>
+                    <a:lstStyle/>
+                    <a:p>
+                      <a:r>
+                        <a:rPr sz="1200" b="0">
+                          <a:solidFill>
+                            <a:srgbClr val="0F172A"/>
+                          </a:solidFill>
+                          <a:latin typeface="PingFang TC"/>
+                          <a:ea typeface="PingFang TC"/>
+                        </a:rPr>
+                        <a:t>2000 / 5 分 / IP</a:t>
+                      </a:r>
+                    </a:p>
+                  </a:txBody>
+                  <a:tcPr marT="25400" marB="25400" marL="101600" anchor="ctr">
+                    <a:solidFill>
+                      <a:srgbClr val="F1F5F9"/>
+                    </a:solidFill>
+                  </a:tcPr>
+                </a:tc>
+                <a:tc>
+                  <a:txBody>
+                    <a:bodyPr/>
+                    <a:lstStyle/>
+                    <a:p>
+                      <a:r>
+                        <a:rPr sz="1200" b="0">
+                          <a:solidFill>
+                            <a:srgbClr val="0F172A"/>
+                          </a:solidFill>
+                          <a:latin typeface="PingFang TC"/>
+                          <a:ea typeface="PingFang TC"/>
+                        </a:rPr>
+                        <a:t>403</a:t>
+                      </a:r>
+                    </a:p>
+                  </a:txBody>
+                  <a:tcPr marT="25400" marB="25400" marL="101600" anchor="ctr">
+                    <a:solidFill>
+                      <a:srgbClr val="F1F5F9"/>
+                    </a:solidFill>
+                  </a:tcPr>
+                </a:tc>
+              </a:tr>
+              <a:tr h="457200">
+                <a:tc>
+                  <a:txBody>
+                    <a:bodyPr/>
+                    <a:lstStyle/>
+                    <a:p>
+                      <a:r>
+                        <a:rPr sz="1200" b="1">
+                          <a:solidFill>
+                            <a:srgbClr val="0F172A"/>
+                          </a:solidFill>
+                          <a:latin typeface="PingFang TC"/>
+                          <a:ea typeface="PingFang TC"/>
+                        </a:rPr>
+                        <a:t>API Gateway</a:t>
+                      </a:r>
+                    </a:p>
+                  </a:txBody>
+                  <a:tcPr marT="25400" marB="25400" marL="101600" anchor="ctr">
+                    <a:solidFill>
+                      <a:srgbClr val="FFFFFF"/>
+                    </a:solidFill>
+                  </a:tcPr>
+                </a:tc>
+                <a:tc>
+                  <a:txBody>
+                    <a:bodyPr/>
+                    <a:lstStyle/>
+                    <a:p>
+                      <a:r>
+                        <a:rPr sz="1200" b="0">
+                          <a:solidFill>
+                            <a:srgbClr val="0F172A"/>
+                          </a:solidFill>
+                          <a:latin typeface="PingFang TC"/>
+                          <a:ea typeface="PingFang TC"/>
+                        </a:rPr>
+                        <a:t>整體 throttle</a:t>
+                      </a:r>
+                    </a:p>
+                  </a:txBody>
+                  <a:tcPr marT="25400" marB="25400" marL="101600" anchor="ctr">
+                    <a:solidFill>
+                      <a:srgbClr val="FFFFFF"/>
+                    </a:solidFill>
+                  </a:tcPr>
+                </a:tc>
+                <a:tc>
+                  <a:txBody>
+                    <a:bodyPr/>
+                    <a:lstStyle/>
+                    <a:p>
+                      <a:r>
+                        <a:rPr sz="1200" b="0">
+                          <a:solidFill>
+                            <a:srgbClr val="0F172A"/>
+                          </a:solidFill>
+                          <a:latin typeface="PingFang TC"/>
+                          <a:ea typeface="PingFang TC"/>
+                        </a:rPr>
+                        <a:t>1000 req/s · burst 2000</a:t>
+                      </a:r>
+                    </a:p>
+                  </a:txBody>
+                  <a:tcPr marT="25400" marB="25400" marL="101600" anchor="ctr">
+                    <a:solidFill>
+                      <a:srgbClr val="FFFFFF"/>
+                    </a:solidFill>
+                  </a:tcPr>
+                </a:tc>
+                <a:tc>
+                  <a:txBody>
+                    <a:bodyPr/>
+                    <a:lstStyle/>
+                    <a:p>
+                      <a:r>
+                        <a:rPr sz="1200" b="0">
+                          <a:solidFill>
+                            <a:srgbClr val="0F172A"/>
+                          </a:solidFill>
+                          <a:latin typeface="PingFang TC"/>
+                          <a:ea typeface="PingFang TC"/>
+                        </a:rPr>
+                        <a:t>429</a:t>
+                      </a:r>
+                    </a:p>
+                  </a:txBody>
+                  <a:tcPr marT="25400" marB="25400" marL="101600" anchor="ctr">
+                    <a:solidFill>
+                      <a:srgbClr val="FFFFFF"/>
+                    </a:solidFill>
+                  </a:tcPr>
+                </a:tc>
+              </a:tr>
+            </a:tbl>
+          </a:graphicData>
+        </a:graphic>
+      </p:graphicFrame>
+      <p:sp>
+        <p:nvSpPr>
+          <p:cNvPr id="14" name="TextBox 13"/>
           <p:cNvSpPr txBox="1"/>
           <p:nvPr/>
         </p:nvSpPr>
         <p:spPr>
           <a:xfrm>
-            <a:off x="548640" y="4023360"/>
-            <a:ext cx="11247120" cy="2194560"/>
+            <a:off x="548640" y="5074920"/>
+            <a:ext cx="11247120" cy="1463040"/>
           </a:xfrm>
           <a:prstGeom prst="rect">
             <a:avLst/>
@@ -14943,52 +15023,52 @@
           <a:p>
             <a:pPr>
               <a:spcAft>
-                <a:spcPts val="900"/>
-              </a:spcAft>
-            </a:pPr>
-            <a:r>
-              <a:rPr sz="1400" b="0">
+                <a:spcPts val="700"/>
+              </a:spcAft>
+            </a:pPr>
+            <a:r>
+              <a:rPr sz="1300" b="0">
                 <a:solidFill>
                   <a:srgbClr val="0F172A"/>
                 </a:solidFill>
                 <a:latin typeface="PingFang TC"/>
                 <a:ea typeface="PingFang TC"/>
               </a:rPr>
-              <a:t>•  EC2 deploy-app.sh:從 SSM 撈設定 → ECR login → docker pull → docker run(換新容器)</a:t>
+              <a:t>•  為何不能只靠 API GW:HTTP API 內建節流是『整體』非 per-IP、也無 API key → 擋單一 IP 濫用必須靠 WAF</a:t>
             </a:r>
           </a:p>
           <a:p>
             <a:pPr>
               <a:spcAft>
-                <a:spcPts val="900"/>
-              </a:spcAft>
-            </a:pPr>
-            <a:r>
-              <a:rPr sz="1400" b="0">
+                <a:spcPts val="700"/>
+              </a:spcAft>
+            </a:pPr>
+            <a:r>
+              <a:rPr sz="1300" b="0">
                 <a:solidFill>
                   <a:srgbClr val="0F172A"/>
                 </a:solidFill>
                 <a:latin typeface="PingFang TC"/>
                 <a:ea typeface="PingFang TC"/>
               </a:rPr>
-              <a:t>•  全 env-gated:本機無這些環境變數 → 維持 SQLite + 記憶體 cache + 即時生圖,不受影響</a:t>
+              <a:t>•  限速值皆 Terraform 變數可調;WAF 阻擋數進 CloudWatch（BlockedRequests）</a:t>
             </a:r>
           </a:p>
           <a:p>
             <a:pPr>
               <a:spcAft>
-                <a:spcPts val="900"/>
-              </a:spcAft>
-            </a:pPr>
-            <a:r>
-              <a:rPr sz="1400" b="0">
+                <a:spcPts val="700"/>
+              </a:spcAft>
+            </a:pPr>
+            <a:r>
+              <a:rPr sz="1300" b="0">
                 <a:solidFill>
                   <a:srgbClr val="0F172A"/>
                 </a:solidFill>
                 <a:latin typeface="PingFang TC"/>
                 <a:ea typeface="PingFang TC"/>
               </a:rPr>
-              <a:t>•  部署踩到的兩個坑:① EC2 role 少 s3:PutObject(500)② CI build amd64 但 EC2 arm64(502)→ buildx 跨平台修正</a:t>
+              <a:t>•  純 infra 變更,不動 app;已 validate/plan 通過(未 apply)</a:t>
             </a:r>
           </a:p>
         </p:txBody>
@@ -15020,6 +15100,976 @@
         <p:spPr>
           <a:xfrm>
             <a:off x="0" y="0"/>
+            <a:ext cx="164592" cy="6858000"/>
+          </a:xfrm>
+          <a:prstGeom prst="rect">
+            <a:avLst/>
+          </a:prstGeom>
+          <a:solidFill>
+            <a:srgbClr val="2563EB"/>
+          </a:solidFill>
+          <a:ln>
+            <a:noFill/>
+          </a:ln>
+          <a:effectLst/>
+        </p:spPr>
+        <p:style>
+          <a:lnRef idx="1">
+            <a:schemeClr val="accent1"/>
+          </a:lnRef>
+          <a:fillRef idx="3">
+            <a:schemeClr val="accent1"/>
+          </a:fillRef>
+          <a:effectRef idx="2">
+            <a:schemeClr val="accent1"/>
+          </a:effectRef>
+          <a:fontRef idx="minor">
+            <a:schemeClr val="lt1"/>
+          </a:fontRef>
+        </p:style>
+        <p:txBody>
+          <a:bodyPr rtlCol="0" anchor="ctr"/>
+          <a:lstStyle/>
+          <a:p>
+            <a:pPr algn="ctr"/>
+          </a:p>
+        </p:txBody>
+      </p:sp>
+      <p:sp>
+        <p:nvSpPr>
+          <p:cNvPr id="3" name="TextBox 2"/>
+          <p:cNvSpPr txBox="1"/>
+          <p:nvPr/>
+        </p:nvSpPr>
+        <p:spPr>
+          <a:xfrm>
+            <a:off x="502920" y="320040"/>
+            <a:ext cx="10972800" cy="1005840"/>
+          </a:xfrm>
+          <a:prstGeom prst="rect">
+            <a:avLst/>
+          </a:prstGeom>
+          <a:noFill/>
+        </p:spPr>
+        <p:txBody>
+          <a:bodyPr wrap="square" anchor="t">
+            <a:spAutoFit/>
+          </a:bodyPr>
+          <a:lstStyle/>
+          <a:p>
+            <a:pPr algn="l">
+              <a:spcAft>
+                <a:spcPts val="200"/>
+              </a:spcAft>
+            </a:pPr>
+            <a:r>
+              <a:rPr sz="1300" b="1">
+                <a:solidFill>
+                  <a:srgbClr val="2563EB"/>
+                </a:solidFill>
+                <a:latin typeface="PingFang TC"/>
+                <a:ea typeface="PingFang TC"/>
+              </a:rPr>
+              <a:t>部署 · CI/CD</a:t>
+            </a:r>
+          </a:p>
+          <a:p>
+            <a:pPr algn="l">
+              <a:spcAft>
+                <a:spcPts val="400"/>
+              </a:spcAft>
+            </a:pPr>
+            <a:r>
+              <a:rPr sz="3000" b="1">
+                <a:solidFill>
+                  <a:srgbClr val="0F172A"/>
+                </a:solidFill>
+                <a:latin typeface="PingFang TC"/>
+                <a:ea typeface="PingFang TC"/>
+              </a:rPr>
+              <a:t>CI/CD 流程（GitHub Actions + OIDC）</a:t>
+            </a:r>
+          </a:p>
+        </p:txBody>
+      </p:sp>
+      <p:sp>
+        <p:nvSpPr>
+          <p:cNvPr id="4" name="Rounded Rectangle 3"/>
+          <p:cNvSpPr/>
+          <p:nvPr/>
+        </p:nvSpPr>
+        <p:spPr>
+          <a:xfrm>
+            <a:off x="457200" y="2286000"/>
+            <a:ext cx="1481328" cy="1280160"/>
+          </a:xfrm>
+          <a:prstGeom prst="roundRect">
+            <a:avLst/>
+          </a:prstGeom>
+          <a:solidFill>
+            <a:srgbClr val="64748B"/>
+          </a:solidFill>
+          <a:ln>
+            <a:solidFill>
+              <a:srgbClr val="64748B"/>
+            </a:solidFill>
+          </a:ln>
+          <a:effectLst/>
+        </p:spPr>
+        <p:style>
+          <a:lnRef idx="1">
+            <a:schemeClr val="accent1"/>
+          </a:lnRef>
+          <a:fillRef idx="3">
+            <a:schemeClr val="accent1"/>
+          </a:fillRef>
+          <a:effectRef idx="2">
+            <a:schemeClr val="accent1"/>
+          </a:effectRef>
+          <a:fontRef idx="minor">
+            <a:schemeClr val="lt1"/>
+          </a:fontRef>
+        </p:style>
+        <p:txBody>
+          <a:bodyPr rtlCol="0" anchor="ctr" wrap="square" tIns="25400" bIns="25400"/>
+          <a:lstStyle/>
+          <a:p>
+            <a:pPr algn="ctr"/>
+            <a:r>
+              <a:rPr sz="1100" b="1">
+                <a:solidFill>
+                  <a:srgbClr val="FFFFFF"/>
+                </a:solidFill>
+                <a:latin typeface="PingFang TC"/>
+                <a:ea typeface="PingFang TC"/>
+              </a:rPr>
+              <a:t>git push</a:t>
+            </a:r>
+          </a:p>
+          <a:p>
+            <a:pPr algn="ctr"/>
+            <a:r>
+              <a:rPr sz="1100" b="0">
+                <a:solidFill>
+                  <a:srgbClr val="FFFFFF"/>
+                </a:solidFill>
+                <a:latin typeface="PingFang TC"/>
+                <a:ea typeface="PingFang TC"/>
+              </a:rPr>
+              <a:t>QR Code Generator/**</a:t>
+            </a:r>
+          </a:p>
+        </p:txBody>
+      </p:sp>
+      <p:cxnSp>
+        <p:nvCxnSpPr>
+          <p:cNvPr id="5" name="Connector 4"/>
+          <p:cNvCxnSpPr/>
+          <p:nvPr/>
+        </p:nvCxnSpPr>
+        <p:spPr>
+          <a:xfrm>
+            <a:off x="1938528" y="2926080"/>
+            <a:ext cx="118872" cy="0"/>
+          </a:xfrm>
+          <a:prstGeom prst="line">
+            <a:avLst/>
+          </a:prstGeom>
+          <a:ln w="22225">
+            <a:solidFill>
+              <a:srgbClr val="64748B"/>
+            </a:solidFill>
+            <a:tailEnd type="triangle" w="med" len="med"/>
+          </a:ln>
+        </p:spPr>
+        <p:style>
+          <a:lnRef idx="2">
+            <a:schemeClr val="accent1"/>
+          </a:lnRef>
+          <a:fillRef idx="0">
+            <a:schemeClr val="accent1"/>
+          </a:fillRef>
+          <a:effectRef idx="1">
+            <a:schemeClr val="accent1"/>
+          </a:effectRef>
+          <a:fontRef idx="minor">
+            <a:schemeClr val="tx1"/>
+          </a:fontRef>
+        </p:style>
+      </p:cxnSp>
+      <p:sp>
+        <p:nvSpPr>
+          <p:cNvPr id="6" name="Rounded Rectangle 5"/>
+          <p:cNvSpPr/>
+          <p:nvPr/>
+        </p:nvSpPr>
+        <p:spPr>
+          <a:xfrm>
+            <a:off x="2057400" y="2286000"/>
+            <a:ext cx="1481328" cy="1280160"/>
+          </a:xfrm>
+          <a:prstGeom prst="roundRect">
+            <a:avLst/>
+          </a:prstGeom>
+          <a:solidFill>
+            <a:srgbClr val="0EA5E9"/>
+          </a:solidFill>
+          <a:ln>
+            <a:solidFill>
+              <a:srgbClr val="0EA5E9"/>
+            </a:solidFill>
+          </a:ln>
+          <a:effectLst/>
+        </p:spPr>
+        <p:style>
+          <a:lnRef idx="1">
+            <a:schemeClr val="accent1"/>
+          </a:lnRef>
+          <a:fillRef idx="3">
+            <a:schemeClr val="accent1"/>
+          </a:fillRef>
+          <a:effectRef idx="2">
+            <a:schemeClr val="accent1"/>
+          </a:effectRef>
+          <a:fontRef idx="minor">
+            <a:schemeClr val="lt1"/>
+          </a:fontRef>
+        </p:style>
+        <p:txBody>
+          <a:bodyPr rtlCol="0" anchor="ctr" wrap="square" tIns="25400" bIns="25400"/>
+          <a:lstStyle/>
+          <a:p>
+            <a:pPr algn="ctr"/>
+            <a:r>
+              <a:rPr sz="1100" b="1">
+                <a:solidFill>
+                  <a:srgbClr val="FFFFFF"/>
+                </a:solidFill>
+                <a:latin typeface="PingFang TC"/>
+                <a:ea typeface="PingFang TC"/>
+              </a:rPr>
+              <a:t>GitHub Actions</a:t>
+            </a:r>
+          </a:p>
+          <a:p>
+            <a:pPr algn="ctr"/>
+            <a:r>
+              <a:rPr sz="1100" b="0">
+                <a:solidFill>
+                  <a:srgbClr val="FFFFFF"/>
+                </a:solidFill>
+                <a:latin typeface="PingFang TC"/>
+                <a:ea typeface="PingFang TC"/>
+              </a:rPr>
+              <a:t>OIDC assume role</a:t>
+            </a:r>
+          </a:p>
+          <a:p>
+            <a:pPr algn="ctr"/>
+            <a:r>
+              <a:rPr sz="1100" b="0">
+                <a:solidFill>
+                  <a:srgbClr val="FFFFFF"/>
+                </a:solidFill>
+                <a:latin typeface="PingFang TC"/>
+                <a:ea typeface="PingFang TC"/>
+              </a:rPr>
+              <a:t>(無長期金鑰)</a:t>
+            </a:r>
+          </a:p>
+        </p:txBody>
+      </p:sp>
+      <p:cxnSp>
+        <p:nvCxnSpPr>
+          <p:cNvPr id="7" name="Connector 6"/>
+          <p:cNvCxnSpPr/>
+          <p:nvPr/>
+        </p:nvCxnSpPr>
+        <p:spPr>
+          <a:xfrm>
+            <a:off x="3538728" y="2926080"/>
+            <a:ext cx="118872" cy="0"/>
+          </a:xfrm>
+          <a:prstGeom prst="line">
+            <a:avLst/>
+          </a:prstGeom>
+          <a:ln w="22225">
+            <a:solidFill>
+              <a:srgbClr val="64748B"/>
+            </a:solidFill>
+            <a:tailEnd type="triangle" w="med" len="med"/>
+          </a:ln>
+        </p:spPr>
+        <p:style>
+          <a:lnRef idx="2">
+            <a:schemeClr val="accent1"/>
+          </a:lnRef>
+          <a:fillRef idx="0">
+            <a:schemeClr val="accent1"/>
+          </a:fillRef>
+          <a:effectRef idx="1">
+            <a:schemeClr val="accent1"/>
+          </a:effectRef>
+          <a:fontRef idx="minor">
+            <a:schemeClr val="tx1"/>
+          </a:fontRef>
+        </p:style>
+      </p:cxnSp>
+      <p:sp>
+        <p:nvSpPr>
+          <p:cNvPr id="8" name="Rounded Rectangle 7"/>
+          <p:cNvSpPr/>
+          <p:nvPr/>
+        </p:nvSpPr>
+        <p:spPr>
+          <a:xfrm>
+            <a:off x="3657600" y="2286000"/>
+            <a:ext cx="1481328" cy="1280160"/>
+          </a:xfrm>
+          <a:prstGeom prst="roundRect">
+            <a:avLst/>
+          </a:prstGeom>
+          <a:solidFill>
+            <a:srgbClr val="2563EB"/>
+          </a:solidFill>
+          <a:ln>
+            <a:solidFill>
+              <a:srgbClr val="2563EB"/>
+            </a:solidFill>
+          </a:ln>
+          <a:effectLst/>
+        </p:spPr>
+        <p:style>
+          <a:lnRef idx="1">
+            <a:schemeClr val="accent1"/>
+          </a:lnRef>
+          <a:fillRef idx="3">
+            <a:schemeClr val="accent1"/>
+          </a:fillRef>
+          <a:effectRef idx="2">
+            <a:schemeClr val="accent1"/>
+          </a:effectRef>
+          <a:fontRef idx="minor">
+            <a:schemeClr val="lt1"/>
+          </a:fontRef>
+        </p:style>
+        <p:txBody>
+          <a:bodyPr rtlCol="0" anchor="ctr" wrap="square" tIns="25400" bIns="25400"/>
+          <a:lstStyle/>
+          <a:p>
+            <a:pPr algn="ctr"/>
+            <a:r>
+              <a:rPr sz="1100" b="1">
+                <a:solidFill>
+                  <a:srgbClr val="FFFFFF"/>
+                </a:solidFill>
+                <a:latin typeface="PingFang TC"/>
+                <a:ea typeface="PingFang TC"/>
+              </a:rPr>
+              <a:t>buildx</a:t>
+            </a:r>
+          </a:p>
+          <a:p>
+            <a:pPr algn="ctr"/>
+            <a:r>
+              <a:rPr sz="1100" b="0">
+                <a:solidFill>
+                  <a:srgbClr val="FFFFFF"/>
+                </a:solidFill>
+                <a:latin typeface="PingFang TC"/>
+                <a:ea typeface="PingFang TC"/>
+              </a:rPr>
+              <a:t>--platform</a:t>
+            </a:r>
+          </a:p>
+          <a:p>
+            <a:pPr algn="ctr"/>
+            <a:r>
+              <a:rPr sz="1100" b="0">
+                <a:solidFill>
+                  <a:srgbClr val="FFFFFF"/>
+                </a:solidFill>
+                <a:latin typeface="PingFang TC"/>
+                <a:ea typeface="PingFang TC"/>
+              </a:rPr>
+              <a:t>linux/arm64</a:t>
+            </a:r>
+          </a:p>
+        </p:txBody>
+      </p:sp>
+      <p:cxnSp>
+        <p:nvCxnSpPr>
+          <p:cNvPr id="9" name="Connector 8"/>
+          <p:cNvCxnSpPr/>
+          <p:nvPr/>
+        </p:nvCxnSpPr>
+        <p:spPr>
+          <a:xfrm>
+            <a:off x="5138928" y="2926080"/>
+            <a:ext cx="118872" cy="0"/>
+          </a:xfrm>
+          <a:prstGeom prst="line">
+            <a:avLst/>
+          </a:prstGeom>
+          <a:ln w="22225">
+            <a:solidFill>
+              <a:srgbClr val="64748B"/>
+            </a:solidFill>
+            <a:tailEnd type="triangle" w="med" len="med"/>
+          </a:ln>
+        </p:spPr>
+        <p:style>
+          <a:lnRef idx="2">
+            <a:schemeClr val="accent1"/>
+          </a:lnRef>
+          <a:fillRef idx="0">
+            <a:schemeClr val="accent1"/>
+          </a:fillRef>
+          <a:effectRef idx="1">
+            <a:schemeClr val="accent1"/>
+          </a:effectRef>
+          <a:fontRef idx="minor">
+            <a:schemeClr val="tx1"/>
+          </a:fontRef>
+        </p:style>
+      </p:cxnSp>
+      <p:sp>
+        <p:nvSpPr>
+          <p:cNvPr id="10" name="Rounded Rectangle 9"/>
+          <p:cNvSpPr/>
+          <p:nvPr/>
+        </p:nvSpPr>
+        <p:spPr>
+          <a:xfrm>
+            <a:off x="5257800" y="2286000"/>
+            <a:ext cx="1481328" cy="1280160"/>
+          </a:xfrm>
+          <a:prstGeom prst="roundRect">
+            <a:avLst/>
+          </a:prstGeom>
+          <a:solidFill>
+            <a:srgbClr val="059669"/>
+          </a:solidFill>
+          <a:ln>
+            <a:solidFill>
+              <a:srgbClr val="059669"/>
+            </a:solidFill>
+          </a:ln>
+          <a:effectLst/>
+        </p:spPr>
+        <p:style>
+          <a:lnRef idx="1">
+            <a:schemeClr val="accent1"/>
+          </a:lnRef>
+          <a:fillRef idx="3">
+            <a:schemeClr val="accent1"/>
+          </a:fillRef>
+          <a:effectRef idx="2">
+            <a:schemeClr val="accent1"/>
+          </a:effectRef>
+          <a:fontRef idx="minor">
+            <a:schemeClr val="lt1"/>
+          </a:fontRef>
+        </p:style>
+        <p:txBody>
+          <a:bodyPr rtlCol="0" anchor="ctr" wrap="square" tIns="25400" bIns="25400"/>
+          <a:lstStyle/>
+          <a:p>
+            <a:pPr algn="ctr"/>
+            <a:r>
+              <a:rPr sz="1100" b="1">
+                <a:solidFill>
+                  <a:srgbClr val="FFFFFF"/>
+                </a:solidFill>
+                <a:latin typeface="PingFang TC"/>
+                <a:ea typeface="PingFang TC"/>
+              </a:rPr>
+              <a:t>ECR push</a:t>
+            </a:r>
+          </a:p>
+          <a:p>
+            <a:pPr algn="ctr"/>
+            <a:r>
+              <a:rPr sz="1100" b="0">
+                <a:solidFill>
+                  <a:srgbClr val="FFFFFF"/>
+                </a:solidFill>
+                <a:latin typeface="PingFang TC"/>
+                <a:ea typeface="PingFang TC"/>
+              </a:rPr>
+              <a:t>tag = SHA</a:t>
+            </a:r>
+          </a:p>
+          <a:p>
+            <a:pPr algn="ctr"/>
+            <a:r>
+              <a:rPr sz="1100" b="0">
+                <a:solidFill>
+                  <a:srgbClr val="FFFFFF"/>
+                </a:solidFill>
+                <a:latin typeface="PingFang TC"/>
+                <a:ea typeface="PingFang TC"/>
+              </a:rPr>
+              <a:t>+ latest</a:t>
+            </a:r>
+          </a:p>
+        </p:txBody>
+      </p:sp>
+      <p:cxnSp>
+        <p:nvCxnSpPr>
+          <p:cNvPr id="11" name="Connector 10"/>
+          <p:cNvCxnSpPr/>
+          <p:nvPr/>
+        </p:nvCxnSpPr>
+        <p:spPr>
+          <a:xfrm>
+            <a:off x="6739128" y="2926080"/>
+            <a:ext cx="118872" cy="0"/>
+          </a:xfrm>
+          <a:prstGeom prst="line">
+            <a:avLst/>
+          </a:prstGeom>
+          <a:ln w="22225">
+            <a:solidFill>
+              <a:srgbClr val="64748B"/>
+            </a:solidFill>
+            <a:tailEnd type="triangle" w="med" len="med"/>
+          </a:ln>
+        </p:spPr>
+        <p:style>
+          <a:lnRef idx="2">
+            <a:schemeClr val="accent1"/>
+          </a:lnRef>
+          <a:fillRef idx="0">
+            <a:schemeClr val="accent1"/>
+          </a:fillRef>
+          <a:effectRef idx="1">
+            <a:schemeClr val="accent1"/>
+          </a:effectRef>
+          <a:fontRef idx="minor">
+            <a:schemeClr val="tx1"/>
+          </a:fontRef>
+        </p:style>
+      </p:cxnSp>
+      <p:sp>
+        <p:nvSpPr>
+          <p:cNvPr id="12" name="Rounded Rectangle 11"/>
+          <p:cNvSpPr/>
+          <p:nvPr/>
+        </p:nvSpPr>
+        <p:spPr>
+          <a:xfrm>
+            <a:off x="6858000" y="2286000"/>
+            <a:ext cx="1481328" cy="1280160"/>
+          </a:xfrm>
+          <a:prstGeom prst="roundRect">
+            <a:avLst/>
+          </a:prstGeom>
+          <a:solidFill>
+            <a:srgbClr val="7C3AED"/>
+          </a:solidFill>
+          <a:ln>
+            <a:solidFill>
+              <a:srgbClr val="7C3AED"/>
+            </a:solidFill>
+          </a:ln>
+          <a:effectLst/>
+        </p:spPr>
+        <p:style>
+          <a:lnRef idx="1">
+            <a:schemeClr val="accent1"/>
+          </a:lnRef>
+          <a:fillRef idx="3">
+            <a:schemeClr val="accent1"/>
+          </a:fillRef>
+          <a:effectRef idx="2">
+            <a:schemeClr val="accent1"/>
+          </a:effectRef>
+          <a:fontRef idx="minor">
+            <a:schemeClr val="lt1"/>
+          </a:fontRef>
+        </p:style>
+        <p:txBody>
+          <a:bodyPr rtlCol="0" anchor="ctr" wrap="square" tIns="25400" bIns="25400"/>
+          <a:lstStyle/>
+          <a:p>
+            <a:pPr algn="ctr"/>
+            <a:r>
+              <a:rPr sz="1100" b="1">
+                <a:solidFill>
+                  <a:srgbClr val="FFFFFF"/>
+                </a:solidFill>
+                <a:latin typeface="PingFang TC"/>
+                <a:ea typeface="PingFang TC"/>
+              </a:rPr>
+              <a:t>SSM 更新</a:t>
+            </a:r>
+          </a:p>
+          <a:p>
+            <a:pPr algn="ctr"/>
+            <a:r>
+              <a:rPr sz="1100" b="0">
+                <a:solidFill>
+                  <a:srgbClr val="FFFFFF"/>
+                </a:solidFill>
+                <a:latin typeface="PingFang TC"/>
+                <a:ea typeface="PingFang TC"/>
+              </a:rPr>
+              <a:t>/qrcode/</a:t>
+            </a:r>
+          </a:p>
+          <a:p>
+            <a:pPr algn="ctr"/>
+            <a:r>
+              <a:rPr sz="1100" b="0">
+                <a:solidFill>
+                  <a:srgbClr val="FFFFFF"/>
+                </a:solidFill>
+                <a:latin typeface="PingFang TC"/>
+                <a:ea typeface="PingFang TC"/>
+              </a:rPr>
+              <a:t>IMAGE_URI</a:t>
+            </a:r>
+          </a:p>
+        </p:txBody>
+      </p:sp>
+      <p:cxnSp>
+        <p:nvCxnSpPr>
+          <p:cNvPr id="13" name="Connector 12"/>
+          <p:cNvCxnSpPr/>
+          <p:nvPr/>
+        </p:nvCxnSpPr>
+        <p:spPr>
+          <a:xfrm>
+            <a:off x="8339328" y="2926080"/>
+            <a:ext cx="118872" cy="0"/>
+          </a:xfrm>
+          <a:prstGeom prst="line">
+            <a:avLst/>
+          </a:prstGeom>
+          <a:ln w="22225">
+            <a:solidFill>
+              <a:srgbClr val="64748B"/>
+            </a:solidFill>
+            <a:tailEnd type="triangle" w="med" len="med"/>
+          </a:ln>
+        </p:spPr>
+        <p:style>
+          <a:lnRef idx="2">
+            <a:schemeClr val="accent1"/>
+          </a:lnRef>
+          <a:fillRef idx="0">
+            <a:schemeClr val="accent1"/>
+          </a:fillRef>
+          <a:effectRef idx="1">
+            <a:schemeClr val="accent1"/>
+          </a:effectRef>
+          <a:fontRef idx="minor">
+            <a:schemeClr val="tx1"/>
+          </a:fontRef>
+        </p:style>
+      </p:cxnSp>
+      <p:sp>
+        <p:nvSpPr>
+          <p:cNvPr id="14" name="Rounded Rectangle 13"/>
+          <p:cNvSpPr/>
+          <p:nvPr/>
+        </p:nvSpPr>
+        <p:spPr>
+          <a:xfrm>
+            <a:off x="8458200" y="2286000"/>
+            <a:ext cx="1481328" cy="1280160"/>
+          </a:xfrm>
+          <a:prstGeom prst="roundRect">
+            <a:avLst/>
+          </a:prstGeom>
+          <a:solidFill>
+            <a:srgbClr val="D97706"/>
+          </a:solidFill>
+          <a:ln>
+            <a:solidFill>
+              <a:srgbClr val="D97706"/>
+            </a:solidFill>
+          </a:ln>
+          <a:effectLst/>
+        </p:spPr>
+        <p:style>
+          <a:lnRef idx="1">
+            <a:schemeClr val="accent1"/>
+          </a:lnRef>
+          <a:fillRef idx="3">
+            <a:schemeClr val="accent1"/>
+          </a:fillRef>
+          <a:effectRef idx="2">
+            <a:schemeClr val="accent1"/>
+          </a:effectRef>
+          <a:fontRef idx="minor">
+            <a:schemeClr val="lt1"/>
+          </a:fontRef>
+        </p:style>
+        <p:txBody>
+          <a:bodyPr rtlCol="0" anchor="ctr" wrap="square" tIns="25400" bIns="25400"/>
+          <a:lstStyle/>
+          <a:p>
+            <a:pPr algn="ctr"/>
+            <a:r>
+              <a:rPr sz="1100" b="1">
+                <a:solidFill>
+                  <a:srgbClr val="FFFFFF"/>
+                </a:solidFill>
+                <a:latin typeface="PingFang TC"/>
+                <a:ea typeface="PingFang TC"/>
+              </a:rPr>
+              <a:t>SSM 部署</a:t>
+            </a:r>
+          </a:p>
+          <a:p>
+            <a:pPr algn="ctr"/>
+            <a:r>
+              <a:rPr sz="1100" b="0">
+                <a:solidFill>
+                  <a:srgbClr val="FFFFFF"/>
+                </a:solidFill>
+                <a:latin typeface="PingFang TC"/>
+                <a:ea typeface="PingFang TC"/>
+              </a:rPr>
+              <a:t>→ EC2</a:t>
+            </a:r>
+          </a:p>
+          <a:p>
+            <a:pPr algn="ctr"/>
+            <a:r>
+              <a:rPr sz="1100" b="0">
+                <a:solidFill>
+                  <a:srgbClr val="FFFFFF"/>
+                </a:solidFill>
+                <a:latin typeface="PingFang TC"/>
+                <a:ea typeface="PingFang TC"/>
+              </a:rPr>
+              <a:t>deploy-app.sh</a:t>
+            </a:r>
+          </a:p>
+        </p:txBody>
+      </p:sp>
+      <p:cxnSp>
+        <p:nvCxnSpPr>
+          <p:cNvPr id="15" name="Connector 14"/>
+          <p:cNvCxnSpPr/>
+          <p:nvPr/>
+        </p:nvCxnSpPr>
+        <p:spPr>
+          <a:xfrm>
+            <a:off x="9939528" y="2926080"/>
+            <a:ext cx="118872" cy="0"/>
+          </a:xfrm>
+          <a:prstGeom prst="line">
+            <a:avLst/>
+          </a:prstGeom>
+          <a:ln w="22225">
+            <a:solidFill>
+              <a:srgbClr val="64748B"/>
+            </a:solidFill>
+            <a:tailEnd type="triangle" w="med" len="med"/>
+          </a:ln>
+        </p:spPr>
+        <p:style>
+          <a:lnRef idx="2">
+            <a:schemeClr val="accent1"/>
+          </a:lnRef>
+          <a:fillRef idx="0">
+            <a:schemeClr val="accent1"/>
+          </a:fillRef>
+          <a:effectRef idx="1">
+            <a:schemeClr val="accent1"/>
+          </a:effectRef>
+          <a:fontRef idx="minor">
+            <a:schemeClr val="tx1"/>
+          </a:fontRef>
+        </p:style>
+      </p:cxnSp>
+      <p:sp>
+        <p:nvSpPr>
+          <p:cNvPr id="16" name="Rounded Rectangle 15"/>
+          <p:cNvSpPr/>
+          <p:nvPr/>
+        </p:nvSpPr>
+        <p:spPr>
+          <a:xfrm>
+            <a:off x="10058400" y="2286000"/>
+            <a:ext cx="1481328" cy="1280160"/>
+          </a:xfrm>
+          <a:prstGeom prst="roundRect">
+            <a:avLst/>
+          </a:prstGeom>
+          <a:solidFill>
+            <a:srgbClr val="059669"/>
+          </a:solidFill>
+          <a:ln>
+            <a:solidFill>
+              <a:srgbClr val="059669"/>
+            </a:solidFill>
+          </a:ln>
+          <a:effectLst/>
+        </p:spPr>
+        <p:style>
+          <a:lnRef idx="1">
+            <a:schemeClr val="accent1"/>
+          </a:lnRef>
+          <a:fillRef idx="3">
+            <a:schemeClr val="accent1"/>
+          </a:fillRef>
+          <a:effectRef idx="2">
+            <a:schemeClr val="accent1"/>
+          </a:effectRef>
+          <a:fontRef idx="minor">
+            <a:schemeClr val="lt1"/>
+          </a:fontRef>
+        </p:style>
+        <p:txBody>
+          <a:bodyPr rtlCol="0" anchor="ctr" wrap="square" tIns="25400" bIns="25400"/>
+          <a:lstStyle/>
+          <a:p>
+            <a:pPr algn="ctr"/>
+            <a:r>
+              <a:rPr sz="1100" b="1">
+                <a:solidFill>
+                  <a:srgbClr val="FFFFFF"/>
+                </a:solidFill>
+                <a:latin typeface="PingFang TC"/>
+                <a:ea typeface="PingFang TC"/>
+              </a:rPr>
+              <a:t>上線</a:t>
+            </a:r>
+          </a:p>
+          <a:p>
+            <a:pPr algn="ctr"/>
+            <a:r>
+              <a:rPr sz="1100" b="0">
+                <a:solidFill>
+                  <a:srgbClr val="FFFFFF"/>
+                </a:solidFill>
+                <a:latin typeface="PingFang TC"/>
+                <a:ea typeface="PingFang TC"/>
+              </a:rPr>
+              <a:t>ALB /health</a:t>
+            </a:r>
+          </a:p>
+          <a:p>
+            <a:pPr algn="ctr"/>
+            <a:r>
+              <a:rPr sz="1100" b="0">
+                <a:solidFill>
+                  <a:srgbClr val="FFFFFF"/>
+                </a:solidFill>
+                <a:latin typeface="PingFang TC"/>
+                <a:ea typeface="PingFang TC"/>
+              </a:rPr>
+              <a:t>通過</a:t>
+            </a:r>
+          </a:p>
+        </p:txBody>
+      </p:sp>
+      <p:sp>
+        <p:nvSpPr>
+          <p:cNvPr id="17" name="TextBox 16"/>
+          <p:cNvSpPr txBox="1"/>
+          <p:nvPr/>
+        </p:nvSpPr>
+        <p:spPr>
+          <a:xfrm>
+            <a:off x="548640" y="4023360"/>
+            <a:ext cx="11247120" cy="2194560"/>
+          </a:xfrm>
+          <a:prstGeom prst="rect">
+            <a:avLst/>
+          </a:prstGeom>
+          <a:noFill/>
+        </p:spPr>
+        <p:txBody>
+          <a:bodyPr wrap="square">
+            <a:spAutoFit/>
+          </a:bodyPr>
+          <a:lstStyle/>
+          <a:p>
+            <a:pPr>
+              <a:spcAft>
+                <a:spcPts val="900"/>
+              </a:spcAft>
+            </a:pPr>
+            <a:r>
+              <a:rPr sz="1400" b="0">
+                <a:solidFill>
+                  <a:srgbClr val="0F172A"/>
+                </a:solidFill>
+                <a:latin typeface="PingFang TC"/>
+                <a:ea typeface="PingFang TC"/>
+              </a:rPr>
+              <a:t>•  EC2 deploy-app.sh:從 SSM 撈設定 → ECR login → docker pull → docker run(換新容器)</a:t>
+            </a:r>
+          </a:p>
+          <a:p>
+            <a:pPr>
+              <a:spcAft>
+                <a:spcPts val="900"/>
+              </a:spcAft>
+            </a:pPr>
+            <a:r>
+              <a:rPr sz="1400" b="0">
+                <a:solidFill>
+                  <a:srgbClr val="0F172A"/>
+                </a:solidFill>
+                <a:latin typeface="PingFang TC"/>
+                <a:ea typeface="PingFang TC"/>
+              </a:rPr>
+              <a:t>•  全 env-gated:本機無這些環境變數 → 維持 SQLite + 記憶體 cache + 即時生圖,不受影響</a:t>
+            </a:r>
+          </a:p>
+          <a:p>
+            <a:pPr>
+              <a:spcAft>
+                <a:spcPts val="900"/>
+              </a:spcAft>
+            </a:pPr>
+            <a:r>
+              <a:rPr sz="1400" b="0">
+                <a:solidFill>
+                  <a:srgbClr val="0F172A"/>
+                </a:solidFill>
+                <a:latin typeface="PingFang TC"/>
+                <a:ea typeface="PingFang TC"/>
+              </a:rPr>
+              <a:t>•  部署踩到的兩個坑:① EC2 role 少 s3:PutObject(500)② CI build amd64 但 EC2 arm64(502)→ buildx 跨平台修正</a:t>
+            </a:r>
+          </a:p>
+        </p:txBody>
+      </p:sp>
+    </p:spTree>
+  </p:cSld>
+  <p:clrMapOvr>
+    <a:masterClrMapping/>
+  </p:clrMapOvr>
+</p:sld>
+</file>
+
+<file path=ppt/slides/slide26.xml><?xml version="1.0" encoding="utf-8"?>
+<p:sld xmlns:a="http://schemas.openxmlformats.org/drawingml/2006/main" xmlns:p="http://schemas.openxmlformats.org/presentationml/2006/main" xmlns:r="http://schemas.openxmlformats.org/officeDocument/2006/relationships">
+  <p:cSld>
+    <p:spTree>
+      <p:nvGrpSpPr>
+        <p:cNvPr id="1" name=""/>
+        <p:cNvGrpSpPr/>
+        <p:nvPr/>
+      </p:nvGrpSpPr>
+      <p:grpSpPr/>
+      <p:sp>
+        <p:nvSpPr>
+          <p:cNvPr id="2" name="Rectangle 1"/>
+          <p:cNvSpPr/>
+          <p:nvPr/>
+        </p:nvSpPr>
+        <p:spPr>
+          <a:xfrm>
+            <a:off x="0" y="0"/>
             <a:ext cx="12191695" cy="6858000"/>
           </a:xfrm>
           <a:prstGeom prst="rect">
@@ -15199,6 +16249,1479 @@
                 <a:ea typeface="PingFang TC"/>
               </a:rPr>
               <a:t>✓  設計依據：DESIGN.md（16 題決策 + 優劣分析）</a:t>
+            </a:r>
+          </a:p>
+        </p:txBody>
+      </p:sp>
+    </p:spTree>
+  </p:cSld>
+  <p:clrMapOvr>
+    <a:masterClrMapping/>
+  </p:clrMapOvr>
+</p:sld>
+</file>
+
+<file path=ppt/slides/slide27.xml><?xml version="1.0" encoding="utf-8"?>
+<p:sld xmlns:a="http://schemas.openxmlformats.org/drawingml/2006/main" xmlns:p="http://schemas.openxmlformats.org/presentationml/2006/main" xmlns:r="http://schemas.openxmlformats.org/officeDocument/2006/relationships">
+  <p:cSld>
+    <p:spTree>
+      <p:nvGrpSpPr>
+        <p:cNvPr id="1" name=""/>
+        <p:cNvGrpSpPr/>
+        <p:nvPr/>
+      </p:nvGrpSpPr>
+      <p:grpSpPr/>
+      <p:sp>
+        <p:nvSpPr>
+          <p:cNvPr id="2" name="Rectangle 1"/>
+          <p:cNvSpPr/>
+          <p:nvPr/>
+        </p:nvSpPr>
+        <p:spPr>
+          <a:xfrm>
+            <a:off x="0" y="0"/>
+            <a:ext cx="164592" cy="6858000"/>
+          </a:xfrm>
+          <a:prstGeom prst="rect">
+            <a:avLst/>
+          </a:prstGeom>
+          <a:solidFill>
+            <a:srgbClr val="2563EB"/>
+          </a:solidFill>
+          <a:ln>
+            <a:noFill/>
+          </a:ln>
+          <a:effectLst/>
+        </p:spPr>
+        <p:style>
+          <a:lnRef idx="1">
+            <a:schemeClr val="accent1"/>
+          </a:lnRef>
+          <a:fillRef idx="3">
+            <a:schemeClr val="accent1"/>
+          </a:fillRef>
+          <a:effectRef idx="2">
+            <a:schemeClr val="accent1"/>
+          </a:effectRef>
+          <a:fontRef idx="minor">
+            <a:schemeClr val="lt1"/>
+          </a:fontRef>
+        </p:style>
+        <p:txBody>
+          <a:bodyPr rtlCol="0" anchor="ctr"/>
+          <a:lstStyle/>
+          <a:p>
+            <a:pPr algn="ctr"/>
+          </a:p>
+        </p:txBody>
+      </p:sp>
+      <p:sp>
+        <p:nvSpPr>
+          <p:cNvPr id="3" name="TextBox 2"/>
+          <p:cNvSpPr txBox="1"/>
+          <p:nvPr/>
+        </p:nvSpPr>
+        <p:spPr>
+          <a:xfrm>
+            <a:off x="502920" y="320040"/>
+            <a:ext cx="10972800" cy="1005840"/>
+          </a:xfrm>
+          <a:prstGeom prst="rect">
+            <a:avLst/>
+          </a:prstGeom>
+          <a:noFill/>
+        </p:spPr>
+        <p:txBody>
+          <a:bodyPr wrap="square" anchor="t">
+            <a:spAutoFit/>
+          </a:bodyPr>
+          <a:lstStyle/>
+          <a:p>
+            <a:pPr algn="l">
+              <a:spcAft>
+                <a:spcPts val="200"/>
+              </a:spcAft>
+            </a:pPr>
+            <a:r>
+              <a:rPr sz="1300" b="1">
+                <a:solidFill>
+                  <a:srgbClr val="2563EB"/>
+                </a:solidFill>
+                <a:latin typeface="PingFang TC"/>
+                <a:ea typeface="PingFang TC"/>
+              </a:rPr>
+              <a:t>下週預告 · NEXT WEEK</a:t>
+            </a:r>
+          </a:p>
+          <a:p>
+            <a:pPr algn="l">
+              <a:spcAft>
+                <a:spcPts val="400"/>
+              </a:spcAft>
+            </a:pPr>
+            <a:r>
+              <a:rPr sz="3000" b="1">
+                <a:solidFill>
+                  <a:srgbClr val="0F172A"/>
+                </a:solidFill>
+                <a:latin typeface="PingFang TC"/>
+                <a:ea typeface="PingFang TC"/>
+              </a:rPr>
+              <a:t>從 Prototype 到 Production 的巨大鴻溝</a:t>
+            </a:r>
+          </a:p>
+        </p:txBody>
+      </p:sp>
+      <p:sp>
+        <p:nvSpPr>
+          <p:cNvPr id="4" name="TextBox 3"/>
+          <p:cNvSpPr txBox="1"/>
+          <p:nvPr/>
+        </p:nvSpPr>
+        <p:spPr>
+          <a:xfrm>
+            <a:off x="548640" y="1371600"/>
+            <a:ext cx="10972800" cy="365760"/>
+          </a:xfrm>
+          <a:prstGeom prst="rect">
+            <a:avLst/>
+          </a:prstGeom>
+          <a:noFill/>
+        </p:spPr>
+        <p:txBody>
+          <a:bodyPr wrap="square" anchor="t">
+            <a:spAutoFit/>
+          </a:bodyPr>
+          <a:lstStyle/>
+          <a:p>
+            <a:pPr algn="l">
+              <a:spcAft>
+                <a:spcPts val="400"/>
+              </a:spcAft>
+            </a:pPr>
+            <a:r>
+              <a:rPr sz="1400" b="0">
+                <a:solidFill>
+                  <a:srgbClr val="64748B"/>
+                </a:solidFill>
+                <a:latin typeface="PingFang TC"/>
+                <a:ea typeface="PingFang TC"/>
+              </a:rPr>
+              <a:t>快速掃過，建立全貌 — 下週 Deep Dive 才是主菜</a:t>
+            </a:r>
+          </a:p>
+        </p:txBody>
+      </p:sp>
+      <p:sp>
+        <p:nvSpPr>
+          <p:cNvPr id="5" name="Rounded Rectangle 4"/>
+          <p:cNvSpPr/>
+          <p:nvPr/>
+        </p:nvSpPr>
+        <p:spPr>
+          <a:xfrm>
+            <a:off x="548640" y="1965960"/>
+            <a:ext cx="3611880" cy="1600200"/>
+          </a:xfrm>
+          <a:prstGeom prst="roundRect">
+            <a:avLst/>
+          </a:prstGeom>
+          <a:solidFill>
+            <a:srgbClr val="F1F5F9"/>
+          </a:solidFill>
+          <a:ln>
+            <a:solidFill>
+              <a:srgbClr val="F1F5F9"/>
+            </a:solidFill>
+          </a:ln>
+          <a:effectLst/>
+        </p:spPr>
+        <p:style>
+          <a:lnRef idx="1">
+            <a:schemeClr val="accent1"/>
+          </a:lnRef>
+          <a:fillRef idx="3">
+            <a:schemeClr val="accent1"/>
+          </a:fillRef>
+          <a:effectRef idx="2">
+            <a:schemeClr val="accent1"/>
+          </a:effectRef>
+          <a:fontRef idx="minor">
+            <a:schemeClr val="lt1"/>
+          </a:fontRef>
+        </p:style>
+        <p:txBody>
+          <a:bodyPr rtlCol="0" anchor="ctr"/>
+          <a:lstStyle/>
+          <a:p>
+            <a:pPr algn="ctr"/>
+          </a:p>
+        </p:txBody>
+      </p:sp>
+      <p:sp>
+        <p:nvSpPr>
+          <p:cNvPr id="6" name="Rectangle 5"/>
+          <p:cNvSpPr/>
+          <p:nvPr/>
+        </p:nvSpPr>
+        <p:spPr>
+          <a:xfrm>
+            <a:off x="548640" y="1965960"/>
+            <a:ext cx="82296" cy="1600200"/>
+          </a:xfrm>
+          <a:prstGeom prst="rect">
+            <a:avLst/>
+          </a:prstGeom>
+          <a:solidFill>
+            <a:srgbClr val="D97706"/>
+          </a:solidFill>
+          <a:ln>
+            <a:noFill/>
+          </a:ln>
+          <a:effectLst/>
+        </p:spPr>
+        <p:style>
+          <a:lnRef idx="1">
+            <a:schemeClr val="accent1"/>
+          </a:lnRef>
+          <a:fillRef idx="3">
+            <a:schemeClr val="accent1"/>
+          </a:fillRef>
+          <a:effectRef idx="2">
+            <a:schemeClr val="accent1"/>
+          </a:effectRef>
+          <a:fontRef idx="minor">
+            <a:schemeClr val="lt1"/>
+          </a:fontRef>
+        </p:style>
+        <p:txBody>
+          <a:bodyPr rtlCol="0" anchor="ctr"/>
+          <a:lstStyle/>
+          <a:p>
+            <a:pPr algn="ctr"/>
+          </a:p>
+        </p:txBody>
+      </p:sp>
+      <p:sp>
+        <p:nvSpPr>
+          <p:cNvPr id="7" name="TextBox 6"/>
+          <p:cNvSpPr txBox="1"/>
+          <p:nvPr/>
+        </p:nvSpPr>
+        <p:spPr>
+          <a:xfrm>
+            <a:off x="822960" y="2148840"/>
+            <a:ext cx="3154680" cy="1325880"/>
+          </a:xfrm>
+          <a:prstGeom prst="rect">
+            <a:avLst/>
+          </a:prstGeom>
+          <a:noFill/>
+        </p:spPr>
+        <p:txBody>
+          <a:bodyPr wrap="square" anchor="t">
+            <a:spAutoFit/>
+          </a:bodyPr>
+          <a:lstStyle/>
+          <a:p>
+            <a:pPr algn="l">
+              <a:spcAft>
+                <a:spcPts val="800"/>
+              </a:spcAft>
+            </a:pPr>
+            <a:r>
+              <a:rPr sz="1600" b="1">
+                <a:solidFill>
+                  <a:srgbClr val="0F172A"/>
+                </a:solidFill>
+                <a:latin typeface="PingFang TC"/>
+                <a:ea typeface="PingFang TC"/>
+              </a:rPr>
+              <a:t>[Error Handling]</a:t>
+            </a:r>
+          </a:p>
+          <a:p>
+            <a:pPr algn="l">
+              <a:spcAft>
+                <a:spcPts val="400"/>
+              </a:spcAft>
+            </a:pPr>
+            <a:r>
+              <a:rPr sz="1300" b="0">
+                <a:solidFill>
+                  <a:srgbClr val="64748B"/>
+                </a:solidFill>
+                <a:latin typeface="PingFang TC"/>
+                <a:ea typeface="PingFang TC"/>
+              </a:rPr>
+              <a:t>遇到不合法輸入直接 Crash。</a:t>
+            </a:r>
+          </a:p>
+        </p:txBody>
+      </p:sp>
+      <p:sp>
+        <p:nvSpPr>
+          <p:cNvPr id="8" name="Rounded Rectangle 7"/>
+          <p:cNvSpPr/>
+          <p:nvPr/>
+        </p:nvSpPr>
+        <p:spPr>
+          <a:xfrm>
+            <a:off x="4407408" y="1965960"/>
+            <a:ext cx="3611880" cy="1600200"/>
+          </a:xfrm>
+          <a:prstGeom prst="roundRect">
+            <a:avLst/>
+          </a:prstGeom>
+          <a:solidFill>
+            <a:srgbClr val="F1F5F9"/>
+          </a:solidFill>
+          <a:ln>
+            <a:solidFill>
+              <a:srgbClr val="F1F5F9"/>
+            </a:solidFill>
+          </a:ln>
+          <a:effectLst/>
+        </p:spPr>
+        <p:style>
+          <a:lnRef idx="1">
+            <a:schemeClr val="accent1"/>
+          </a:lnRef>
+          <a:fillRef idx="3">
+            <a:schemeClr val="accent1"/>
+          </a:fillRef>
+          <a:effectRef idx="2">
+            <a:schemeClr val="accent1"/>
+          </a:effectRef>
+          <a:fontRef idx="minor">
+            <a:schemeClr val="lt1"/>
+          </a:fontRef>
+        </p:style>
+        <p:txBody>
+          <a:bodyPr rtlCol="0" anchor="ctr"/>
+          <a:lstStyle/>
+          <a:p>
+            <a:pPr algn="ctr"/>
+          </a:p>
+        </p:txBody>
+      </p:sp>
+      <p:sp>
+        <p:nvSpPr>
+          <p:cNvPr id="9" name="Rectangle 8"/>
+          <p:cNvSpPr/>
+          <p:nvPr/>
+        </p:nvSpPr>
+        <p:spPr>
+          <a:xfrm>
+            <a:off x="4407408" y="1965960"/>
+            <a:ext cx="82296" cy="1600200"/>
+          </a:xfrm>
+          <a:prstGeom prst="rect">
+            <a:avLst/>
+          </a:prstGeom>
+          <a:solidFill>
+            <a:srgbClr val="D97706"/>
+          </a:solidFill>
+          <a:ln>
+            <a:noFill/>
+          </a:ln>
+          <a:effectLst/>
+        </p:spPr>
+        <p:style>
+          <a:lnRef idx="1">
+            <a:schemeClr val="accent1"/>
+          </a:lnRef>
+          <a:fillRef idx="3">
+            <a:schemeClr val="accent1"/>
+          </a:fillRef>
+          <a:effectRef idx="2">
+            <a:schemeClr val="accent1"/>
+          </a:effectRef>
+          <a:fontRef idx="minor">
+            <a:schemeClr val="lt1"/>
+          </a:fontRef>
+        </p:style>
+        <p:txBody>
+          <a:bodyPr rtlCol="0" anchor="ctr"/>
+          <a:lstStyle/>
+          <a:p>
+            <a:pPr algn="ctr"/>
+          </a:p>
+        </p:txBody>
+      </p:sp>
+      <p:sp>
+        <p:nvSpPr>
+          <p:cNvPr id="10" name="TextBox 9"/>
+          <p:cNvSpPr txBox="1"/>
+          <p:nvPr/>
+        </p:nvSpPr>
+        <p:spPr>
+          <a:xfrm>
+            <a:off x="4681728" y="2148840"/>
+            <a:ext cx="3154680" cy="1325880"/>
+          </a:xfrm>
+          <a:prstGeom prst="rect">
+            <a:avLst/>
+          </a:prstGeom>
+          <a:noFill/>
+        </p:spPr>
+        <p:txBody>
+          <a:bodyPr wrap="square" anchor="t">
+            <a:spAutoFit/>
+          </a:bodyPr>
+          <a:lstStyle/>
+          <a:p>
+            <a:pPr algn="l">
+              <a:spcAft>
+                <a:spcPts val="800"/>
+              </a:spcAft>
+            </a:pPr>
+            <a:r>
+              <a:rPr sz="1600" b="1">
+                <a:solidFill>
+                  <a:srgbClr val="0F172A"/>
+                </a:solidFill>
+                <a:latin typeface="PingFang TC"/>
+                <a:ea typeface="PingFang TC"/>
+              </a:rPr>
+              <a:t>[Rate Limiting]</a:t>
+            </a:r>
+          </a:p>
+          <a:p>
+            <a:pPr algn="l">
+              <a:spcAft>
+                <a:spcPts val="400"/>
+              </a:spcAft>
+            </a:pPr>
+            <a:r>
+              <a:rPr sz="1300" b="0">
+                <a:solidFill>
+                  <a:srgbClr val="64748B"/>
+                </a:solidFill>
+                <a:latin typeface="PingFang TC"/>
+                <a:ea typeface="PingFang TC"/>
+              </a:rPr>
+              <a:t>毫無防護，極易被 Script 惡意灌爆 API。</a:t>
+            </a:r>
+          </a:p>
+        </p:txBody>
+      </p:sp>
+      <p:sp>
+        <p:nvSpPr>
+          <p:cNvPr id="11" name="Rounded Rectangle 10"/>
+          <p:cNvSpPr/>
+          <p:nvPr/>
+        </p:nvSpPr>
+        <p:spPr>
+          <a:xfrm>
+            <a:off x="8266176" y="1965960"/>
+            <a:ext cx="3611880" cy="1600200"/>
+          </a:xfrm>
+          <a:prstGeom prst="roundRect">
+            <a:avLst/>
+          </a:prstGeom>
+          <a:solidFill>
+            <a:srgbClr val="F1F5F9"/>
+          </a:solidFill>
+          <a:ln>
+            <a:solidFill>
+              <a:srgbClr val="F1F5F9"/>
+            </a:solidFill>
+          </a:ln>
+          <a:effectLst/>
+        </p:spPr>
+        <p:style>
+          <a:lnRef idx="1">
+            <a:schemeClr val="accent1"/>
+          </a:lnRef>
+          <a:fillRef idx="3">
+            <a:schemeClr val="accent1"/>
+          </a:fillRef>
+          <a:effectRef idx="2">
+            <a:schemeClr val="accent1"/>
+          </a:effectRef>
+          <a:fontRef idx="minor">
+            <a:schemeClr val="lt1"/>
+          </a:fontRef>
+        </p:style>
+        <p:txBody>
+          <a:bodyPr rtlCol="0" anchor="ctr"/>
+          <a:lstStyle/>
+          <a:p>
+            <a:pPr algn="ctr"/>
+          </a:p>
+        </p:txBody>
+      </p:sp>
+      <p:sp>
+        <p:nvSpPr>
+          <p:cNvPr id="12" name="Rectangle 11"/>
+          <p:cNvSpPr/>
+          <p:nvPr/>
+        </p:nvSpPr>
+        <p:spPr>
+          <a:xfrm>
+            <a:off x="8266176" y="1965960"/>
+            <a:ext cx="82296" cy="1600200"/>
+          </a:xfrm>
+          <a:prstGeom prst="rect">
+            <a:avLst/>
+          </a:prstGeom>
+          <a:solidFill>
+            <a:srgbClr val="D97706"/>
+          </a:solidFill>
+          <a:ln>
+            <a:noFill/>
+          </a:ln>
+          <a:effectLst/>
+        </p:spPr>
+        <p:style>
+          <a:lnRef idx="1">
+            <a:schemeClr val="accent1"/>
+          </a:lnRef>
+          <a:fillRef idx="3">
+            <a:schemeClr val="accent1"/>
+          </a:fillRef>
+          <a:effectRef idx="2">
+            <a:schemeClr val="accent1"/>
+          </a:effectRef>
+          <a:fontRef idx="minor">
+            <a:schemeClr val="lt1"/>
+          </a:fontRef>
+        </p:style>
+        <p:txBody>
+          <a:bodyPr rtlCol="0" anchor="ctr"/>
+          <a:lstStyle/>
+          <a:p>
+            <a:pPr algn="ctr"/>
+          </a:p>
+        </p:txBody>
+      </p:sp>
+      <p:sp>
+        <p:nvSpPr>
+          <p:cNvPr id="13" name="TextBox 12"/>
+          <p:cNvSpPr txBox="1"/>
+          <p:nvPr/>
+        </p:nvSpPr>
+        <p:spPr>
+          <a:xfrm>
+            <a:off x="8540496" y="2148840"/>
+            <a:ext cx="3154680" cy="1325880"/>
+          </a:xfrm>
+          <a:prstGeom prst="rect">
+            <a:avLst/>
+          </a:prstGeom>
+          <a:noFill/>
+        </p:spPr>
+        <p:txBody>
+          <a:bodyPr wrap="square" anchor="t">
+            <a:spAutoFit/>
+          </a:bodyPr>
+          <a:lstStyle/>
+          <a:p>
+            <a:pPr algn="l">
+              <a:spcAft>
+                <a:spcPts val="800"/>
+              </a:spcAft>
+            </a:pPr>
+            <a:r>
+              <a:rPr sz="1600" b="1">
+                <a:solidFill>
+                  <a:srgbClr val="0F172A"/>
+                </a:solidFill>
+                <a:latin typeface="PingFang TC"/>
+                <a:ea typeface="PingFang TC"/>
+              </a:rPr>
+              <a:t>[Auth &amp; Isolation]</a:t>
+            </a:r>
+          </a:p>
+          <a:p>
+            <a:pPr algn="l">
+              <a:spcAft>
+                <a:spcPts val="400"/>
+              </a:spcAft>
+            </a:pPr>
+            <a:r>
+              <a:rPr sz="1300" b="0">
+                <a:solidFill>
+                  <a:srgbClr val="64748B"/>
+                </a:solidFill>
+                <a:latin typeface="PingFang TC"/>
+                <a:ea typeface="PingFang TC"/>
+              </a:rPr>
+              <a:t>缺乏多租戶概念，資料全公開。</a:t>
+            </a:r>
+          </a:p>
+        </p:txBody>
+      </p:sp>
+      <p:sp>
+        <p:nvSpPr>
+          <p:cNvPr id="14" name="Rounded Rectangle 13"/>
+          <p:cNvSpPr/>
+          <p:nvPr/>
+        </p:nvSpPr>
+        <p:spPr>
+          <a:xfrm>
+            <a:off x="548640" y="3840480"/>
+            <a:ext cx="3611880" cy="1600200"/>
+          </a:xfrm>
+          <a:prstGeom prst="roundRect">
+            <a:avLst/>
+          </a:prstGeom>
+          <a:solidFill>
+            <a:srgbClr val="F1F5F9"/>
+          </a:solidFill>
+          <a:ln>
+            <a:solidFill>
+              <a:srgbClr val="F1F5F9"/>
+            </a:solidFill>
+          </a:ln>
+          <a:effectLst/>
+        </p:spPr>
+        <p:style>
+          <a:lnRef idx="1">
+            <a:schemeClr val="accent1"/>
+          </a:lnRef>
+          <a:fillRef idx="3">
+            <a:schemeClr val="accent1"/>
+          </a:fillRef>
+          <a:effectRef idx="2">
+            <a:schemeClr val="accent1"/>
+          </a:effectRef>
+          <a:fontRef idx="minor">
+            <a:schemeClr val="lt1"/>
+          </a:fontRef>
+        </p:style>
+        <p:txBody>
+          <a:bodyPr rtlCol="0" anchor="ctr"/>
+          <a:lstStyle/>
+          <a:p>
+            <a:pPr algn="ctr"/>
+          </a:p>
+        </p:txBody>
+      </p:sp>
+      <p:sp>
+        <p:nvSpPr>
+          <p:cNvPr id="15" name="Rectangle 14"/>
+          <p:cNvSpPr/>
+          <p:nvPr/>
+        </p:nvSpPr>
+        <p:spPr>
+          <a:xfrm>
+            <a:off x="548640" y="3840480"/>
+            <a:ext cx="82296" cy="1600200"/>
+          </a:xfrm>
+          <a:prstGeom prst="rect">
+            <a:avLst/>
+          </a:prstGeom>
+          <a:solidFill>
+            <a:srgbClr val="0EA5E9"/>
+          </a:solidFill>
+          <a:ln>
+            <a:noFill/>
+          </a:ln>
+          <a:effectLst/>
+        </p:spPr>
+        <p:style>
+          <a:lnRef idx="1">
+            <a:schemeClr val="accent1"/>
+          </a:lnRef>
+          <a:fillRef idx="3">
+            <a:schemeClr val="accent1"/>
+          </a:fillRef>
+          <a:effectRef idx="2">
+            <a:schemeClr val="accent1"/>
+          </a:effectRef>
+          <a:fontRef idx="minor">
+            <a:schemeClr val="lt1"/>
+          </a:fontRef>
+        </p:style>
+        <p:txBody>
+          <a:bodyPr rtlCol="0" anchor="ctr"/>
+          <a:lstStyle/>
+          <a:p>
+            <a:pPr algn="ctr"/>
+          </a:p>
+        </p:txBody>
+      </p:sp>
+      <p:sp>
+        <p:nvSpPr>
+          <p:cNvPr id="16" name="TextBox 15"/>
+          <p:cNvSpPr txBox="1"/>
+          <p:nvPr/>
+        </p:nvSpPr>
+        <p:spPr>
+          <a:xfrm>
+            <a:off x="822960" y="4023360"/>
+            <a:ext cx="3154680" cy="1325880"/>
+          </a:xfrm>
+          <a:prstGeom prst="rect">
+            <a:avLst/>
+          </a:prstGeom>
+          <a:noFill/>
+        </p:spPr>
+        <p:txBody>
+          <a:bodyPr wrap="square" anchor="t">
+            <a:spAutoFit/>
+          </a:bodyPr>
+          <a:lstStyle/>
+          <a:p>
+            <a:pPr algn="l">
+              <a:spcAft>
+                <a:spcPts val="800"/>
+              </a:spcAft>
+            </a:pPr>
+            <a:r>
+              <a:rPr sz="1600" b="1">
+                <a:solidFill>
+                  <a:srgbClr val="0F172A"/>
+                </a:solidFill>
+                <a:latin typeface="PingFang TC"/>
+                <a:ea typeface="PingFang TC"/>
+              </a:rPr>
+              <a:t>[Monitoring]</a:t>
+            </a:r>
+          </a:p>
+          <a:p>
+            <a:pPr algn="l">
+              <a:spcAft>
+                <a:spcPts val="400"/>
+              </a:spcAft>
+            </a:pPr>
+            <a:r>
+              <a:rPr sz="1300" b="0">
+                <a:solidFill>
+                  <a:srgbClr val="64748B"/>
+                </a:solidFill>
+                <a:latin typeface="PingFang TC"/>
+                <a:ea typeface="PingFang TC"/>
+              </a:rPr>
+              <a:t>服務掛了完全沒有 Alerting，處於盲飛狀態。</a:t>
+            </a:r>
+          </a:p>
+        </p:txBody>
+      </p:sp>
+      <p:sp>
+        <p:nvSpPr>
+          <p:cNvPr id="17" name="Rounded Rectangle 16"/>
+          <p:cNvSpPr/>
+          <p:nvPr/>
+        </p:nvSpPr>
+        <p:spPr>
+          <a:xfrm>
+            <a:off x="4407408" y="3840480"/>
+            <a:ext cx="3611880" cy="1600200"/>
+          </a:xfrm>
+          <a:prstGeom prst="roundRect">
+            <a:avLst/>
+          </a:prstGeom>
+          <a:solidFill>
+            <a:srgbClr val="F1F5F9"/>
+          </a:solidFill>
+          <a:ln>
+            <a:solidFill>
+              <a:srgbClr val="F1F5F9"/>
+            </a:solidFill>
+          </a:ln>
+          <a:effectLst/>
+        </p:spPr>
+        <p:style>
+          <a:lnRef idx="1">
+            <a:schemeClr val="accent1"/>
+          </a:lnRef>
+          <a:fillRef idx="3">
+            <a:schemeClr val="accent1"/>
+          </a:fillRef>
+          <a:effectRef idx="2">
+            <a:schemeClr val="accent1"/>
+          </a:effectRef>
+          <a:fontRef idx="minor">
+            <a:schemeClr val="lt1"/>
+          </a:fontRef>
+        </p:style>
+        <p:txBody>
+          <a:bodyPr rtlCol="0" anchor="ctr"/>
+          <a:lstStyle/>
+          <a:p>
+            <a:pPr algn="ctr"/>
+          </a:p>
+        </p:txBody>
+      </p:sp>
+      <p:sp>
+        <p:nvSpPr>
+          <p:cNvPr id="18" name="Rectangle 17"/>
+          <p:cNvSpPr/>
+          <p:nvPr/>
+        </p:nvSpPr>
+        <p:spPr>
+          <a:xfrm>
+            <a:off x="4407408" y="3840480"/>
+            <a:ext cx="82296" cy="1600200"/>
+          </a:xfrm>
+          <a:prstGeom prst="rect">
+            <a:avLst/>
+          </a:prstGeom>
+          <a:solidFill>
+            <a:srgbClr val="0EA5E9"/>
+          </a:solidFill>
+          <a:ln>
+            <a:noFill/>
+          </a:ln>
+          <a:effectLst/>
+        </p:spPr>
+        <p:style>
+          <a:lnRef idx="1">
+            <a:schemeClr val="accent1"/>
+          </a:lnRef>
+          <a:fillRef idx="3">
+            <a:schemeClr val="accent1"/>
+          </a:fillRef>
+          <a:effectRef idx="2">
+            <a:schemeClr val="accent1"/>
+          </a:effectRef>
+          <a:fontRef idx="minor">
+            <a:schemeClr val="lt1"/>
+          </a:fontRef>
+        </p:style>
+        <p:txBody>
+          <a:bodyPr rtlCol="0" anchor="ctr"/>
+          <a:lstStyle/>
+          <a:p>
+            <a:pPr algn="ctr"/>
+          </a:p>
+        </p:txBody>
+      </p:sp>
+      <p:sp>
+        <p:nvSpPr>
+          <p:cNvPr id="19" name="TextBox 18"/>
+          <p:cNvSpPr txBox="1"/>
+          <p:nvPr/>
+        </p:nvSpPr>
+        <p:spPr>
+          <a:xfrm>
+            <a:off x="4681728" y="4023360"/>
+            <a:ext cx="3154680" cy="1325880"/>
+          </a:xfrm>
+          <a:prstGeom prst="rect">
+            <a:avLst/>
+          </a:prstGeom>
+          <a:noFill/>
+        </p:spPr>
+        <p:txBody>
+          <a:bodyPr wrap="square" anchor="t">
+            <a:spAutoFit/>
+          </a:bodyPr>
+          <a:lstStyle/>
+          <a:p>
+            <a:pPr algn="l">
+              <a:spcAft>
+                <a:spcPts val="800"/>
+              </a:spcAft>
+            </a:pPr>
+            <a:r>
+              <a:rPr sz="1600" b="1">
+                <a:solidFill>
+                  <a:srgbClr val="0F172A"/>
+                </a:solidFill>
+                <a:latin typeface="PingFang TC"/>
+                <a:ea typeface="PingFang TC"/>
+              </a:rPr>
+              <a:t>[Data Cleanup]</a:t>
+            </a:r>
+          </a:p>
+          <a:p>
+            <a:pPr algn="l">
+              <a:spcAft>
+                <a:spcPts val="400"/>
+              </a:spcAft>
+            </a:pPr>
+            <a:r>
+              <a:rPr sz="1300" b="0">
+                <a:solidFill>
+                  <a:srgbClr val="64748B"/>
+                </a:solidFill>
+                <a:latin typeface="PingFang TC"/>
+                <a:ea typeface="PingFang TC"/>
+              </a:rPr>
+              <a:t>過期資料永不刪除，一年後 DB 將面臨嚴重 Bloat。</a:t>
+            </a:r>
+          </a:p>
+        </p:txBody>
+      </p:sp>
+      <p:sp>
+        <p:nvSpPr>
+          <p:cNvPr id="20" name="Rounded Rectangle 19"/>
+          <p:cNvSpPr/>
+          <p:nvPr/>
+        </p:nvSpPr>
+        <p:spPr>
+          <a:xfrm>
+            <a:off x="8266176" y="3840480"/>
+            <a:ext cx="3611880" cy="1600200"/>
+          </a:xfrm>
+          <a:prstGeom prst="roundRect">
+            <a:avLst/>
+          </a:prstGeom>
+          <a:solidFill>
+            <a:srgbClr val="F1F5F9"/>
+          </a:solidFill>
+          <a:ln>
+            <a:solidFill>
+              <a:srgbClr val="F1F5F9"/>
+            </a:solidFill>
+          </a:ln>
+          <a:effectLst/>
+        </p:spPr>
+        <p:style>
+          <a:lnRef idx="1">
+            <a:schemeClr val="accent1"/>
+          </a:lnRef>
+          <a:fillRef idx="3">
+            <a:schemeClr val="accent1"/>
+          </a:fillRef>
+          <a:effectRef idx="2">
+            <a:schemeClr val="accent1"/>
+          </a:effectRef>
+          <a:fontRef idx="minor">
+            <a:schemeClr val="lt1"/>
+          </a:fontRef>
+        </p:style>
+        <p:txBody>
+          <a:bodyPr rtlCol="0" anchor="ctr"/>
+          <a:lstStyle/>
+          <a:p>
+            <a:pPr algn="ctr"/>
+          </a:p>
+        </p:txBody>
+      </p:sp>
+      <p:sp>
+        <p:nvSpPr>
+          <p:cNvPr id="21" name="Rectangle 20"/>
+          <p:cNvSpPr/>
+          <p:nvPr/>
+        </p:nvSpPr>
+        <p:spPr>
+          <a:xfrm>
+            <a:off x="8266176" y="3840480"/>
+            <a:ext cx="82296" cy="1600200"/>
+          </a:xfrm>
+          <a:prstGeom prst="rect">
+            <a:avLst/>
+          </a:prstGeom>
+          <a:solidFill>
+            <a:srgbClr val="0EA5E9"/>
+          </a:solidFill>
+          <a:ln>
+            <a:noFill/>
+          </a:ln>
+          <a:effectLst/>
+        </p:spPr>
+        <p:style>
+          <a:lnRef idx="1">
+            <a:schemeClr val="accent1"/>
+          </a:lnRef>
+          <a:fillRef idx="3">
+            <a:schemeClr val="accent1"/>
+          </a:fillRef>
+          <a:effectRef idx="2">
+            <a:schemeClr val="accent1"/>
+          </a:effectRef>
+          <a:fontRef idx="minor">
+            <a:schemeClr val="lt1"/>
+          </a:fontRef>
+        </p:style>
+        <p:txBody>
+          <a:bodyPr rtlCol="0" anchor="ctr"/>
+          <a:lstStyle/>
+          <a:p>
+            <a:pPr algn="ctr"/>
+          </a:p>
+        </p:txBody>
+      </p:sp>
+      <p:sp>
+        <p:nvSpPr>
+          <p:cNvPr id="22" name="TextBox 21"/>
+          <p:cNvSpPr txBox="1"/>
+          <p:nvPr/>
+        </p:nvSpPr>
+        <p:spPr>
+          <a:xfrm>
+            <a:off x="8540496" y="4023360"/>
+            <a:ext cx="3154680" cy="1325880"/>
+          </a:xfrm>
+          <a:prstGeom prst="rect">
+            <a:avLst/>
+          </a:prstGeom>
+          <a:noFill/>
+        </p:spPr>
+        <p:txBody>
+          <a:bodyPr wrap="square" anchor="t">
+            <a:spAutoFit/>
+          </a:bodyPr>
+          <a:lstStyle/>
+          <a:p>
+            <a:pPr algn="l">
+              <a:spcAft>
+                <a:spcPts val="800"/>
+              </a:spcAft>
+            </a:pPr>
+            <a:r>
+              <a:rPr sz="1600" b="1">
+                <a:solidFill>
+                  <a:srgbClr val="0F172A"/>
+                </a:solidFill>
+                <a:latin typeface="PingFang TC"/>
+                <a:ea typeface="PingFang TC"/>
+              </a:rPr>
+              <a:t>[Caching / CDN]</a:t>
+            </a:r>
+          </a:p>
+          <a:p>
+            <a:pPr algn="l">
+              <a:spcAft>
+                <a:spcPts val="400"/>
+              </a:spcAft>
+            </a:pPr>
+            <a:r>
+              <a:rPr sz="1300" b="0">
+                <a:solidFill>
+                  <a:srgbClr val="64748B"/>
+                </a:solidFill>
+                <a:latin typeface="PingFang TC"/>
+                <a:ea typeface="PingFang TC"/>
+              </a:rPr>
+              <a:t>每次轉址都直擊 DB，流量一來直接癱瘓。
+→ 下週 Deep Dive 展開</a:t>
+            </a:r>
+          </a:p>
+        </p:txBody>
+      </p:sp>
+    </p:spTree>
+  </p:cSld>
+  <p:clrMapOvr>
+    <a:masterClrMapping/>
+  </p:clrMapOvr>
+</p:sld>
+</file>
+
+<file path=ppt/slides/slide28.xml><?xml version="1.0" encoding="utf-8"?>
+<p:sld xmlns:a="http://schemas.openxmlformats.org/drawingml/2006/main" xmlns:p="http://schemas.openxmlformats.org/presentationml/2006/main" xmlns:r="http://schemas.openxmlformats.org/officeDocument/2006/relationships">
+  <p:cSld>
+    <p:spTree>
+      <p:nvGrpSpPr>
+        <p:cNvPr id="1" name=""/>
+        <p:cNvGrpSpPr/>
+        <p:nvPr/>
+      </p:nvGrpSpPr>
+      <p:grpSpPr/>
+      <p:sp>
+        <p:nvSpPr>
+          <p:cNvPr id="2" name="Rectangle 1"/>
+          <p:cNvSpPr/>
+          <p:nvPr/>
+        </p:nvSpPr>
+        <p:spPr>
+          <a:xfrm>
+            <a:off x="0" y="0"/>
+            <a:ext cx="164592" cy="6858000"/>
+          </a:xfrm>
+          <a:prstGeom prst="rect">
+            <a:avLst/>
+          </a:prstGeom>
+          <a:solidFill>
+            <a:srgbClr val="2563EB"/>
+          </a:solidFill>
+          <a:ln>
+            <a:noFill/>
+          </a:ln>
+          <a:effectLst/>
+        </p:spPr>
+        <p:style>
+          <a:lnRef idx="1">
+            <a:schemeClr val="accent1"/>
+          </a:lnRef>
+          <a:fillRef idx="3">
+            <a:schemeClr val="accent1"/>
+          </a:fillRef>
+          <a:effectRef idx="2">
+            <a:schemeClr val="accent1"/>
+          </a:effectRef>
+          <a:fontRef idx="minor">
+            <a:schemeClr val="lt1"/>
+          </a:fontRef>
+        </p:style>
+        <p:txBody>
+          <a:bodyPr rtlCol="0" anchor="ctr"/>
+          <a:lstStyle/>
+          <a:p>
+            <a:pPr algn="ctr"/>
+          </a:p>
+        </p:txBody>
+      </p:sp>
+      <p:sp>
+        <p:nvSpPr>
+          <p:cNvPr id="3" name="TextBox 2"/>
+          <p:cNvSpPr txBox="1"/>
+          <p:nvPr/>
+        </p:nvSpPr>
+        <p:spPr>
+          <a:xfrm>
+            <a:off x="502920" y="320040"/>
+            <a:ext cx="10972800" cy="1005840"/>
+          </a:xfrm>
+          <a:prstGeom prst="rect">
+            <a:avLst/>
+          </a:prstGeom>
+          <a:noFill/>
+        </p:spPr>
+        <p:txBody>
+          <a:bodyPr wrap="square" anchor="t">
+            <a:spAutoFit/>
+          </a:bodyPr>
+          <a:lstStyle/>
+          <a:p>
+            <a:pPr algn="l">
+              <a:spcAft>
+                <a:spcPts val="200"/>
+              </a:spcAft>
+            </a:pPr>
+            <a:r>
+              <a:rPr sz="1300" b="1">
+                <a:solidFill>
+                  <a:srgbClr val="2563EB"/>
+                </a:solidFill>
+                <a:latin typeface="PingFang TC"/>
+                <a:ea typeface="PingFang TC"/>
+              </a:rPr>
+              <a:t>下週預告 · DEEP DIVE</a:t>
+            </a:r>
+          </a:p>
+          <a:p>
+            <a:pPr algn="l">
+              <a:spcAft>
+                <a:spcPts val="400"/>
+              </a:spcAft>
+            </a:pPr>
+            <a:r>
+              <a:rPr sz="3000" b="1">
+                <a:solidFill>
+                  <a:srgbClr val="0F172A"/>
+                </a:solidFill>
+                <a:latin typeface="PingFang TC"/>
+                <a:ea typeface="PingFang TC"/>
+              </a:rPr>
+              <a:t>壓力測試與極限擴展 (Deep Dive)</a:t>
+            </a:r>
+          </a:p>
+        </p:txBody>
+      </p:sp>
+      <p:sp>
+        <p:nvSpPr>
+          <p:cNvPr id="4" name="TextBox 3"/>
+          <p:cNvSpPr txBox="1"/>
+          <p:nvPr/>
+        </p:nvSpPr>
+        <p:spPr>
+          <a:xfrm>
+            <a:off x="548640" y="2011680"/>
+            <a:ext cx="5486400" cy="2926080"/>
+          </a:xfrm>
+          <a:prstGeom prst="rect">
+            <a:avLst/>
+          </a:prstGeom>
+          <a:noFill/>
+        </p:spPr>
+        <p:txBody>
+          <a:bodyPr wrap="square" anchor="t">
+            <a:spAutoFit/>
+          </a:bodyPr>
+          <a:lstStyle/>
+          <a:p>
+            <a:pPr algn="l">
+              <a:spcAft>
+                <a:spcPts val="1600"/>
+              </a:spcAft>
+            </a:pPr>
+            <a:r>
+              <a:rPr sz="2600" b="1">
+                <a:solidFill>
+                  <a:srgbClr val="2563EB"/>
+                </a:solidFill>
+                <a:latin typeface="PingFang TC"/>
+                <a:ea typeface="PingFang TC"/>
+              </a:rPr>
+              <a:t>1,000 QPS  →  50,000 QPS</a:t>
+            </a:r>
+          </a:p>
+          <a:p>
+            <a:pPr algn="l">
+              <a:spcAft>
+                <a:spcPts val="400"/>
+              </a:spcAft>
+            </a:pPr>
+            <a:r>
+              <a:rPr sz="1900" b="1">
+                <a:solidFill>
+                  <a:srgbClr val="0F172A"/>
+                </a:solidFill>
+                <a:latin typeface="PingFang TC"/>
+                <a:ea typeface="PingFang TC"/>
+              </a:rPr>
+              <a:t>當大型客戶上線，</a:t>
+            </a:r>
+          </a:p>
+          <a:p>
+            <a:pPr algn="l">
+              <a:spcAft>
+                <a:spcPts val="400"/>
+              </a:spcAft>
+            </a:pPr>
+            <a:r>
+              <a:rPr sz="1900" b="1">
+                <a:solidFill>
+                  <a:srgbClr val="0F172A"/>
+                </a:solidFill>
+                <a:latin typeface="PingFang TC"/>
+                <a:ea typeface="PingFang TC"/>
+              </a:rPr>
+              <a:t>流量瞬間暴增 50 倍，</a:t>
+            </a:r>
+          </a:p>
+          <a:p>
+            <a:pPr algn="l">
+              <a:spcAft>
+                <a:spcPts val="400"/>
+              </a:spcAft>
+            </a:pPr>
+            <a:r>
+              <a:rPr sz="1900" b="1">
+                <a:solidFill>
+                  <a:srgbClr val="0F172A"/>
+                </a:solidFill>
+                <a:latin typeface="PingFang TC"/>
+                <a:ea typeface="PingFang TC"/>
+              </a:rPr>
+              <a:t>這個架構哪會先崩潰？</a:t>
+            </a:r>
+          </a:p>
+        </p:txBody>
+      </p:sp>
+      <p:sp>
+        <p:nvSpPr>
+          <p:cNvPr id="5" name="TextBox 4"/>
+          <p:cNvSpPr txBox="1"/>
+          <p:nvPr/>
+        </p:nvSpPr>
+        <p:spPr>
+          <a:xfrm>
+            <a:off x="6400800" y="2057400"/>
+            <a:ext cx="5303520" cy="2194560"/>
+          </a:xfrm>
+          <a:prstGeom prst="rect">
+            <a:avLst/>
+          </a:prstGeom>
+          <a:noFill/>
+        </p:spPr>
+        <p:txBody>
+          <a:bodyPr wrap="square">
+            <a:spAutoFit/>
+          </a:bodyPr>
+          <a:lstStyle/>
+          <a:p>
+            <a:pPr>
+              <a:spcAft>
+                <a:spcPts val="1400"/>
+              </a:spcAft>
+            </a:pPr>
+            <a:r>
+              <a:rPr sz="1600" b="0">
+                <a:solidFill>
+                  <a:srgbClr val="0F172A"/>
+                </a:solidFill>
+                <a:latin typeface="PingFang TC"/>
+                <a:ea typeface="PingFang TC"/>
+              </a:rPr>
+              <a:t>•  流量暴增 Scenario 推演（Server vs DB vs Network）</a:t>
+            </a:r>
+          </a:p>
+          <a:p>
+            <a:pPr>
+              <a:spcAft>
+                <a:spcPts val="1400"/>
+              </a:spcAft>
+            </a:pPr>
+            <a:r>
+              <a:rPr sz="1600" b="0">
+                <a:solidFill>
+                  <a:srgbClr val="0F172A"/>
+                </a:solidFill>
+                <a:latin typeface="PingFang TC"/>
+                <a:ea typeface="PingFang TC"/>
+              </a:rPr>
+              <a:t>•  Event-Driven Analytics Pipeline 架構</a:t>
+            </a:r>
+          </a:p>
+          <a:p>
+            <a:pPr>
+              <a:spcAft>
+                <a:spcPts val="1400"/>
+              </a:spcAft>
+            </a:pPr>
+            <a:r>
+              <a:rPr sz="1600" b="0">
+                <a:solidFill>
+                  <a:srgbClr val="0F172A"/>
+                </a:solidFill>
+                <a:latin typeface="PingFang TC"/>
+                <a:ea typeface="PingFang TC"/>
+              </a:rPr>
+              <a:t>•  System Design 面試實戰答題框架</a:t>
+            </a:r>
+          </a:p>
+        </p:txBody>
+      </p:sp>
+      <p:sp>
+        <p:nvSpPr>
+          <p:cNvPr id="6" name="Rounded Rectangle 5"/>
+          <p:cNvSpPr/>
+          <p:nvPr/>
+        </p:nvSpPr>
+        <p:spPr>
+          <a:xfrm>
+            <a:off x="6400800" y="4343400"/>
+            <a:ext cx="5303520" cy="1051560"/>
+          </a:xfrm>
+          <a:prstGeom prst="roundRect">
+            <a:avLst/>
+          </a:prstGeom>
+          <a:solidFill>
+            <a:srgbClr val="F1F5F9"/>
+          </a:solidFill>
+          <a:ln>
+            <a:solidFill>
+              <a:srgbClr val="F1F5F9"/>
+            </a:solidFill>
+          </a:ln>
+          <a:effectLst/>
+        </p:spPr>
+        <p:style>
+          <a:lnRef idx="1">
+            <a:schemeClr val="accent1"/>
+          </a:lnRef>
+          <a:fillRef idx="3">
+            <a:schemeClr val="accent1"/>
+          </a:fillRef>
+          <a:effectRef idx="2">
+            <a:schemeClr val="accent1"/>
+          </a:effectRef>
+          <a:fontRef idx="minor">
+            <a:schemeClr val="lt1"/>
+          </a:fontRef>
+        </p:style>
+        <p:txBody>
+          <a:bodyPr rtlCol="0" anchor="ctr"/>
+          <a:lstStyle/>
+          <a:p>
+            <a:pPr algn="ctr"/>
+          </a:p>
+        </p:txBody>
+      </p:sp>
+      <p:sp>
+        <p:nvSpPr>
+          <p:cNvPr id="7" name="Rectangle 6"/>
+          <p:cNvSpPr/>
+          <p:nvPr/>
+        </p:nvSpPr>
+        <p:spPr>
+          <a:xfrm>
+            <a:off x="6400800" y="4343400"/>
+            <a:ext cx="82296" cy="1051560"/>
+          </a:xfrm>
+          <a:prstGeom prst="rect">
+            <a:avLst/>
+          </a:prstGeom>
+          <a:solidFill>
+            <a:srgbClr val="0EA5E9"/>
+          </a:solidFill>
+          <a:ln>
+            <a:noFill/>
+          </a:ln>
+          <a:effectLst/>
+        </p:spPr>
+        <p:style>
+          <a:lnRef idx="1">
+            <a:schemeClr val="accent1"/>
+          </a:lnRef>
+          <a:fillRef idx="3">
+            <a:schemeClr val="accent1"/>
+          </a:fillRef>
+          <a:effectRef idx="2">
+            <a:schemeClr val="accent1"/>
+          </a:effectRef>
+          <a:fontRef idx="minor">
+            <a:schemeClr val="lt1"/>
+          </a:fontRef>
+        </p:style>
+        <p:txBody>
+          <a:bodyPr rtlCol="0" anchor="ctr"/>
+          <a:lstStyle/>
+          <a:p>
+            <a:pPr algn="ctr"/>
+          </a:p>
+        </p:txBody>
+      </p:sp>
+      <p:sp>
+        <p:nvSpPr>
+          <p:cNvPr id="8" name="TextBox 7"/>
+          <p:cNvSpPr txBox="1"/>
+          <p:nvPr/>
+        </p:nvSpPr>
+        <p:spPr>
+          <a:xfrm>
+            <a:off x="6675120" y="4526280"/>
+            <a:ext cx="4846320" cy="822960"/>
+          </a:xfrm>
+          <a:prstGeom prst="rect">
+            <a:avLst/>
+          </a:prstGeom>
+          <a:noFill/>
+        </p:spPr>
+        <p:txBody>
+          <a:bodyPr wrap="square" anchor="t">
+            <a:spAutoFit/>
+          </a:bodyPr>
+          <a:lstStyle/>
+          <a:p>
+            <a:pPr algn="l">
+              <a:spcAft>
+                <a:spcPts val="600"/>
+              </a:spcAft>
+            </a:pPr>
+            <a:r>
+              <a:rPr sz="1500" b="1">
+                <a:solidFill>
+                  <a:srgbClr val="0F172A"/>
+                </a:solidFill>
+                <a:latin typeface="PingFang TC"/>
+                <a:ea typeface="PingFang TC"/>
+              </a:rPr>
+              <a:t>課前準備</a:t>
+            </a:r>
+          </a:p>
+          <a:p>
+            <a:pPr algn="l">
+              <a:spcAft>
+                <a:spcPts val="400"/>
+              </a:spcAft>
+            </a:pPr>
+            <a:r>
+              <a:rPr sz="1400" b="0">
+                <a:solidFill>
+                  <a:srgbClr val="64748B"/>
+                </a:solidFill>
+                <a:latin typeface="PingFang TC"/>
+                <a:ea typeface="PingFang TC"/>
+              </a:rPr>
+              <a:t>複習教材 Deep Dive 章節</a:t>
             </a:r>
           </a:p>
         </p:txBody>

</xml_diff>

<commit_message>
Add data cleanup cron: EventBridge + Lambda (expired + soft-deleted-past-retention)
- infra/modules/cleanup: VPC Lambda (pg8000 pure-python zip) + EventBridge Scheduler
  (daily) + lambda SG→RDS ingress + IAM; deletes expired QRs & old soft-deleted rows
  and their scan_events; retention/grace/schedule as variables
- src/cleanup.py: single-source SQLAlchemy text() script (Lambda + local SQLite test)
- data module exposes database_url (sensitive) for Lambda env
- docs: DESIGN appendix C/G + PPT (30p) + README
- terraform validate/plan pass (86 resources); not applied

Co-Authored-By: Claude Opus 4.8 <noreply@anthropic.com>
</commit_message>
<xml_diff>
--- a/QR Code Generator/QR_Code_Generator.pptx
+++ b/QR Code Generator/QR_Code_Generator.pptx
@@ -34,6 +34,7 @@
     <p:sldId id="282" r:id="rId33"/>
     <p:sldId id="283" r:id="rId34"/>
     <p:sldId id="284" r:id="rId35"/>
+    <p:sldId id="285" r:id="rId36"/>
   </p:sldIdLst>
   <p:sldSz cx="12191695" cy="6858000" type="screen4x3"/>
   <p:notesSz cx="6858000" cy="9144000"/>
@@ -12897,7 +12898,7 @@
                           <a:latin typeface="PingFang TC"/>
                           <a:ea typeface="PingFang TC"/>
                         </a:rPr>
-                        <a:t>設計有 cron，未實作</a:t>
+                        <a:t>✅ 已實作</a:t>
                       </a:r>
                     </a:p>
                   </a:txBody>
@@ -12920,7 +12921,7 @@
                           <a:latin typeface="PingFang TC"/>
                           <a:ea typeface="PingFang TC"/>
                         </a:rPr>
-                        <a:t>定期清過期/未點擊，防 DB bloat</a:t>
+                        <a:t>EventBridge + Lambda 定時清理</a:t>
                       </a:r>
                     </a:p>
                   </a:txBody>
@@ -16093,7 +16094,7 @@
                 <a:latin typeface="PingFang TC"/>
                 <a:ea typeface="PingFang TC"/>
               </a:rPr>
-              <a:t>部署 · CI/CD</a:t>
+              <a:t>可靠性 · DATA CLEANUP</a:t>
             </a:r>
           </a:p>
           <a:p>
@@ -16110,7 +16111,7 @@
                 <a:latin typeface="PingFang TC"/>
                 <a:ea typeface="PingFang TC"/>
               </a:rPr>
-              <a:t>CI/CD 流程（GitHub Actions + OIDC）</a:t>
+              <a:t>定時清理:EventBridge + Lambda（防 DB bloat）</a:t>
             </a:r>
           </a:p>
         </p:txBody>
@@ -16123,18 +16124,18 @@
         </p:nvSpPr>
         <p:spPr>
           <a:xfrm>
-            <a:off x="457200" y="2286000"/>
-            <a:ext cx="1481328" cy="1280160"/>
+            <a:off x="548640" y="1920240"/>
+            <a:ext cx="2743200" cy="868680"/>
           </a:xfrm>
           <a:prstGeom prst="roundRect">
             <a:avLst/>
           </a:prstGeom>
           <a:solidFill>
-            <a:srgbClr val="64748B"/>
+            <a:srgbClr val="D97706"/>
           </a:solidFill>
           <a:ln>
             <a:solidFill>
-              <a:srgbClr val="64748B"/>
+              <a:srgbClr val="D97706"/>
             </a:solidFill>
           </a:ln>
           <a:effectLst/>
@@ -16159,195 +16160,41 @@
           <a:p>
             <a:pPr algn="ctr"/>
             <a:r>
-              <a:rPr sz="1100" b="1">
+              <a:rPr sz="1200" b="1">
                 <a:solidFill>
                   <a:srgbClr val="FFFFFF"/>
                 </a:solidFill>
                 <a:latin typeface="PingFang TC"/>
                 <a:ea typeface="PingFang TC"/>
               </a:rPr>
-              <a:t>git push</a:t>
+              <a:t>EventBridge Scheduler</a:t>
             </a:r>
           </a:p>
           <a:p>
             <a:pPr algn="ctr"/>
             <a:r>
-              <a:rPr sz="1100" b="0">
+              <a:rPr sz="1200" b="0">
                 <a:solidFill>
                   <a:srgbClr val="FFFFFF"/>
                 </a:solidFill>
                 <a:latin typeface="PingFang TC"/>
                 <a:ea typeface="PingFang TC"/>
               </a:rPr>
-              <a:t>QR Code Generator/**</a:t>
-            </a:r>
-          </a:p>
-        </p:txBody>
-      </p:sp>
-      <p:cxnSp>
-        <p:nvCxnSpPr>
-          <p:cNvPr id="5" name="Connector 4"/>
-          <p:cNvCxnSpPr/>
-          <p:nvPr/>
-        </p:nvCxnSpPr>
-        <p:spPr>
-          <a:xfrm>
-            <a:off x="1938528" y="2926080"/>
-            <a:ext cx="118872" cy="0"/>
-          </a:xfrm>
-          <a:prstGeom prst="line">
-            <a:avLst/>
-          </a:prstGeom>
-          <a:ln w="22225">
-            <a:solidFill>
-              <a:srgbClr val="64748B"/>
-            </a:solidFill>
-            <a:tailEnd type="triangle" w="med" len="med"/>
-          </a:ln>
-        </p:spPr>
-        <p:style>
-          <a:lnRef idx="2">
-            <a:schemeClr val="accent1"/>
-          </a:lnRef>
-          <a:fillRef idx="0">
-            <a:schemeClr val="accent1"/>
-          </a:fillRef>
-          <a:effectRef idx="1">
-            <a:schemeClr val="accent1"/>
-          </a:effectRef>
-          <a:fontRef idx="minor">
-            <a:schemeClr val="tx1"/>
-          </a:fontRef>
-        </p:style>
-      </p:cxnSp>
-      <p:sp>
-        <p:nvSpPr>
-          <p:cNvPr id="6" name="Rounded Rectangle 5"/>
+              <a:t>每日 03:00 UTC</a:t>
+            </a:r>
+          </a:p>
+        </p:txBody>
+      </p:sp>
+      <p:sp>
+        <p:nvSpPr>
+          <p:cNvPr id="5" name="Rounded Rectangle 4"/>
           <p:cNvSpPr/>
           <p:nvPr/>
         </p:nvSpPr>
         <p:spPr>
           <a:xfrm>
-            <a:off x="2057400" y="2286000"/>
-            <a:ext cx="1481328" cy="1280160"/>
-          </a:xfrm>
-          <a:prstGeom prst="roundRect">
-            <a:avLst/>
-          </a:prstGeom>
-          <a:solidFill>
-            <a:srgbClr val="0EA5E9"/>
-          </a:solidFill>
-          <a:ln>
-            <a:solidFill>
-              <a:srgbClr val="0EA5E9"/>
-            </a:solidFill>
-          </a:ln>
-          <a:effectLst/>
-        </p:spPr>
-        <p:style>
-          <a:lnRef idx="1">
-            <a:schemeClr val="accent1"/>
-          </a:lnRef>
-          <a:fillRef idx="3">
-            <a:schemeClr val="accent1"/>
-          </a:fillRef>
-          <a:effectRef idx="2">
-            <a:schemeClr val="accent1"/>
-          </a:effectRef>
-          <a:fontRef idx="minor">
-            <a:schemeClr val="lt1"/>
-          </a:fontRef>
-        </p:style>
-        <p:txBody>
-          <a:bodyPr rtlCol="0" anchor="ctr" wrap="square" tIns="25400" bIns="25400"/>
-          <a:lstStyle/>
-          <a:p>
-            <a:pPr algn="ctr"/>
-            <a:r>
-              <a:rPr sz="1100" b="1">
-                <a:solidFill>
-                  <a:srgbClr val="FFFFFF"/>
-                </a:solidFill>
-                <a:latin typeface="PingFang TC"/>
-                <a:ea typeface="PingFang TC"/>
-              </a:rPr>
-              <a:t>GitHub Actions</a:t>
-            </a:r>
-          </a:p>
-          <a:p>
-            <a:pPr algn="ctr"/>
-            <a:r>
-              <a:rPr sz="1100" b="0">
-                <a:solidFill>
-                  <a:srgbClr val="FFFFFF"/>
-                </a:solidFill>
-                <a:latin typeface="PingFang TC"/>
-                <a:ea typeface="PingFang TC"/>
-              </a:rPr>
-              <a:t>OIDC assume role</a:t>
-            </a:r>
-          </a:p>
-          <a:p>
-            <a:pPr algn="ctr"/>
-            <a:r>
-              <a:rPr sz="1100" b="0">
-                <a:solidFill>
-                  <a:srgbClr val="FFFFFF"/>
-                </a:solidFill>
-                <a:latin typeface="PingFang TC"/>
-                <a:ea typeface="PingFang TC"/>
-              </a:rPr>
-              <a:t>(無長期金鑰)</a:t>
-            </a:r>
-          </a:p>
-        </p:txBody>
-      </p:sp>
-      <p:cxnSp>
-        <p:nvCxnSpPr>
-          <p:cNvPr id="7" name="Connector 6"/>
-          <p:cNvCxnSpPr/>
-          <p:nvPr/>
-        </p:nvCxnSpPr>
-        <p:spPr>
-          <a:xfrm>
-            <a:off x="3538728" y="2926080"/>
-            <a:ext cx="118872" cy="0"/>
-          </a:xfrm>
-          <a:prstGeom prst="line">
-            <a:avLst/>
-          </a:prstGeom>
-          <a:ln w="22225">
-            <a:solidFill>
-              <a:srgbClr val="64748B"/>
-            </a:solidFill>
-            <a:tailEnd type="triangle" w="med" len="med"/>
-          </a:ln>
-        </p:spPr>
-        <p:style>
-          <a:lnRef idx="2">
-            <a:schemeClr val="accent1"/>
-          </a:lnRef>
-          <a:fillRef idx="0">
-            <a:schemeClr val="accent1"/>
-          </a:fillRef>
-          <a:effectRef idx="1">
-            <a:schemeClr val="accent1"/>
-          </a:effectRef>
-          <a:fontRef idx="minor">
-            <a:schemeClr val="tx1"/>
-          </a:fontRef>
-        </p:style>
-      </p:cxnSp>
-      <p:sp>
-        <p:nvSpPr>
-          <p:cNvPr id="8" name="Rounded Rectangle 7"/>
-          <p:cNvSpPr/>
-          <p:nvPr/>
-        </p:nvSpPr>
-        <p:spPr>
-          <a:xfrm>
-            <a:off x="3657600" y="2286000"/>
-            <a:ext cx="1481328" cy="1280160"/>
+            <a:off x="3657600" y="1920240"/>
+            <a:ext cx="2743200" cy="868680"/>
           </a:xfrm>
           <a:prstGeom prst="roundRect">
             <a:avLst/>
@@ -16382,90 +16229,41 @@
           <a:p>
             <a:pPr algn="ctr"/>
             <a:r>
-              <a:rPr sz="1100" b="1">
+              <a:rPr sz="1200" b="1">
                 <a:solidFill>
                   <a:srgbClr val="FFFFFF"/>
                 </a:solidFill>
                 <a:latin typeface="PingFang TC"/>
                 <a:ea typeface="PingFang TC"/>
               </a:rPr>
-              <a:t>buildx</a:t>
+              <a:t>Lambda (VPC)</a:t>
             </a:r>
           </a:p>
           <a:p>
             <a:pPr algn="ctr"/>
             <a:r>
-              <a:rPr sz="1100" b="0">
+              <a:rPr sz="1200" b="0">
                 <a:solidFill>
                   <a:srgbClr val="FFFFFF"/>
                 </a:solidFill>
                 <a:latin typeface="PingFang TC"/>
                 <a:ea typeface="PingFang TC"/>
               </a:rPr>
-              <a:t>--platform</a:t>
-            </a:r>
-          </a:p>
-          <a:p>
-            <a:pPr algn="ctr"/>
-            <a:r>
-              <a:rPr sz="1100" b="0">
-                <a:solidFill>
-                  <a:srgbClr val="FFFFFF"/>
-                </a:solidFill>
-                <a:latin typeface="PingFang TC"/>
-                <a:ea typeface="PingFang TC"/>
-              </a:rPr>
-              <a:t>linux/arm64</a:t>
-            </a:r>
-          </a:p>
-        </p:txBody>
-      </p:sp>
-      <p:cxnSp>
-        <p:nvCxnSpPr>
-          <p:cNvPr id="9" name="Connector 8"/>
-          <p:cNvCxnSpPr/>
-          <p:nvPr/>
-        </p:nvCxnSpPr>
-        <p:spPr>
-          <a:xfrm>
-            <a:off x="5138928" y="2926080"/>
-            <a:ext cx="118872" cy="0"/>
-          </a:xfrm>
-          <a:prstGeom prst="line">
-            <a:avLst/>
-          </a:prstGeom>
-          <a:ln w="22225">
-            <a:solidFill>
-              <a:srgbClr val="64748B"/>
-            </a:solidFill>
-            <a:tailEnd type="triangle" w="med" len="med"/>
-          </a:ln>
-        </p:spPr>
-        <p:style>
-          <a:lnRef idx="2">
-            <a:schemeClr val="accent1"/>
-          </a:lnRef>
-          <a:fillRef idx="0">
-            <a:schemeClr val="accent1"/>
-          </a:fillRef>
-          <a:effectRef idx="1">
-            <a:schemeClr val="accent1"/>
-          </a:effectRef>
-          <a:fontRef idx="minor">
-            <a:schemeClr val="tx1"/>
-          </a:fontRef>
-        </p:style>
-      </p:cxnSp>
-      <p:sp>
-        <p:nvSpPr>
-          <p:cNvPr id="10" name="Rounded Rectangle 9"/>
+              <a:t>pg8000 純 Python</a:t>
+            </a:r>
+          </a:p>
+        </p:txBody>
+      </p:sp>
+      <p:sp>
+        <p:nvSpPr>
+          <p:cNvPr id="6" name="Rounded Rectangle 5"/>
           <p:cNvSpPr/>
           <p:nvPr/>
         </p:nvSpPr>
         <p:spPr>
           <a:xfrm>
-            <a:off x="5257800" y="2286000"/>
-            <a:ext cx="1481328" cy="1280160"/>
+            <a:off x="6766560" y="1920240"/>
+            <a:ext cx="2377440" cy="868680"/>
           </a:xfrm>
           <a:prstGeom prst="roundRect">
             <a:avLst/>
@@ -16500,54 +16298,41 @@
           <a:p>
             <a:pPr algn="ctr"/>
             <a:r>
-              <a:rPr sz="1100" b="1">
+              <a:rPr sz="1200" b="1">
                 <a:solidFill>
                   <a:srgbClr val="FFFFFF"/>
                 </a:solidFill>
                 <a:latin typeface="PingFang TC"/>
                 <a:ea typeface="PingFang TC"/>
               </a:rPr>
-              <a:t>ECR push</a:t>
+              <a:t>RDS PostgreSQL</a:t>
             </a:r>
           </a:p>
           <a:p>
             <a:pPr algn="ctr"/>
             <a:r>
-              <a:rPr sz="1100" b="0">
+              <a:rPr sz="1200" b="0">
                 <a:solidFill>
                   <a:srgbClr val="FFFFFF"/>
                 </a:solidFill>
                 <a:latin typeface="PingFang TC"/>
                 <a:ea typeface="PingFang TC"/>
               </a:rPr>
-              <a:t>tag = SHA</a:t>
-            </a:r>
-          </a:p>
-          <a:p>
-            <a:pPr algn="ctr"/>
-            <a:r>
-              <a:rPr sz="1100" b="0">
-                <a:solidFill>
-                  <a:srgbClr val="FFFFFF"/>
-                </a:solidFill>
-                <a:latin typeface="PingFang TC"/>
-                <a:ea typeface="PingFang TC"/>
-              </a:rPr>
-              <a:t>+ latest</a:t>
+              <a:t>DELETE</a:t>
             </a:r>
           </a:p>
         </p:txBody>
       </p:sp>
       <p:cxnSp>
         <p:nvCxnSpPr>
-          <p:cNvPr id="11" name="Connector 10"/>
+          <p:cNvPr id="7" name="Connector 6"/>
           <p:cNvCxnSpPr/>
           <p:nvPr/>
         </p:nvCxnSpPr>
         <p:spPr>
           <a:xfrm>
-            <a:off x="6739128" y="2926080"/>
-            <a:ext cx="118872" cy="0"/>
+            <a:off x="3291840" y="2350008"/>
+            <a:ext cx="365760" cy="0"/>
           </a:xfrm>
           <a:prstGeom prst="line">
             <a:avLst/>
@@ -16574,98 +16359,16 @@
           </a:fontRef>
         </p:style>
       </p:cxnSp>
-      <p:sp>
-        <p:nvSpPr>
-          <p:cNvPr id="12" name="Rounded Rectangle 11"/>
-          <p:cNvSpPr/>
-          <p:nvPr/>
-        </p:nvSpPr>
-        <p:spPr>
-          <a:xfrm>
-            <a:off x="6858000" y="2286000"/>
-            <a:ext cx="1481328" cy="1280160"/>
-          </a:xfrm>
-          <a:prstGeom prst="roundRect">
-            <a:avLst/>
-          </a:prstGeom>
-          <a:solidFill>
-            <a:srgbClr val="7C3AED"/>
-          </a:solidFill>
-          <a:ln>
-            <a:solidFill>
-              <a:srgbClr val="7C3AED"/>
-            </a:solidFill>
-          </a:ln>
-          <a:effectLst/>
-        </p:spPr>
-        <p:style>
-          <a:lnRef idx="1">
-            <a:schemeClr val="accent1"/>
-          </a:lnRef>
-          <a:fillRef idx="3">
-            <a:schemeClr val="accent1"/>
-          </a:fillRef>
-          <a:effectRef idx="2">
-            <a:schemeClr val="accent1"/>
-          </a:effectRef>
-          <a:fontRef idx="minor">
-            <a:schemeClr val="lt1"/>
-          </a:fontRef>
-        </p:style>
-        <p:txBody>
-          <a:bodyPr rtlCol="0" anchor="ctr" wrap="square" tIns="25400" bIns="25400"/>
-          <a:lstStyle/>
-          <a:p>
-            <a:pPr algn="ctr"/>
-            <a:r>
-              <a:rPr sz="1100" b="1">
-                <a:solidFill>
-                  <a:srgbClr val="FFFFFF"/>
-                </a:solidFill>
-                <a:latin typeface="PingFang TC"/>
-                <a:ea typeface="PingFang TC"/>
-              </a:rPr>
-              <a:t>SSM 更新</a:t>
-            </a:r>
-          </a:p>
-          <a:p>
-            <a:pPr algn="ctr"/>
-            <a:r>
-              <a:rPr sz="1100" b="0">
-                <a:solidFill>
-                  <a:srgbClr val="FFFFFF"/>
-                </a:solidFill>
-                <a:latin typeface="PingFang TC"/>
-                <a:ea typeface="PingFang TC"/>
-              </a:rPr>
-              <a:t>/qrcode/</a:t>
-            </a:r>
-          </a:p>
-          <a:p>
-            <a:pPr algn="ctr"/>
-            <a:r>
-              <a:rPr sz="1100" b="0">
-                <a:solidFill>
-                  <a:srgbClr val="FFFFFF"/>
-                </a:solidFill>
-                <a:latin typeface="PingFang TC"/>
-                <a:ea typeface="PingFang TC"/>
-              </a:rPr>
-              <a:t>IMAGE_URI</a:t>
-            </a:r>
-          </a:p>
-        </p:txBody>
-      </p:sp>
       <p:cxnSp>
         <p:nvCxnSpPr>
-          <p:cNvPr id="13" name="Connector 12"/>
+          <p:cNvPr id="8" name="Connector 7"/>
           <p:cNvCxnSpPr/>
           <p:nvPr/>
         </p:nvCxnSpPr>
         <p:spPr>
           <a:xfrm>
-            <a:off x="8339328" y="2926080"/>
-            <a:ext cx="118872" cy="0"/>
+            <a:off x="6400800" y="2350008"/>
+            <a:ext cx="365760" cy="0"/>
           </a:xfrm>
           <a:prstGeom prst="line">
             <a:avLst/>
@@ -16692,216 +16395,327 @@
           </a:fontRef>
         </p:style>
       </p:cxnSp>
-      <p:sp>
-        <p:nvSpPr>
-          <p:cNvPr id="14" name="Rounded Rectangle 13"/>
-          <p:cNvSpPr/>
-          <p:nvPr/>
-        </p:nvSpPr>
-        <p:spPr>
-          <a:xfrm>
-            <a:off x="8458200" y="2286000"/>
-            <a:ext cx="1481328" cy="1280160"/>
-          </a:xfrm>
-          <a:prstGeom prst="roundRect">
-            <a:avLst/>
-          </a:prstGeom>
-          <a:solidFill>
-            <a:srgbClr val="D97706"/>
-          </a:solidFill>
-          <a:ln>
-            <a:solidFill>
-              <a:srgbClr val="D97706"/>
-            </a:solidFill>
-          </a:ln>
-          <a:effectLst/>
-        </p:spPr>
-        <p:style>
-          <a:lnRef idx="1">
-            <a:schemeClr val="accent1"/>
-          </a:lnRef>
-          <a:fillRef idx="3">
-            <a:schemeClr val="accent1"/>
-          </a:fillRef>
-          <a:effectRef idx="2">
-            <a:schemeClr val="accent1"/>
-          </a:effectRef>
-          <a:fontRef idx="minor">
-            <a:schemeClr val="lt1"/>
-          </a:fontRef>
-        </p:style>
-        <p:txBody>
-          <a:bodyPr rtlCol="0" anchor="ctr" wrap="square" tIns="25400" bIns="25400"/>
-          <a:lstStyle/>
-          <a:p>
-            <a:pPr algn="ctr"/>
-            <a:r>
-              <a:rPr sz="1100" b="1">
-                <a:solidFill>
-                  <a:srgbClr val="FFFFFF"/>
-                </a:solidFill>
-                <a:latin typeface="PingFang TC"/>
-                <a:ea typeface="PingFang TC"/>
-              </a:rPr>
-              <a:t>SSM 部署</a:t>
-            </a:r>
-          </a:p>
-          <a:p>
-            <a:pPr algn="ctr"/>
-            <a:r>
-              <a:rPr sz="1100" b="0">
-                <a:solidFill>
-                  <a:srgbClr val="FFFFFF"/>
-                </a:solidFill>
-                <a:latin typeface="PingFang TC"/>
-                <a:ea typeface="PingFang TC"/>
-              </a:rPr>
-              <a:t>→ EC2</a:t>
-            </a:r>
-          </a:p>
-          <a:p>
-            <a:pPr algn="ctr"/>
-            <a:r>
-              <a:rPr sz="1100" b="0">
-                <a:solidFill>
-                  <a:srgbClr val="FFFFFF"/>
-                </a:solidFill>
-                <a:latin typeface="PingFang TC"/>
-                <a:ea typeface="PingFang TC"/>
-              </a:rPr>
-              <a:t>deploy-app.sh</a:t>
-            </a:r>
-          </a:p>
-        </p:txBody>
-      </p:sp>
-      <p:cxnSp>
-        <p:nvCxnSpPr>
-          <p:cNvPr id="15" name="Connector 14"/>
-          <p:cNvCxnSpPr/>
-          <p:nvPr/>
-        </p:nvCxnSpPr>
-        <p:spPr>
-          <a:xfrm>
-            <a:off x="9939528" y="2926080"/>
-            <a:ext cx="118872" cy="0"/>
-          </a:xfrm>
-          <a:prstGeom prst="line">
-            <a:avLst/>
-          </a:prstGeom>
-          <a:ln w="22225">
-            <a:solidFill>
-              <a:srgbClr val="64748B"/>
-            </a:solidFill>
-            <a:tailEnd type="triangle" w="med" len="med"/>
-          </a:ln>
-        </p:spPr>
-        <p:style>
-          <a:lnRef idx="2">
-            <a:schemeClr val="accent1"/>
-          </a:lnRef>
-          <a:fillRef idx="0">
-            <a:schemeClr val="accent1"/>
-          </a:fillRef>
-          <a:effectRef idx="1">
-            <a:schemeClr val="accent1"/>
-          </a:effectRef>
-          <a:fontRef idx="minor">
-            <a:schemeClr val="tx1"/>
-          </a:fontRef>
-        </p:style>
-      </p:cxnSp>
-      <p:sp>
-        <p:nvSpPr>
-          <p:cNvPr id="16" name="Rounded Rectangle 15"/>
-          <p:cNvSpPr/>
-          <p:nvPr/>
-        </p:nvSpPr>
-        <p:spPr>
-          <a:xfrm>
-            <a:off x="10058400" y="2286000"/>
-            <a:ext cx="1481328" cy="1280160"/>
-          </a:xfrm>
-          <a:prstGeom prst="roundRect">
-            <a:avLst/>
-          </a:prstGeom>
-          <a:solidFill>
-            <a:srgbClr val="059669"/>
-          </a:solidFill>
-          <a:ln>
-            <a:solidFill>
-              <a:srgbClr val="059669"/>
-            </a:solidFill>
-          </a:ln>
-          <a:effectLst/>
-        </p:spPr>
-        <p:style>
-          <a:lnRef idx="1">
-            <a:schemeClr val="accent1"/>
-          </a:lnRef>
-          <a:fillRef idx="3">
-            <a:schemeClr val="accent1"/>
-          </a:fillRef>
-          <a:effectRef idx="2">
-            <a:schemeClr val="accent1"/>
-          </a:effectRef>
-          <a:fontRef idx="minor">
-            <a:schemeClr val="lt1"/>
-          </a:fontRef>
-        </p:style>
-        <p:txBody>
-          <a:bodyPr rtlCol="0" anchor="ctr" wrap="square" tIns="25400" bIns="25400"/>
-          <a:lstStyle/>
-          <a:p>
-            <a:pPr algn="ctr"/>
-            <a:r>
-              <a:rPr sz="1100" b="1">
-                <a:solidFill>
-                  <a:srgbClr val="FFFFFF"/>
-                </a:solidFill>
-                <a:latin typeface="PingFang TC"/>
-                <a:ea typeface="PingFang TC"/>
-              </a:rPr>
-              <a:t>上線</a:t>
-            </a:r>
-          </a:p>
-          <a:p>
-            <a:pPr algn="ctr"/>
-            <a:r>
-              <a:rPr sz="1100" b="0">
-                <a:solidFill>
-                  <a:srgbClr val="FFFFFF"/>
-                </a:solidFill>
-                <a:latin typeface="PingFang TC"/>
-                <a:ea typeface="PingFang TC"/>
-              </a:rPr>
-              <a:t>ALB /health</a:t>
-            </a:r>
-          </a:p>
-          <a:p>
-            <a:pPr algn="ctr"/>
-            <a:r>
-              <a:rPr sz="1100" b="0">
-                <a:solidFill>
-                  <a:srgbClr val="FFFFFF"/>
-                </a:solidFill>
-                <a:latin typeface="PingFang TC"/>
-                <a:ea typeface="PingFang TC"/>
-              </a:rPr>
-              <a:t>通過</a:t>
-            </a:r>
-          </a:p>
-        </p:txBody>
-      </p:sp>
-      <p:sp>
-        <p:nvSpPr>
-          <p:cNvPr id="17" name="TextBox 16"/>
+      <p:graphicFrame>
+        <p:nvGraphicFramePr>
+          <p:cNvPr id="9" name="Table 8"/>
+          <p:cNvGraphicFramePr>
+            <a:graphicFrameLocks noGrp="1"/>
+          </p:cNvGraphicFramePr>
+          <p:nvPr/>
+        </p:nvGraphicFramePr>
+        <p:xfrm>
+          <a:off x="548640" y="3200400"/>
+          <a:ext cx="11109960" cy="1737360"/>
+        </p:xfrm>
+        <a:graphic>
+          <a:graphicData uri="http://schemas.openxmlformats.org/drawingml/2006/table">
+            <a:tbl>
+              <a:tblPr firstRow="1" bandRow="1">
+                <a:tableStyleId>{5C22544A-7EE6-4342-B048-85BDC9FD1C3A}</a:tableStyleId>
+              </a:tblPr>
+              <a:tblGrid>
+                <a:gridCol w="2377440"/>
+                <a:gridCol w="6446520"/>
+                <a:gridCol w="2286000"/>
+              </a:tblGrid>
+              <a:tr h="434340">
+                <a:tc>
+                  <a:txBody>
+                    <a:bodyPr/>
+                    <a:lstStyle/>
+                    <a:p>
+                      <a:r>
+                        <a:rPr sz="1200" b="1">
+                          <a:solidFill>
+                            <a:srgbClr val="FFFFFF"/>
+                          </a:solidFill>
+                          <a:latin typeface="PingFang TC"/>
+                          <a:ea typeface="PingFang TC"/>
+                        </a:rPr>
+                        <a:t>清理目標</a:t>
+                      </a:r>
+                    </a:p>
+                  </a:txBody>
+                  <a:tcPr marT="25400" marB="25400" marL="101600" anchor="ctr">
+                    <a:solidFill>
+                      <a:srgbClr val="2563EB"/>
+                    </a:solidFill>
+                  </a:tcPr>
+                </a:tc>
+                <a:tc>
+                  <a:txBody>
+                    <a:bodyPr/>
+                    <a:lstStyle/>
+                    <a:p>
+                      <a:r>
+                        <a:rPr sz="1200" b="1">
+                          <a:solidFill>
+                            <a:srgbClr val="FFFFFF"/>
+                          </a:solidFill>
+                          <a:latin typeface="PingFang TC"/>
+                          <a:ea typeface="PingFang TC"/>
+                        </a:rPr>
+                        <a:t>條件</a:t>
+                      </a:r>
+                    </a:p>
+                  </a:txBody>
+                  <a:tcPr marT="25400" marB="25400" marL="101600" anchor="ctr">
+                    <a:solidFill>
+                      <a:srgbClr val="2563EB"/>
+                    </a:solidFill>
+                  </a:tcPr>
+                </a:tc>
+                <a:tc>
+                  <a:txBody>
+                    <a:bodyPr/>
+                    <a:lstStyle/>
+                    <a:p>
+                      <a:r>
+                        <a:rPr sz="1200" b="1">
+                          <a:solidFill>
+                            <a:srgbClr val="FFFFFF"/>
+                          </a:solidFill>
+                          <a:latin typeface="PingFang TC"/>
+                          <a:ea typeface="PingFang TC"/>
+                        </a:rPr>
+                        <a:t>預設保留</a:t>
+                      </a:r>
+                    </a:p>
+                  </a:txBody>
+                  <a:tcPr marT="25400" marB="25400" marL="101600" anchor="ctr">
+                    <a:solidFill>
+                      <a:srgbClr val="2563EB"/>
+                    </a:solidFill>
+                  </a:tcPr>
+                </a:tc>
+              </a:tr>
+              <a:tr h="434340">
+                <a:tc>
+                  <a:txBody>
+                    <a:bodyPr/>
+                    <a:lstStyle/>
+                    <a:p>
+                      <a:r>
+                        <a:rPr sz="1200" b="1">
+                          <a:solidFill>
+                            <a:srgbClr val="0F172A"/>
+                          </a:solidFill>
+                          <a:latin typeface="PingFang TC"/>
+                          <a:ea typeface="PingFang TC"/>
+                        </a:rPr>
+                        <a:t>過期 QR</a:t>
+                      </a:r>
+                    </a:p>
+                  </a:txBody>
+                  <a:tcPr marT="25400" marB="25400" marL="101600" anchor="ctr">
+                    <a:solidFill>
+                      <a:srgbClr val="FFFFFF"/>
+                    </a:solidFill>
+                  </a:tcPr>
+                </a:tc>
+                <a:tc>
+                  <a:txBody>
+                    <a:bodyPr/>
+                    <a:lstStyle/>
+                    <a:p>
+                      <a:r>
+                        <a:rPr sz="1200" b="0">
+                          <a:solidFill>
+                            <a:srgbClr val="0F172A"/>
+                          </a:solidFill>
+                          <a:latin typeface="PingFang TC"/>
+                          <a:ea typeface="PingFang TC"/>
+                        </a:rPr>
+                        <a:t>expires_at &lt; now - grace</a:t>
+                      </a:r>
+                    </a:p>
+                  </a:txBody>
+                  <a:tcPr marT="25400" marB="25400" marL="101600" anchor="ctr">
+                    <a:solidFill>
+                      <a:srgbClr val="FFFFFF"/>
+                    </a:solidFill>
+                  </a:tcPr>
+                </a:tc>
+                <a:tc>
+                  <a:txBody>
+                    <a:bodyPr/>
+                    <a:lstStyle/>
+                    <a:p>
+                      <a:r>
+                        <a:rPr sz="1200" b="0">
+                          <a:solidFill>
+                            <a:srgbClr val="0F172A"/>
+                          </a:solidFill>
+                          <a:latin typeface="PingFang TC"/>
+                          <a:ea typeface="PingFang TC"/>
+                        </a:rPr>
+                        <a:t>30 天</a:t>
+                      </a:r>
+                    </a:p>
+                  </a:txBody>
+                  <a:tcPr marT="25400" marB="25400" marL="101600" anchor="ctr">
+                    <a:solidFill>
+                      <a:srgbClr val="FFFFFF"/>
+                    </a:solidFill>
+                  </a:tcPr>
+                </a:tc>
+              </a:tr>
+              <a:tr h="434340">
+                <a:tc>
+                  <a:txBody>
+                    <a:bodyPr/>
+                    <a:lstStyle/>
+                    <a:p>
+                      <a:r>
+                        <a:rPr sz="1200" b="1">
+                          <a:solidFill>
+                            <a:srgbClr val="0F172A"/>
+                          </a:solidFill>
+                          <a:latin typeface="PingFang TC"/>
+                          <a:ea typeface="PingFang TC"/>
+                        </a:rPr>
+                        <a:t>軟刪除超期</a:t>
+                      </a:r>
+                    </a:p>
+                  </a:txBody>
+                  <a:tcPr marT="25400" marB="25400" marL="101600" anchor="ctr">
+                    <a:solidFill>
+                      <a:srgbClr val="F1F5F9"/>
+                    </a:solidFill>
+                  </a:tcPr>
+                </a:tc>
+                <a:tc>
+                  <a:txBody>
+                    <a:bodyPr/>
+                    <a:lstStyle/>
+                    <a:p>
+                      <a:r>
+                        <a:rPr sz="1200" b="0">
+                          <a:solidFill>
+                            <a:srgbClr val="0F172A"/>
+                          </a:solidFill>
+                          <a:latin typeface="PingFang TC"/>
+                          <a:ea typeface="PingFang TC"/>
+                        </a:rPr>
+                        <a:t>is_deleted 且 updated_at &lt; now - retention</a:t>
+                      </a:r>
+                    </a:p>
+                  </a:txBody>
+                  <a:tcPr marT="25400" marB="25400" marL="101600" anchor="ctr">
+                    <a:solidFill>
+                      <a:srgbClr val="F1F5F9"/>
+                    </a:solidFill>
+                  </a:tcPr>
+                </a:tc>
+                <a:tc>
+                  <a:txBody>
+                    <a:bodyPr/>
+                    <a:lstStyle/>
+                    <a:p>
+                      <a:r>
+                        <a:rPr sz="1200" b="0">
+                          <a:solidFill>
+                            <a:srgbClr val="0F172A"/>
+                          </a:solidFill>
+                          <a:latin typeface="PingFang TC"/>
+                          <a:ea typeface="PingFang TC"/>
+                        </a:rPr>
+                        <a:t>30 天</a:t>
+                      </a:r>
+                    </a:p>
+                  </a:txBody>
+                  <a:tcPr marT="25400" marB="25400" marL="101600" anchor="ctr">
+                    <a:solidFill>
+                      <a:srgbClr val="F1F5F9"/>
+                    </a:solidFill>
+                  </a:tcPr>
+                </a:tc>
+              </a:tr>
+              <a:tr h="434340">
+                <a:tc>
+                  <a:txBody>
+                    <a:bodyPr/>
+                    <a:lstStyle/>
+                    <a:p>
+                      <a:r>
+                        <a:rPr sz="1200" b="1">
+                          <a:solidFill>
+                            <a:srgbClr val="0F172A"/>
+                          </a:solidFill>
+                          <a:latin typeface="PingFang TC"/>
+                          <a:ea typeface="PingFang TC"/>
+                        </a:rPr>
+                        <a:t>連帶</a:t>
+                      </a:r>
+                    </a:p>
+                  </a:txBody>
+                  <a:tcPr marT="25400" marB="25400" marL="101600" anchor="ctr">
+                    <a:solidFill>
+                      <a:srgbClr val="FFFFFF"/>
+                    </a:solidFill>
+                  </a:tcPr>
+                </a:tc>
+                <a:tc>
+                  <a:txBody>
+                    <a:bodyPr/>
+                    <a:lstStyle/>
+                    <a:p>
+                      <a:r>
+                        <a:rPr sz="1200" b="0">
+                          <a:solidFill>
+                            <a:srgbClr val="0F172A"/>
+                          </a:solidFill>
+                          <a:latin typeface="PingFang TC"/>
+                          <a:ea typeface="PingFang TC"/>
+                        </a:rPr>
+                        <a:t>上述 token 的 scan_events 一併刪</a:t>
+                      </a:r>
+                    </a:p>
+                  </a:txBody>
+                  <a:tcPr marT="25400" marB="25400" marL="101600" anchor="ctr">
+                    <a:solidFill>
+                      <a:srgbClr val="FFFFFF"/>
+                    </a:solidFill>
+                  </a:tcPr>
+                </a:tc>
+                <a:tc>
+                  <a:txBody>
+                    <a:bodyPr/>
+                    <a:lstStyle/>
+                    <a:p>
+                      <a:r>
+                        <a:rPr sz="1200" b="0">
+                          <a:solidFill>
+                            <a:srgbClr val="0F172A"/>
+                          </a:solidFill>
+                          <a:latin typeface="PingFang TC"/>
+                          <a:ea typeface="PingFang TC"/>
+                        </a:rPr>
+                        <a:t>—</a:t>
+                      </a:r>
+                    </a:p>
+                  </a:txBody>
+                  <a:tcPr marT="25400" marB="25400" marL="101600" anchor="ctr">
+                    <a:solidFill>
+                      <a:srgbClr val="FFFFFF"/>
+                    </a:solidFill>
+                  </a:tcPr>
+                </a:tc>
+              </a:tr>
+            </a:tbl>
+          </a:graphicData>
+        </a:graphic>
+      </p:graphicFrame>
+      <p:sp>
+        <p:nvSpPr>
+          <p:cNvPr id="10" name="TextBox 9"/>
           <p:cNvSpPr txBox="1"/>
           <p:nvPr/>
         </p:nvSpPr>
         <p:spPr>
           <a:xfrm>
-            <a:off x="548640" y="4023360"/>
-            <a:ext cx="11247120" cy="2194560"/>
+            <a:off x="548640" y="5120640"/>
+            <a:ext cx="11247120" cy="1280160"/>
           </a:xfrm>
           <a:prstGeom prst="rect">
             <a:avLst/>
@@ -16916,52 +16730,35 @@
           <a:p>
             <a:pPr>
               <a:spcAft>
-                <a:spcPts val="900"/>
+                <a:spcPts val="800"/>
               </a:spcAft>
             </a:pPr>
             <a:r>
-              <a:rPr sz="1400" b="0">
+              <a:rPr sz="1300" b="0">
                 <a:solidFill>
                   <a:srgbClr val="0F172A"/>
                 </a:solidFill>
                 <a:latin typeface="PingFang TC"/>
                 <a:ea typeface="PingFang TC"/>
               </a:rPr>
-              <a:t>•  EC2 deploy-app.sh:從 SSM 撈設定 → ECR login → docker pull → docker run(換新容器)</a:t>
+              <a:t>•  單一來源:cleanup.py(SQLAlchemy+text SQL)Lambda 與本機共用;Lambda 用純 Python pg8000 免二進位打包</a:t>
             </a:r>
           </a:p>
           <a:p>
             <a:pPr>
               <a:spcAft>
-                <a:spcPts val="900"/>
+                <a:spcPts val="800"/>
               </a:spcAft>
             </a:pPr>
             <a:r>
-              <a:rPr sz="1400" b="0">
+              <a:rPr sz="1300" b="0">
                 <a:solidFill>
                   <a:srgbClr val="0F172A"/>
                 </a:solidFill>
                 <a:latin typeface="PingFang TC"/>
                 <a:ea typeface="PingFang TC"/>
               </a:rPr>
-              <a:t>•  全 env-gated:本機無這些環境變數 → 維持 SQLite + 記憶體 cache + 即時生圖,不受影響</a:t>
-            </a:r>
-          </a:p>
-          <a:p>
-            <a:pPr>
-              <a:spcAft>
-                <a:spcPts val="900"/>
-              </a:spcAft>
-            </a:pPr>
-            <a:r>
-              <a:rPr sz="1400" b="0">
-                <a:solidFill>
-                  <a:srgbClr val="0F172A"/>
-                </a:solidFill>
-                <a:latin typeface="PingFang TC"/>
-                <a:ea typeface="PingFang TC"/>
-              </a:rPr>
-              <a:t>•  部署踩到的兩個坑:① EC2 role 少 s3:PutObject(500)② CI build amd64 但 EC2 arm64(502)→ buildx 跨平台修正</a:t>
+              <a:t>•  與 app 實例解耦(不用 app 內排程,免多實例重複跑/leader election);保留天數皆 Terraform 變數可調</a:t>
             </a:r>
           </a:p>
         </p:txBody>
@@ -16993,13 +16790,13 @@
         <p:spPr>
           <a:xfrm>
             <a:off x="0" y="0"/>
-            <a:ext cx="12191695" cy="6858000"/>
+            <a:ext cx="164592" cy="6858000"/>
           </a:xfrm>
           <a:prstGeom prst="rect">
             <a:avLst/>
           </a:prstGeom>
           <a:solidFill>
-            <a:srgbClr val="0F172A"/>
+            <a:srgbClr val="2563EB"/>
           </a:solidFill>
           <a:ln>
             <a:noFill/>
@@ -17036,8 +16833,8 @@
         </p:nvSpPr>
         <p:spPr>
           <a:xfrm>
-            <a:off x="822960" y="1097280"/>
-            <a:ext cx="10515600" cy="1097280"/>
+            <a:off x="502920" y="320040"/>
+            <a:ext cx="10972800" cy="1005840"/>
           </a:xfrm>
           <a:prstGeom prst="rect">
             <a:avLst/>
@@ -17049,6 +16846,23 @@
             <a:spAutoFit/>
           </a:bodyPr>
           <a:lstStyle/>
+          <a:p>
+            <a:pPr algn="l">
+              <a:spcAft>
+                <a:spcPts val="200"/>
+              </a:spcAft>
+            </a:pPr>
+            <a:r>
+              <a:rPr sz="1300" b="1">
+                <a:solidFill>
+                  <a:srgbClr val="2563EB"/>
+                </a:solidFill>
+                <a:latin typeface="PingFang TC"/>
+                <a:ea typeface="PingFang TC"/>
+              </a:rPr>
+              <a:t>部署 · CI/CD</a:t>
+            </a:r>
+          </a:p>
           <a:p>
             <a:pPr algn="l">
               <a:spcAft>
@@ -17056,45 +16870,805 @@
               </a:spcAft>
             </a:pPr>
             <a:r>
-              <a:rPr sz="1600" b="1">
-                <a:solidFill>
-                  <a:srgbClr val="2563EB"/>
-                </a:solidFill>
-                <a:latin typeface="PingFang TC"/>
-                <a:ea typeface="PingFang TC"/>
-              </a:rPr>
-              <a:t>原型狀態</a:t>
-            </a:r>
-          </a:p>
-          <a:p>
-            <a:pPr algn="l">
-              <a:spcAft>
-                <a:spcPts val="400"/>
-              </a:spcAft>
-            </a:pPr>
-            <a:r>
               <a:rPr sz="3000" b="1">
                 <a:solidFill>
+                  <a:srgbClr val="0F172A"/>
+                </a:solidFill>
+                <a:latin typeface="PingFang TC"/>
+                <a:ea typeface="PingFang TC"/>
+              </a:rPr>
+              <a:t>CI/CD 流程（GitHub Actions + OIDC）</a:t>
+            </a:r>
+          </a:p>
+        </p:txBody>
+      </p:sp>
+      <p:sp>
+        <p:nvSpPr>
+          <p:cNvPr id="4" name="Rounded Rectangle 3"/>
+          <p:cNvSpPr/>
+          <p:nvPr/>
+        </p:nvSpPr>
+        <p:spPr>
+          <a:xfrm>
+            <a:off x="457200" y="2286000"/>
+            <a:ext cx="1481328" cy="1280160"/>
+          </a:xfrm>
+          <a:prstGeom prst="roundRect">
+            <a:avLst/>
+          </a:prstGeom>
+          <a:solidFill>
+            <a:srgbClr val="64748B"/>
+          </a:solidFill>
+          <a:ln>
+            <a:solidFill>
+              <a:srgbClr val="64748B"/>
+            </a:solidFill>
+          </a:ln>
+          <a:effectLst/>
+        </p:spPr>
+        <p:style>
+          <a:lnRef idx="1">
+            <a:schemeClr val="accent1"/>
+          </a:lnRef>
+          <a:fillRef idx="3">
+            <a:schemeClr val="accent1"/>
+          </a:fillRef>
+          <a:effectRef idx="2">
+            <a:schemeClr val="accent1"/>
+          </a:effectRef>
+          <a:fontRef idx="minor">
+            <a:schemeClr val="lt1"/>
+          </a:fontRef>
+        </p:style>
+        <p:txBody>
+          <a:bodyPr rtlCol="0" anchor="ctr" wrap="square" tIns="25400" bIns="25400"/>
+          <a:lstStyle/>
+          <a:p>
+            <a:pPr algn="ctr"/>
+            <a:r>
+              <a:rPr sz="1100" b="1">
+                <a:solidFill>
                   <a:srgbClr val="FFFFFF"/>
                 </a:solidFill>
                 <a:latin typeface="PingFang TC"/>
                 <a:ea typeface="PingFang TC"/>
               </a:rPr>
-              <a:t>可跑的 FastAPI 實作 + 管理頁前端</a:t>
-            </a:r>
-          </a:p>
-        </p:txBody>
-      </p:sp>
-      <p:sp>
-        <p:nvSpPr>
-          <p:cNvPr id="4" name="TextBox 3"/>
+              <a:t>git push</a:t>
+            </a:r>
+          </a:p>
+          <a:p>
+            <a:pPr algn="ctr"/>
+            <a:r>
+              <a:rPr sz="1100" b="0">
+                <a:solidFill>
+                  <a:srgbClr val="FFFFFF"/>
+                </a:solidFill>
+                <a:latin typeface="PingFang TC"/>
+                <a:ea typeface="PingFang TC"/>
+              </a:rPr>
+              <a:t>QR Code Generator/**</a:t>
+            </a:r>
+          </a:p>
+        </p:txBody>
+      </p:sp>
+      <p:cxnSp>
+        <p:nvCxnSpPr>
+          <p:cNvPr id="5" name="Connector 4"/>
+          <p:cNvCxnSpPr/>
+          <p:nvPr/>
+        </p:nvCxnSpPr>
+        <p:spPr>
+          <a:xfrm>
+            <a:off x="1938528" y="2926080"/>
+            <a:ext cx="118872" cy="0"/>
+          </a:xfrm>
+          <a:prstGeom prst="line">
+            <a:avLst/>
+          </a:prstGeom>
+          <a:ln w="22225">
+            <a:solidFill>
+              <a:srgbClr val="64748B"/>
+            </a:solidFill>
+            <a:tailEnd type="triangle" w="med" len="med"/>
+          </a:ln>
+        </p:spPr>
+        <p:style>
+          <a:lnRef idx="2">
+            <a:schemeClr val="accent1"/>
+          </a:lnRef>
+          <a:fillRef idx="0">
+            <a:schemeClr val="accent1"/>
+          </a:fillRef>
+          <a:effectRef idx="1">
+            <a:schemeClr val="accent1"/>
+          </a:effectRef>
+          <a:fontRef idx="minor">
+            <a:schemeClr val="tx1"/>
+          </a:fontRef>
+        </p:style>
+      </p:cxnSp>
+      <p:sp>
+        <p:nvSpPr>
+          <p:cNvPr id="6" name="Rounded Rectangle 5"/>
+          <p:cNvSpPr/>
+          <p:nvPr/>
+        </p:nvSpPr>
+        <p:spPr>
+          <a:xfrm>
+            <a:off x="2057400" y="2286000"/>
+            <a:ext cx="1481328" cy="1280160"/>
+          </a:xfrm>
+          <a:prstGeom prst="roundRect">
+            <a:avLst/>
+          </a:prstGeom>
+          <a:solidFill>
+            <a:srgbClr val="0EA5E9"/>
+          </a:solidFill>
+          <a:ln>
+            <a:solidFill>
+              <a:srgbClr val="0EA5E9"/>
+            </a:solidFill>
+          </a:ln>
+          <a:effectLst/>
+        </p:spPr>
+        <p:style>
+          <a:lnRef idx="1">
+            <a:schemeClr val="accent1"/>
+          </a:lnRef>
+          <a:fillRef idx="3">
+            <a:schemeClr val="accent1"/>
+          </a:fillRef>
+          <a:effectRef idx="2">
+            <a:schemeClr val="accent1"/>
+          </a:effectRef>
+          <a:fontRef idx="minor">
+            <a:schemeClr val="lt1"/>
+          </a:fontRef>
+        </p:style>
+        <p:txBody>
+          <a:bodyPr rtlCol="0" anchor="ctr" wrap="square" tIns="25400" bIns="25400"/>
+          <a:lstStyle/>
+          <a:p>
+            <a:pPr algn="ctr"/>
+            <a:r>
+              <a:rPr sz="1100" b="1">
+                <a:solidFill>
+                  <a:srgbClr val="FFFFFF"/>
+                </a:solidFill>
+                <a:latin typeface="PingFang TC"/>
+                <a:ea typeface="PingFang TC"/>
+              </a:rPr>
+              <a:t>GitHub Actions</a:t>
+            </a:r>
+          </a:p>
+          <a:p>
+            <a:pPr algn="ctr"/>
+            <a:r>
+              <a:rPr sz="1100" b="0">
+                <a:solidFill>
+                  <a:srgbClr val="FFFFFF"/>
+                </a:solidFill>
+                <a:latin typeface="PingFang TC"/>
+                <a:ea typeface="PingFang TC"/>
+              </a:rPr>
+              <a:t>OIDC assume role</a:t>
+            </a:r>
+          </a:p>
+          <a:p>
+            <a:pPr algn="ctr"/>
+            <a:r>
+              <a:rPr sz="1100" b="0">
+                <a:solidFill>
+                  <a:srgbClr val="FFFFFF"/>
+                </a:solidFill>
+                <a:latin typeface="PingFang TC"/>
+                <a:ea typeface="PingFang TC"/>
+              </a:rPr>
+              <a:t>(無長期金鑰)</a:t>
+            </a:r>
+          </a:p>
+        </p:txBody>
+      </p:sp>
+      <p:cxnSp>
+        <p:nvCxnSpPr>
+          <p:cNvPr id="7" name="Connector 6"/>
+          <p:cNvCxnSpPr/>
+          <p:nvPr/>
+        </p:nvCxnSpPr>
+        <p:spPr>
+          <a:xfrm>
+            <a:off x="3538728" y="2926080"/>
+            <a:ext cx="118872" cy="0"/>
+          </a:xfrm>
+          <a:prstGeom prst="line">
+            <a:avLst/>
+          </a:prstGeom>
+          <a:ln w="22225">
+            <a:solidFill>
+              <a:srgbClr val="64748B"/>
+            </a:solidFill>
+            <a:tailEnd type="triangle" w="med" len="med"/>
+          </a:ln>
+        </p:spPr>
+        <p:style>
+          <a:lnRef idx="2">
+            <a:schemeClr val="accent1"/>
+          </a:lnRef>
+          <a:fillRef idx="0">
+            <a:schemeClr val="accent1"/>
+          </a:fillRef>
+          <a:effectRef idx="1">
+            <a:schemeClr val="accent1"/>
+          </a:effectRef>
+          <a:fontRef idx="minor">
+            <a:schemeClr val="tx1"/>
+          </a:fontRef>
+        </p:style>
+      </p:cxnSp>
+      <p:sp>
+        <p:nvSpPr>
+          <p:cNvPr id="8" name="Rounded Rectangle 7"/>
+          <p:cNvSpPr/>
+          <p:nvPr/>
+        </p:nvSpPr>
+        <p:spPr>
+          <a:xfrm>
+            <a:off x="3657600" y="2286000"/>
+            <a:ext cx="1481328" cy="1280160"/>
+          </a:xfrm>
+          <a:prstGeom prst="roundRect">
+            <a:avLst/>
+          </a:prstGeom>
+          <a:solidFill>
+            <a:srgbClr val="2563EB"/>
+          </a:solidFill>
+          <a:ln>
+            <a:solidFill>
+              <a:srgbClr val="2563EB"/>
+            </a:solidFill>
+          </a:ln>
+          <a:effectLst/>
+        </p:spPr>
+        <p:style>
+          <a:lnRef idx="1">
+            <a:schemeClr val="accent1"/>
+          </a:lnRef>
+          <a:fillRef idx="3">
+            <a:schemeClr val="accent1"/>
+          </a:fillRef>
+          <a:effectRef idx="2">
+            <a:schemeClr val="accent1"/>
+          </a:effectRef>
+          <a:fontRef idx="minor">
+            <a:schemeClr val="lt1"/>
+          </a:fontRef>
+        </p:style>
+        <p:txBody>
+          <a:bodyPr rtlCol="0" anchor="ctr" wrap="square" tIns="25400" bIns="25400"/>
+          <a:lstStyle/>
+          <a:p>
+            <a:pPr algn="ctr"/>
+            <a:r>
+              <a:rPr sz="1100" b="1">
+                <a:solidFill>
+                  <a:srgbClr val="FFFFFF"/>
+                </a:solidFill>
+                <a:latin typeface="PingFang TC"/>
+                <a:ea typeface="PingFang TC"/>
+              </a:rPr>
+              <a:t>buildx</a:t>
+            </a:r>
+          </a:p>
+          <a:p>
+            <a:pPr algn="ctr"/>
+            <a:r>
+              <a:rPr sz="1100" b="0">
+                <a:solidFill>
+                  <a:srgbClr val="FFFFFF"/>
+                </a:solidFill>
+                <a:latin typeface="PingFang TC"/>
+                <a:ea typeface="PingFang TC"/>
+              </a:rPr>
+              <a:t>--platform</a:t>
+            </a:r>
+          </a:p>
+          <a:p>
+            <a:pPr algn="ctr"/>
+            <a:r>
+              <a:rPr sz="1100" b="0">
+                <a:solidFill>
+                  <a:srgbClr val="FFFFFF"/>
+                </a:solidFill>
+                <a:latin typeface="PingFang TC"/>
+                <a:ea typeface="PingFang TC"/>
+              </a:rPr>
+              <a:t>linux/arm64</a:t>
+            </a:r>
+          </a:p>
+        </p:txBody>
+      </p:sp>
+      <p:cxnSp>
+        <p:nvCxnSpPr>
+          <p:cNvPr id="9" name="Connector 8"/>
+          <p:cNvCxnSpPr/>
+          <p:nvPr/>
+        </p:nvCxnSpPr>
+        <p:spPr>
+          <a:xfrm>
+            <a:off x="5138928" y="2926080"/>
+            <a:ext cx="118872" cy="0"/>
+          </a:xfrm>
+          <a:prstGeom prst="line">
+            <a:avLst/>
+          </a:prstGeom>
+          <a:ln w="22225">
+            <a:solidFill>
+              <a:srgbClr val="64748B"/>
+            </a:solidFill>
+            <a:tailEnd type="triangle" w="med" len="med"/>
+          </a:ln>
+        </p:spPr>
+        <p:style>
+          <a:lnRef idx="2">
+            <a:schemeClr val="accent1"/>
+          </a:lnRef>
+          <a:fillRef idx="0">
+            <a:schemeClr val="accent1"/>
+          </a:fillRef>
+          <a:effectRef idx="1">
+            <a:schemeClr val="accent1"/>
+          </a:effectRef>
+          <a:fontRef idx="minor">
+            <a:schemeClr val="tx1"/>
+          </a:fontRef>
+        </p:style>
+      </p:cxnSp>
+      <p:sp>
+        <p:nvSpPr>
+          <p:cNvPr id="10" name="Rounded Rectangle 9"/>
+          <p:cNvSpPr/>
+          <p:nvPr/>
+        </p:nvSpPr>
+        <p:spPr>
+          <a:xfrm>
+            <a:off x="5257800" y="2286000"/>
+            <a:ext cx="1481328" cy="1280160"/>
+          </a:xfrm>
+          <a:prstGeom prst="roundRect">
+            <a:avLst/>
+          </a:prstGeom>
+          <a:solidFill>
+            <a:srgbClr val="059669"/>
+          </a:solidFill>
+          <a:ln>
+            <a:solidFill>
+              <a:srgbClr val="059669"/>
+            </a:solidFill>
+          </a:ln>
+          <a:effectLst/>
+        </p:spPr>
+        <p:style>
+          <a:lnRef idx="1">
+            <a:schemeClr val="accent1"/>
+          </a:lnRef>
+          <a:fillRef idx="3">
+            <a:schemeClr val="accent1"/>
+          </a:fillRef>
+          <a:effectRef idx="2">
+            <a:schemeClr val="accent1"/>
+          </a:effectRef>
+          <a:fontRef idx="minor">
+            <a:schemeClr val="lt1"/>
+          </a:fontRef>
+        </p:style>
+        <p:txBody>
+          <a:bodyPr rtlCol="0" anchor="ctr" wrap="square" tIns="25400" bIns="25400"/>
+          <a:lstStyle/>
+          <a:p>
+            <a:pPr algn="ctr"/>
+            <a:r>
+              <a:rPr sz="1100" b="1">
+                <a:solidFill>
+                  <a:srgbClr val="FFFFFF"/>
+                </a:solidFill>
+                <a:latin typeface="PingFang TC"/>
+                <a:ea typeface="PingFang TC"/>
+              </a:rPr>
+              <a:t>ECR push</a:t>
+            </a:r>
+          </a:p>
+          <a:p>
+            <a:pPr algn="ctr"/>
+            <a:r>
+              <a:rPr sz="1100" b="0">
+                <a:solidFill>
+                  <a:srgbClr val="FFFFFF"/>
+                </a:solidFill>
+                <a:latin typeface="PingFang TC"/>
+                <a:ea typeface="PingFang TC"/>
+              </a:rPr>
+              <a:t>tag = SHA</a:t>
+            </a:r>
+          </a:p>
+          <a:p>
+            <a:pPr algn="ctr"/>
+            <a:r>
+              <a:rPr sz="1100" b="0">
+                <a:solidFill>
+                  <a:srgbClr val="FFFFFF"/>
+                </a:solidFill>
+                <a:latin typeface="PingFang TC"/>
+                <a:ea typeface="PingFang TC"/>
+              </a:rPr>
+              <a:t>+ latest</a:t>
+            </a:r>
+          </a:p>
+        </p:txBody>
+      </p:sp>
+      <p:cxnSp>
+        <p:nvCxnSpPr>
+          <p:cNvPr id="11" name="Connector 10"/>
+          <p:cNvCxnSpPr/>
+          <p:nvPr/>
+        </p:nvCxnSpPr>
+        <p:spPr>
+          <a:xfrm>
+            <a:off x="6739128" y="2926080"/>
+            <a:ext cx="118872" cy="0"/>
+          </a:xfrm>
+          <a:prstGeom prst="line">
+            <a:avLst/>
+          </a:prstGeom>
+          <a:ln w="22225">
+            <a:solidFill>
+              <a:srgbClr val="64748B"/>
+            </a:solidFill>
+            <a:tailEnd type="triangle" w="med" len="med"/>
+          </a:ln>
+        </p:spPr>
+        <p:style>
+          <a:lnRef idx="2">
+            <a:schemeClr val="accent1"/>
+          </a:lnRef>
+          <a:fillRef idx="0">
+            <a:schemeClr val="accent1"/>
+          </a:fillRef>
+          <a:effectRef idx="1">
+            <a:schemeClr val="accent1"/>
+          </a:effectRef>
+          <a:fontRef idx="minor">
+            <a:schemeClr val="tx1"/>
+          </a:fontRef>
+        </p:style>
+      </p:cxnSp>
+      <p:sp>
+        <p:nvSpPr>
+          <p:cNvPr id="12" name="Rounded Rectangle 11"/>
+          <p:cNvSpPr/>
+          <p:nvPr/>
+        </p:nvSpPr>
+        <p:spPr>
+          <a:xfrm>
+            <a:off x="6858000" y="2286000"/>
+            <a:ext cx="1481328" cy="1280160"/>
+          </a:xfrm>
+          <a:prstGeom prst="roundRect">
+            <a:avLst/>
+          </a:prstGeom>
+          <a:solidFill>
+            <a:srgbClr val="7C3AED"/>
+          </a:solidFill>
+          <a:ln>
+            <a:solidFill>
+              <a:srgbClr val="7C3AED"/>
+            </a:solidFill>
+          </a:ln>
+          <a:effectLst/>
+        </p:spPr>
+        <p:style>
+          <a:lnRef idx="1">
+            <a:schemeClr val="accent1"/>
+          </a:lnRef>
+          <a:fillRef idx="3">
+            <a:schemeClr val="accent1"/>
+          </a:fillRef>
+          <a:effectRef idx="2">
+            <a:schemeClr val="accent1"/>
+          </a:effectRef>
+          <a:fontRef idx="minor">
+            <a:schemeClr val="lt1"/>
+          </a:fontRef>
+        </p:style>
+        <p:txBody>
+          <a:bodyPr rtlCol="0" anchor="ctr" wrap="square" tIns="25400" bIns="25400"/>
+          <a:lstStyle/>
+          <a:p>
+            <a:pPr algn="ctr"/>
+            <a:r>
+              <a:rPr sz="1100" b="1">
+                <a:solidFill>
+                  <a:srgbClr val="FFFFFF"/>
+                </a:solidFill>
+                <a:latin typeface="PingFang TC"/>
+                <a:ea typeface="PingFang TC"/>
+              </a:rPr>
+              <a:t>SSM 更新</a:t>
+            </a:r>
+          </a:p>
+          <a:p>
+            <a:pPr algn="ctr"/>
+            <a:r>
+              <a:rPr sz="1100" b="0">
+                <a:solidFill>
+                  <a:srgbClr val="FFFFFF"/>
+                </a:solidFill>
+                <a:latin typeface="PingFang TC"/>
+                <a:ea typeface="PingFang TC"/>
+              </a:rPr>
+              <a:t>/qrcode/</a:t>
+            </a:r>
+          </a:p>
+          <a:p>
+            <a:pPr algn="ctr"/>
+            <a:r>
+              <a:rPr sz="1100" b="0">
+                <a:solidFill>
+                  <a:srgbClr val="FFFFFF"/>
+                </a:solidFill>
+                <a:latin typeface="PingFang TC"/>
+                <a:ea typeface="PingFang TC"/>
+              </a:rPr>
+              <a:t>IMAGE_URI</a:t>
+            </a:r>
+          </a:p>
+        </p:txBody>
+      </p:sp>
+      <p:cxnSp>
+        <p:nvCxnSpPr>
+          <p:cNvPr id="13" name="Connector 12"/>
+          <p:cNvCxnSpPr/>
+          <p:nvPr/>
+        </p:nvCxnSpPr>
+        <p:spPr>
+          <a:xfrm>
+            <a:off x="8339328" y="2926080"/>
+            <a:ext cx="118872" cy="0"/>
+          </a:xfrm>
+          <a:prstGeom prst="line">
+            <a:avLst/>
+          </a:prstGeom>
+          <a:ln w="22225">
+            <a:solidFill>
+              <a:srgbClr val="64748B"/>
+            </a:solidFill>
+            <a:tailEnd type="triangle" w="med" len="med"/>
+          </a:ln>
+        </p:spPr>
+        <p:style>
+          <a:lnRef idx="2">
+            <a:schemeClr val="accent1"/>
+          </a:lnRef>
+          <a:fillRef idx="0">
+            <a:schemeClr val="accent1"/>
+          </a:fillRef>
+          <a:effectRef idx="1">
+            <a:schemeClr val="accent1"/>
+          </a:effectRef>
+          <a:fontRef idx="minor">
+            <a:schemeClr val="tx1"/>
+          </a:fontRef>
+        </p:style>
+      </p:cxnSp>
+      <p:sp>
+        <p:nvSpPr>
+          <p:cNvPr id="14" name="Rounded Rectangle 13"/>
+          <p:cNvSpPr/>
+          <p:nvPr/>
+        </p:nvSpPr>
+        <p:spPr>
+          <a:xfrm>
+            <a:off x="8458200" y="2286000"/>
+            <a:ext cx="1481328" cy="1280160"/>
+          </a:xfrm>
+          <a:prstGeom prst="roundRect">
+            <a:avLst/>
+          </a:prstGeom>
+          <a:solidFill>
+            <a:srgbClr val="D97706"/>
+          </a:solidFill>
+          <a:ln>
+            <a:solidFill>
+              <a:srgbClr val="D97706"/>
+            </a:solidFill>
+          </a:ln>
+          <a:effectLst/>
+        </p:spPr>
+        <p:style>
+          <a:lnRef idx="1">
+            <a:schemeClr val="accent1"/>
+          </a:lnRef>
+          <a:fillRef idx="3">
+            <a:schemeClr val="accent1"/>
+          </a:fillRef>
+          <a:effectRef idx="2">
+            <a:schemeClr val="accent1"/>
+          </a:effectRef>
+          <a:fontRef idx="minor">
+            <a:schemeClr val="lt1"/>
+          </a:fontRef>
+        </p:style>
+        <p:txBody>
+          <a:bodyPr rtlCol="0" anchor="ctr" wrap="square" tIns="25400" bIns="25400"/>
+          <a:lstStyle/>
+          <a:p>
+            <a:pPr algn="ctr"/>
+            <a:r>
+              <a:rPr sz="1100" b="1">
+                <a:solidFill>
+                  <a:srgbClr val="FFFFFF"/>
+                </a:solidFill>
+                <a:latin typeface="PingFang TC"/>
+                <a:ea typeface="PingFang TC"/>
+              </a:rPr>
+              <a:t>SSM 部署</a:t>
+            </a:r>
+          </a:p>
+          <a:p>
+            <a:pPr algn="ctr"/>
+            <a:r>
+              <a:rPr sz="1100" b="0">
+                <a:solidFill>
+                  <a:srgbClr val="FFFFFF"/>
+                </a:solidFill>
+                <a:latin typeface="PingFang TC"/>
+                <a:ea typeface="PingFang TC"/>
+              </a:rPr>
+              <a:t>→ EC2</a:t>
+            </a:r>
+          </a:p>
+          <a:p>
+            <a:pPr algn="ctr"/>
+            <a:r>
+              <a:rPr sz="1100" b="0">
+                <a:solidFill>
+                  <a:srgbClr val="FFFFFF"/>
+                </a:solidFill>
+                <a:latin typeface="PingFang TC"/>
+                <a:ea typeface="PingFang TC"/>
+              </a:rPr>
+              <a:t>deploy-app.sh</a:t>
+            </a:r>
+          </a:p>
+        </p:txBody>
+      </p:sp>
+      <p:cxnSp>
+        <p:nvCxnSpPr>
+          <p:cNvPr id="15" name="Connector 14"/>
+          <p:cNvCxnSpPr/>
+          <p:nvPr/>
+        </p:nvCxnSpPr>
+        <p:spPr>
+          <a:xfrm>
+            <a:off x="9939528" y="2926080"/>
+            <a:ext cx="118872" cy="0"/>
+          </a:xfrm>
+          <a:prstGeom prst="line">
+            <a:avLst/>
+          </a:prstGeom>
+          <a:ln w="22225">
+            <a:solidFill>
+              <a:srgbClr val="64748B"/>
+            </a:solidFill>
+            <a:tailEnd type="triangle" w="med" len="med"/>
+          </a:ln>
+        </p:spPr>
+        <p:style>
+          <a:lnRef idx="2">
+            <a:schemeClr val="accent1"/>
+          </a:lnRef>
+          <a:fillRef idx="0">
+            <a:schemeClr val="accent1"/>
+          </a:fillRef>
+          <a:effectRef idx="1">
+            <a:schemeClr val="accent1"/>
+          </a:effectRef>
+          <a:fontRef idx="minor">
+            <a:schemeClr val="tx1"/>
+          </a:fontRef>
+        </p:style>
+      </p:cxnSp>
+      <p:sp>
+        <p:nvSpPr>
+          <p:cNvPr id="16" name="Rounded Rectangle 15"/>
+          <p:cNvSpPr/>
+          <p:nvPr/>
+        </p:nvSpPr>
+        <p:spPr>
+          <a:xfrm>
+            <a:off x="10058400" y="2286000"/>
+            <a:ext cx="1481328" cy="1280160"/>
+          </a:xfrm>
+          <a:prstGeom prst="roundRect">
+            <a:avLst/>
+          </a:prstGeom>
+          <a:solidFill>
+            <a:srgbClr val="059669"/>
+          </a:solidFill>
+          <a:ln>
+            <a:solidFill>
+              <a:srgbClr val="059669"/>
+            </a:solidFill>
+          </a:ln>
+          <a:effectLst/>
+        </p:spPr>
+        <p:style>
+          <a:lnRef idx="1">
+            <a:schemeClr val="accent1"/>
+          </a:lnRef>
+          <a:fillRef idx="3">
+            <a:schemeClr val="accent1"/>
+          </a:fillRef>
+          <a:effectRef idx="2">
+            <a:schemeClr val="accent1"/>
+          </a:effectRef>
+          <a:fontRef idx="minor">
+            <a:schemeClr val="lt1"/>
+          </a:fontRef>
+        </p:style>
+        <p:txBody>
+          <a:bodyPr rtlCol="0" anchor="ctr" wrap="square" tIns="25400" bIns="25400"/>
+          <a:lstStyle/>
+          <a:p>
+            <a:pPr algn="ctr"/>
+            <a:r>
+              <a:rPr sz="1100" b="1">
+                <a:solidFill>
+                  <a:srgbClr val="FFFFFF"/>
+                </a:solidFill>
+                <a:latin typeface="PingFang TC"/>
+                <a:ea typeface="PingFang TC"/>
+              </a:rPr>
+              <a:t>上線</a:t>
+            </a:r>
+          </a:p>
+          <a:p>
+            <a:pPr algn="ctr"/>
+            <a:r>
+              <a:rPr sz="1100" b="0">
+                <a:solidFill>
+                  <a:srgbClr val="FFFFFF"/>
+                </a:solidFill>
+                <a:latin typeface="PingFang TC"/>
+                <a:ea typeface="PingFang TC"/>
+              </a:rPr>
+              <a:t>ALB /health</a:t>
+            </a:r>
+          </a:p>
+          <a:p>
+            <a:pPr algn="ctr"/>
+            <a:r>
+              <a:rPr sz="1100" b="0">
+                <a:solidFill>
+                  <a:srgbClr val="FFFFFF"/>
+                </a:solidFill>
+                <a:latin typeface="PingFang TC"/>
+                <a:ea typeface="PingFang TC"/>
+              </a:rPr>
+              <a:t>通過</a:t>
+            </a:r>
+          </a:p>
+        </p:txBody>
+      </p:sp>
+      <p:sp>
+        <p:nvSpPr>
+          <p:cNvPr id="17" name="TextBox 16"/>
           <p:cNvSpPr txBox="1"/>
           <p:nvPr/>
         </p:nvSpPr>
         <p:spPr>
           <a:xfrm>
-            <a:off x="822960" y="2743200"/>
-            <a:ext cx="10515600" cy="2743200"/>
+            <a:off x="548640" y="4023360"/>
+            <a:ext cx="11247120" cy="2194560"/>
           </a:xfrm>
           <a:prstGeom prst="rect">
             <a:avLst/>
@@ -17109,69 +17683,52 @@
           <a:p>
             <a:pPr>
               <a:spcAft>
-                <a:spcPts val="1200"/>
+                <a:spcPts val="900"/>
               </a:spcAft>
             </a:pPr>
             <a:r>
-              <a:rPr sz="1600" b="0">
-                <a:solidFill>
-                  <a:srgbClr val="E2E8F0"/>
-                </a:solidFill>
-                <a:latin typeface="PingFang TC"/>
-                <a:ea typeface="PingFang TC"/>
-              </a:rPr>
-              <a:t>✓  7 個 API 端點 + 管理頁前端（建立/清單/編輯/刪除/分析）</a:t>
+              <a:rPr sz="1400" b="0">
+                <a:solidFill>
+                  <a:srgbClr val="0F172A"/>
+                </a:solidFill>
+                <a:latin typeface="PingFang TC"/>
+                <a:ea typeface="PingFang TC"/>
+              </a:rPr>
+              <a:t>•  EC2 deploy-app.sh:從 SSM 撈設定 → ECR login → docker pull → docker run(換新容器)</a:t>
             </a:r>
           </a:p>
           <a:p>
             <a:pPr>
               <a:spcAft>
-                <a:spcPts val="1200"/>
+                <a:spcPts val="900"/>
               </a:spcAft>
             </a:pPr>
             <a:r>
-              <a:rPr sz="1600" b="0">
-                <a:solidFill>
-                  <a:srgbClr val="E2E8F0"/>
-                </a:solidFill>
-                <a:latin typeface="PingFang TC"/>
-                <a:ea typeface="PingFang TC"/>
-              </a:rPr>
-              <a:t>✓  全部 curl 驗證通過：302 / 404 / 410 / 8 碼 token / 正規化 / SSRF / 過期</a:t>
+              <a:rPr sz="1400" b="0">
+                <a:solidFill>
+                  <a:srgbClr val="0F172A"/>
+                </a:solidFill>
+                <a:latin typeface="PingFang TC"/>
+                <a:ea typeface="PingFang TC"/>
+              </a:rPr>
+              <a:t>•  全 env-gated:本機無這些環境變數 → 維持 SQLite + 記憶體 cache + 即時生圖,不受影響</a:t>
             </a:r>
           </a:p>
           <a:p>
             <a:pPr>
               <a:spcAft>
-                <a:spcPts val="1200"/>
+                <a:spcPts val="900"/>
               </a:spcAft>
             </a:pPr>
             <a:r>
-              <a:rPr sz="1600" b="0">
-                <a:solidFill>
-                  <a:srgbClr val="E2E8F0"/>
-                </a:solidFill>
-                <a:latin typeface="PingFang TC"/>
-                <a:ea typeface="PingFang TC"/>
-              </a:rPr>
-              <a:t>✓  production 替換點已在程式註解標明（Redis / 佇列 / CDN / 預聚合 / PostgreSQL）</a:t>
-            </a:r>
-          </a:p>
-          <a:p>
-            <a:pPr>
-              <a:spcAft>
-                <a:spcPts val="1200"/>
-              </a:spcAft>
-            </a:pPr>
-            <a:r>
-              <a:rPr sz="1600" b="0">
-                <a:solidFill>
-                  <a:srgbClr val="E2E8F0"/>
-                </a:solidFill>
-                <a:latin typeface="PingFang TC"/>
-                <a:ea typeface="PingFang TC"/>
-              </a:rPr>
-              <a:t>✓  設計依據：DESIGN.md（16 題決策 + 優劣分析）</a:t>
+              <a:rPr sz="1400" b="0">
+                <a:solidFill>
+                  <a:srgbClr val="0F172A"/>
+                </a:solidFill>
+                <a:latin typeface="PingFang TC"/>
+                <a:ea typeface="PingFang TC"/>
+              </a:rPr>
+              <a:t>•  部署踩到的兩個坑:① EC2 role 少 s3:PutObject(500)② CI build amd64 但 EC2 arm64(502)→ buildx 跨平台修正</a:t>
             </a:r>
           </a:p>
         </p:txBody>
@@ -17203,13 +17760,13 @@
         <p:spPr>
           <a:xfrm>
             <a:off x="0" y="0"/>
-            <a:ext cx="164592" cy="6858000"/>
+            <a:ext cx="12191695" cy="6858000"/>
           </a:xfrm>
           <a:prstGeom prst="rect">
             <a:avLst/>
           </a:prstGeom>
           <a:solidFill>
-            <a:srgbClr val="2563EB"/>
+            <a:srgbClr val="0F172A"/>
           </a:solidFill>
           <a:ln>
             <a:noFill/>
@@ -17246,8 +17803,8 @@
         </p:nvSpPr>
         <p:spPr>
           <a:xfrm>
-            <a:off x="502920" y="320040"/>
-            <a:ext cx="10972800" cy="1005840"/>
+            <a:off x="822960" y="1097280"/>
+            <a:ext cx="10515600" cy="1097280"/>
           </a:xfrm>
           <a:prstGeom prst="rect">
             <a:avLst/>
@@ -17259,23 +17816,6 @@
             <a:spAutoFit/>
           </a:bodyPr>
           <a:lstStyle/>
-          <a:p>
-            <a:pPr algn="l">
-              <a:spcAft>
-                <a:spcPts val="200"/>
-              </a:spcAft>
-            </a:pPr>
-            <a:r>
-              <a:rPr sz="1300" b="1">
-                <a:solidFill>
-                  <a:srgbClr val="2563EB"/>
-                </a:solidFill>
-                <a:latin typeface="PingFang TC"/>
-                <a:ea typeface="PingFang TC"/>
-              </a:rPr>
-              <a:t>下週預告 · NEXT WEEK</a:t>
-            </a:r>
-          </a:p>
           <a:p>
             <a:pPr algn="l">
               <a:spcAft>
@@ -17283,39 +17823,16 @@
               </a:spcAft>
             </a:pPr>
             <a:r>
-              <a:rPr sz="3000" b="1">
-                <a:solidFill>
-                  <a:srgbClr val="0F172A"/>
-                </a:solidFill>
-                <a:latin typeface="PingFang TC"/>
-                <a:ea typeface="PingFang TC"/>
-              </a:rPr>
-              <a:t>從 Prototype 到 Production 的巨大鴻溝</a:t>
-            </a:r>
-          </a:p>
-        </p:txBody>
-      </p:sp>
-      <p:sp>
-        <p:nvSpPr>
-          <p:cNvPr id="4" name="TextBox 3"/>
-          <p:cNvSpPr txBox="1"/>
-          <p:nvPr/>
-        </p:nvSpPr>
-        <p:spPr>
-          <a:xfrm>
-            <a:off x="548640" y="1371600"/>
-            <a:ext cx="10972800" cy="365760"/>
-          </a:xfrm>
-          <a:prstGeom prst="rect">
-            <a:avLst/>
-          </a:prstGeom>
-          <a:noFill/>
-        </p:spPr>
-        <p:txBody>
-          <a:bodyPr wrap="square" anchor="t">
-            <a:spAutoFit/>
-          </a:bodyPr>
-          <a:lstStyle/>
+              <a:rPr sz="1600" b="1">
+                <a:solidFill>
+                  <a:srgbClr val="2563EB"/>
+                </a:solidFill>
+                <a:latin typeface="PingFang TC"/>
+                <a:ea typeface="PingFang TC"/>
+              </a:rPr>
+              <a:t>原型狀態</a:t>
+            </a:r>
+          </a:p>
           <a:p>
             <a:pPr algn="l">
               <a:spcAft>
@@ -17323,897 +17840,105 @@
               </a:spcAft>
             </a:pPr>
             <a:r>
-              <a:rPr sz="1400" b="0">
-                <a:solidFill>
-                  <a:srgbClr val="64748B"/>
-                </a:solidFill>
-                <a:latin typeface="PingFang TC"/>
-                <a:ea typeface="PingFang TC"/>
-              </a:rPr>
-              <a:t>快速掃過，建立全貌 — 下週 Deep Dive 才是主菜</a:t>
-            </a:r>
-          </a:p>
-        </p:txBody>
-      </p:sp>
-      <p:sp>
-        <p:nvSpPr>
-          <p:cNvPr id="5" name="Rounded Rectangle 4"/>
-          <p:cNvSpPr/>
-          <p:nvPr/>
-        </p:nvSpPr>
-        <p:spPr>
-          <a:xfrm>
-            <a:off x="548640" y="1965960"/>
-            <a:ext cx="3611880" cy="1600200"/>
-          </a:xfrm>
-          <a:prstGeom prst="roundRect">
-            <a:avLst/>
-          </a:prstGeom>
-          <a:solidFill>
-            <a:srgbClr val="F1F5F9"/>
-          </a:solidFill>
-          <a:ln>
-            <a:solidFill>
-              <a:srgbClr val="F1F5F9"/>
-            </a:solidFill>
-          </a:ln>
-          <a:effectLst/>
-        </p:spPr>
-        <p:style>
-          <a:lnRef idx="1">
-            <a:schemeClr val="accent1"/>
-          </a:lnRef>
-          <a:fillRef idx="3">
-            <a:schemeClr val="accent1"/>
-          </a:fillRef>
-          <a:effectRef idx="2">
-            <a:schemeClr val="accent1"/>
-          </a:effectRef>
-          <a:fontRef idx="minor">
-            <a:schemeClr val="lt1"/>
-          </a:fontRef>
-        </p:style>
-        <p:txBody>
-          <a:bodyPr rtlCol="0" anchor="ctr"/>
-          <a:lstStyle/>
-          <a:p>
-            <a:pPr algn="ctr"/>
-          </a:p>
-        </p:txBody>
-      </p:sp>
-      <p:sp>
-        <p:nvSpPr>
-          <p:cNvPr id="6" name="Rectangle 5"/>
-          <p:cNvSpPr/>
-          <p:nvPr/>
-        </p:nvSpPr>
-        <p:spPr>
-          <a:xfrm>
-            <a:off x="548640" y="1965960"/>
-            <a:ext cx="82296" cy="1600200"/>
+              <a:rPr sz="3000" b="1">
+                <a:solidFill>
+                  <a:srgbClr val="FFFFFF"/>
+                </a:solidFill>
+                <a:latin typeface="PingFang TC"/>
+                <a:ea typeface="PingFang TC"/>
+              </a:rPr>
+              <a:t>可跑的 FastAPI 實作 + 管理頁前端</a:t>
+            </a:r>
+          </a:p>
+        </p:txBody>
+      </p:sp>
+      <p:sp>
+        <p:nvSpPr>
+          <p:cNvPr id="4" name="TextBox 3"/>
+          <p:cNvSpPr txBox="1"/>
+          <p:nvPr/>
+        </p:nvSpPr>
+        <p:spPr>
+          <a:xfrm>
+            <a:off x="822960" y="2743200"/>
+            <a:ext cx="10515600" cy="2743200"/>
           </a:xfrm>
           <a:prstGeom prst="rect">
             <a:avLst/>
           </a:prstGeom>
-          <a:solidFill>
-            <a:srgbClr val="D97706"/>
-          </a:solidFill>
-          <a:ln>
-            <a:noFill/>
-          </a:ln>
-          <a:effectLst/>
-        </p:spPr>
-        <p:style>
-          <a:lnRef idx="1">
-            <a:schemeClr val="accent1"/>
-          </a:lnRef>
-          <a:fillRef idx="3">
-            <a:schemeClr val="accent1"/>
-          </a:fillRef>
-          <a:effectRef idx="2">
-            <a:schemeClr val="accent1"/>
-          </a:effectRef>
-          <a:fontRef idx="minor">
-            <a:schemeClr val="lt1"/>
-          </a:fontRef>
-        </p:style>
-        <p:txBody>
-          <a:bodyPr rtlCol="0" anchor="ctr"/>
-          <a:lstStyle/>
-          <a:p>
-            <a:pPr algn="ctr"/>
-          </a:p>
-        </p:txBody>
-      </p:sp>
-      <p:sp>
-        <p:nvSpPr>
-          <p:cNvPr id="7" name="TextBox 6"/>
-          <p:cNvSpPr txBox="1"/>
-          <p:nvPr/>
-        </p:nvSpPr>
-        <p:spPr>
-          <a:xfrm>
-            <a:off x="822960" y="2148840"/>
-            <a:ext cx="3154680" cy="1325880"/>
-          </a:xfrm>
-          <a:prstGeom prst="rect">
-            <a:avLst/>
-          </a:prstGeom>
           <a:noFill/>
         </p:spPr>
         <p:txBody>
-          <a:bodyPr wrap="square" anchor="t">
+          <a:bodyPr wrap="square">
             <a:spAutoFit/>
           </a:bodyPr>
           <a:lstStyle/>
           <a:p>
-            <a:pPr algn="l">
+            <a:pPr>
               <a:spcAft>
-                <a:spcPts val="800"/>
+                <a:spcPts val="1200"/>
               </a:spcAft>
             </a:pPr>
             <a:r>
-              <a:rPr sz="1600" b="1">
-                <a:solidFill>
-                  <a:srgbClr val="0F172A"/>
-                </a:solidFill>
-                <a:latin typeface="PingFang TC"/>
-                <a:ea typeface="PingFang TC"/>
-              </a:rPr>
-              <a:t>[Error Handling]</a:t>
-            </a:r>
-          </a:p>
-          <a:p>
-            <a:pPr algn="l">
+              <a:rPr sz="1600" b="0">
+                <a:solidFill>
+                  <a:srgbClr val="E2E8F0"/>
+                </a:solidFill>
+                <a:latin typeface="PingFang TC"/>
+                <a:ea typeface="PingFang TC"/>
+              </a:rPr>
+              <a:t>✓  7 個 API 端點 + 管理頁前端（建立/清單/編輯/刪除/分析）</a:t>
+            </a:r>
+          </a:p>
+          <a:p>
+            <a:pPr>
               <a:spcAft>
-                <a:spcPts val="400"/>
+                <a:spcPts val="1200"/>
               </a:spcAft>
             </a:pPr>
             <a:r>
-              <a:rPr sz="1300" b="0">
-                <a:solidFill>
-                  <a:srgbClr val="64748B"/>
-                </a:solidFill>
-                <a:latin typeface="PingFang TC"/>
-                <a:ea typeface="PingFang TC"/>
-              </a:rPr>
-              <a:t>遇到不合法輸入直接 Crash。</a:t>
-            </a:r>
-          </a:p>
-        </p:txBody>
-      </p:sp>
-      <p:sp>
-        <p:nvSpPr>
-          <p:cNvPr id="8" name="Rounded Rectangle 7"/>
-          <p:cNvSpPr/>
-          <p:nvPr/>
-        </p:nvSpPr>
-        <p:spPr>
-          <a:xfrm>
-            <a:off x="4407408" y="1965960"/>
-            <a:ext cx="3611880" cy="1600200"/>
-          </a:xfrm>
-          <a:prstGeom prst="roundRect">
-            <a:avLst/>
-          </a:prstGeom>
-          <a:solidFill>
-            <a:srgbClr val="F1F5F9"/>
-          </a:solidFill>
-          <a:ln>
-            <a:solidFill>
-              <a:srgbClr val="F1F5F9"/>
-            </a:solidFill>
-          </a:ln>
-          <a:effectLst/>
-        </p:spPr>
-        <p:style>
-          <a:lnRef idx="1">
-            <a:schemeClr val="accent1"/>
-          </a:lnRef>
-          <a:fillRef idx="3">
-            <a:schemeClr val="accent1"/>
-          </a:fillRef>
-          <a:effectRef idx="2">
-            <a:schemeClr val="accent1"/>
-          </a:effectRef>
-          <a:fontRef idx="minor">
-            <a:schemeClr val="lt1"/>
-          </a:fontRef>
-        </p:style>
-        <p:txBody>
-          <a:bodyPr rtlCol="0" anchor="ctr"/>
-          <a:lstStyle/>
-          <a:p>
-            <a:pPr algn="ctr"/>
-          </a:p>
-        </p:txBody>
-      </p:sp>
-      <p:sp>
-        <p:nvSpPr>
-          <p:cNvPr id="9" name="Rectangle 8"/>
-          <p:cNvSpPr/>
-          <p:nvPr/>
-        </p:nvSpPr>
-        <p:spPr>
-          <a:xfrm>
-            <a:off x="4407408" y="1965960"/>
-            <a:ext cx="82296" cy="1600200"/>
-          </a:xfrm>
-          <a:prstGeom prst="rect">
-            <a:avLst/>
-          </a:prstGeom>
-          <a:solidFill>
-            <a:srgbClr val="D97706"/>
-          </a:solidFill>
-          <a:ln>
-            <a:noFill/>
-          </a:ln>
-          <a:effectLst/>
-        </p:spPr>
-        <p:style>
-          <a:lnRef idx="1">
-            <a:schemeClr val="accent1"/>
-          </a:lnRef>
-          <a:fillRef idx="3">
-            <a:schemeClr val="accent1"/>
-          </a:fillRef>
-          <a:effectRef idx="2">
-            <a:schemeClr val="accent1"/>
-          </a:effectRef>
-          <a:fontRef idx="minor">
-            <a:schemeClr val="lt1"/>
-          </a:fontRef>
-        </p:style>
-        <p:txBody>
-          <a:bodyPr rtlCol="0" anchor="ctr"/>
-          <a:lstStyle/>
-          <a:p>
-            <a:pPr algn="ctr"/>
-          </a:p>
-        </p:txBody>
-      </p:sp>
-      <p:sp>
-        <p:nvSpPr>
-          <p:cNvPr id="10" name="TextBox 9"/>
-          <p:cNvSpPr txBox="1"/>
-          <p:nvPr/>
-        </p:nvSpPr>
-        <p:spPr>
-          <a:xfrm>
-            <a:off x="4681728" y="2148840"/>
-            <a:ext cx="3154680" cy="1325880"/>
-          </a:xfrm>
-          <a:prstGeom prst="rect">
-            <a:avLst/>
-          </a:prstGeom>
-          <a:noFill/>
-        </p:spPr>
-        <p:txBody>
-          <a:bodyPr wrap="square" anchor="t">
-            <a:spAutoFit/>
-          </a:bodyPr>
-          <a:lstStyle/>
-          <a:p>
-            <a:pPr algn="l">
+              <a:rPr sz="1600" b="0">
+                <a:solidFill>
+                  <a:srgbClr val="E2E8F0"/>
+                </a:solidFill>
+                <a:latin typeface="PingFang TC"/>
+                <a:ea typeface="PingFang TC"/>
+              </a:rPr>
+              <a:t>✓  全部 curl 驗證通過：302 / 404 / 410 / 8 碼 token / 正規化 / SSRF / 過期</a:t>
+            </a:r>
+          </a:p>
+          <a:p>
+            <a:pPr>
               <a:spcAft>
-                <a:spcPts val="800"/>
+                <a:spcPts val="1200"/>
               </a:spcAft>
             </a:pPr>
             <a:r>
-              <a:rPr sz="1600" b="1">
-                <a:solidFill>
-                  <a:srgbClr val="0F172A"/>
-                </a:solidFill>
-                <a:latin typeface="PingFang TC"/>
-                <a:ea typeface="PingFang TC"/>
-              </a:rPr>
-              <a:t>[Rate Limiting]</a:t>
-            </a:r>
-          </a:p>
-          <a:p>
-            <a:pPr algn="l">
+              <a:rPr sz="1600" b="0">
+                <a:solidFill>
+                  <a:srgbClr val="E2E8F0"/>
+                </a:solidFill>
+                <a:latin typeface="PingFang TC"/>
+                <a:ea typeface="PingFang TC"/>
+              </a:rPr>
+              <a:t>✓  production 替換點已在程式註解標明（Redis / 佇列 / CDN / 預聚合 / PostgreSQL）</a:t>
+            </a:r>
+          </a:p>
+          <a:p>
+            <a:pPr>
               <a:spcAft>
-                <a:spcPts val="400"/>
+                <a:spcPts val="1200"/>
               </a:spcAft>
             </a:pPr>
             <a:r>
-              <a:rPr sz="1300" b="0">
-                <a:solidFill>
-                  <a:srgbClr val="64748B"/>
-                </a:solidFill>
-                <a:latin typeface="PingFang TC"/>
-                <a:ea typeface="PingFang TC"/>
-              </a:rPr>
-              <a:t>毫無防護，極易被 Script 惡意灌爆 API。</a:t>
-            </a:r>
-          </a:p>
-        </p:txBody>
-      </p:sp>
-      <p:sp>
-        <p:nvSpPr>
-          <p:cNvPr id="11" name="Rounded Rectangle 10"/>
-          <p:cNvSpPr/>
-          <p:nvPr/>
-        </p:nvSpPr>
-        <p:spPr>
-          <a:xfrm>
-            <a:off x="8266176" y="1965960"/>
-            <a:ext cx="3611880" cy="1600200"/>
-          </a:xfrm>
-          <a:prstGeom prst="roundRect">
-            <a:avLst/>
-          </a:prstGeom>
-          <a:solidFill>
-            <a:srgbClr val="F1F5F9"/>
-          </a:solidFill>
-          <a:ln>
-            <a:solidFill>
-              <a:srgbClr val="F1F5F9"/>
-            </a:solidFill>
-          </a:ln>
-          <a:effectLst/>
-        </p:spPr>
-        <p:style>
-          <a:lnRef idx="1">
-            <a:schemeClr val="accent1"/>
-          </a:lnRef>
-          <a:fillRef idx="3">
-            <a:schemeClr val="accent1"/>
-          </a:fillRef>
-          <a:effectRef idx="2">
-            <a:schemeClr val="accent1"/>
-          </a:effectRef>
-          <a:fontRef idx="minor">
-            <a:schemeClr val="lt1"/>
-          </a:fontRef>
-        </p:style>
-        <p:txBody>
-          <a:bodyPr rtlCol="0" anchor="ctr"/>
-          <a:lstStyle/>
-          <a:p>
-            <a:pPr algn="ctr"/>
-          </a:p>
-        </p:txBody>
-      </p:sp>
-      <p:sp>
-        <p:nvSpPr>
-          <p:cNvPr id="12" name="Rectangle 11"/>
-          <p:cNvSpPr/>
-          <p:nvPr/>
-        </p:nvSpPr>
-        <p:spPr>
-          <a:xfrm>
-            <a:off x="8266176" y="1965960"/>
-            <a:ext cx="82296" cy="1600200"/>
-          </a:xfrm>
-          <a:prstGeom prst="rect">
-            <a:avLst/>
-          </a:prstGeom>
-          <a:solidFill>
-            <a:srgbClr val="D97706"/>
-          </a:solidFill>
-          <a:ln>
-            <a:noFill/>
-          </a:ln>
-          <a:effectLst/>
-        </p:spPr>
-        <p:style>
-          <a:lnRef idx="1">
-            <a:schemeClr val="accent1"/>
-          </a:lnRef>
-          <a:fillRef idx="3">
-            <a:schemeClr val="accent1"/>
-          </a:fillRef>
-          <a:effectRef idx="2">
-            <a:schemeClr val="accent1"/>
-          </a:effectRef>
-          <a:fontRef idx="minor">
-            <a:schemeClr val="lt1"/>
-          </a:fontRef>
-        </p:style>
-        <p:txBody>
-          <a:bodyPr rtlCol="0" anchor="ctr"/>
-          <a:lstStyle/>
-          <a:p>
-            <a:pPr algn="ctr"/>
-          </a:p>
-        </p:txBody>
-      </p:sp>
-      <p:sp>
-        <p:nvSpPr>
-          <p:cNvPr id="13" name="TextBox 12"/>
-          <p:cNvSpPr txBox="1"/>
-          <p:nvPr/>
-        </p:nvSpPr>
-        <p:spPr>
-          <a:xfrm>
-            <a:off x="8540496" y="2148840"/>
-            <a:ext cx="3154680" cy="1325880"/>
-          </a:xfrm>
-          <a:prstGeom prst="rect">
-            <a:avLst/>
-          </a:prstGeom>
-          <a:noFill/>
-        </p:spPr>
-        <p:txBody>
-          <a:bodyPr wrap="square" anchor="t">
-            <a:spAutoFit/>
-          </a:bodyPr>
-          <a:lstStyle/>
-          <a:p>
-            <a:pPr algn="l">
-              <a:spcAft>
-                <a:spcPts val="800"/>
-              </a:spcAft>
-            </a:pPr>
-            <a:r>
-              <a:rPr sz="1600" b="1">
-                <a:solidFill>
-                  <a:srgbClr val="0F172A"/>
-                </a:solidFill>
-                <a:latin typeface="PingFang TC"/>
-                <a:ea typeface="PingFang TC"/>
-              </a:rPr>
-              <a:t>[Auth &amp; Isolation]</a:t>
-            </a:r>
-          </a:p>
-          <a:p>
-            <a:pPr algn="l">
-              <a:spcAft>
-                <a:spcPts val="400"/>
-              </a:spcAft>
-            </a:pPr>
-            <a:r>
-              <a:rPr sz="1300" b="0">
-                <a:solidFill>
-                  <a:srgbClr val="64748B"/>
-                </a:solidFill>
-                <a:latin typeface="PingFang TC"/>
-                <a:ea typeface="PingFang TC"/>
-              </a:rPr>
-              <a:t>缺乏多租戶概念，資料全公開。</a:t>
-            </a:r>
-          </a:p>
-        </p:txBody>
-      </p:sp>
-      <p:sp>
-        <p:nvSpPr>
-          <p:cNvPr id="14" name="Rounded Rectangle 13"/>
-          <p:cNvSpPr/>
-          <p:nvPr/>
-        </p:nvSpPr>
-        <p:spPr>
-          <a:xfrm>
-            <a:off x="548640" y="3840480"/>
-            <a:ext cx="3611880" cy="1600200"/>
-          </a:xfrm>
-          <a:prstGeom prst="roundRect">
-            <a:avLst/>
-          </a:prstGeom>
-          <a:solidFill>
-            <a:srgbClr val="F1F5F9"/>
-          </a:solidFill>
-          <a:ln>
-            <a:solidFill>
-              <a:srgbClr val="F1F5F9"/>
-            </a:solidFill>
-          </a:ln>
-          <a:effectLst/>
-        </p:spPr>
-        <p:style>
-          <a:lnRef idx="1">
-            <a:schemeClr val="accent1"/>
-          </a:lnRef>
-          <a:fillRef idx="3">
-            <a:schemeClr val="accent1"/>
-          </a:fillRef>
-          <a:effectRef idx="2">
-            <a:schemeClr val="accent1"/>
-          </a:effectRef>
-          <a:fontRef idx="minor">
-            <a:schemeClr val="lt1"/>
-          </a:fontRef>
-        </p:style>
-        <p:txBody>
-          <a:bodyPr rtlCol="0" anchor="ctr"/>
-          <a:lstStyle/>
-          <a:p>
-            <a:pPr algn="ctr"/>
-          </a:p>
-        </p:txBody>
-      </p:sp>
-      <p:sp>
-        <p:nvSpPr>
-          <p:cNvPr id="15" name="Rectangle 14"/>
-          <p:cNvSpPr/>
-          <p:nvPr/>
-        </p:nvSpPr>
-        <p:spPr>
-          <a:xfrm>
-            <a:off x="548640" y="3840480"/>
-            <a:ext cx="82296" cy="1600200"/>
-          </a:xfrm>
-          <a:prstGeom prst="rect">
-            <a:avLst/>
-          </a:prstGeom>
-          <a:solidFill>
-            <a:srgbClr val="0EA5E9"/>
-          </a:solidFill>
-          <a:ln>
-            <a:noFill/>
-          </a:ln>
-          <a:effectLst/>
-        </p:spPr>
-        <p:style>
-          <a:lnRef idx="1">
-            <a:schemeClr val="accent1"/>
-          </a:lnRef>
-          <a:fillRef idx="3">
-            <a:schemeClr val="accent1"/>
-          </a:fillRef>
-          <a:effectRef idx="2">
-            <a:schemeClr val="accent1"/>
-          </a:effectRef>
-          <a:fontRef idx="minor">
-            <a:schemeClr val="lt1"/>
-          </a:fontRef>
-        </p:style>
-        <p:txBody>
-          <a:bodyPr rtlCol="0" anchor="ctr"/>
-          <a:lstStyle/>
-          <a:p>
-            <a:pPr algn="ctr"/>
-          </a:p>
-        </p:txBody>
-      </p:sp>
-      <p:sp>
-        <p:nvSpPr>
-          <p:cNvPr id="16" name="TextBox 15"/>
-          <p:cNvSpPr txBox="1"/>
-          <p:nvPr/>
-        </p:nvSpPr>
-        <p:spPr>
-          <a:xfrm>
-            <a:off x="822960" y="4023360"/>
-            <a:ext cx="3154680" cy="1325880"/>
-          </a:xfrm>
-          <a:prstGeom prst="rect">
-            <a:avLst/>
-          </a:prstGeom>
-          <a:noFill/>
-        </p:spPr>
-        <p:txBody>
-          <a:bodyPr wrap="square" anchor="t">
-            <a:spAutoFit/>
-          </a:bodyPr>
-          <a:lstStyle/>
-          <a:p>
-            <a:pPr algn="l">
-              <a:spcAft>
-                <a:spcPts val="800"/>
-              </a:spcAft>
-            </a:pPr>
-            <a:r>
-              <a:rPr sz="1600" b="1">
-                <a:solidFill>
-                  <a:srgbClr val="0F172A"/>
-                </a:solidFill>
-                <a:latin typeface="PingFang TC"/>
-                <a:ea typeface="PingFang TC"/>
-              </a:rPr>
-              <a:t>[Monitoring]</a:t>
-            </a:r>
-          </a:p>
-          <a:p>
-            <a:pPr algn="l">
-              <a:spcAft>
-                <a:spcPts val="400"/>
-              </a:spcAft>
-            </a:pPr>
-            <a:r>
-              <a:rPr sz="1300" b="0">
-                <a:solidFill>
-                  <a:srgbClr val="64748B"/>
-                </a:solidFill>
-                <a:latin typeface="PingFang TC"/>
-                <a:ea typeface="PingFang TC"/>
-              </a:rPr>
-              <a:t>服務掛了完全沒有 Alerting，處於盲飛狀態。</a:t>
-            </a:r>
-          </a:p>
-        </p:txBody>
-      </p:sp>
-      <p:sp>
-        <p:nvSpPr>
-          <p:cNvPr id="17" name="Rounded Rectangle 16"/>
-          <p:cNvSpPr/>
-          <p:nvPr/>
-        </p:nvSpPr>
-        <p:spPr>
-          <a:xfrm>
-            <a:off x="4407408" y="3840480"/>
-            <a:ext cx="3611880" cy="1600200"/>
-          </a:xfrm>
-          <a:prstGeom prst="roundRect">
-            <a:avLst/>
-          </a:prstGeom>
-          <a:solidFill>
-            <a:srgbClr val="F1F5F9"/>
-          </a:solidFill>
-          <a:ln>
-            <a:solidFill>
-              <a:srgbClr val="F1F5F9"/>
-            </a:solidFill>
-          </a:ln>
-          <a:effectLst/>
-        </p:spPr>
-        <p:style>
-          <a:lnRef idx="1">
-            <a:schemeClr val="accent1"/>
-          </a:lnRef>
-          <a:fillRef idx="3">
-            <a:schemeClr val="accent1"/>
-          </a:fillRef>
-          <a:effectRef idx="2">
-            <a:schemeClr val="accent1"/>
-          </a:effectRef>
-          <a:fontRef idx="minor">
-            <a:schemeClr val="lt1"/>
-          </a:fontRef>
-        </p:style>
-        <p:txBody>
-          <a:bodyPr rtlCol="0" anchor="ctr"/>
-          <a:lstStyle/>
-          <a:p>
-            <a:pPr algn="ctr"/>
-          </a:p>
-        </p:txBody>
-      </p:sp>
-      <p:sp>
-        <p:nvSpPr>
-          <p:cNvPr id="18" name="Rectangle 17"/>
-          <p:cNvSpPr/>
-          <p:nvPr/>
-        </p:nvSpPr>
-        <p:spPr>
-          <a:xfrm>
-            <a:off x="4407408" y="3840480"/>
-            <a:ext cx="82296" cy="1600200"/>
-          </a:xfrm>
-          <a:prstGeom prst="rect">
-            <a:avLst/>
-          </a:prstGeom>
-          <a:solidFill>
-            <a:srgbClr val="0EA5E9"/>
-          </a:solidFill>
-          <a:ln>
-            <a:noFill/>
-          </a:ln>
-          <a:effectLst/>
-        </p:spPr>
-        <p:style>
-          <a:lnRef idx="1">
-            <a:schemeClr val="accent1"/>
-          </a:lnRef>
-          <a:fillRef idx="3">
-            <a:schemeClr val="accent1"/>
-          </a:fillRef>
-          <a:effectRef idx="2">
-            <a:schemeClr val="accent1"/>
-          </a:effectRef>
-          <a:fontRef idx="minor">
-            <a:schemeClr val="lt1"/>
-          </a:fontRef>
-        </p:style>
-        <p:txBody>
-          <a:bodyPr rtlCol="0" anchor="ctr"/>
-          <a:lstStyle/>
-          <a:p>
-            <a:pPr algn="ctr"/>
-          </a:p>
-        </p:txBody>
-      </p:sp>
-      <p:sp>
-        <p:nvSpPr>
-          <p:cNvPr id="19" name="TextBox 18"/>
-          <p:cNvSpPr txBox="1"/>
-          <p:nvPr/>
-        </p:nvSpPr>
-        <p:spPr>
-          <a:xfrm>
-            <a:off x="4681728" y="4023360"/>
-            <a:ext cx="3154680" cy="1325880"/>
-          </a:xfrm>
-          <a:prstGeom prst="rect">
-            <a:avLst/>
-          </a:prstGeom>
-          <a:noFill/>
-        </p:spPr>
-        <p:txBody>
-          <a:bodyPr wrap="square" anchor="t">
-            <a:spAutoFit/>
-          </a:bodyPr>
-          <a:lstStyle/>
-          <a:p>
-            <a:pPr algn="l">
-              <a:spcAft>
-                <a:spcPts val="800"/>
-              </a:spcAft>
-            </a:pPr>
-            <a:r>
-              <a:rPr sz="1600" b="1">
-                <a:solidFill>
-                  <a:srgbClr val="0F172A"/>
-                </a:solidFill>
-                <a:latin typeface="PingFang TC"/>
-                <a:ea typeface="PingFang TC"/>
-              </a:rPr>
-              <a:t>[Data Cleanup]</a:t>
-            </a:r>
-          </a:p>
-          <a:p>
-            <a:pPr algn="l">
-              <a:spcAft>
-                <a:spcPts val="400"/>
-              </a:spcAft>
-            </a:pPr>
-            <a:r>
-              <a:rPr sz="1300" b="0">
-                <a:solidFill>
-                  <a:srgbClr val="64748B"/>
-                </a:solidFill>
-                <a:latin typeface="PingFang TC"/>
-                <a:ea typeface="PingFang TC"/>
-              </a:rPr>
-              <a:t>過期資料永不刪除，一年後 DB 將面臨嚴重 Bloat。</a:t>
-            </a:r>
-          </a:p>
-        </p:txBody>
-      </p:sp>
-      <p:sp>
-        <p:nvSpPr>
-          <p:cNvPr id="20" name="Rounded Rectangle 19"/>
-          <p:cNvSpPr/>
-          <p:nvPr/>
-        </p:nvSpPr>
-        <p:spPr>
-          <a:xfrm>
-            <a:off x="8266176" y="3840480"/>
-            <a:ext cx="3611880" cy="1600200"/>
-          </a:xfrm>
-          <a:prstGeom prst="roundRect">
-            <a:avLst/>
-          </a:prstGeom>
-          <a:solidFill>
-            <a:srgbClr val="F1F5F9"/>
-          </a:solidFill>
-          <a:ln>
-            <a:solidFill>
-              <a:srgbClr val="F1F5F9"/>
-            </a:solidFill>
-          </a:ln>
-          <a:effectLst/>
-        </p:spPr>
-        <p:style>
-          <a:lnRef idx="1">
-            <a:schemeClr val="accent1"/>
-          </a:lnRef>
-          <a:fillRef idx="3">
-            <a:schemeClr val="accent1"/>
-          </a:fillRef>
-          <a:effectRef idx="2">
-            <a:schemeClr val="accent1"/>
-          </a:effectRef>
-          <a:fontRef idx="minor">
-            <a:schemeClr val="lt1"/>
-          </a:fontRef>
-        </p:style>
-        <p:txBody>
-          <a:bodyPr rtlCol="0" anchor="ctr"/>
-          <a:lstStyle/>
-          <a:p>
-            <a:pPr algn="ctr"/>
-          </a:p>
-        </p:txBody>
-      </p:sp>
-      <p:sp>
-        <p:nvSpPr>
-          <p:cNvPr id="21" name="Rectangle 20"/>
-          <p:cNvSpPr/>
-          <p:nvPr/>
-        </p:nvSpPr>
-        <p:spPr>
-          <a:xfrm>
-            <a:off x="8266176" y="3840480"/>
-            <a:ext cx="82296" cy="1600200"/>
-          </a:xfrm>
-          <a:prstGeom prst="rect">
-            <a:avLst/>
-          </a:prstGeom>
-          <a:solidFill>
-            <a:srgbClr val="0EA5E9"/>
-          </a:solidFill>
-          <a:ln>
-            <a:noFill/>
-          </a:ln>
-          <a:effectLst/>
-        </p:spPr>
-        <p:style>
-          <a:lnRef idx="1">
-            <a:schemeClr val="accent1"/>
-          </a:lnRef>
-          <a:fillRef idx="3">
-            <a:schemeClr val="accent1"/>
-          </a:fillRef>
-          <a:effectRef idx="2">
-            <a:schemeClr val="accent1"/>
-          </a:effectRef>
-          <a:fontRef idx="minor">
-            <a:schemeClr val="lt1"/>
-          </a:fontRef>
-        </p:style>
-        <p:txBody>
-          <a:bodyPr rtlCol="0" anchor="ctr"/>
-          <a:lstStyle/>
-          <a:p>
-            <a:pPr algn="ctr"/>
-          </a:p>
-        </p:txBody>
-      </p:sp>
-      <p:sp>
-        <p:nvSpPr>
-          <p:cNvPr id="22" name="TextBox 21"/>
-          <p:cNvSpPr txBox="1"/>
-          <p:nvPr/>
-        </p:nvSpPr>
-        <p:spPr>
-          <a:xfrm>
-            <a:off x="8540496" y="4023360"/>
-            <a:ext cx="3154680" cy="1325880"/>
-          </a:xfrm>
-          <a:prstGeom prst="rect">
-            <a:avLst/>
-          </a:prstGeom>
-          <a:noFill/>
-        </p:spPr>
-        <p:txBody>
-          <a:bodyPr wrap="square" anchor="t">
-            <a:spAutoFit/>
-          </a:bodyPr>
-          <a:lstStyle/>
-          <a:p>
-            <a:pPr algn="l">
-              <a:spcAft>
-                <a:spcPts val="800"/>
-              </a:spcAft>
-            </a:pPr>
-            <a:r>
-              <a:rPr sz="1600" b="1">
-                <a:solidFill>
-                  <a:srgbClr val="0F172A"/>
-                </a:solidFill>
-                <a:latin typeface="PingFang TC"/>
-                <a:ea typeface="PingFang TC"/>
-              </a:rPr>
-              <a:t>[Caching / CDN]</a:t>
-            </a:r>
-          </a:p>
-          <a:p>
-            <a:pPr algn="l">
-              <a:spcAft>
-                <a:spcPts val="400"/>
-              </a:spcAft>
-            </a:pPr>
-            <a:r>
-              <a:rPr sz="1300" b="0">
-                <a:solidFill>
-                  <a:srgbClr val="64748B"/>
-                </a:solidFill>
-                <a:latin typeface="PingFang TC"/>
-                <a:ea typeface="PingFang TC"/>
-              </a:rPr>
-              <a:t>每次轉址都直擊 DB，流量一來直接癱瘓。
-→ 下週 Deep Dive 展開</a:t>
+              <a:rPr sz="1600" b="0">
+                <a:solidFill>
+                  <a:srgbClr val="E2E8F0"/>
+                </a:solidFill>
+                <a:latin typeface="PingFang TC"/>
+                <a:ea typeface="PingFang TC"/>
+              </a:rPr>
+              <a:t>✓  設計依據：DESIGN.md（16 題決策 + 優劣分析）</a:t>
             </a:r>
           </a:p>
         </p:txBody>
@@ -18315,7 +18040,7 @@
                 <a:latin typeface="PingFang TC"/>
                 <a:ea typeface="PingFang TC"/>
               </a:rPr>
-              <a:t>下週預告 · DEEP DIVE</a:t>
+              <a:t>下週預告 · NEXT WEEK</a:t>
             </a:r>
           </a:p>
           <a:p>
@@ -18332,7 +18057,7 @@
                 <a:latin typeface="PingFang TC"/>
                 <a:ea typeface="PingFang TC"/>
               </a:rPr>
-              <a:t>壓力測試與極限擴展 (Deep Dive)</a:t>
+              <a:t>從 Prototype 到 Production 的巨大鴻溝</a:t>
             </a:r>
           </a:p>
         </p:txBody>
@@ -18345,8 +18070,8 @@
         </p:nvSpPr>
         <p:spPr>
           <a:xfrm>
-            <a:off x="548640" y="2011680"/>
-            <a:ext cx="5486400" cy="2926080"/>
+            <a:off x="548640" y="1371600"/>
+            <a:ext cx="10972800" cy="365760"/>
           </a:xfrm>
           <a:prstGeom prst="rect">
             <a:avLst/>
@@ -18358,23 +18083,6 @@
             <a:spAutoFit/>
           </a:bodyPr>
           <a:lstStyle/>
-          <a:p>
-            <a:pPr algn="l">
-              <a:spcAft>
-                <a:spcPts val="1600"/>
-              </a:spcAft>
-            </a:pPr>
-            <a:r>
-              <a:rPr sz="2600" b="1">
-                <a:solidFill>
-                  <a:srgbClr val="2563EB"/>
-                </a:solidFill>
-                <a:latin typeface="PingFang TC"/>
-                <a:ea typeface="PingFang TC"/>
-              </a:rPr>
-              <a:t>1,000 QPS  →  50,000 QPS</a:t>
-            </a:r>
-          </a:p>
           <a:p>
             <a:pPr algn="l">
               <a:spcAft>
@@ -18382,136 +18090,28 @@
               </a:spcAft>
             </a:pPr>
             <a:r>
-              <a:rPr sz="1900" b="1">
-                <a:solidFill>
-                  <a:srgbClr val="0F172A"/>
-                </a:solidFill>
-                <a:latin typeface="PingFang TC"/>
-                <a:ea typeface="PingFang TC"/>
-              </a:rPr>
-              <a:t>當大型客戶上線，</a:t>
-            </a:r>
-          </a:p>
-          <a:p>
-            <a:pPr algn="l">
-              <a:spcAft>
-                <a:spcPts val="400"/>
-              </a:spcAft>
-            </a:pPr>
-            <a:r>
-              <a:rPr sz="1900" b="1">
-                <a:solidFill>
-                  <a:srgbClr val="0F172A"/>
-                </a:solidFill>
-                <a:latin typeface="PingFang TC"/>
-                <a:ea typeface="PingFang TC"/>
-              </a:rPr>
-              <a:t>流量瞬間暴增 50 倍，</a:t>
-            </a:r>
-          </a:p>
-          <a:p>
-            <a:pPr algn="l">
-              <a:spcAft>
-                <a:spcPts val="400"/>
-              </a:spcAft>
-            </a:pPr>
-            <a:r>
-              <a:rPr sz="1900" b="1">
-                <a:solidFill>
-                  <a:srgbClr val="0F172A"/>
-                </a:solidFill>
-                <a:latin typeface="PingFang TC"/>
-                <a:ea typeface="PingFang TC"/>
-              </a:rPr>
-              <a:t>這個架構哪會先崩潰？</a:t>
-            </a:r>
-          </a:p>
-        </p:txBody>
-      </p:sp>
-      <p:sp>
-        <p:nvSpPr>
-          <p:cNvPr id="5" name="TextBox 4"/>
-          <p:cNvSpPr txBox="1"/>
-          <p:nvPr/>
-        </p:nvSpPr>
-        <p:spPr>
-          <a:xfrm>
-            <a:off x="6400800" y="2057400"/>
-            <a:ext cx="5303520" cy="2194560"/>
-          </a:xfrm>
-          <a:prstGeom prst="rect">
-            <a:avLst/>
-          </a:prstGeom>
-          <a:noFill/>
-        </p:spPr>
-        <p:txBody>
-          <a:bodyPr wrap="square">
-            <a:spAutoFit/>
-          </a:bodyPr>
-          <a:lstStyle/>
-          <a:p>
-            <a:pPr>
-              <a:spcAft>
-                <a:spcPts val="1400"/>
-              </a:spcAft>
-            </a:pPr>
-            <a:r>
-              <a:rPr sz="1600" b="0">
-                <a:solidFill>
-                  <a:srgbClr val="0F172A"/>
-                </a:solidFill>
-                <a:latin typeface="PingFang TC"/>
-                <a:ea typeface="PingFang TC"/>
-              </a:rPr>
-              <a:t>•  流量暴增 Scenario 推演（Server vs DB vs Network）</a:t>
-            </a:r>
-          </a:p>
-          <a:p>
-            <a:pPr>
-              <a:spcAft>
-                <a:spcPts val="1400"/>
-              </a:spcAft>
-            </a:pPr>
-            <a:r>
-              <a:rPr sz="1600" b="0">
-                <a:solidFill>
-                  <a:srgbClr val="0F172A"/>
-                </a:solidFill>
-                <a:latin typeface="PingFang TC"/>
-                <a:ea typeface="PingFang TC"/>
-              </a:rPr>
-              <a:t>•  Event-Driven Analytics Pipeline 架構</a:t>
-            </a:r>
-          </a:p>
-          <a:p>
-            <a:pPr>
-              <a:spcAft>
-                <a:spcPts val="1400"/>
-              </a:spcAft>
-            </a:pPr>
-            <a:r>
-              <a:rPr sz="1600" b="0">
-                <a:solidFill>
-                  <a:srgbClr val="0F172A"/>
-                </a:solidFill>
-                <a:latin typeface="PingFang TC"/>
-                <a:ea typeface="PingFang TC"/>
-              </a:rPr>
-              <a:t>•  System Design 面試實戰答題框架</a:t>
-            </a:r>
-          </a:p>
-        </p:txBody>
-      </p:sp>
-      <p:sp>
-        <p:nvSpPr>
-          <p:cNvPr id="6" name="Rounded Rectangle 5"/>
+              <a:rPr sz="1400" b="0">
+                <a:solidFill>
+                  <a:srgbClr val="64748B"/>
+                </a:solidFill>
+                <a:latin typeface="PingFang TC"/>
+                <a:ea typeface="PingFang TC"/>
+              </a:rPr>
+              <a:t>快速掃過，建立全貌 — 下週 Deep Dive 才是主菜</a:t>
+            </a:r>
+          </a:p>
+        </p:txBody>
+      </p:sp>
+      <p:sp>
+        <p:nvSpPr>
+          <p:cNvPr id="5" name="Rounded Rectangle 4"/>
           <p:cNvSpPr/>
           <p:nvPr/>
         </p:nvSpPr>
         <p:spPr>
           <a:xfrm>
-            <a:off x="6400800" y="4343400"/>
-            <a:ext cx="5303520" cy="1051560"/>
+            <a:off x="548640" y="1965960"/>
+            <a:ext cx="3611880" cy="1600200"/>
           </a:xfrm>
           <a:prstGeom prst="roundRect">
             <a:avLst/>
@@ -18550,14 +18150,455 @@
       </p:sp>
       <p:sp>
         <p:nvSpPr>
-          <p:cNvPr id="7" name="Rectangle 6"/>
+          <p:cNvPr id="6" name="Rectangle 5"/>
           <p:cNvSpPr/>
           <p:nvPr/>
         </p:nvSpPr>
         <p:spPr>
           <a:xfrm>
-            <a:off x="6400800" y="4343400"/>
-            <a:ext cx="82296" cy="1051560"/>
+            <a:off x="548640" y="1965960"/>
+            <a:ext cx="82296" cy="1600200"/>
+          </a:xfrm>
+          <a:prstGeom prst="rect">
+            <a:avLst/>
+          </a:prstGeom>
+          <a:solidFill>
+            <a:srgbClr val="D97706"/>
+          </a:solidFill>
+          <a:ln>
+            <a:noFill/>
+          </a:ln>
+          <a:effectLst/>
+        </p:spPr>
+        <p:style>
+          <a:lnRef idx="1">
+            <a:schemeClr val="accent1"/>
+          </a:lnRef>
+          <a:fillRef idx="3">
+            <a:schemeClr val="accent1"/>
+          </a:fillRef>
+          <a:effectRef idx="2">
+            <a:schemeClr val="accent1"/>
+          </a:effectRef>
+          <a:fontRef idx="minor">
+            <a:schemeClr val="lt1"/>
+          </a:fontRef>
+        </p:style>
+        <p:txBody>
+          <a:bodyPr rtlCol="0" anchor="ctr"/>
+          <a:lstStyle/>
+          <a:p>
+            <a:pPr algn="ctr"/>
+          </a:p>
+        </p:txBody>
+      </p:sp>
+      <p:sp>
+        <p:nvSpPr>
+          <p:cNvPr id="7" name="TextBox 6"/>
+          <p:cNvSpPr txBox="1"/>
+          <p:nvPr/>
+        </p:nvSpPr>
+        <p:spPr>
+          <a:xfrm>
+            <a:off x="822960" y="2148840"/>
+            <a:ext cx="3154680" cy="1325880"/>
+          </a:xfrm>
+          <a:prstGeom prst="rect">
+            <a:avLst/>
+          </a:prstGeom>
+          <a:noFill/>
+        </p:spPr>
+        <p:txBody>
+          <a:bodyPr wrap="square" anchor="t">
+            <a:spAutoFit/>
+          </a:bodyPr>
+          <a:lstStyle/>
+          <a:p>
+            <a:pPr algn="l">
+              <a:spcAft>
+                <a:spcPts val="800"/>
+              </a:spcAft>
+            </a:pPr>
+            <a:r>
+              <a:rPr sz="1600" b="1">
+                <a:solidFill>
+                  <a:srgbClr val="0F172A"/>
+                </a:solidFill>
+                <a:latin typeface="PingFang TC"/>
+                <a:ea typeface="PingFang TC"/>
+              </a:rPr>
+              <a:t>[Error Handling]</a:t>
+            </a:r>
+          </a:p>
+          <a:p>
+            <a:pPr algn="l">
+              <a:spcAft>
+                <a:spcPts val="400"/>
+              </a:spcAft>
+            </a:pPr>
+            <a:r>
+              <a:rPr sz="1300" b="0">
+                <a:solidFill>
+                  <a:srgbClr val="64748B"/>
+                </a:solidFill>
+                <a:latin typeface="PingFang TC"/>
+                <a:ea typeface="PingFang TC"/>
+              </a:rPr>
+              <a:t>遇到不合法輸入直接 Crash。</a:t>
+            </a:r>
+          </a:p>
+        </p:txBody>
+      </p:sp>
+      <p:sp>
+        <p:nvSpPr>
+          <p:cNvPr id="8" name="Rounded Rectangle 7"/>
+          <p:cNvSpPr/>
+          <p:nvPr/>
+        </p:nvSpPr>
+        <p:spPr>
+          <a:xfrm>
+            <a:off x="4407408" y="1965960"/>
+            <a:ext cx="3611880" cy="1600200"/>
+          </a:xfrm>
+          <a:prstGeom prst="roundRect">
+            <a:avLst/>
+          </a:prstGeom>
+          <a:solidFill>
+            <a:srgbClr val="F1F5F9"/>
+          </a:solidFill>
+          <a:ln>
+            <a:solidFill>
+              <a:srgbClr val="F1F5F9"/>
+            </a:solidFill>
+          </a:ln>
+          <a:effectLst/>
+        </p:spPr>
+        <p:style>
+          <a:lnRef idx="1">
+            <a:schemeClr val="accent1"/>
+          </a:lnRef>
+          <a:fillRef idx="3">
+            <a:schemeClr val="accent1"/>
+          </a:fillRef>
+          <a:effectRef idx="2">
+            <a:schemeClr val="accent1"/>
+          </a:effectRef>
+          <a:fontRef idx="minor">
+            <a:schemeClr val="lt1"/>
+          </a:fontRef>
+        </p:style>
+        <p:txBody>
+          <a:bodyPr rtlCol="0" anchor="ctr"/>
+          <a:lstStyle/>
+          <a:p>
+            <a:pPr algn="ctr"/>
+          </a:p>
+        </p:txBody>
+      </p:sp>
+      <p:sp>
+        <p:nvSpPr>
+          <p:cNvPr id="9" name="Rectangle 8"/>
+          <p:cNvSpPr/>
+          <p:nvPr/>
+        </p:nvSpPr>
+        <p:spPr>
+          <a:xfrm>
+            <a:off x="4407408" y="1965960"/>
+            <a:ext cx="82296" cy="1600200"/>
+          </a:xfrm>
+          <a:prstGeom prst="rect">
+            <a:avLst/>
+          </a:prstGeom>
+          <a:solidFill>
+            <a:srgbClr val="D97706"/>
+          </a:solidFill>
+          <a:ln>
+            <a:noFill/>
+          </a:ln>
+          <a:effectLst/>
+        </p:spPr>
+        <p:style>
+          <a:lnRef idx="1">
+            <a:schemeClr val="accent1"/>
+          </a:lnRef>
+          <a:fillRef idx="3">
+            <a:schemeClr val="accent1"/>
+          </a:fillRef>
+          <a:effectRef idx="2">
+            <a:schemeClr val="accent1"/>
+          </a:effectRef>
+          <a:fontRef idx="minor">
+            <a:schemeClr val="lt1"/>
+          </a:fontRef>
+        </p:style>
+        <p:txBody>
+          <a:bodyPr rtlCol="0" anchor="ctr"/>
+          <a:lstStyle/>
+          <a:p>
+            <a:pPr algn="ctr"/>
+          </a:p>
+        </p:txBody>
+      </p:sp>
+      <p:sp>
+        <p:nvSpPr>
+          <p:cNvPr id="10" name="TextBox 9"/>
+          <p:cNvSpPr txBox="1"/>
+          <p:nvPr/>
+        </p:nvSpPr>
+        <p:spPr>
+          <a:xfrm>
+            <a:off x="4681728" y="2148840"/>
+            <a:ext cx="3154680" cy="1325880"/>
+          </a:xfrm>
+          <a:prstGeom prst="rect">
+            <a:avLst/>
+          </a:prstGeom>
+          <a:noFill/>
+        </p:spPr>
+        <p:txBody>
+          <a:bodyPr wrap="square" anchor="t">
+            <a:spAutoFit/>
+          </a:bodyPr>
+          <a:lstStyle/>
+          <a:p>
+            <a:pPr algn="l">
+              <a:spcAft>
+                <a:spcPts val="800"/>
+              </a:spcAft>
+            </a:pPr>
+            <a:r>
+              <a:rPr sz="1600" b="1">
+                <a:solidFill>
+                  <a:srgbClr val="0F172A"/>
+                </a:solidFill>
+                <a:latin typeface="PingFang TC"/>
+                <a:ea typeface="PingFang TC"/>
+              </a:rPr>
+              <a:t>[Rate Limiting]</a:t>
+            </a:r>
+          </a:p>
+          <a:p>
+            <a:pPr algn="l">
+              <a:spcAft>
+                <a:spcPts val="400"/>
+              </a:spcAft>
+            </a:pPr>
+            <a:r>
+              <a:rPr sz="1300" b="0">
+                <a:solidFill>
+                  <a:srgbClr val="64748B"/>
+                </a:solidFill>
+                <a:latin typeface="PingFang TC"/>
+                <a:ea typeface="PingFang TC"/>
+              </a:rPr>
+              <a:t>毫無防護，極易被 Script 惡意灌爆 API。</a:t>
+            </a:r>
+          </a:p>
+        </p:txBody>
+      </p:sp>
+      <p:sp>
+        <p:nvSpPr>
+          <p:cNvPr id="11" name="Rounded Rectangle 10"/>
+          <p:cNvSpPr/>
+          <p:nvPr/>
+        </p:nvSpPr>
+        <p:spPr>
+          <a:xfrm>
+            <a:off x="8266176" y="1965960"/>
+            <a:ext cx="3611880" cy="1600200"/>
+          </a:xfrm>
+          <a:prstGeom prst="roundRect">
+            <a:avLst/>
+          </a:prstGeom>
+          <a:solidFill>
+            <a:srgbClr val="F1F5F9"/>
+          </a:solidFill>
+          <a:ln>
+            <a:solidFill>
+              <a:srgbClr val="F1F5F9"/>
+            </a:solidFill>
+          </a:ln>
+          <a:effectLst/>
+        </p:spPr>
+        <p:style>
+          <a:lnRef idx="1">
+            <a:schemeClr val="accent1"/>
+          </a:lnRef>
+          <a:fillRef idx="3">
+            <a:schemeClr val="accent1"/>
+          </a:fillRef>
+          <a:effectRef idx="2">
+            <a:schemeClr val="accent1"/>
+          </a:effectRef>
+          <a:fontRef idx="minor">
+            <a:schemeClr val="lt1"/>
+          </a:fontRef>
+        </p:style>
+        <p:txBody>
+          <a:bodyPr rtlCol="0" anchor="ctr"/>
+          <a:lstStyle/>
+          <a:p>
+            <a:pPr algn="ctr"/>
+          </a:p>
+        </p:txBody>
+      </p:sp>
+      <p:sp>
+        <p:nvSpPr>
+          <p:cNvPr id="12" name="Rectangle 11"/>
+          <p:cNvSpPr/>
+          <p:nvPr/>
+        </p:nvSpPr>
+        <p:spPr>
+          <a:xfrm>
+            <a:off x="8266176" y="1965960"/>
+            <a:ext cx="82296" cy="1600200"/>
+          </a:xfrm>
+          <a:prstGeom prst="rect">
+            <a:avLst/>
+          </a:prstGeom>
+          <a:solidFill>
+            <a:srgbClr val="D97706"/>
+          </a:solidFill>
+          <a:ln>
+            <a:noFill/>
+          </a:ln>
+          <a:effectLst/>
+        </p:spPr>
+        <p:style>
+          <a:lnRef idx="1">
+            <a:schemeClr val="accent1"/>
+          </a:lnRef>
+          <a:fillRef idx="3">
+            <a:schemeClr val="accent1"/>
+          </a:fillRef>
+          <a:effectRef idx="2">
+            <a:schemeClr val="accent1"/>
+          </a:effectRef>
+          <a:fontRef idx="minor">
+            <a:schemeClr val="lt1"/>
+          </a:fontRef>
+        </p:style>
+        <p:txBody>
+          <a:bodyPr rtlCol="0" anchor="ctr"/>
+          <a:lstStyle/>
+          <a:p>
+            <a:pPr algn="ctr"/>
+          </a:p>
+        </p:txBody>
+      </p:sp>
+      <p:sp>
+        <p:nvSpPr>
+          <p:cNvPr id="13" name="TextBox 12"/>
+          <p:cNvSpPr txBox="1"/>
+          <p:nvPr/>
+        </p:nvSpPr>
+        <p:spPr>
+          <a:xfrm>
+            <a:off x="8540496" y="2148840"/>
+            <a:ext cx="3154680" cy="1325880"/>
+          </a:xfrm>
+          <a:prstGeom prst="rect">
+            <a:avLst/>
+          </a:prstGeom>
+          <a:noFill/>
+        </p:spPr>
+        <p:txBody>
+          <a:bodyPr wrap="square" anchor="t">
+            <a:spAutoFit/>
+          </a:bodyPr>
+          <a:lstStyle/>
+          <a:p>
+            <a:pPr algn="l">
+              <a:spcAft>
+                <a:spcPts val="800"/>
+              </a:spcAft>
+            </a:pPr>
+            <a:r>
+              <a:rPr sz="1600" b="1">
+                <a:solidFill>
+                  <a:srgbClr val="0F172A"/>
+                </a:solidFill>
+                <a:latin typeface="PingFang TC"/>
+                <a:ea typeface="PingFang TC"/>
+              </a:rPr>
+              <a:t>[Auth &amp; Isolation]</a:t>
+            </a:r>
+          </a:p>
+          <a:p>
+            <a:pPr algn="l">
+              <a:spcAft>
+                <a:spcPts val="400"/>
+              </a:spcAft>
+            </a:pPr>
+            <a:r>
+              <a:rPr sz="1300" b="0">
+                <a:solidFill>
+                  <a:srgbClr val="64748B"/>
+                </a:solidFill>
+                <a:latin typeface="PingFang TC"/>
+                <a:ea typeface="PingFang TC"/>
+              </a:rPr>
+              <a:t>缺乏多租戶概念，資料全公開。</a:t>
+            </a:r>
+          </a:p>
+        </p:txBody>
+      </p:sp>
+      <p:sp>
+        <p:nvSpPr>
+          <p:cNvPr id="14" name="Rounded Rectangle 13"/>
+          <p:cNvSpPr/>
+          <p:nvPr/>
+        </p:nvSpPr>
+        <p:spPr>
+          <a:xfrm>
+            <a:off x="548640" y="3840480"/>
+            <a:ext cx="3611880" cy="1600200"/>
+          </a:xfrm>
+          <a:prstGeom prst="roundRect">
+            <a:avLst/>
+          </a:prstGeom>
+          <a:solidFill>
+            <a:srgbClr val="F1F5F9"/>
+          </a:solidFill>
+          <a:ln>
+            <a:solidFill>
+              <a:srgbClr val="F1F5F9"/>
+            </a:solidFill>
+          </a:ln>
+          <a:effectLst/>
+        </p:spPr>
+        <p:style>
+          <a:lnRef idx="1">
+            <a:schemeClr val="accent1"/>
+          </a:lnRef>
+          <a:fillRef idx="3">
+            <a:schemeClr val="accent1"/>
+          </a:fillRef>
+          <a:effectRef idx="2">
+            <a:schemeClr val="accent1"/>
+          </a:effectRef>
+          <a:fontRef idx="minor">
+            <a:schemeClr val="lt1"/>
+          </a:fontRef>
+        </p:style>
+        <p:txBody>
+          <a:bodyPr rtlCol="0" anchor="ctr"/>
+          <a:lstStyle/>
+          <a:p>
+            <a:pPr algn="ctr"/>
+          </a:p>
+        </p:txBody>
+      </p:sp>
+      <p:sp>
+        <p:nvSpPr>
+          <p:cNvPr id="15" name="Rectangle 14"/>
+          <p:cNvSpPr/>
+          <p:nvPr/>
+        </p:nvSpPr>
+        <p:spPr>
+          <a:xfrm>
+            <a:off x="548640" y="3840480"/>
+            <a:ext cx="82296" cy="1600200"/>
           </a:xfrm>
           <a:prstGeom prst="rect">
             <a:avLst/>
@@ -18594,14 +18635,14 @@
       </p:sp>
       <p:sp>
         <p:nvSpPr>
-          <p:cNvPr id="8" name="TextBox 7"/>
+          <p:cNvPr id="16" name="TextBox 15"/>
           <p:cNvSpPr txBox="1"/>
           <p:nvPr/>
         </p:nvSpPr>
         <p:spPr>
           <a:xfrm>
-            <a:off x="6675120" y="4526280"/>
-            <a:ext cx="4846320" cy="822960"/>
+            <a:off x="822960" y="4023360"/>
+            <a:ext cx="3154680" cy="1325880"/>
           </a:xfrm>
           <a:prstGeom prst="rect">
             <a:avLst/>
@@ -18616,18 +18657,18 @@
           <a:p>
             <a:pPr algn="l">
               <a:spcAft>
-                <a:spcPts val="600"/>
+                <a:spcPts val="800"/>
               </a:spcAft>
             </a:pPr>
             <a:r>
-              <a:rPr sz="1500" b="1">
+              <a:rPr sz="1600" b="1">
                 <a:solidFill>
                   <a:srgbClr val="0F172A"/>
                 </a:solidFill>
                 <a:latin typeface="PingFang TC"/>
                 <a:ea typeface="PingFang TC"/>
               </a:rPr>
-              <a:t>課前準備</a:t>
+              <a:t>[Monitoring]</a:t>
             </a:r>
           </a:p>
           <a:p>
@@ -18637,14 +18678,309 @@
               </a:spcAft>
             </a:pPr>
             <a:r>
-              <a:rPr sz="1400" b="0">
+              <a:rPr sz="1300" b="0">
                 <a:solidFill>
                   <a:srgbClr val="64748B"/>
                 </a:solidFill>
                 <a:latin typeface="PingFang TC"/>
                 <a:ea typeface="PingFang TC"/>
               </a:rPr>
-              <a:t>複習教材 Deep Dive 章節</a:t>
+              <a:t>服務掛了完全沒有 Alerting，處於盲飛狀態。</a:t>
+            </a:r>
+          </a:p>
+        </p:txBody>
+      </p:sp>
+      <p:sp>
+        <p:nvSpPr>
+          <p:cNvPr id="17" name="Rounded Rectangle 16"/>
+          <p:cNvSpPr/>
+          <p:nvPr/>
+        </p:nvSpPr>
+        <p:spPr>
+          <a:xfrm>
+            <a:off x="4407408" y="3840480"/>
+            <a:ext cx="3611880" cy="1600200"/>
+          </a:xfrm>
+          <a:prstGeom prst="roundRect">
+            <a:avLst/>
+          </a:prstGeom>
+          <a:solidFill>
+            <a:srgbClr val="F1F5F9"/>
+          </a:solidFill>
+          <a:ln>
+            <a:solidFill>
+              <a:srgbClr val="F1F5F9"/>
+            </a:solidFill>
+          </a:ln>
+          <a:effectLst/>
+        </p:spPr>
+        <p:style>
+          <a:lnRef idx="1">
+            <a:schemeClr val="accent1"/>
+          </a:lnRef>
+          <a:fillRef idx="3">
+            <a:schemeClr val="accent1"/>
+          </a:fillRef>
+          <a:effectRef idx="2">
+            <a:schemeClr val="accent1"/>
+          </a:effectRef>
+          <a:fontRef idx="minor">
+            <a:schemeClr val="lt1"/>
+          </a:fontRef>
+        </p:style>
+        <p:txBody>
+          <a:bodyPr rtlCol="0" anchor="ctr"/>
+          <a:lstStyle/>
+          <a:p>
+            <a:pPr algn="ctr"/>
+          </a:p>
+        </p:txBody>
+      </p:sp>
+      <p:sp>
+        <p:nvSpPr>
+          <p:cNvPr id="18" name="Rectangle 17"/>
+          <p:cNvSpPr/>
+          <p:nvPr/>
+        </p:nvSpPr>
+        <p:spPr>
+          <a:xfrm>
+            <a:off x="4407408" y="3840480"/>
+            <a:ext cx="82296" cy="1600200"/>
+          </a:xfrm>
+          <a:prstGeom prst="rect">
+            <a:avLst/>
+          </a:prstGeom>
+          <a:solidFill>
+            <a:srgbClr val="0EA5E9"/>
+          </a:solidFill>
+          <a:ln>
+            <a:noFill/>
+          </a:ln>
+          <a:effectLst/>
+        </p:spPr>
+        <p:style>
+          <a:lnRef idx="1">
+            <a:schemeClr val="accent1"/>
+          </a:lnRef>
+          <a:fillRef idx="3">
+            <a:schemeClr val="accent1"/>
+          </a:fillRef>
+          <a:effectRef idx="2">
+            <a:schemeClr val="accent1"/>
+          </a:effectRef>
+          <a:fontRef idx="minor">
+            <a:schemeClr val="lt1"/>
+          </a:fontRef>
+        </p:style>
+        <p:txBody>
+          <a:bodyPr rtlCol="0" anchor="ctr"/>
+          <a:lstStyle/>
+          <a:p>
+            <a:pPr algn="ctr"/>
+          </a:p>
+        </p:txBody>
+      </p:sp>
+      <p:sp>
+        <p:nvSpPr>
+          <p:cNvPr id="19" name="TextBox 18"/>
+          <p:cNvSpPr txBox="1"/>
+          <p:nvPr/>
+        </p:nvSpPr>
+        <p:spPr>
+          <a:xfrm>
+            <a:off x="4681728" y="4023360"/>
+            <a:ext cx="3154680" cy="1325880"/>
+          </a:xfrm>
+          <a:prstGeom prst="rect">
+            <a:avLst/>
+          </a:prstGeom>
+          <a:noFill/>
+        </p:spPr>
+        <p:txBody>
+          <a:bodyPr wrap="square" anchor="t">
+            <a:spAutoFit/>
+          </a:bodyPr>
+          <a:lstStyle/>
+          <a:p>
+            <a:pPr algn="l">
+              <a:spcAft>
+                <a:spcPts val="800"/>
+              </a:spcAft>
+            </a:pPr>
+            <a:r>
+              <a:rPr sz="1600" b="1">
+                <a:solidFill>
+                  <a:srgbClr val="0F172A"/>
+                </a:solidFill>
+                <a:latin typeface="PingFang TC"/>
+                <a:ea typeface="PingFang TC"/>
+              </a:rPr>
+              <a:t>[Data Cleanup]</a:t>
+            </a:r>
+          </a:p>
+          <a:p>
+            <a:pPr algn="l">
+              <a:spcAft>
+                <a:spcPts val="400"/>
+              </a:spcAft>
+            </a:pPr>
+            <a:r>
+              <a:rPr sz="1300" b="0">
+                <a:solidFill>
+                  <a:srgbClr val="64748B"/>
+                </a:solidFill>
+                <a:latin typeface="PingFang TC"/>
+                <a:ea typeface="PingFang TC"/>
+              </a:rPr>
+              <a:t>過期資料永不刪除，一年後 DB 將面臨嚴重 Bloat。</a:t>
+            </a:r>
+          </a:p>
+        </p:txBody>
+      </p:sp>
+      <p:sp>
+        <p:nvSpPr>
+          <p:cNvPr id="20" name="Rounded Rectangle 19"/>
+          <p:cNvSpPr/>
+          <p:nvPr/>
+        </p:nvSpPr>
+        <p:spPr>
+          <a:xfrm>
+            <a:off x="8266176" y="3840480"/>
+            <a:ext cx="3611880" cy="1600200"/>
+          </a:xfrm>
+          <a:prstGeom prst="roundRect">
+            <a:avLst/>
+          </a:prstGeom>
+          <a:solidFill>
+            <a:srgbClr val="F1F5F9"/>
+          </a:solidFill>
+          <a:ln>
+            <a:solidFill>
+              <a:srgbClr val="F1F5F9"/>
+            </a:solidFill>
+          </a:ln>
+          <a:effectLst/>
+        </p:spPr>
+        <p:style>
+          <a:lnRef idx="1">
+            <a:schemeClr val="accent1"/>
+          </a:lnRef>
+          <a:fillRef idx="3">
+            <a:schemeClr val="accent1"/>
+          </a:fillRef>
+          <a:effectRef idx="2">
+            <a:schemeClr val="accent1"/>
+          </a:effectRef>
+          <a:fontRef idx="minor">
+            <a:schemeClr val="lt1"/>
+          </a:fontRef>
+        </p:style>
+        <p:txBody>
+          <a:bodyPr rtlCol="0" anchor="ctr"/>
+          <a:lstStyle/>
+          <a:p>
+            <a:pPr algn="ctr"/>
+          </a:p>
+        </p:txBody>
+      </p:sp>
+      <p:sp>
+        <p:nvSpPr>
+          <p:cNvPr id="21" name="Rectangle 20"/>
+          <p:cNvSpPr/>
+          <p:nvPr/>
+        </p:nvSpPr>
+        <p:spPr>
+          <a:xfrm>
+            <a:off x="8266176" y="3840480"/>
+            <a:ext cx="82296" cy="1600200"/>
+          </a:xfrm>
+          <a:prstGeom prst="rect">
+            <a:avLst/>
+          </a:prstGeom>
+          <a:solidFill>
+            <a:srgbClr val="0EA5E9"/>
+          </a:solidFill>
+          <a:ln>
+            <a:noFill/>
+          </a:ln>
+          <a:effectLst/>
+        </p:spPr>
+        <p:style>
+          <a:lnRef idx="1">
+            <a:schemeClr val="accent1"/>
+          </a:lnRef>
+          <a:fillRef idx="3">
+            <a:schemeClr val="accent1"/>
+          </a:fillRef>
+          <a:effectRef idx="2">
+            <a:schemeClr val="accent1"/>
+          </a:effectRef>
+          <a:fontRef idx="minor">
+            <a:schemeClr val="lt1"/>
+          </a:fontRef>
+        </p:style>
+        <p:txBody>
+          <a:bodyPr rtlCol="0" anchor="ctr"/>
+          <a:lstStyle/>
+          <a:p>
+            <a:pPr algn="ctr"/>
+          </a:p>
+        </p:txBody>
+      </p:sp>
+      <p:sp>
+        <p:nvSpPr>
+          <p:cNvPr id="22" name="TextBox 21"/>
+          <p:cNvSpPr txBox="1"/>
+          <p:nvPr/>
+        </p:nvSpPr>
+        <p:spPr>
+          <a:xfrm>
+            <a:off x="8540496" y="4023360"/>
+            <a:ext cx="3154680" cy="1325880"/>
+          </a:xfrm>
+          <a:prstGeom prst="rect">
+            <a:avLst/>
+          </a:prstGeom>
+          <a:noFill/>
+        </p:spPr>
+        <p:txBody>
+          <a:bodyPr wrap="square" anchor="t">
+            <a:spAutoFit/>
+          </a:bodyPr>
+          <a:lstStyle/>
+          <a:p>
+            <a:pPr algn="l">
+              <a:spcAft>
+                <a:spcPts val="800"/>
+              </a:spcAft>
+            </a:pPr>
+            <a:r>
+              <a:rPr sz="1600" b="1">
+                <a:solidFill>
+                  <a:srgbClr val="0F172A"/>
+                </a:solidFill>
+                <a:latin typeface="PingFang TC"/>
+                <a:ea typeface="PingFang TC"/>
+              </a:rPr>
+              <a:t>[Caching / CDN]</a:t>
+            </a:r>
+          </a:p>
+          <a:p>
+            <a:pPr algn="l">
+              <a:spcAft>
+                <a:spcPts val="400"/>
+              </a:spcAft>
+            </a:pPr>
+            <a:r>
+              <a:rPr sz="1300" b="0">
+                <a:solidFill>
+                  <a:srgbClr val="64748B"/>
+                </a:solidFill>
+                <a:latin typeface="PingFang TC"/>
+                <a:ea typeface="PingFang TC"/>
+              </a:rPr>
+              <a:t>每次轉址都直擊 DB，流量一來直接癱瘓。
+→ 下週 Deep Dive 展開</a:t>
             </a:r>
           </a:p>
         </p:txBody>
@@ -19513,6 +19849,437 @@
 </p:sld>
 </file>
 
+<file path=ppt/slides/slide30.xml><?xml version="1.0" encoding="utf-8"?>
+<p:sld xmlns:a="http://schemas.openxmlformats.org/drawingml/2006/main" xmlns:p="http://schemas.openxmlformats.org/presentationml/2006/main" xmlns:r="http://schemas.openxmlformats.org/officeDocument/2006/relationships">
+  <p:cSld>
+    <p:spTree>
+      <p:nvGrpSpPr>
+        <p:cNvPr id="1" name=""/>
+        <p:cNvGrpSpPr/>
+        <p:nvPr/>
+      </p:nvGrpSpPr>
+      <p:grpSpPr/>
+      <p:sp>
+        <p:nvSpPr>
+          <p:cNvPr id="2" name="Rectangle 1"/>
+          <p:cNvSpPr/>
+          <p:nvPr/>
+        </p:nvSpPr>
+        <p:spPr>
+          <a:xfrm>
+            <a:off x="0" y="0"/>
+            <a:ext cx="164592" cy="6858000"/>
+          </a:xfrm>
+          <a:prstGeom prst="rect">
+            <a:avLst/>
+          </a:prstGeom>
+          <a:solidFill>
+            <a:srgbClr val="2563EB"/>
+          </a:solidFill>
+          <a:ln>
+            <a:noFill/>
+          </a:ln>
+          <a:effectLst/>
+        </p:spPr>
+        <p:style>
+          <a:lnRef idx="1">
+            <a:schemeClr val="accent1"/>
+          </a:lnRef>
+          <a:fillRef idx="3">
+            <a:schemeClr val="accent1"/>
+          </a:fillRef>
+          <a:effectRef idx="2">
+            <a:schemeClr val="accent1"/>
+          </a:effectRef>
+          <a:fontRef idx="minor">
+            <a:schemeClr val="lt1"/>
+          </a:fontRef>
+        </p:style>
+        <p:txBody>
+          <a:bodyPr rtlCol="0" anchor="ctr"/>
+          <a:lstStyle/>
+          <a:p>
+            <a:pPr algn="ctr"/>
+          </a:p>
+        </p:txBody>
+      </p:sp>
+      <p:sp>
+        <p:nvSpPr>
+          <p:cNvPr id="3" name="TextBox 2"/>
+          <p:cNvSpPr txBox="1"/>
+          <p:nvPr/>
+        </p:nvSpPr>
+        <p:spPr>
+          <a:xfrm>
+            <a:off x="502920" y="320040"/>
+            <a:ext cx="10972800" cy="1005840"/>
+          </a:xfrm>
+          <a:prstGeom prst="rect">
+            <a:avLst/>
+          </a:prstGeom>
+          <a:noFill/>
+        </p:spPr>
+        <p:txBody>
+          <a:bodyPr wrap="square" anchor="t">
+            <a:spAutoFit/>
+          </a:bodyPr>
+          <a:lstStyle/>
+          <a:p>
+            <a:pPr algn="l">
+              <a:spcAft>
+                <a:spcPts val="200"/>
+              </a:spcAft>
+            </a:pPr>
+            <a:r>
+              <a:rPr sz="1300" b="1">
+                <a:solidFill>
+                  <a:srgbClr val="2563EB"/>
+                </a:solidFill>
+                <a:latin typeface="PingFang TC"/>
+                <a:ea typeface="PingFang TC"/>
+              </a:rPr>
+              <a:t>下週預告 · DEEP DIVE</a:t>
+            </a:r>
+          </a:p>
+          <a:p>
+            <a:pPr algn="l">
+              <a:spcAft>
+                <a:spcPts val="400"/>
+              </a:spcAft>
+            </a:pPr>
+            <a:r>
+              <a:rPr sz="3000" b="1">
+                <a:solidFill>
+                  <a:srgbClr val="0F172A"/>
+                </a:solidFill>
+                <a:latin typeface="PingFang TC"/>
+                <a:ea typeface="PingFang TC"/>
+              </a:rPr>
+              <a:t>壓力測試與極限擴展 (Deep Dive)</a:t>
+            </a:r>
+          </a:p>
+        </p:txBody>
+      </p:sp>
+      <p:sp>
+        <p:nvSpPr>
+          <p:cNvPr id="4" name="TextBox 3"/>
+          <p:cNvSpPr txBox="1"/>
+          <p:nvPr/>
+        </p:nvSpPr>
+        <p:spPr>
+          <a:xfrm>
+            <a:off x="548640" y="2011680"/>
+            <a:ext cx="5486400" cy="2926080"/>
+          </a:xfrm>
+          <a:prstGeom prst="rect">
+            <a:avLst/>
+          </a:prstGeom>
+          <a:noFill/>
+        </p:spPr>
+        <p:txBody>
+          <a:bodyPr wrap="square" anchor="t">
+            <a:spAutoFit/>
+          </a:bodyPr>
+          <a:lstStyle/>
+          <a:p>
+            <a:pPr algn="l">
+              <a:spcAft>
+                <a:spcPts val="1600"/>
+              </a:spcAft>
+            </a:pPr>
+            <a:r>
+              <a:rPr sz="2600" b="1">
+                <a:solidFill>
+                  <a:srgbClr val="2563EB"/>
+                </a:solidFill>
+                <a:latin typeface="PingFang TC"/>
+                <a:ea typeface="PingFang TC"/>
+              </a:rPr>
+              <a:t>1,000 QPS  →  50,000 QPS</a:t>
+            </a:r>
+          </a:p>
+          <a:p>
+            <a:pPr algn="l">
+              <a:spcAft>
+                <a:spcPts val="400"/>
+              </a:spcAft>
+            </a:pPr>
+            <a:r>
+              <a:rPr sz="1900" b="1">
+                <a:solidFill>
+                  <a:srgbClr val="0F172A"/>
+                </a:solidFill>
+                <a:latin typeface="PingFang TC"/>
+                <a:ea typeface="PingFang TC"/>
+              </a:rPr>
+              <a:t>當大型客戶上線，</a:t>
+            </a:r>
+          </a:p>
+          <a:p>
+            <a:pPr algn="l">
+              <a:spcAft>
+                <a:spcPts val="400"/>
+              </a:spcAft>
+            </a:pPr>
+            <a:r>
+              <a:rPr sz="1900" b="1">
+                <a:solidFill>
+                  <a:srgbClr val="0F172A"/>
+                </a:solidFill>
+                <a:latin typeface="PingFang TC"/>
+                <a:ea typeface="PingFang TC"/>
+              </a:rPr>
+              <a:t>流量瞬間暴增 50 倍，</a:t>
+            </a:r>
+          </a:p>
+          <a:p>
+            <a:pPr algn="l">
+              <a:spcAft>
+                <a:spcPts val="400"/>
+              </a:spcAft>
+            </a:pPr>
+            <a:r>
+              <a:rPr sz="1900" b="1">
+                <a:solidFill>
+                  <a:srgbClr val="0F172A"/>
+                </a:solidFill>
+                <a:latin typeface="PingFang TC"/>
+                <a:ea typeface="PingFang TC"/>
+              </a:rPr>
+              <a:t>這個架構哪會先崩潰？</a:t>
+            </a:r>
+          </a:p>
+        </p:txBody>
+      </p:sp>
+      <p:sp>
+        <p:nvSpPr>
+          <p:cNvPr id="5" name="TextBox 4"/>
+          <p:cNvSpPr txBox="1"/>
+          <p:nvPr/>
+        </p:nvSpPr>
+        <p:spPr>
+          <a:xfrm>
+            <a:off x="6400800" y="2057400"/>
+            <a:ext cx="5303520" cy="2194560"/>
+          </a:xfrm>
+          <a:prstGeom prst="rect">
+            <a:avLst/>
+          </a:prstGeom>
+          <a:noFill/>
+        </p:spPr>
+        <p:txBody>
+          <a:bodyPr wrap="square">
+            <a:spAutoFit/>
+          </a:bodyPr>
+          <a:lstStyle/>
+          <a:p>
+            <a:pPr>
+              <a:spcAft>
+                <a:spcPts val="1400"/>
+              </a:spcAft>
+            </a:pPr>
+            <a:r>
+              <a:rPr sz="1600" b="0">
+                <a:solidFill>
+                  <a:srgbClr val="0F172A"/>
+                </a:solidFill>
+                <a:latin typeface="PingFang TC"/>
+                <a:ea typeface="PingFang TC"/>
+              </a:rPr>
+              <a:t>•  流量暴增 Scenario 推演（Server vs DB vs Network）</a:t>
+            </a:r>
+          </a:p>
+          <a:p>
+            <a:pPr>
+              <a:spcAft>
+                <a:spcPts val="1400"/>
+              </a:spcAft>
+            </a:pPr>
+            <a:r>
+              <a:rPr sz="1600" b="0">
+                <a:solidFill>
+                  <a:srgbClr val="0F172A"/>
+                </a:solidFill>
+                <a:latin typeface="PingFang TC"/>
+                <a:ea typeface="PingFang TC"/>
+              </a:rPr>
+              <a:t>•  Event-Driven Analytics Pipeline 架構</a:t>
+            </a:r>
+          </a:p>
+          <a:p>
+            <a:pPr>
+              <a:spcAft>
+                <a:spcPts val="1400"/>
+              </a:spcAft>
+            </a:pPr>
+            <a:r>
+              <a:rPr sz="1600" b="0">
+                <a:solidFill>
+                  <a:srgbClr val="0F172A"/>
+                </a:solidFill>
+                <a:latin typeface="PingFang TC"/>
+                <a:ea typeface="PingFang TC"/>
+              </a:rPr>
+              <a:t>•  System Design 面試實戰答題框架</a:t>
+            </a:r>
+          </a:p>
+        </p:txBody>
+      </p:sp>
+      <p:sp>
+        <p:nvSpPr>
+          <p:cNvPr id="6" name="Rounded Rectangle 5"/>
+          <p:cNvSpPr/>
+          <p:nvPr/>
+        </p:nvSpPr>
+        <p:spPr>
+          <a:xfrm>
+            <a:off x="6400800" y="4343400"/>
+            <a:ext cx="5303520" cy="1051560"/>
+          </a:xfrm>
+          <a:prstGeom prst="roundRect">
+            <a:avLst/>
+          </a:prstGeom>
+          <a:solidFill>
+            <a:srgbClr val="F1F5F9"/>
+          </a:solidFill>
+          <a:ln>
+            <a:solidFill>
+              <a:srgbClr val="F1F5F9"/>
+            </a:solidFill>
+          </a:ln>
+          <a:effectLst/>
+        </p:spPr>
+        <p:style>
+          <a:lnRef idx="1">
+            <a:schemeClr val="accent1"/>
+          </a:lnRef>
+          <a:fillRef idx="3">
+            <a:schemeClr val="accent1"/>
+          </a:fillRef>
+          <a:effectRef idx="2">
+            <a:schemeClr val="accent1"/>
+          </a:effectRef>
+          <a:fontRef idx="minor">
+            <a:schemeClr val="lt1"/>
+          </a:fontRef>
+        </p:style>
+        <p:txBody>
+          <a:bodyPr rtlCol="0" anchor="ctr"/>
+          <a:lstStyle/>
+          <a:p>
+            <a:pPr algn="ctr"/>
+          </a:p>
+        </p:txBody>
+      </p:sp>
+      <p:sp>
+        <p:nvSpPr>
+          <p:cNvPr id="7" name="Rectangle 6"/>
+          <p:cNvSpPr/>
+          <p:nvPr/>
+        </p:nvSpPr>
+        <p:spPr>
+          <a:xfrm>
+            <a:off x="6400800" y="4343400"/>
+            <a:ext cx="82296" cy="1051560"/>
+          </a:xfrm>
+          <a:prstGeom prst="rect">
+            <a:avLst/>
+          </a:prstGeom>
+          <a:solidFill>
+            <a:srgbClr val="0EA5E9"/>
+          </a:solidFill>
+          <a:ln>
+            <a:noFill/>
+          </a:ln>
+          <a:effectLst/>
+        </p:spPr>
+        <p:style>
+          <a:lnRef idx="1">
+            <a:schemeClr val="accent1"/>
+          </a:lnRef>
+          <a:fillRef idx="3">
+            <a:schemeClr val="accent1"/>
+          </a:fillRef>
+          <a:effectRef idx="2">
+            <a:schemeClr val="accent1"/>
+          </a:effectRef>
+          <a:fontRef idx="minor">
+            <a:schemeClr val="lt1"/>
+          </a:fontRef>
+        </p:style>
+        <p:txBody>
+          <a:bodyPr rtlCol="0" anchor="ctr"/>
+          <a:lstStyle/>
+          <a:p>
+            <a:pPr algn="ctr"/>
+          </a:p>
+        </p:txBody>
+      </p:sp>
+      <p:sp>
+        <p:nvSpPr>
+          <p:cNvPr id="8" name="TextBox 7"/>
+          <p:cNvSpPr txBox="1"/>
+          <p:nvPr/>
+        </p:nvSpPr>
+        <p:spPr>
+          <a:xfrm>
+            <a:off x="6675120" y="4526280"/>
+            <a:ext cx="4846320" cy="822960"/>
+          </a:xfrm>
+          <a:prstGeom prst="rect">
+            <a:avLst/>
+          </a:prstGeom>
+          <a:noFill/>
+        </p:spPr>
+        <p:txBody>
+          <a:bodyPr wrap="square" anchor="t">
+            <a:spAutoFit/>
+          </a:bodyPr>
+          <a:lstStyle/>
+          <a:p>
+            <a:pPr algn="l">
+              <a:spcAft>
+                <a:spcPts val="600"/>
+              </a:spcAft>
+            </a:pPr>
+            <a:r>
+              <a:rPr sz="1500" b="1">
+                <a:solidFill>
+                  <a:srgbClr val="0F172A"/>
+                </a:solidFill>
+                <a:latin typeface="PingFang TC"/>
+                <a:ea typeface="PingFang TC"/>
+              </a:rPr>
+              <a:t>課前準備</a:t>
+            </a:r>
+          </a:p>
+          <a:p>
+            <a:pPr algn="l">
+              <a:spcAft>
+                <a:spcPts val="400"/>
+              </a:spcAft>
+            </a:pPr>
+            <a:r>
+              <a:rPr sz="1400" b="0">
+                <a:solidFill>
+                  <a:srgbClr val="64748B"/>
+                </a:solidFill>
+                <a:latin typeface="PingFang TC"/>
+                <a:ea typeface="PingFang TC"/>
+              </a:rPr>
+              <a:t>複習教材 Deep Dive 章節</a:t>
+            </a:r>
+          </a:p>
+        </p:txBody>
+      </p:sp>
+    </p:spTree>
+  </p:cSld>
+  <p:clrMapOvr>
+    <a:masterClrMapping/>
+  </p:clrMapOvr>
+</p:sld>
+</file>
+
 <file path=ppt/slides/slide4.xml><?xml version="1.0" encoding="utf-8"?>
 <p:sld xmlns:a="http://schemas.openxmlformats.org/drawingml/2006/main" xmlns:p="http://schemas.openxmlformats.org/presentationml/2006/main" xmlns:r="http://schemas.openxmlformats.org/officeDocument/2006/relationships">
   <p:cSld>

</xml_diff>

<commit_message>
Add monitoring/alerting: CloudWatch alarms→SNS email + Logs + Dashboard + Synthetic canary
- infra/modules/monitoring: ~10 metric alarms (ALB/EC2/RDS/ElastiCache/API GW/Lambda/
  CloudFront[us-east-1]/canary) → SNS email; app log group; CloudWatch dashboard;
  syn-nodejs canary probing CloudFront /health every 5m
- compute: awslogs docker log driver → CloudWatch Logs + EC2 logs IAM; arn_suffix outputs
- data/edge: db/redis/cloudfront id outputs for alarm dimensions
- docs: DESIGN appendix C/H + PPT (31p) + README; alert_email variable
- terraform validate/plan pass (105 resources); not applied

Co-Authored-By: Claude Opus 4.8 <noreply@anthropic.com>
</commit_message>
<xml_diff>
--- a/QR Code Generator/QR_Code_Generator.pptx
+++ b/QR Code Generator/QR_Code_Generator.pptx
@@ -35,6 +35,7 @@
     <p:sldId id="283" r:id="rId34"/>
     <p:sldId id="284" r:id="rId35"/>
     <p:sldId id="285" r:id="rId36"/>
+    <p:sldId id="286" r:id="rId37"/>
   </p:sldIdLst>
   <p:sldSz cx="12191695" cy="6858000" type="screen4x3"/>
   <p:notesSz cx="6858000" cy="9144000"/>
@@ -12827,13 +12828,13 @@
                           <a:latin typeface="PingFang TC"/>
                           <a:ea typeface="PingFang TC"/>
                         </a:rPr>
-                        <a:t>無</a:t>
+                        <a:t>✅ 已實作</a:t>
                       </a:r>
                     </a:p>
                   </a:txBody>
                   <a:tcPr marT="25400" marB="25400" marL="101600" anchor="ctr">
                     <a:solidFill>
-                      <a:srgbClr val="FEE2E2"/>
+                      <a:srgbClr val="F1F5F9"/>
                     </a:solidFill>
                   </a:tcPr>
                 </a:tc>
@@ -12850,7 +12851,7 @@
                           <a:latin typeface="PingFang TC"/>
                           <a:ea typeface="PingFang TC"/>
                         </a:rPr>
-                        <a:t>metrics · 日誌 · 掛掉告警</a:t>
+                        <a:t>CloudWatch alarms→SNS + Logs + canary</a:t>
                       </a:r>
                     </a:p>
                   </a:txBody>
@@ -16860,7 +16861,7 @@
                 <a:latin typeface="PingFang TC"/>
                 <a:ea typeface="PingFang TC"/>
               </a:rPr>
-              <a:t>部署 · CI/CD</a:t>
+              <a:t>可靠性 · MONITORING</a:t>
             </a:r>
           </a:p>
           <a:p>
@@ -16877,7 +16878,7 @@
                 <a:latin typeface="PingFang TC"/>
                 <a:ea typeface="PingFang TC"/>
               </a:rPr>
-              <a:t>CI/CD 流程（GitHub Actions + OIDC）</a:t>
+              <a:t>CloudWatch alarms → SNS + Logs + Dashboard + Canary</a:t>
             </a:r>
           </a:p>
         </p:txBody>
@@ -16890,231 +16891,8 @@
         </p:nvSpPr>
         <p:spPr>
           <a:xfrm>
-            <a:off x="457200" y="2286000"/>
-            <a:ext cx="1481328" cy="1280160"/>
-          </a:xfrm>
-          <a:prstGeom prst="roundRect">
-            <a:avLst/>
-          </a:prstGeom>
-          <a:solidFill>
-            <a:srgbClr val="64748B"/>
-          </a:solidFill>
-          <a:ln>
-            <a:solidFill>
-              <a:srgbClr val="64748B"/>
-            </a:solidFill>
-          </a:ln>
-          <a:effectLst/>
-        </p:spPr>
-        <p:style>
-          <a:lnRef idx="1">
-            <a:schemeClr val="accent1"/>
-          </a:lnRef>
-          <a:fillRef idx="3">
-            <a:schemeClr val="accent1"/>
-          </a:fillRef>
-          <a:effectRef idx="2">
-            <a:schemeClr val="accent1"/>
-          </a:effectRef>
-          <a:fontRef idx="minor">
-            <a:schemeClr val="lt1"/>
-          </a:fontRef>
-        </p:style>
-        <p:txBody>
-          <a:bodyPr rtlCol="0" anchor="ctr" wrap="square" tIns="25400" bIns="25400"/>
-          <a:lstStyle/>
-          <a:p>
-            <a:pPr algn="ctr"/>
-            <a:r>
-              <a:rPr sz="1100" b="1">
-                <a:solidFill>
-                  <a:srgbClr val="FFFFFF"/>
-                </a:solidFill>
-                <a:latin typeface="PingFang TC"/>
-                <a:ea typeface="PingFang TC"/>
-              </a:rPr>
-              <a:t>git push</a:t>
-            </a:r>
-          </a:p>
-          <a:p>
-            <a:pPr algn="ctr"/>
-            <a:r>
-              <a:rPr sz="1100" b="0">
-                <a:solidFill>
-                  <a:srgbClr val="FFFFFF"/>
-                </a:solidFill>
-                <a:latin typeface="PingFang TC"/>
-                <a:ea typeface="PingFang TC"/>
-              </a:rPr>
-              <a:t>QR Code Generator/**</a:t>
-            </a:r>
-          </a:p>
-        </p:txBody>
-      </p:sp>
-      <p:cxnSp>
-        <p:nvCxnSpPr>
-          <p:cNvPr id="5" name="Connector 4"/>
-          <p:cNvCxnSpPr/>
-          <p:nvPr/>
-        </p:nvCxnSpPr>
-        <p:spPr>
-          <a:xfrm>
-            <a:off x="1938528" y="2926080"/>
-            <a:ext cx="118872" cy="0"/>
-          </a:xfrm>
-          <a:prstGeom prst="line">
-            <a:avLst/>
-          </a:prstGeom>
-          <a:ln w="22225">
-            <a:solidFill>
-              <a:srgbClr val="64748B"/>
-            </a:solidFill>
-            <a:tailEnd type="triangle" w="med" len="med"/>
-          </a:ln>
-        </p:spPr>
-        <p:style>
-          <a:lnRef idx="2">
-            <a:schemeClr val="accent1"/>
-          </a:lnRef>
-          <a:fillRef idx="0">
-            <a:schemeClr val="accent1"/>
-          </a:fillRef>
-          <a:effectRef idx="1">
-            <a:schemeClr val="accent1"/>
-          </a:effectRef>
-          <a:fontRef idx="minor">
-            <a:schemeClr val="tx1"/>
-          </a:fontRef>
-        </p:style>
-      </p:cxnSp>
-      <p:sp>
-        <p:nvSpPr>
-          <p:cNvPr id="6" name="Rounded Rectangle 5"/>
-          <p:cNvSpPr/>
-          <p:nvPr/>
-        </p:nvSpPr>
-        <p:spPr>
-          <a:xfrm>
-            <a:off x="2057400" y="2286000"/>
-            <a:ext cx="1481328" cy="1280160"/>
-          </a:xfrm>
-          <a:prstGeom prst="roundRect">
-            <a:avLst/>
-          </a:prstGeom>
-          <a:solidFill>
-            <a:srgbClr val="0EA5E9"/>
-          </a:solidFill>
-          <a:ln>
-            <a:solidFill>
-              <a:srgbClr val="0EA5E9"/>
-            </a:solidFill>
-          </a:ln>
-          <a:effectLst/>
-        </p:spPr>
-        <p:style>
-          <a:lnRef idx="1">
-            <a:schemeClr val="accent1"/>
-          </a:lnRef>
-          <a:fillRef idx="3">
-            <a:schemeClr val="accent1"/>
-          </a:fillRef>
-          <a:effectRef idx="2">
-            <a:schemeClr val="accent1"/>
-          </a:effectRef>
-          <a:fontRef idx="minor">
-            <a:schemeClr val="lt1"/>
-          </a:fontRef>
-        </p:style>
-        <p:txBody>
-          <a:bodyPr rtlCol="0" anchor="ctr" wrap="square" tIns="25400" bIns="25400"/>
-          <a:lstStyle/>
-          <a:p>
-            <a:pPr algn="ctr"/>
-            <a:r>
-              <a:rPr sz="1100" b="1">
-                <a:solidFill>
-                  <a:srgbClr val="FFFFFF"/>
-                </a:solidFill>
-                <a:latin typeface="PingFang TC"/>
-                <a:ea typeface="PingFang TC"/>
-              </a:rPr>
-              <a:t>GitHub Actions</a:t>
-            </a:r>
-          </a:p>
-          <a:p>
-            <a:pPr algn="ctr"/>
-            <a:r>
-              <a:rPr sz="1100" b="0">
-                <a:solidFill>
-                  <a:srgbClr val="FFFFFF"/>
-                </a:solidFill>
-                <a:latin typeface="PingFang TC"/>
-                <a:ea typeface="PingFang TC"/>
-              </a:rPr>
-              <a:t>OIDC assume role</a:t>
-            </a:r>
-          </a:p>
-          <a:p>
-            <a:pPr algn="ctr"/>
-            <a:r>
-              <a:rPr sz="1100" b="0">
-                <a:solidFill>
-                  <a:srgbClr val="FFFFFF"/>
-                </a:solidFill>
-                <a:latin typeface="PingFang TC"/>
-                <a:ea typeface="PingFang TC"/>
-              </a:rPr>
-              <a:t>(無長期金鑰)</a:t>
-            </a:r>
-          </a:p>
-        </p:txBody>
-      </p:sp>
-      <p:cxnSp>
-        <p:nvCxnSpPr>
-          <p:cNvPr id="7" name="Connector 6"/>
-          <p:cNvCxnSpPr/>
-          <p:nvPr/>
-        </p:nvCxnSpPr>
-        <p:spPr>
-          <a:xfrm>
-            <a:off x="3538728" y="2926080"/>
-            <a:ext cx="118872" cy="0"/>
-          </a:xfrm>
-          <a:prstGeom prst="line">
-            <a:avLst/>
-          </a:prstGeom>
-          <a:ln w="22225">
-            <a:solidFill>
-              <a:srgbClr val="64748B"/>
-            </a:solidFill>
-            <a:tailEnd type="triangle" w="med" len="med"/>
-          </a:ln>
-        </p:spPr>
-        <p:style>
-          <a:lnRef idx="2">
-            <a:schemeClr val="accent1"/>
-          </a:lnRef>
-          <a:fillRef idx="0">
-            <a:schemeClr val="accent1"/>
-          </a:fillRef>
-          <a:effectRef idx="1">
-            <a:schemeClr val="accent1"/>
-          </a:effectRef>
-          <a:fontRef idx="minor">
-            <a:schemeClr val="tx1"/>
-          </a:fontRef>
-        </p:style>
-      </p:cxnSp>
-      <p:sp>
-        <p:nvSpPr>
-          <p:cNvPr id="8" name="Rounded Rectangle 7"/>
-          <p:cNvSpPr/>
-          <p:nvPr/>
-        </p:nvSpPr>
-        <p:spPr>
-          <a:xfrm>
-            <a:off x="3657600" y="2286000"/>
-            <a:ext cx="1481328" cy="1280160"/>
+            <a:off x="548640" y="1828800"/>
+            <a:ext cx="2926080" cy="822960"/>
           </a:xfrm>
           <a:prstGeom prst="roundRect">
             <a:avLst/>
@@ -17156,7 +16934,7 @@
                 <a:latin typeface="PingFang TC"/>
                 <a:ea typeface="PingFang TC"/>
               </a:rPr>
-              <a:t>buildx</a:t>
+              <a:t>CloudWatch Alarms</a:t>
             </a:r>
           </a:p>
           <a:p>
@@ -17169,70 +16947,90 @@
                 <a:latin typeface="PingFang TC"/>
                 <a:ea typeface="PingFang TC"/>
               </a:rPr>
-              <a:t>--platform</a:t>
-            </a:r>
-          </a:p>
-          <a:p>
-            <a:pPr algn="ctr"/>
-            <a:r>
-              <a:rPr sz="1100" b="0">
-                <a:solidFill>
-                  <a:srgbClr val="FFFFFF"/>
-                </a:solidFill>
-                <a:latin typeface="PingFang TC"/>
-                <a:ea typeface="PingFang TC"/>
-              </a:rPr>
-              <a:t>linux/arm64</a:t>
-            </a:r>
-          </a:p>
-        </p:txBody>
-      </p:sp>
-      <p:cxnSp>
-        <p:nvCxnSpPr>
-          <p:cNvPr id="9" name="Connector 8"/>
-          <p:cNvCxnSpPr/>
-          <p:nvPr/>
-        </p:nvCxnSpPr>
-        <p:spPr>
-          <a:xfrm>
-            <a:off x="5138928" y="2926080"/>
-            <a:ext cx="118872" cy="0"/>
-          </a:xfrm>
-          <a:prstGeom prst="line">
-            <a:avLst/>
-          </a:prstGeom>
-          <a:ln w="22225">
+              <a:t>ALB/RDS/EC2/API GW/Lambda/CF</a:t>
+            </a:r>
+          </a:p>
+        </p:txBody>
+      </p:sp>
+      <p:sp>
+        <p:nvSpPr>
+          <p:cNvPr id="5" name="Rounded Rectangle 4"/>
+          <p:cNvSpPr/>
+          <p:nvPr/>
+        </p:nvSpPr>
+        <p:spPr>
+          <a:xfrm>
+            <a:off x="3931920" y="1828800"/>
+            <a:ext cx="2377440" cy="822960"/>
+          </a:xfrm>
+          <a:prstGeom prst="roundRect">
+            <a:avLst/>
+          </a:prstGeom>
+          <a:solidFill>
+            <a:srgbClr val="D97706"/>
+          </a:solidFill>
+          <a:ln>
             <a:solidFill>
-              <a:srgbClr val="64748B"/>
+              <a:srgbClr val="D97706"/>
             </a:solidFill>
-            <a:tailEnd type="triangle" w="med" len="med"/>
           </a:ln>
+          <a:effectLst/>
         </p:spPr>
         <p:style>
-          <a:lnRef idx="2">
+          <a:lnRef idx="1">
             <a:schemeClr val="accent1"/>
           </a:lnRef>
-          <a:fillRef idx="0">
+          <a:fillRef idx="3">
             <a:schemeClr val="accent1"/>
           </a:fillRef>
-          <a:effectRef idx="1">
+          <a:effectRef idx="2">
             <a:schemeClr val="accent1"/>
           </a:effectRef>
           <a:fontRef idx="minor">
-            <a:schemeClr val="tx1"/>
+            <a:schemeClr val="lt1"/>
           </a:fontRef>
         </p:style>
-      </p:cxnSp>
-      <p:sp>
-        <p:nvSpPr>
-          <p:cNvPr id="10" name="Rounded Rectangle 9"/>
+        <p:txBody>
+          <a:bodyPr rtlCol="0" anchor="ctr" wrap="square" tIns="25400" bIns="25400"/>
+          <a:lstStyle/>
+          <a:p>
+            <a:pPr algn="ctr"/>
+            <a:r>
+              <a:rPr sz="1200" b="1">
+                <a:solidFill>
+                  <a:srgbClr val="FFFFFF"/>
+                </a:solidFill>
+                <a:latin typeface="PingFang TC"/>
+                <a:ea typeface="PingFang TC"/>
+              </a:rPr>
+              <a:t>SNS topic</a:t>
+            </a:r>
+          </a:p>
+          <a:p>
+            <a:pPr algn="ctr"/>
+            <a:r>
+              <a:rPr sz="1200" b="0">
+                <a:solidFill>
+                  <a:srgbClr val="FFFFFF"/>
+                </a:solidFill>
+                <a:latin typeface="PingFang TC"/>
+                <a:ea typeface="PingFang TC"/>
+              </a:rPr>
+              <a:t>→ Email 通知</a:t>
+            </a:r>
+          </a:p>
+        </p:txBody>
+      </p:sp>
+      <p:sp>
+        <p:nvSpPr>
+          <p:cNvPr id="6" name="Rounded Rectangle 5"/>
           <p:cNvSpPr/>
           <p:nvPr/>
         </p:nvSpPr>
         <p:spPr>
           <a:xfrm>
-            <a:off x="5257800" y="2286000"/>
-            <a:ext cx="1481328" cy="1280160"/>
+            <a:off x="6766560" y="1828800"/>
+            <a:ext cx="2377440" cy="822960"/>
           </a:xfrm>
           <a:prstGeom prst="roundRect">
             <a:avLst/>
@@ -17267,54 +17065,41 @@
           <a:p>
             <a:pPr algn="ctr"/>
             <a:r>
-              <a:rPr sz="1100" b="1">
+              <a:rPr sz="1200" b="1">
                 <a:solidFill>
                   <a:srgbClr val="FFFFFF"/>
                 </a:solidFill>
                 <a:latin typeface="PingFang TC"/>
                 <a:ea typeface="PingFang TC"/>
               </a:rPr>
-              <a:t>ECR push</a:t>
+              <a:t>Synthetic Canary</a:t>
             </a:r>
           </a:p>
           <a:p>
             <a:pPr algn="ctr"/>
             <a:r>
-              <a:rPr sz="1100" b="0">
+              <a:rPr sz="1200" b="0">
                 <a:solidFill>
                   <a:srgbClr val="FFFFFF"/>
                 </a:solidFill>
                 <a:latin typeface="PingFang TC"/>
                 <a:ea typeface="PingFang TC"/>
               </a:rPr>
-              <a:t>tag = SHA</a:t>
-            </a:r>
-          </a:p>
-          <a:p>
-            <a:pPr algn="ctr"/>
-            <a:r>
-              <a:rPr sz="1100" b="0">
-                <a:solidFill>
-                  <a:srgbClr val="FFFFFF"/>
-                </a:solidFill>
-                <a:latin typeface="PingFang TC"/>
-                <a:ea typeface="PingFang TC"/>
-              </a:rPr>
-              <a:t>+ latest</a:t>
+              <a:t>每 5 分 /health</a:t>
             </a:r>
           </a:p>
         </p:txBody>
       </p:sp>
       <p:cxnSp>
         <p:nvCxnSpPr>
-          <p:cNvPr id="11" name="Connector 10"/>
+          <p:cNvPr id="7" name="Connector 6"/>
           <p:cNvCxnSpPr/>
           <p:nvPr/>
         </p:nvCxnSpPr>
         <p:spPr>
           <a:xfrm>
-            <a:off x="6739128" y="2926080"/>
-            <a:ext cx="118872" cy="0"/>
+            <a:off x="3474720" y="2240280"/>
+            <a:ext cx="457200" cy="0"/>
           </a:xfrm>
           <a:prstGeom prst="line">
             <a:avLst/>
@@ -17341,103 +17126,21 @@
           </a:fontRef>
         </p:style>
       </p:cxnSp>
-      <p:sp>
-        <p:nvSpPr>
-          <p:cNvPr id="12" name="Rounded Rectangle 11"/>
-          <p:cNvSpPr/>
-          <p:nvPr/>
-        </p:nvSpPr>
-        <p:spPr>
-          <a:xfrm>
-            <a:off x="6858000" y="2286000"/>
-            <a:ext cx="1481328" cy="1280160"/>
-          </a:xfrm>
-          <a:prstGeom prst="roundRect">
-            <a:avLst/>
-          </a:prstGeom>
-          <a:solidFill>
-            <a:srgbClr val="7C3AED"/>
-          </a:solidFill>
-          <a:ln>
-            <a:solidFill>
-              <a:srgbClr val="7C3AED"/>
-            </a:solidFill>
-          </a:ln>
-          <a:effectLst/>
-        </p:spPr>
-        <p:style>
-          <a:lnRef idx="1">
-            <a:schemeClr val="accent1"/>
-          </a:lnRef>
-          <a:fillRef idx="3">
-            <a:schemeClr val="accent1"/>
-          </a:fillRef>
-          <a:effectRef idx="2">
-            <a:schemeClr val="accent1"/>
-          </a:effectRef>
-          <a:fontRef idx="minor">
-            <a:schemeClr val="lt1"/>
-          </a:fontRef>
-        </p:style>
-        <p:txBody>
-          <a:bodyPr rtlCol="0" anchor="ctr" wrap="square" tIns="25400" bIns="25400"/>
-          <a:lstStyle/>
-          <a:p>
-            <a:pPr algn="ctr"/>
-            <a:r>
-              <a:rPr sz="1100" b="1">
-                <a:solidFill>
-                  <a:srgbClr val="FFFFFF"/>
-                </a:solidFill>
-                <a:latin typeface="PingFang TC"/>
-                <a:ea typeface="PingFang TC"/>
-              </a:rPr>
-              <a:t>SSM 更新</a:t>
-            </a:r>
-          </a:p>
-          <a:p>
-            <a:pPr algn="ctr"/>
-            <a:r>
-              <a:rPr sz="1100" b="0">
-                <a:solidFill>
-                  <a:srgbClr val="FFFFFF"/>
-                </a:solidFill>
-                <a:latin typeface="PingFang TC"/>
-                <a:ea typeface="PingFang TC"/>
-              </a:rPr>
-              <a:t>/qrcode/</a:t>
-            </a:r>
-          </a:p>
-          <a:p>
-            <a:pPr algn="ctr"/>
-            <a:r>
-              <a:rPr sz="1100" b="0">
-                <a:solidFill>
-                  <a:srgbClr val="FFFFFF"/>
-                </a:solidFill>
-                <a:latin typeface="PingFang TC"/>
-                <a:ea typeface="PingFang TC"/>
-              </a:rPr>
-              <a:t>IMAGE_URI</a:t>
-            </a:r>
-          </a:p>
-        </p:txBody>
-      </p:sp>
       <p:cxnSp>
         <p:nvCxnSpPr>
-          <p:cNvPr id="13" name="Connector 12"/>
+          <p:cNvPr id="8" name="Connector 7"/>
           <p:cNvCxnSpPr/>
           <p:nvPr/>
         </p:nvCxnSpPr>
         <p:spPr>
-          <a:xfrm>
-            <a:off x="8339328" y="2926080"/>
-            <a:ext cx="118872" cy="0"/>
+          <a:xfrm flipH="1">
+            <a:off x="6309360" y="2240280"/>
+            <a:ext cx="457200" cy="0"/>
           </a:xfrm>
           <a:prstGeom prst="line">
             <a:avLst/>
           </a:prstGeom>
-          <a:ln w="22225">
+          <a:ln w="15240">
             <a:solidFill>
               <a:srgbClr val="64748B"/>
             </a:solidFill>
@@ -17459,216 +17162,330 @@
           </a:fontRef>
         </p:style>
       </p:cxnSp>
-      <p:sp>
-        <p:nvSpPr>
-          <p:cNvPr id="14" name="Rounded Rectangle 13"/>
-          <p:cNvSpPr/>
-          <p:nvPr/>
-        </p:nvSpPr>
-        <p:spPr>
-          <a:xfrm>
-            <a:off x="8458200" y="2286000"/>
-            <a:ext cx="1481328" cy="1280160"/>
-          </a:xfrm>
-          <a:prstGeom prst="roundRect">
-            <a:avLst/>
-          </a:prstGeom>
-          <a:solidFill>
-            <a:srgbClr val="D97706"/>
-          </a:solidFill>
-          <a:ln>
-            <a:solidFill>
-              <a:srgbClr val="D97706"/>
-            </a:solidFill>
-          </a:ln>
-          <a:effectLst/>
-        </p:spPr>
-        <p:style>
-          <a:lnRef idx="1">
-            <a:schemeClr val="accent1"/>
-          </a:lnRef>
-          <a:fillRef idx="3">
-            <a:schemeClr val="accent1"/>
-          </a:fillRef>
-          <a:effectRef idx="2">
-            <a:schemeClr val="accent1"/>
-          </a:effectRef>
-          <a:fontRef idx="minor">
-            <a:schemeClr val="lt1"/>
-          </a:fontRef>
-        </p:style>
-        <p:txBody>
-          <a:bodyPr rtlCol="0" anchor="ctr" wrap="square" tIns="25400" bIns="25400"/>
-          <a:lstStyle/>
-          <a:p>
-            <a:pPr algn="ctr"/>
-            <a:r>
-              <a:rPr sz="1100" b="1">
-                <a:solidFill>
-                  <a:srgbClr val="FFFFFF"/>
-                </a:solidFill>
-                <a:latin typeface="PingFang TC"/>
-                <a:ea typeface="PingFang TC"/>
-              </a:rPr>
-              <a:t>SSM 部署</a:t>
-            </a:r>
-          </a:p>
-          <a:p>
-            <a:pPr algn="ctr"/>
-            <a:r>
-              <a:rPr sz="1100" b="0">
-                <a:solidFill>
-                  <a:srgbClr val="FFFFFF"/>
-                </a:solidFill>
-                <a:latin typeface="PingFang TC"/>
-                <a:ea typeface="PingFang TC"/>
-              </a:rPr>
-              <a:t>→ EC2</a:t>
-            </a:r>
-          </a:p>
-          <a:p>
-            <a:pPr algn="ctr"/>
-            <a:r>
-              <a:rPr sz="1100" b="0">
-                <a:solidFill>
-                  <a:srgbClr val="FFFFFF"/>
-                </a:solidFill>
-                <a:latin typeface="PingFang TC"/>
-                <a:ea typeface="PingFang TC"/>
-              </a:rPr>
-              <a:t>deploy-app.sh</a:t>
-            </a:r>
-          </a:p>
-        </p:txBody>
-      </p:sp>
-      <p:cxnSp>
-        <p:nvCxnSpPr>
-          <p:cNvPr id="15" name="Connector 14"/>
-          <p:cNvCxnSpPr/>
-          <p:nvPr/>
-        </p:nvCxnSpPr>
-        <p:spPr>
-          <a:xfrm>
-            <a:off x="9939528" y="2926080"/>
-            <a:ext cx="118872" cy="0"/>
-          </a:xfrm>
-          <a:prstGeom prst="line">
-            <a:avLst/>
-          </a:prstGeom>
-          <a:ln w="22225">
-            <a:solidFill>
-              <a:srgbClr val="64748B"/>
-            </a:solidFill>
-            <a:tailEnd type="triangle" w="med" len="med"/>
-          </a:ln>
-        </p:spPr>
-        <p:style>
-          <a:lnRef idx="2">
-            <a:schemeClr val="accent1"/>
-          </a:lnRef>
-          <a:fillRef idx="0">
-            <a:schemeClr val="accent1"/>
-          </a:fillRef>
-          <a:effectRef idx="1">
-            <a:schemeClr val="accent1"/>
-          </a:effectRef>
-          <a:fontRef idx="minor">
-            <a:schemeClr val="tx1"/>
-          </a:fontRef>
-        </p:style>
-      </p:cxnSp>
-      <p:sp>
-        <p:nvSpPr>
-          <p:cNvPr id="16" name="Rounded Rectangle 15"/>
-          <p:cNvSpPr/>
-          <p:nvPr/>
-        </p:nvSpPr>
-        <p:spPr>
-          <a:xfrm>
-            <a:off x="10058400" y="2286000"/>
-            <a:ext cx="1481328" cy="1280160"/>
-          </a:xfrm>
-          <a:prstGeom prst="roundRect">
-            <a:avLst/>
-          </a:prstGeom>
-          <a:solidFill>
-            <a:srgbClr val="059669"/>
-          </a:solidFill>
-          <a:ln>
-            <a:solidFill>
-              <a:srgbClr val="059669"/>
-            </a:solidFill>
-          </a:ln>
-          <a:effectLst/>
-        </p:spPr>
-        <p:style>
-          <a:lnRef idx="1">
-            <a:schemeClr val="accent1"/>
-          </a:lnRef>
-          <a:fillRef idx="3">
-            <a:schemeClr val="accent1"/>
-          </a:fillRef>
-          <a:effectRef idx="2">
-            <a:schemeClr val="accent1"/>
-          </a:effectRef>
-          <a:fontRef idx="minor">
-            <a:schemeClr val="lt1"/>
-          </a:fontRef>
-        </p:style>
-        <p:txBody>
-          <a:bodyPr rtlCol="0" anchor="ctr" wrap="square" tIns="25400" bIns="25400"/>
-          <a:lstStyle/>
-          <a:p>
-            <a:pPr algn="ctr"/>
-            <a:r>
-              <a:rPr sz="1100" b="1">
-                <a:solidFill>
-                  <a:srgbClr val="FFFFFF"/>
-                </a:solidFill>
-                <a:latin typeface="PingFang TC"/>
-                <a:ea typeface="PingFang TC"/>
-              </a:rPr>
-              <a:t>上線</a:t>
-            </a:r>
-          </a:p>
-          <a:p>
-            <a:pPr algn="ctr"/>
-            <a:r>
-              <a:rPr sz="1100" b="0">
-                <a:solidFill>
-                  <a:srgbClr val="FFFFFF"/>
-                </a:solidFill>
-                <a:latin typeface="PingFang TC"/>
-                <a:ea typeface="PingFang TC"/>
-              </a:rPr>
-              <a:t>ALB /health</a:t>
-            </a:r>
-          </a:p>
-          <a:p>
-            <a:pPr algn="ctr"/>
-            <a:r>
-              <a:rPr sz="1100" b="0">
-                <a:solidFill>
-                  <a:srgbClr val="FFFFFF"/>
-                </a:solidFill>
-                <a:latin typeface="PingFang TC"/>
-                <a:ea typeface="PingFang TC"/>
-              </a:rPr>
-              <a:t>通過</a:t>
-            </a:r>
-          </a:p>
-        </p:txBody>
-      </p:sp>
-      <p:sp>
-        <p:nvSpPr>
-          <p:cNvPr id="17" name="TextBox 16"/>
+      <p:graphicFrame>
+        <p:nvGraphicFramePr>
+          <p:cNvPr id="9" name="Table 8"/>
+          <p:cNvGraphicFramePr>
+            <a:graphicFrameLocks noGrp="1"/>
+          </p:cNvGraphicFramePr>
+          <p:nvPr/>
+        </p:nvGraphicFramePr>
+        <p:xfrm>
+          <a:off x="548640" y="3017520"/>
+          <a:ext cx="11109960" cy="2651760"/>
+        </p:xfrm>
+        <a:graphic>
+          <a:graphicData uri="http://schemas.openxmlformats.org/drawingml/2006/table">
+            <a:tbl>
+              <a:tblPr firstRow="1" bandRow="1">
+                <a:tableStyleId>{5C22544A-7EE6-4342-B048-85BDC9FD1C3A}</a:tableStyleId>
+              </a:tblPr>
+              <a:tblGrid>
+                <a:gridCol w="2011680"/>
+                <a:gridCol w="9098280"/>
+              </a:tblGrid>
+              <a:tr h="441960">
+                <a:tc>
+                  <a:txBody>
+                    <a:bodyPr/>
+                    <a:lstStyle/>
+                    <a:p>
+                      <a:r>
+                        <a:rPr sz="1200" b="1">
+                          <a:solidFill>
+                            <a:srgbClr val="FFFFFF"/>
+                          </a:solidFill>
+                          <a:latin typeface="PingFang TC"/>
+                          <a:ea typeface="PingFang TC"/>
+                        </a:rPr>
+                        <a:t>面向</a:t>
+                      </a:r>
+                    </a:p>
+                  </a:txBody>
+                  <a:tcPr marT="25400" marB="25400" marL="101600" anchor="ctr">
+                    <a:solidFill>
+                      <a:srgbClr val="2563EB"/>
+                    </a:solidFill>
+                  </a:tcPr>
+                </a:tc>
+                <a:tc>
+                  <a:txBody>
+                    <a:bodyPr/>
+                    <a:lstStyle/>
+                    <a:p>
+                      <a:r>
+                        <a:rPr sz="1200" b="1">
+                          <a:solidFill>
+                            <a:srgbClr val="FFFFFF"/>
+                          </a:solidFill>
+                          <a:latin typeface="PingFang TC"/>
+                          <a:ea typeface="PingFang TC"/>
+                        </a:rPr>
+                        <a:t>內容</a:t>
+                      </a:r>
+                    </a:p>
+                  </a:txBody>
+                  <a:tcPr marT="25400" marB="25400" marL="101600" anchor="ctr">
+                    <a:solidFill>
+                      <a:srgbClr val="2563EB"/>
+                    </a:solidFill>
+                  </a:tcPr>
+                </a:tc>
+              </a:tr>
+              <a:tr h="441960">
+                <a:tc>
+                  <a:txBody>
+                    <a:bodyPr/>
+                    <a:lstStyle/>
+                    <a:p>
+                      <a:r>
+                        <a:rPr sz="1200" b="1">
+                          <a:solidFill>
+                            <a:srgbClr val="0F172A"/>
+                          </a:solidFill>
+                          <a:latin typeface="PingFang TC"/>
+                          <a:ea typeface="PingFang TC"/>
+                        </a:rPr>
+                        <a:t>告警 alarms</a:t>
+                      </a:r>
+                    </a:p>
+                  </a:txBody>
+                  <a:tcPr marT="25400" marB="25400" marL="101600" anchor="ctr">
+                    <a:solidFill>
+                      <a:srgbClr val="FFFFFF"/>
+                    </a:solidFill>
+                  </a:tcPr>
+                </a:tc>
+                <a:tc>
+                  <a:txBody>
+                    <a:bodyPr/>
+                    <a:lstStyle/>
+                    <a:p>
+                      <a:r>
+                        <a:rPr sz="1200" b="0">
+                          <a:solidFill>
+                            <a:srgbClr val="0F172A"/>
+                          </a:solidFill>
+                          <a:latin typeface="PingFang TC"/>
+                          <a:ea typeface="PingFang TC"/>
+                        </a:rPr>
+                        <a:t>ALB unhealthy/5xx/latency · RDS CPU/storage · ElastiCache · API GW 5xx · Lambda errors · CloudFront 5xx(us-east-1)</a:t>
+                      </a:r>
+                    </a:p>
+                  </a:txBody>
+                  <a:tcPr marT="25400" marB="25400" marL="101600" anchor="ctr">
+                    <a:solidFill>
+                      <a:srgbClr val="FFFFFF"/>
+                    </a:solidFill>
+                  </a:tcPr>
+                </a:tc>
+              </a:tr>
+              <a:tr h="441960">
+                <a:tc>
+                  <a:txBody>
+                    <a:bodyPr/>
+                    <a:lstStyle/>
+                    <a:p>
+                      <a:r>
+                        <a:rPr sz="1200" b="1">
+                          <a:solidFill>
+                            <a:srgbClr val="0F172A"/>
+                          </a:solidFill>
+                          <a:latin typeface="PingFang TC"/>
+                          <a:ea typeface="PingFang TC"/>
+                        </a:rPr>
+                        <a:t>通知</a:t>
+                      </a:r>
+                    </a:p>
+                  </a:txBody>
+                  <a:tcPr marT="25400" marB="25400" marL="101600" anchor="ctr">
+                    <a:solidFill>
+                      <a:srgbClr val="F1F5F9"/>
+                    </a:solidFill>
+                  </a:tcPr>
+                </a:tc>
+                <a:tc>
+                  <a:txBody>
+                    <a:bodyPr/>
+                    <a:lstStyle/>
+                    <a:p>
+                      <a:r>
+                        <a:rPr sz="1200" b="0">
+                          <a:solidFill>
+                            <a:srgbClr val="0F172A"/>
+                          </a:solidFill>
+                          <a:latin typeface="PingFang TC"/>
+                          <a:ea typeface="PingFang TC"/>
+                        </a:rPr>
+                        <a:t>CloudWatch alarm → SNS topic → email（alert_email,需點確認信）</a:t>
+                      </a:r>
+                    </a:p>
+                  </a:txBody>
+                  <a:tcPr marT="25400" marB="25400" marL="101600" anchor="ctr">
+                    <a:solidFill>
+                      <a:srgbClr val="F1F5F9"/>
+                    </a:solidFill>
+                  </a:tcPr>
+                </a:tc>
+              </a:tr>
+              <a:tr h="441960">
+                <a:tc>
+                  <a:txBody>
+                    <a:bodyPr/>
+                    <a:lstStyle/>
+                    <a:p>
+                      <a:r>
+                        <a:rPr sz="1200" b="1">
+                          <a:solidFill>
+                            <a:srgbClr val="0F172A"/>
+                          </a:solidFill>
+                          <a:latin typeface="PingFang TC"/>
+                          <a:ea typeface="PingFang TC"/>
+                        </a:rPr>
+                        <a:t>App logs</a:t>
+                      </a:r>
+                    </a:p>
+                  </a:txBody>
+                  <a:tcPr marT="25400" marB="25400" marL="101600" anchor="ctr">
+                    <a:solidFill>
+                      <a:srgbClr val="FFFFFF"/>
+                    </a:solidFill>
+                  </a:tcPr>
+                </a:tc>
+                <a:tc>
+                  <a:txBody>
+                    <a:bodyPr/>
+                    <a:lstStyle/>
+                    <a:p>
+                      <a:r>
+                        <a:rPr sz="1200" b="0">
+                          <a:solidFill>
+                            <a:srgbClr val="0F172A"/>
+                          </a:solidFill>
+                          <a:latin typeface="PingFang TC"/>
+                          <a:ea typeface="PingFang TC"/>
+                        </a:rPr>
+                        <a:t>EC2 容器 awslogs driver → CloudWatch Logs /qrcode/app（retention 14d）</a:t>
+                      </a:r>
+                    </a:p>
+                  </a:txBody>
+                  <a:tcPr marT="25400" marB="25400" marL="101600" anchor="ctr">
+                    <a:solidFill>
+                      <a:srgbClr val="FFFFFF"/>
+                    </a:solidFill>
+                  </a:tcPr>
+                </a:tc>
+              </a:tr>
+              <a:tr h="441960">
+                <a:tc>
+                  <a:txBody>
+                    <a:bodyPr/>
+                    <a:lstStyle/>
+                    <a:p>
+                      <a:r>
+                        <a:rPr sz="1200" b="1">
+                          <a:solidFill>
+                            <a:srgbClr val="0F172A"/>
+                          </a:solidFill>
+                          <a:latin typeface="PingFang TC"/>
+                          <a:ea typeface="PingFang TC"/>
+                        </a:rPr>
+                        <a:t>Dashboard</a:t>
+                      </a:r>
+                    </a:p>
+                  </a:txBody>
+                  <a:tcPr marT="25400" marB="25400" marL="101600" anchor="ctr">
+                    <a:solidFill>
+                      <a:srgbClr val="F1F5F9"/>
+                    </a:solidFill>
+                  </a:tcPr>
+                </a:tc>
+                <a:tc>
+                  <a:txBody>
+                    <a:bodyPr/>
+                    <a:lstStyle/>
+                    <a:p>
+                      <a:r>
+                        <a:rPr sz="1200" b="0">
+                          <a:solidFill>
+                            <a:srgbClr val="0F172A"/>
+                          </a:solidFill>
+                          <a:latin typeface="PingFang TC"/>
+                          <a:ea typeface="PingFang TC"/>
+                        </a:rPr>
+                        <a:t>qrcode-overview：ALB/RDS/EC2/API GW/Lambda 一頁</a:t>
+                      </a:r>
+                    </a:p>
+                  </a:txBody>
+                  <a:tcPr marT="25400" marB="25400" marL="101600" anchor="ctr">
+                    <a:solidFill>
+                      <a:srgbClr val="F1F5F9"/>
+                    </a:solidFill>
+                  </a:tcPr>
+                </a:tc>
+              </a:tr>
+              <a:tr h="441960">
+                <a:tc>
+                  <a:txBody>
+                    <a:bodyPr/>
+                    <a:lstStyle/>
+                    <a:p>
+                      <a:r>
+                        <a:rPr sz="1200" b="1">
+                          <a:solidFill>
+                            <a:srgbClr val="0F172A"/>
+                          </a:solidFill>
+                          <a:latin typeface="PingFang TC"/>
+                          <a:ea typeface="PingFang TC"/>
+                        </a:rPr>
+                        <a:t>Canary</a:t>
+                      </a:r>
+                    </a:p>
+                  </a:txBody>
+                  <a:tcPr marT="25400" marB="25400" marL="101600" anchor="ctr">
+                    <a:solidFill>
+                      <a:srgbClr val="FFFFFF"/>
+                    </a:solidFill>
+                  </a:tcPr>
+                </a:tc>
+                <a:tc>
+                  <a:txBody>
+                    <a:bodyPr/>
+                    <a:lstStyle/>
+                    <a:p>
+                      <a:r>
+                        <a:rPr sz="1200" b="0">
+                          <a:solidFill>
+                            <a:srgbClr val="0F172A"/>
+                          </a:solidFill>
+                          <a:latin typeface="PingFang TC"/>
+                          <a:ea typeface="PingFang TC"/>
+                        </a:rPr>
+                        <a:t>syn-nodejs-puppeteer 每 5 分探測 CloudFront /health → 失敗即 alarm</a:t>
+                      </a:r>
+                    </a:p>
+                  </a:txBody>
+                  <a:tcPr marT="25400" marB="25400" marL="101600" anchor="ctr">
+                    <a:solidFill>
+                      <a:srgbClr val="FFFFFF"/>
+                    </a:solidFill>
+                  </a:tcPr>
+                </a:tc>
+              </a:tr>
+            </a:tbl>
+          </a:graphicData>
+        </a:graphic>
+      </p:graphicFrame>
+      <p:sp>
+        <p:nvSpPr>
+          <p:cNvPr id="10" name="TextBox 9"/>
           <p:cNvSpPr txBox="1"/>
           <p:nvPr/>
         </p:nvSpPr>
         <p:spPr>
           <a:xfrm>
-            <a:off x="548640" y="4023360"/>
-            <a:ext cx="11247120" cy="2194560"/>
+            <a:off x="548640" y="5852160"/>
+            <a:ext cx="11247120" cy="731520"/>
           </a:xfrm>
           <a:prstGeom prst="rect">
             <a:avLst/>
@@ -17683,52 +17500,18 @@
           <a:p>
             <a:pPr>
               <a:spcAft>
-                <a:spcPts val="900"/>
+                <a:spcPts val="400"/>
               </a:spcAft>
             </a:pPr>
             <a:r>
-              <a:rPr sz="1400" b="0">
+              <a:rPr sz="1200" b="0">
                 <a:solidFill>
                   <a:srgbClr val="0F172A"/>
                 </a:solidFill>
                 <a:latin typeface="PingFang TC"/>
                 <a:ea typeface="PingFang TC"/>
               </a:rPr>
-              <a:t>•  EC2 deploy-app.sh:從 SSM 撈設定 → ECR login → docker pull → docker run(換新容器)</a:t>
-            </a:r>
-          </a:p>
-          <a:p>
-            <a:pPr>
-              <a:spcAft>
-                <a:spcPts val="900"/>
-              </a:spcAft>
-            </a:pPr>
-            <a:r>
-              <a:rPr sz="1400" b="0">
-                <a:solidFill>
-                  <a:srgbClr val="0F172A"/>
-                </a:solidFill>
-                <a:latin typeface="PingFang TC"/>
-                <a:ea typeface="PingFang TC"/>
-              </a:rPr>
-              <a:t>•  全 env-gated:本機無這些環境變數 → 維持 SQLite + 記憶體 cache + 即時生圖,不受影響</a:t>
-            </a:r>
-          </a:p>
-          <a:p>
-            <a:pPr>
-              <a:spcAft>
-                <a:spcPts val="900"/>
-              </a:spcAft>
-            </a:pPr>
-            <a:r>
-              <a:rPr sz="1400" b="0">
-                <a:solidFill>
-                  <a:srgbClr val="0F172A"/>
-                </a:solidFill>
-                <a:latin typeface="PingFang TC"/>
-                <a:ea typeface="PingFang TC"/>
-              </a:rPr>
-              <a:t>•  部署踩到的兩個坑:① EC2 role 少 s3:PutObject(500)② CI build amd64 但 EC2 arm64(502)→ buildx 跨平台修正</a:t>
+              <a:t>•  解決『服務掛了沒人知道』;canary 是端到端外部探測(連 CloudFront/整鏈路掛掉都測得到)。純 infra,已 validate/plan 通過(未 apply)。</a:t>
             </a:r>
           </a:p>
         </p:txBody>
@@ -17760,13 +17543,13 @@
         <p:spPr>
           <a:xfrm>
             <a:off x="0" y="0"/>
-            <a:ext cx="12191695" cy="6858000"/>
+            <a:ext cx="164592" cy="6858000"/>
           </a:xfrm>
           <a:prstGeom prst="rect">
             <a:avLst/>
           </a:prstGeom>
           <a:solidFill>
-            <a:srgbClr val="0F172A"/>
+            <a:srgbClr val="2563EB"/>
           </a:solidFill>
           <a:ln>
             <a:noFill/>
@@ -17803,8 +17586,8 @@
         </p:nvSpPr>
         <p:spPr>
           <a:xfrm>
-            <a:off x="822960" y="1097280"/>
-            <a:ext cx="10515600" cy="1097280"/>
+            <a:off x="502920" y="320040"/>
+            <a:ext cx="10972800" cy="1005840"/>
           </a:xfrm>
           <a:prstGeom prst="rect">
             <a:avLst/>
@@ -17816,6 +17599,23 @@
             <a:spAutoFit/>
           </a:bodyPr>
           <a:lstStyle/>
+          <a:p>
+            <a:pPr algn="l">
+              <a:spcAft>
+                <a:spcPts val="200"/>
+              </a:spcAft>
+            </a:pPr>
+            <a:r>
+              <a:rPr sz="1300" b="1">
+                <a:solidFill>
+                  <a:srgbClr val="2563EB"/>
+                </a:solidFill>
+                <a:latin typeface="PingFang TC"/>
+                <a:ea typeface="PingFang TC"/>
+              </a:rPr>
+              <a:t>部署 · CI/CD</a:t>
+            </a:r>
+          </a:p>
           <a:p>
             <a:pPr algn="l">
               <a:spcAft>
@@ -17823,45 +17623,805 @@
               </a:spcAft>
             </a:pPr>
             <a:r>
-              <a:rPr sz="1600" b="1">
-                <a:solidFill>
-                  <a:srgbClr val="2563EB"/>
-                </a:solidFill>
-                <a:latin typeface="PingFang TC"/>
-                <a:ea typeface="PingFang TC"/>
-              </a:rPr>
-              <a:t>原型狀態</a:t>
-            </a:r>
-          </a:p>
-          <a:p>
-            <a:pPr algn="l">
-              <a:spcAft>
-                <a:spcPts val="400"/>
-              </a:spcAft>
-            </a:pPr>
-            <a:r>
               <a:rPr sz="3000" b="1">
                 <a:solidFill>
+                  <a:srgbClr val="0F172A"/>
+                </a:solidFill>
+                <a:latin typeface="PingFang TC"/>
+                <a:ea typeface="PingFang TC"/>
+              </a:rPr>
+              <a:t>CI/CD 流程（GitHub Actions + OIDC）</a:t>
+            </a:r>
+          </a:p>
+        </p:txBody>
+      </p:sp>
+      <p:sp>
+        <p:nvSpPr>
+          <p:cNvPr id="4" name="Rounded Rectangle 3"/>
+          <p:cNvSpPr/>
+          <p:nvPr/>
+        </p:nvSpPr>
+        <p:spPr>
+          <a:xfrm>
+            <a:off x="457200" y="2286000"/>
+            <a:ext cx="1481328" cy="1280160"/>
+          </a:xfrm>
+          <a:prstGeom prst="roundRect">
+            <a:avLst/>
+          </a:prstGeom>
+          <a:solidFill>
+            <a:srgbClr val="64748B"/>
+          </a:solidFill>
+          <a:ln>
+            <a:solidFill>
+              <a:srgbClr val="64748B"/>
+            </a:solidFill>
+          </a:ln>
+          <a:effectLst/>
+        </p:spPr>
+        <p:style>
+          <a:lnRef idx="1">
+            <a:schemeClr val="accent1"/>
+          </a:lnRef>
+          <a:fillRef idx="3">
+            <a:schemeClr val="accent1"/>
+          </a:fillRef>
+          <a:effectRef idx="2">
+            <a:schemeClr val="accent1"/>
+          </a:effectRef>
+          <a:fontRef idx="minor">
+            <a:schemeClr val="lt1"/>
+          </a:fontRef>
+        </p:style>
+        <p:txBody>
+          <a:bodyPr rtlCol="0" anchor="ctr" wrap="square" tIns="25400" bIns="25400"/>
+          <a:lstStyle/>
+          <a:p>
+            <a:pPr algn="ctr"/>
+            <a:r>
+              <a:rPr sz="1100" b="1">
+                <a:solidFill>
                   <a:srgbClr val="FFFFFF"/>
                 </a:solidFill>
                 <a:latin typeface="PingFang TC"/>
                 <a:ea typeface="PingFang TC"/>
               </a:rPr>
-              <a:t>可跑的 FastAPI 實作 + 管理頁前端</a:t>
-            </a:r>
-          </a:p>
-        </p:txBody>
-      </p:sp>
-      <p:sp>
-        <p:nvSpPr>
-          <p:cNvPr id="4" name="TextBox 3"/>
+              <a:t>git push</a:t>
+            </a:r>
+          </a:p>
+          <a:p>
+            <a:pPr algn="ctr"/>
+            <a:r>
+              <a:rPr sz="1100" b="0">
+                <a:solidFill>
+                  <a:srgbClr val="FFFFFF"/>
+                </a:solidFill>
+                <a:latin typeface="PingFang TC"/>
+                <a:ea typeface="PingFang TC"/>
+              </a:rPr>
+              <a:t>QR Code Generator/**</a:t>
+            </a:r>
+          </a:p>
+        </p:txBody>
+      </p:sp>
+      <p:cxnSp>
+        <p:nvCxnSpPr>
+          <p:cNvPr id="5" name="Connector 4"/>
+          <p:cNvCxnSpPr/>
+          <p:nvPr/>
+        </p:nvCxnSpPr>
+        <p:spPr>
+          <a:xfrm>
+            <a:off x="1938528" y="2926080"/>
+            <a:ext cx="118872" cy="0"/>
+          </a:xfrm>
+          <a:prstGeom prst="line">
+            <a:avLst/>
+          </a:prstGeom>
+          <a:ln w="22225">
+            <a:solidFill>
+              <a:srgbClr val="64748B"/>
+            </a:solidFill>
+            <a:tailEnd type="triangle" w="med" len="med"/>
+          </a:ln>
+        </p:spPr>
+        <p:style>
+          <a:lnRef idx="2">
+            <a:schemeClr val="accent1"/>
+          </a:lnRef>
+          <a:fillRef idx="0">
+            <a:schemeClr val="accent1"/>
+          </a:fillRef>
+          <a:effectRef idx="1">
+            <a:schemeClr val="accent1"/>
+          </a:effectRef>
+          <a:fontRef idx="minor">
+            <a:schemeClr val="tx1"/>
+          </a:fontRef>
+        </p:style>
+      </p:cxnSp>
+      <p:sp>
+        <p:nvSpPr>
+          <p:cNvPr id="6" name="Rounded Rectangle 5"/>
+          <p:cNvSpPr/>
+          <p:nvPr/>
+        </p:nvSpPr>
+        <p:spPr>
+          <a:xfrm>
+            <a:off x="2057400" y="2286000"/>
+            <a:ext cx="1481328" cy="1280160"/>
+          </a:xfrm>
+          <a:prstGeom prst="roundRect">
+            <a:avLst/>
+          </a:prstGeom>
+          <a:solidFill>
+            <a:srgbClr val="0EA5E9"/>
+          </a:solidFill>
+          <a:ln>
+            <a:solidFill>
+              <a:srgbClr val="0EA5E9"/>
+            </a:solidFill>
+          </a:ln>
+          <a:effectLst/>
+        </p:spPr>
+        <p:style>
+          <a:lnRef idx="1">
+            <a:schemeClr val="accent1"/>
+          </a:lnRef>
+          <a:fillRef idx="3">
+            <a:schemeClr val="accent1"/>
+          </a:fillRef>
+          <a:effectRef idx="2">
+            <a:schemeClr val="accent1"/>
+          </a:effectRef>
+          <a:fontRef idx="minor">
+            <a:schemeClr val="lt1"/>
+          </a:fontRef>
+        </p:style>
+        <p:txBody>
+          <a:bodyPr rtlCol="0" anchor="ctr" wrap="square" tIns="25400" bIns="25400"/>
+          <a:lstStyle/>
+          <a:p>
+            <a:pPr algn="ctr"/>
+            <a:r>
+              <a:rPr sz="1100" b="1">
+                <a:solidFill>
+                  <a:srgbClr val="FFFFFF"/>
+                </a:solidFill>
+                <a:latin typeface="PingFang TC"/>
+                <a:ea typeface="PingFang TC"/>
+              </a:rPr>
+              <a:t>GitHub Actions</a:t>
+            </a:r>
+          </a:p>
+          <a:p>
+            <a:pPr algn="ctr"/>
+            <a:r>
+              <a:rPr sz="1100" b="0">
+                <a:solidFill>
+                  <a:srgbClr val="FFFFFF"/>
+                </a:solidFill>
+                <a:latin typeface="PingFang TC"/>
+                <a:ea typeface="PingFang TC"/>
+              </a:rPr>
+              <a:t>OIDC assume role</a:t>
+            </a:r>
+          </a:p>
+          <a:p>
+            <a:pPr algn="ctr"/>
+            <a:r>
+              <a:rPr sz="1100" b="0">
+                <a:solidFill>
+                  <a:srgbClr val="FFFFFF"/>
+                </a:solidFill>
+                <a:latin typeface="PingFang TC"/>
+                <a:ea typeface="PingFang TC"/>
+              </a:rPr>
+              <a:t>(無長期金鑰)</a:t>
+            </a:r>
+          </a:p>
+        </p:txBody>
+      </p:sp>
+      <p:cxnSp>
+        <p:nvCxnSpPr>
+          <p:cNvPr id="7" name="Connector 6"/>
+          <p:cNvCxnSpPr/>
+          <p:nvPr/>
+        </p:nvCxnSpPr>
+        <p:spPr>
+          <a:xfrm>
+            <a:off x="3538728" y="2926080"/>
+            <a:ext cx="118872" cy="0"/>
+          </a:xfrm>
+          <a:prstGeom prst="line">
+            <a:avLst/>
+          </a:prstGeom>
+          <a:ln w="22225">
+            <a:solidFill>
+              <a:srgbClr val="64748B"/>
+            </a:solidFill>
+            <a:tailEnd type="triangle" w="med" len="med"/>
+          </a:ln>
+        </p:spPr>
+        <p:style>
+          <a:lnRef idx="2">
+            <a:schemeClr val="accent1"/>
+          </a:lnRef>
+          <a:fillRef idx="0">
+            <a:schemeClr val="accent1"/>
+          </a:fillRef>
+          <a:effectRef idx="1">
+            <a:schemeClr val="accent1"/>
+          </a:effectRef>
+          <a:fontRef idx="minor">
+            <a:schemeClr val="tx1"/>
+          </a:fontRef>
+        </p:style>
+      </p:cxnSp>
+      <p:sp>
+        <p:nvSpPr>
+          <p:cNvPr id="8" name="Rounded Rectangle 7"/>
+          <p:cNvSpPr/>
+          <p:nvPr/>
+        </p:nvSpPr>
+        <p:spPr>
+          <a:xfrm>
+            <a:off x="3657600" y="2286000"/>
+            <a:ext cx="1481328" cy="1280160"/>
+          </a:xfrm>
+          <a:prstGeom prst="roundRect">
+            <a:avLst/>
+          </a:prstGeom>
+          <a:solidFill>
+            <a:srgbClr val="2563EB"/>
+          </a:solidFill>
+          <a:ln>
+            <a:solidFill>
+              <a:srgbClr val="2563EB"/>
+            </a:solidFill>
+          </a:ln>
+          <a:effectLst/>
+        </p:spPr>
+        <p:style>
+          <a:lnRef idx="1">
+            <a:schemeClr val="accent1"/>
+          </a:lnRef>
+          <a:fillRef idx="3">
+            <a:schemeClr val="accent1"/>
+          </a:fillRef>
+          <a:effectRef idx="2">
+            <a:schemeClr val="accent1"/>
+          </a:effectRef>
+          <a:fontRef idx="minor">
+            <a:schemeClr val="lt1"/>
+          </a:fontRef>
+        </p:style>
+        <p:txBody>
+          <a:bodyPr rtlCol="0" anchor="ctr" wrap="square" tIns="25400" bIns="25400"/>
+          <a:lstStyle/>
+          <a:p>
+            <a:pPr algn="ctr"/>
+            <a:r>
+              <a:rPr sz="1100" b="1">
+                <a:solidFill>
+                  <a:srgbClr val="FFFFFF"/>
+                </a:solidFill>
+                <a:latin typeface="PingFang TC"/>
+                <a:ea typeface="PingFang TC"/>
+              </a:rPr>
+              <a:t>buildx</a:t>
+            </a:r>
+          </a:p>
+          <a:p>
+            <a:pPr algn="ctr"/>
+            <a:r>
+              <a:rPr sz="1100" b="0">
+                <a:solidFill>
+                  <a:srgbClr val="FFFFFF"/>
+                </a:solidFill>
+                <a:latin typeface="PingFang TC"/>
+                <a:ea typeface="PingFang TC"/>
+              </a:rPr>
+              <a:t>--platform</a:t>
+            </a:r>
+          </a:p>
+          <a:p>
+            <a:pPr algn="ctr"/>
+            <a:r>
+              <a:rPr sz="1100" b="0">
+                <a:solidFill>
+                  <a:srgbClr val="FFFFFF"/>
+                </a:solidFill>
+                <a:latin typeface="PingFang TC"/>
+                <a:ea typeface="PingFang TC"/>
+              </a:rPr>
+              <a:t>linux/arm64</a:t>
+            </a:r>
+          </a:p>
+        </p:txBody>
+      </p:sp>
+      <p:cxnSp>
+        <p:nvCxnSpPr>
+          <p:cNvPr id="9" name="Connector 8"/>
+          <p:cNvCxnSpPr/>
+          <p:nvPr/>
+        </p:nvCxnSpPr>
+        <p:spPr>
+          <a:xfrm>
+            <a:off x="5138928" y="2926080"/>
+            <a:ext cx="118872" cy="0"/>
+          </a:xfrm>
+          <a:prstGeom prst="line">
+            <a:avLst/>
+          </a:prstGeom>
+          <a:ln w="22225">
+            <a:solidFill>
+              <a:srgbClr val="64748B"/>
+            </a:solidFill>
+            <a:tailEnd type="triangle" w="med" len="med"/>
+          </a:ln>
+        </p:spPr>
+        <p:style>
+          <a:lnRef idx="2">
+            <a:schemeClr val="accent1"/>
+          </a:lnRef>
+          <a:fillRef idx="0">
+            <a:schemeClr val="accent1"/>
+          </a:fillRef>
+          <a:effectRef idx="1">
+            <a:schemeClr val="accent1"/>
+          </a:effectRef>
+          <a:fontRef idx="minor">
+            <a:schemeClr val="tx1"/>
+          </a:fontRef>
+        </p:style>
+      </p:cxnSp>
+      <p:sp>
+        <p:nvSpPr>
+          <p:cNvPr id="10" name="Rounded Rectangle 9"/>
+          <p:cNvSpPr/>
+          <p:nvPr/>
+        </p:nvSpPr>
+        <p:spPr>
+          <a:xfrm>
+            <a:off x="5257800" y="2286000"/>
+            <a:ext cx="1481328" cy="1280160"/>
+          </a:xfrm>
+          <a:prstGeom prst="roundRect">
+            <a:avLst/>
+          </a:prstGeom>
+          <a:solidFill>
+            <a:srgbClr val="059669"/>
+          </a:solidFill>
+          <a:ln>
+            <a:solidFill>
+              <a:srgbClr val="059669"/>
+            </a:solidFill>
+          </a:ln>
+          <a:effectLst/>
+        </p:spPr>
+        <p:style>
+          <a:lnRef idx="1">
+            <a:schemeClr val="accent1"/>
+          </a:lnRef>
+          <a:fillRef idx="3">
+            <a:schemeClr val="accent1"/>
+          </a:fillRef>
+          <a:effectRef idx="2">
+            <a:schemeClr val="accent1"/>
+          </a:effectRef>
+          <a:fontRef idx="minor">
+            <a:schemeClr val="lt1"/>
+          </a:fontRef>
+        </p:style>
+        <p:txBody>
+          <a:bodyPr rtlCol="0" anchor="ctr" wrap="square" tIns="25400" bIns="25400"/>
+          <a:lstStyle/>
+          <a:p>
+            <a:pPr algn="ctr"/>
+            <a:r>
+              <a:rPr sz="1100" b="1">
+                <a:solidFill>
+                  <a:srgbClr val="FFFFFF"/>
+                </a:solidFill>
+                <a:latin typeface="PingFang TC"/>
+                <a:ea typeface="PingFang TC"/>
+              </a:rPr>
+              <a:t>ECR push</a:t>
+            </a:r>
+          </a:p>
+          <a:p>
+            <a:pPr algn="ctr"/>
+            <a:r>
+              <a:rPr sz="1100" b="0">
+                <a:solidFill>
+                  <a:srgbClr val="FFFFFF"/>
+                </a:solidFill>
+                <a:latin typeface="PingFang TC"/>
+                <a:ea typeface="PingFang TC"/>
+              </a:rPr>
+              <a:t>tag = SHA</a:t>
+            </a:r>
+          </a:p>
+          <a:p>
+            <a:pPr algn="ctr"/>
+            <a:r>
+              <a:rPr sz="1100" b="0">
+                <a:solidFill>
+                  <a:srgbClr val="FFFFFF"/>
+                </a:solidFill>
+                <a:latin typeface="PingFang TC"/>
+                <a:ea typeface="PingFang TC"/>
+              </a:rPr>
+              <a:t>+ latest</a:t>
+            </a:r>
+          </a:p>
+        </p:txBody>
+      </p:sp>
+      <p:cxnSp>
+        <p:nvCxnSpPr>
+          <p:cNvPr id="11" name="Connector 10"/>
+          <p:cNvCxnSpPr/>
+          <p:nvPr/>
+        </p:nvCxnSpPr>
+        <p:spPr>
+          <a:xfrm>
+            <a:off x="6739128" y="2926080"/>
+            <a:ext cx="118872" cy="0"/>
+          </a:xfrm>
+          <a:prstGeom prst="line">
+            <a:avLst/>
+          </a:prstGeom>
+          <a:ln w="22225">
+            <a:solidFill>
+              <a:srgbClr val="64748B"/>
+            </a:solidFill>
+            <a:tailEnd type="triangle" w="med" len="med"/>
+          </a:ln>
+        </p:spPr>
+        <p:style>
+          <a:lnRef idx="2">
+            <a:schemeClr val="accent1"/>
+          </a:lnRef>
+          <a:fillRef idx="0">
+            <a:schemeClr val="accent1"/>
+          </a:fillRef>
+          <a:effectRef idx="1">
+            <a:schemeClr val="accent1"/>
+          </a:effectRef>
+          <a:fontRef idx="minor">
+            <a:schemeClr val="tx1"/>
+          </a:fontRef>
+        </p:style>
+      </p:cxnSp>
+      <p:sp>
+        <p:nvSpPr>
+          <p:cNvPr id="12" name="Rounded Rectangle 11"/>
+          <p:cNvSpPr/>
+          <p:nvPr/>
+        </p:nvSpPr>
+        <p:spPr>
+          <a:xfrm>
+            <a:off x="6858000" y="2286000"/>
+            <a:ext cx="1481328" cy="1280160"/>
+          </a:xfrm>
+          <a:prstGeom prst="roundRect">
+            <a:avLst/>
+          </a:prstGeom>
+          <a:solidFill>
+            <a:srgbClr val="7C3AED"/>
+          </a:solidFill>
+          <a:ln>
+            <a:solidFill>
+              <a:srgbClr val="7C3AED"/>
+            </a:solidFill>
+          </a:ln>
+          <a:effectLst/>
+        </p:spPr>
+        <p:style>
+          <a:lnRef idx="1">
+            <a:schemeClr val="accent1"/>
+          </a:lnRef>
+          <a:fillRef idx="3">
+            <a:schemeClr val="accent1"/>
+          </a:fillRef>
+          <a:effectRef idx="2">
+            <a:schemeClr val="accent1"/>
+          </a:effectRef>
+          <a:fontRef idx="minor">
+            <a:schemeClr val="lt1"/>
+          </a:fontRef>
+        </p:style>
+        <p:txBody>
+          <a:bodyPr rtlCol="0" anchor="ctr" wrap="square" tIns="25400" bIns="25400"/>
+          <a:lstStyle/>
+          <a:p>
+            <a:pPr algn="ctr"/>
+            <a:r>
+              <a:rPr sz="1100" b="1">
+                <a:solidFill>
+                  <a:srgbClr val="FFFFFF"/>
+                </a:solidFill>
+                <a:latin typeface="PingFang TC"/>
+                <a:ea typeface="PingFang TC"/>
+              </a:rPr>
+              <a:t>SSM 更新</a:t>
+            </a:r>
+          </a:p>
+          <a:p>
+            <a:pPr algn="ctr"/>
+            <a:r>
+              <a:rPr sz="1100" b="0">
+                <a:solidFill>
+                  <a:srgbClr val="FFFFFF"/>
+                </a:solidFill>
+                <a:latin typeface="PingFang TC"/>
+                <a:ea typeface="PingFang TC"/>
+              </a:rPr>
+              <a:t>/qrcode/</a:t>
+            </a:r>
+          </a:p>
+          <a:p>
+            <a:pPr algn="ctr"/>
+            <a:r>
+              <a:rPr sz="1100" b="0">
+                <a:solidFill>
+                  <a:srgbClr val="FFFFFF"/>
+                </a:solidFill>
+                <a:latin typeface="PingFang TC"/>
+                <a:ea typeface="PingFang TC"/>
+              </a:rPr>
+              <a:t>IMAGE_URI</a:t>
+            </a:r>
+          </a:p>
+        </p:txBody>
+      </p:sp>
+      <p:cxnSp>
+        <p:nvCxnSpPr>
+          <p:cNvPr id="13" name="Connector 12"/>
+          <p:cNvCxnSpPr/>
+          <p:nvPr/>
+        </p:nvCxnSpPr>
+        <p:spPr>
+          <a:xfrm>
+            <a:off x="8339328" y="2926080"/>
+            <a:ext cx="118872" cy="0"/>
+          </a:xfrm>
+          <a:prstGeom prst="line">
+            <a:avLst/>
+          </a:prstGeom>
+          <a:ln w="22225">
+            <a:solidFill>
+              <a:srgbClr val="64748B"/>
+            </a:solidFill>
+            <a:tailEnd type="triangle" w="med" len="med"/>
+          </a:ln>
+        </p:spPr>
+        <p:style>
+          <a:lnRef idx="2">
+            <a:schemeClr val="accent1"/>
+          </a:lnRef>
+          <a:fillRef idx="0">
+            <a:schemeClr val="accent1"/>
+          </a:fillRef>
+          <a:effectRef idx="1">
+            <a:schemeClr val="accent1"/>
+          </a:effectRef>
+          <a:fontRef idx="minor">
+            <a:schemeClr val="tx1"/>
+          </a:fontRef>
+        </p:style>
+      </p:cxnSp>
+      <p:sp>
+        <p:nvSpPr>
+          <p:cNvPr id="14" name="Rounded Rectangle 13"/>
+          <p:cNvSpPr/>
+          <p:nvPr/>
+        </p:nvSpPr>
+        <p:spPr>
+          <a:xfrm>
+            <a:off x="8458200" y="2286000"/>
+            <a:ext cx="1481328" cy="1280160"/>
+          </a:xfrm>
+          <a:prstGeom prst="roundRect">
+            <a:avLst/>
+          </a:prstGeom>
+          <a:solidFill>
+            <a:srgbClr val="D97706"/>
+          </a:solidFill>
+          <a:ln>
+            <a:solidFill>
+              <a:srgbClr val="D97706"/>
+            </a:solidFill>
+          </a:ln>
+          <a:effectLst/>
+        </p:spPr>
+        <p:style>
+          <a:lnRef idx="1">
+            <a:schemeClr val="accent1"/>
+          </a:lnRef>
+          <a:fillRef idx="3">
+            <a:schemeClr val="accent1"/>
+          </a:fillRef>
+          <a:effectRef idx="2">
+            <a:schemeClr val="accent1"/>
+          </a:effectRef>
+          <a:fontRef idx="minor">
+            <a:schemeClr val="lt1"/>
+          </a:fontRef>
+        </p:style>
+        <p:txBody>
+          <a:bodyPr rtlCol="0" anchor="ctr" wrap="square" tIns="25400" bIns="25400"/>
+          <a:lstStyle/>
+          <a:p>
+            <a:pPr algn="ctr"/>
+            <a:r>
+              <a:rPr sz="1100" b="1">
+                <a:solidFill>
+                  <a:srgbClr val="FFFFFF"/>
+                </a:solidFill>
+                <a:latin typeface="PingFang TC"/>
+                <a:ea typeface="PingFang TC"/>
+              </a:rPr>
+              <a:t>SSM 部署</a:t>
+            </a:r>
+          </a:p>
+          <a:p>
+            <a:pPr algn="ctr"/>
+            <a:r>
+              <a:rPr sz="1100" b="0">
+                <a:solidFill>
+                  <a:srgbClr val="FFFFFF"/>
+                </a:solidFill>
+                <a:latin typeface="PingFang TC"/>
+                <a:ea typeface="PingFang TC"/>
+              </a:rPr>
+              <a:t>→ EC2</a:t>
+            </a:r>
+          </a:p>
+          <a:p>
+            <a:pPr algn="ctr"/>
+            <a:r>
+              <a:rPr sz="1100" b="0">
+                <a:solidFill>
+                  <a:srgbClr val="FFFFFF"/>
+                </a:solidFill>
+                <a:latin typeface="PingFang TC"/>
+                <a:ea typeface="PingFang TC"/>
+              </a:rPr>
+              <a:t>deploy-app.sh</a:t>
+            </a:r>
+          </a:p>
+        </p:txBody>
+      </p:sp>
+      <p:cxnSp>
+        <p:nvCxnSpPr>
+          <p:cNvPr id="15" name="Connector 14"/>
+          <p:cNvCxnSpPr/>
+          <p:nvPr/>
+        </p:nvCxnSpPr>
+        <p:spPr>
+          <a:xfrm>
+            <a:off x="9939528" y="2926080"/>
+            <a:ext cx="118872" cy="0"/>
+          </a:xfrm>
+          <a:prstGeom prst="line">
+            <a:avLst/>
+          </a:prstGeom>
+          <a:ln w="22225">
+            <a:solidFill>
+              <a:srgbClr val="64748B"/>
+            </a:solidFill>
+            <a:tailEnd type="triangle" w="med" len="med"/>
+          </a:ln>
+        </p:spPr>
+        <p:style>
+          <a:lnRef idx="2">
+            <a:schemeClr val="accent1"/>
+          </a:lnRef>
+          <a:fillRef idx="0">
+            <a:schemeClr val="accent1"/>
+          </a:fillRef>
+          <a:effectRef idx="1">
+            <a:schemeClr val="accent1"/>
+          </a:effectRef>
+          <a:fontRef idx="minor">
+            <a:schemeClr val="tx1"/>
+          </a:fontRef>
+        </p:style>
+      </p:cxnSp>
+      <p:sp>
+        <p:nvSpPr>
+          <p:cNvPr id="16" name="Rounded Rectangle 15"/>
+          <p:cNvSpPr/>
+          <p:nvPr/>
+        </p:nvSpPr>
+        <p:spPr>
+          <a:xfrm>
+            <a:off x="10058400" y="2286000"/>
+            <a:ext cx="1481328" cy="1280160"/>
+          </a:xfrm>
+          <a:prstGeom prst="roundRect">
+            <a:avLst/>
+          </a:prstGeom>
+          <a:solidFill>
+            <a:srgbClr val="059669"/>
+          </a:solidFill>
+          <a:ln>
+            <a:solidFill>
+              <a:srgbClr val="059669"/>
+            </a:solidFill>
+          </a:ln>
+          <a:effectLst/>
+        </p:spPr>
+        <p:style>
+          <a:lnRef idx="1">
+            <a:schemeClr val="accent1"/>
+          </a:lnRef>
+          <a:fillRef idx="3">
+            <a:schemeClr val="accent1"/>
+          </a:fillRef>
+          <a:effectRef idx="2">
+            <a:schemeClr val="accent1"/>
+          </a:effectRef>
+          <a:fontRef idx="minor">
+            <a:schemeClr val="lt1"/>
+          </a:fontRef>
+        </p:style>
+        <p:txBody>
+          <a:bodyPr rtlCol="0" anchor="ctr" wrap="square" tIns="25400" bIns="25400"/>
+          <a:lstStyle/>
+          <a:p>
+            <a:pPr algn="ctr"/>
+            <a:r>
+              <a:rPr sz="1100" b="1">
+                <a:solidFill>
+                  <a:srgbClr val="FFFFFF"/>
+                </a:solidFill>
+                <a:latin typeface="PingFang TC"/>
+                <a:ea typeface="PingFang TC"/>
+              </a:rPr>
+              <a:t>上線</a:t>
+            </a:r>
+          </a:p>
+          <a:p>
+            <a:pPr algn="ctr"/>
+            <a:r>
+              <a:rPr sz="1100" b="0">
+                <a:solidFill>
+                  <a:srgbClr val="FFFFFF"/>
+                </a:solidFill>
+                <a:latin typeface="PingFang TC"/>
+                <a:ea typeface="PingFang TC"/>
+              </a:rPr>
+              <a:t>ALB /health</a:t>
+            </a:r>
+          </a:p>
+          <a:p>
+            <a:pPr algn="ctr"/>
+            <a:r>
+              <a:rPr sz="1100" b="0">
+                <a:solidFill>
+                  <a:srgbClr val="FFFFFF"/>
+                </a:solidFill>
+                <a:latin typeface="PingFang TC"/>
+                <a:ea typeface="PingFang TC"/>
+              </a:rPr>
+              <a:t>通過</a:t>
+            </a:r>
+          </a:p>
+        </p:txBody>
+      </p:sp>
+      <p:sp>
+        <p:nvSpPr>
+          <p:cNvPr id="17" name="TextBox 16"/>
           <p:cNvSpPr txBox="1"/>
           <p:nvPr/>
         </p:nvSpPr>
         <p:spPr>
           <a:xfrm>
-            <a:off x="822960" y="2743200"/>
-            <a:ext cx="10515600" cy="2743200"/>
+            <a:off x="548640" y="4023360"/>
+            <a:ext cx="11247120" cy="2194560"/>
           </a:xfrm>
           <a:prstGeom prst="rect">
             <a:avLst/>
@@ -17876,69 +18436,52 @@
           <a:p>
             <a:pPr>
               <a:spcAft>
-                <a:spcPts val="1200"/>
+                <a:spcPts val="900"/>
               </a:spcAft>
             </a:pPr>
             <a:r>
-              <a:rPr sz="1600" b="0">
-                <a:solidFill>
-                  <a:srgbClr val="E2E8F0"/>
-                </a:solidFill>
-                <a:latin typeface="PingFang TC"/>
-                <a:ea typeface="PingFang TC"/>
-              </a:rPr>
-              <a:t>✓  7 個 API 端點 + 管理頁前端（建立/清單/編輯/刪除/分析）</a:t>
+              <a:rPr sz="1400" b="0">
+                <a:solidFill>
+                  <a:srgbClr val="0F172A"/>
+                </a:solidFill>
+                <a:latin typeface="PingFang TC"/>
+                <a:ea typeface="PingFang TC"/>
+              </a:rPr>
+              <a:t>•  EC2 deploy-app.sh:從 SSM 撈設定 → ECR login → docker pull → docker run(換新容器)</a:t>
             </a:r>
           </a:p>
           <a:p>
             <a:pPr>
               <a:spcAft>
-                <a:spcPts val="1200"/>
+                <a:spcPts val="900"/>
               </a:spcAft>
             </a:pPr>
             <a:r>
-              <a:rPr sz="1600" b="0">
-                <a:solidFill>
-                  <a:srgbClr val="E2E8F0"/>
-                </a:solidFill>
-                <a:latin typeface="PingFang TC"/>
-                <a:ea typeface="PingFang TC"/>
-              </a:rPr>
-              <a:t>✓  全部 curl 驗證通過：302 / 404 / 410 / 8 碼 token / 正規化 / SSRF / 過期</a:t>
+              <a:rPr sz="1400" b="0">
+                <a:solidFill>
+                  <a:srgbClr val="0F172A"/>
+                </a:solidFill>
+                <a:latin typeface="PingFang TC"/>
+                <a:ea typeface="PingFang TC"/>
+              </a:rPr>
+              <a:t>•  全 env-gated:本機無這些環境變數 → 維持 SQLite + 記憶體 cache + 即時生圖,不受影響</a:t>
             </a:r>
           </a:p>
           <a:p>
             <a:pPr>
               <a:spcAft>
-                <a:spcPts val="1200"/>
+                <a:spcPts val="900"/>
               </a:spcAft>
             </a:pPr>
             <a:r>
-              <a:rPr sz="1600" b="0">
-                <a:solidFill>
-                  <a:srgbClr val="E2E8F0"/>
-                </a:solidFill>
-                <a:latin typeface="PingFang TC"/>
-                <a:ea typeface="PingFang TC"/>
-              </a:rPr>
-              <a:t>✓  production 替換點已在程式註解標明（Redis / 佇列 / CDN / 預聚合 / PostgreSQL）</a:t>
-            </a:r>
-          </a:p>
-          <a:p>
-            <a:pPr>
-              <a:spcAft>
-                <a:spcPts val="1200"/>
-              </a:spcAft>
-            </a:pPr>
-            <a:r>
-              <a:rPr sz="1600" b="0">
-                <a:solidFill>
-                  <a:srgbClr val="E2E8F0"/>
-                </a:solidFill>
-                <a:latin typeface="PingFang TC"/>
-                <a:ea typeface="PingFang TC"/>
-              </a:rPr>
-              <a:t>✓  設計依據：DESIGN.md（16 題決策 + 優劣分析）</a:t>
+              <a:rPr sz="1400" b="0">
+                <a:solidFill>
+                  <a:srgbClr val="0F172A"/>
+                </a:solidFill>
+                <a:latin typeface="PingFang TC"/>
+                <a:ea typeface="PingFang TC"/>
+              </a:rPr>
+              <a:t>•  部署踩到的兩個坑:① EC2 role 少 s3:PutObject(500)② CI build amd64 但 EC2 arm64(502)→ buildx 跨平台修正</a:t>
             </a:r>
           </a:p>
         </p:txBody>
@@ -17970,13 +18513,13 @@
         <p:spPr>
           <a:xfrm>
             <a:off x="0" y="0"/>
-            <a:ext cx="164592" cy="6858000"/>
+            <a:ext cx="12191695" cy="6858000"/>
           </a:xfrm>
           <a:prstGeom prst="rect">
             <a:avLst/>
           </a:prstGeom>
           <a:solidFill>
-            <a:srgbClr val="2563EB"/>
+            <a:srgbClr val="0F172A"/>
           </a:solidFill>
           <a:ln>
             <a:noFill/>
@@ -18013,8 +18556,8 @@
         </p:nvSpPr>
         <p:spPr>
           <a:xfrm>
-            <a:off x="502920" y="320040"/>
-            <a:ext cx="10972800" cy="1005840"/>
+            <a:off x="822960" y="1097280"/>
+            <a:ext cx="10515600" cy="1097280"/>
           </a:xfrm>
           <a:prstGeom prst="rect">
             <a:avLst/>
@@ -18026,23 +18569,6 @@
             <a:spAutoFit/>
           </a:bodyPr>
           <a:lstStyle/>
-          <a:p>
-            <a:pPr algn="l">
-              <a:spcAft>
-                <a:spcPts val="200"/>
-              </a:spcAft>
-            </a:pPr>
-            <a:r>
-              <a:rPr sz="1300" b="1">
-                <a:solidFill>
-                  <a:srgbClr val="2563EB"/>
-                </a:solidFill>
-                <a:latin typeface="PingFang TC"/>
-                <a:ea typeface="PingFang TC"/>
-              </a:rPr>
-              <a:t>下週預告 · NEXT WEEK</a:t>
-            </a:r>
-          </a:p>
           <a:p>
             <a:pPr algn="l">
               <a:spcAft>
@@ -18050,39 +18576,16 @@
               </a:spcAft>
             </a:pPr>
             <a:r>
-              <a:rPr sz="3000" b="1">
-                <a:solidFill>
-                  <a:srgbClr val="0F172A"/>
-                </a:solidFill>
-                <a:latin typeface="PingFang TC"/>
-                <a:ea typeface="PingFang TC"/>
-              </a:rPr>
-              <a:t>從 Prototype 到 Production 的巨大鴻溝</a:t>
-            </a:r>
-          </a:p>
-        </p:txBody>
-      </p:sp>
-      <p:sp>
-        <p:nvSpPr>
-          <p:cNvPr id="4" name="TextBox 3"/>
-          <p:cNvSpPr txBox="1"/>
-          <p:nvPr/>
-        </p:nvSpPr>
-        <p:spPr>
-          <a:xfrm>
-            <a:off x="548640" y="1371600"/>
-            <a:ext cx="10972800" cy="365760"/>
-          </a:xfrm>
-          <a:prstGeom prst="rect">
-            <a:avLst/>
-          </a:prstGeom>
-          <a:noFill/>
-        </p:spPr>
-        <p:txBody>
-          <a:bodyPr wrap="square" anchor="t">
-            <a:spAutoFit/>
-          </a:bodyPr>
-          <a:lstStyle/>
+              <a:rPr sz="1600" b="1">
+                <a:solidFill>
+                  <a:srgbClr val="2563EB"/>
+                </a:solidFill>
+                <a:latin typeface="PingFang TC"/>
+                <a:ea typeface="PingFang TC"/>
+              </a:rPr>
+              <a:t>原型狀態</a:t>
+            </a:r>
+          </a:p>
           <a:p>
             <a:pPr algn="l">
               <a:spcAft>
@@ -18090,897 +18593,105 @@
               </a:spcAft>
             </a:pPr>
             <a:r>
-              <a:rPr sz="1400" b="0">
-                <a:solidFill>
-                  <a:srgbClr val="64748B"/>
-                </a:solidFill>
-                <a:latin typeface="PingFang TC"/>
-                <a:ea typeface="PingFang TC"/>
-              </a:rPr>
-              <a:t>快速掃過，建立全貌 — 下週 Deep Dive 才是主菜</a:t>
-            </a:r>
-          </a:p>
-        </p:txBody>
-      </p:sp>
-      <p:sp>
-        <p:nvSpPr>
-          <p:cNvPr id="5" name="Rounded Rectangle 4"/>
-          <p:cNvSpPr/>
-          <p:nvPr/>
-        </p:nvSpPr>
-        <p:spPr>
-          <a:xfrm>
-            <a:off x="548640" y="1965960"/>
-            <a:ext cx="3611880" cy="1600200"/>
-          </a:xfrm>
-          <a:prstGeom prst="roundRect">
-            <a:avLst/>
-          </a:prstGeom>
-          <a:solidFill>
-            <a:srgbClr val="F1F5F9"/>
-          </a:solidFill>
-          <a:ln>
-            <a:solidFill>
-              <a:srgbClr val="F1F5F9"/>
-            </a:solidFill>
-          </a:ln>
-          <a:effectLst/>
-        </p:spPr>
-        <p:style>
-          <a:lnRef idx="1">
-            <a:schemeClr val="accent1"/>
-          </a:lnRef>
-          <a:fillRef idx="3">
-            <a:schemeClr val="accent1"/>
-          </a:fillRef>
-          <a:effectRef idx="2">
-            <a:schemeClr val="accent1"/>
-          </a:effectRef>
-          <a:fontRef idx="minor">
-            <a:schemeClr val="lt1"/>
-          </a:fontRef>
-        </p:style>
-        <p:txBody>
-          <a:bodyPr rtlCol="0" anchor="ctr"/>
-          <a:lstStyle/>
-          <a:p>
-            <a:pPr algn="ctr"/>
-          </a:p>
-        </p:txBody>
-      </p:sp>
-      <p:sp>
-        <p:nvSpPr>
-          <p:cNvPr id="6" name="Rectangle 5"/>
-          <p:cNvSpPr/>
-          <p:nvPr/>
-        </p:nvSpPr>
-        <p:spPr>
-          <a:xfrm>
-            <a:off x="548640" y="1965960"/>
-            <a:ext cx="82296" cy="1600200"/>
+              <a:rPr sz="3000" b="1">
+                <a:solidFill>
+                  <a:srgbClr val="FFFFFF"/>
+                </a:solidFill>
+                <a:latin typeface="PingFang TC"/>
+                <a:ea typeface="PingFang TC"/>
+              </a:rPr>
+              <a:t>可跑的 FastAPI 實作 + 管理頁前端</a:t>
+            </a:r>
+          </a:p>
+        </p:txBody>
+      </p:sp>
+      <p:sp>
+        <p:nvSpPr>
+          <p:cNvPr id="4" name="TextBox 3"/>
+          <p:cNvSpPr txBox="1"/>
+          <p:nvPr/>
+        </p:nvSpPr>
+        <p:spPr>
+          <a:xfrm>
+            <a:off x="822960" y="2743200"/>
+            <a:ext cx="10515600" cy="2743200"/>
           </a:xfrm>
           <a:prstGeom prst="rect">
             <a:avLst/>
           </a:prstGeom>
-          <a:solidFill>
-            <a:srgbClr val="D97706"/>
-          </a:solidFill>
-          <a:ln>
-            <a:noFill/>
-          </a:ln>
-          <a:effectLst/>
-        </p:spPr>
-        <p:style>
-          <a:lnRef idx="1">
-            <a:schemeClr val="accent1"/>
-          </a:lnRef>
-          <a:fillRef idx="3">
-            <a:schemeClr val="accent1"/>
-          </a:fillRef>
-          <a:effectRef idx="2">
-            <a:schemeClr val="accent1"/>
-          </a:effectRef>
-          <a:fontRef idx="minor">
-            <a:schemeClr val="lt1"/>
-          </a:fontRef>
-        </p:style>
-        <p:txBody>
-          <a:bodyPr rtlCol="0" anchor="ctr"/>
-          <a:lstStyle/>
-          <a:p>
-            <a:pPr algn="ctr"/>
-          </a:p>
-        </p:txBody>
-      </p:sp>
-      <p:sp>
-        <p:nvSpPr>
-          <p:cNvPr id="7" name="TextBox 6"/>
-          <p:cNvSpPr txBox="1"/>
-          <p:nvPr/>
-        </p:nvSpPr>
-        <p:spPr>
-          <a:xfrm>
-            <a:off x="822960" y="2148840"/>
-            <a:ext cx="3154680" cy="1325880"/>
-          </a:xfrm>
-          <a:prstGeom prst="rect">
-            <a:avLst/>
-          </a:prstGeom>
           <a:noFill/>
         </p:spPr>
         <p:txBody>
-          <a:bodyPr wrap="square" anchor="t">
+          <a:bodyPr wrap="square">
             <a:spAutoFit/>
           </a:bodyPr>
           <a:lstStyle/>
           <a:p>
-            <a:pPr algn="l">
+            <a:pPr>
               <a:spcAft>
-                <a:spcPts val="800"/>
+                <a:spcPts val="1200"/>
               </a:spcAft>
             </a:pPr>
             <a:r>
-              <a:rPr sz="1600" b="1">
-                <a:solidFill>
-                  <a:srgbClr val="0F172A"/>
-                </a:solidFill>
-                <a:latin typeface="PingFang TC"/>
-                <a:ea typeface="PingFang TC"/>
-              </a:rPr>
-              <a:t>[Error Handling]</a:t>
-            </a:r>
-          </a:p>
-          <a:p>
-            <a:pPr algn="l">
+              <a:rPr sz="1600" b="0">
+                <a:solidFill>
+                  <a:srgbClr val="E2E8F0"/>
+                </a:solidFill>
+                <a:latin typeface="PingFang TC"/>
+                <a:ea typeface="PingFang TC"/>
+              </a:rPr>
+              <a:t>✓  7 個 API 端點 + 管理頁前端（建立/清單/編輯/刪除/分析）</a:t>
+            </a:r>
+          </a:p>
+          <a:p>
+            <a:pPr>
               <a:spcAft>
-                <a:spcPts val="400"/>
+                <a:spcPts val="1200"/>
               </a:spcAft>
             </a:pPr>
             <a:r>
-              <a:rPr sz="1300" b="0">
-                <a:solidFill>
-                  <a:srgbClr val="64748B"/>
-                </a:solidFill>
-                <a:latin typeface="PingFang TC"/>
-                <a:ea typeface="PingFang TC"/>
-              </a:rPr>
-              <a:t>遇到不合法輸入直接 Crash。</a:t>
-            </a:r>
-          </a:p>
-        </p:txBody>
-      </p:sp>
-      <p:sp>
-        <p:nvSpPr>
-          <p:cNvPr id="8" name="Rounded Rectangle 7"/>
-          <p:cNvSpPr/>
-          <p:nvPr/>
-        </p:nvSpPr>
-        <p:spPr>
-          <a:xfrm>
-            <a:off x="4407408" y="1965960"/>
-            <a:ext cx="3611880" cy="1600200"/>
-          </a:xfrm>
-          <a:prstGeom prst="roundRect">
-            <a:avLst/>
-          </a:prstGeom>
-          <a:solidFill>
-            <a:srgbClr val="F1F5F9"/>
-          </a:solidFill>
-          <a:ln>
-            <a:solidFill>
-              <a:srgbClr val="F1F5F9"/>
-            </a:solidFill>
-          </a:ln>
-          <a:effectLst/>
-        </p:spPr>
-        <p:style>
-          <a:lnRef idx="1">
-            <a:schemeClr val="accent1"/>
-          </a:lnRef>
-          <a:fillRef idx="3">
-            <a:schemeClr val="accent1"/>
-          </a:fillRef>
-          <a:effectRef idx="2">
-            <a:schemeClr val="accent1"/>
-          </a:effectRef>
-          <a:fontRef idx="minor">
-            <a:schemeClr val="lt1"/>
-          </a:fontRef>
-        </p:style>
-        <p:txBody>
-          <a:bodyPr rtlCol="0" anchor="ctr"/>
-          <a:lstStyle/>
-          <a:p>
-            <a:pPr algn="ctr"/>
-          </a:p>
-        </p:txBody>
-      </p:sp>
-      <p:sp>
-        <p:nvSpPr>
-          <p:cNvPr id="9" name="Rectangle 8"/>
-          <p:cNvSpPr/>
-          <p:nvPr/>
-        </p:nvSpPr>
-        <p:spPr>
-          <a:xfrm>
-            <a:off x="4407408" y="1965960"/>
-            <a:ext cx="82296" cy="1600200"/>
-          </a:xfrm>
-          <a:prstGeom prst="rect">
-            <a:avLst/>
-          </a:prstGeom>
-          <a:solidFill>
-            <a:srgbClr val="D97706"/>
-          </a:solidFill>
-          <a:ln>
-            <a:noFill/>
-          </a:ln>
-          <a:effectLst/>
-        </p:spPr>
-        <p:style>
-          <a:lnRef idx="1">
-            <a:schemeClr val="accent1"/>
-          </a:lnRef>
-          <a:fillRef idx="3">
-            <a:schemeClr val="accent1"/>
-          </a:fillRef>
-          <a:effectRef idx="2">
-            <a:schemeClr val="accent1"/>
-          </a:effectRef>
-          <a:fontRef idx="minor">
-            <a:schemeClr val="lt1"/>
-          </a:fontRef>
-        </p:style>
-        <p:txBody>
-          <a:bodyPr rtlCol="0" anchor="ctr"/>
-          <a:lstStyle/>
-          <a:p>
-            <a:pPr algn="ctr"/>
-          </a:p>
-        </p:txBody>
-      </p:sp>
-      <p:sp>
-        <p:nvSpPr>
-          <p:cNvPr id="10" name="TextBox 9"/>
-          <p:cNvSpPr txBox="1"/>
-          <p:nvPr/>
-        </p:nvSpPr>
-        <p:spPr>
-          <a:xfrm>
-            <a:off x="4681728" y="2148840"/>
-            <a:ext cx="3154680" cy="1325880"/>
-          </a:xfrm>
-          <a:prstGeom prst="rect">
-            <a:avLst/>
-          </a:prstGeom>
-          <a:noFill/>
-        </p:spPr>
-        <p:txBody>
-          <a:bodyPr wrap="square" anchor="t">
-            <a:spAutoFit/>
-          </a:bodyPr>
-          <a:lstStyle/>
-          <a:p>
-            <a:pPr algn="l">
+              <a:rPr sz="1600" b="0">
+                <a:solidFill>
+                  <a:srgbClr val="E2E8F0"/>
+                </a:solidFill>
+                <a:latin typeface="PingFang TC"/>
+                <a:ea typeface="PingFang TC"/>
+              </a:rPr>
+              <a:t>✓  全部 curl 驗證通過：302 / 404 / 410 / 8 碼 token / 正規化 / SSRF / 過期</a:t>
+            </a:r>
+          </a:p>
+          <a:p>
+            <a:pPr>
               <a:spcAft>
-                <a:spcPts val="800"/>
+                <a:spcPts val="1200"/>
               </a:spcAft>
             </a:pPr>
             <a:r>
-              <a:rPr sz="1600" b="1">
-                <a:solidFill>
-                  <a:srgbClr val="0F172A"/>
-                </a:solidFill>
-                <a:latin typeface="PingFang TC"/>
-                <a:ea typeface="PingFang TC"/>
-              </a:rPr>
-              <a:t>[Rate Limiting]</a:t>
-            </a:r>
-          </a:p>
-          <a:p>
-            <a:pPr algn="l">
+              <a:rPr sz="1600" b="0">
+                <a:solidFill>
+                  <a:srgbClr val="E2E8F0"/>
+                </a:solidFill>
+                <a:latin typeface="PingFang TC"/>
+                <a:ea typeface="PingFang TC"/>
+              </a:rPr>
+              <a:t>✓  production 替換點已在程式註解標明（Redis / 佇列 / CDN / 預聚合 / PostgreSQL）</a:t>
+            </a:r>
+          </a:p>
+          <a:p>
+            <a:pPr>
               <a:spcAft>
-                <a:spcPts val="400"/>
+                <a:spcPts val="1200"/>
               </a:spcAft>
             </a:pPr>
             <a:r>
-              <a:rPr sz="1300" b="0">
-                <a:solidFill>
-                  <a:srgbClr val="64748B"/>
-                </a:solidFill>
-                <a:latin typeface="PingFang TC"/>
-                <a:ea typeface="PingFang TC"/>
-              </a:rPr>
-              <a:t>毫無防護，極易被 Script 惡意灌爆 API。</a:t>
-            </a:r>
-          </a:p>
-        </p:txBody>
-      </p:sp>
-      <p:sp>
-        <p:nvSpPr>
-          <p:cNvPr id="11" name="Rounded Rectangle 10"/>
-          <p:cNvSpPr/>
-          <p:nvPr/>
-        </p:nvSpPr>
-        <p:spPr>
-          <a:xfrm>
-            <a:off x="8266176" y="1965960"/>
-            <a:ext cx="3611880" cy="1600200"/>
-          </a:xfrm>
-          <a:prstGeom prst="roundRect">
-            <a:avLst/>
-          </a:prstGeom>
-          <a:solidFill>
-            <a:srgbClr val="F1F5F9"/>
-          </a:solidFill>
-          <a:ln>
-            <a:solidFill>
-              <a:srgbClr val="F1F5F9"/>
-            </a:solidFill>
-          </a:ln>
-          <a:effectLst/>
-        </p:spPr>
-        <p:style>
-          <a:lnRef idx="1">
-            <a:schemeClr val="accent1"/>
-          </a:lnRef>
-          <a:fillRef idx="3">
-            <a:schemeClr val="accent1"/>
-          </a:fillRef>
-          <a:effectRef idx="2">
-            <a:schemeClr val="accent1"/>
-          </a:effectRef>
-          <a:fontRef idx="minor">
-            <a:schemeClr val="lt1"/>
-          </a:fontRef>
-        </p:style>
-        <p:txBody>
-          <a:bodyPr rtlCol="0" anchor="ctr"/>
-          <a:lstStyle/>
-          <a:p>
-            <a:pPr algn="ctr"/>
-          </a:p>
-        </p:txBody>
-      </p:sp>
-      <p:sp>
-        <p:nvSpPr>
-          <p:cNvPr id="12" name="Rectangle 11"/>
-          <p:cNvSpPr/>
-          <p:nvPr/>
-        </p:nvSpPr>
-        <p:spPr>
-          <a:xfrm>
-            <a:off x="8266176" y="1965960"/>
-            <a:ext cx="82296" cy="1600200"/>
-          </a:xfrm>
-          <a:prstGeom prst="rect">
-            <a:avLst/>
-          </a:prstGeom>
-          <a:solidFill>
-            <a:srgbClr val="D97706"/>
-          </a:solidFill>
-          <a:ln>
-            <a:noFill/>
-          </a:ln>
-          <a:effectLst/>
-        </p:spPr>
-        <p:style>
-          <a:lnRef idx="1">
-            <a:schemeClr val="accent1"/>
-          </a:lnRef>
-          <a:fillRef idx="3">
-            <a:schemeClr val="accent1"/>
-          </a:fillRef>
-          <a:effectRef idx="2">
-            <a:schemeClr val="accent1"/>
-          </a:effectRef>
-          <a:fontRef idx="minor">
-            <a:schemeClr val="lt1"/>
-          </a:fontRef>
-        </p:style>
-        <p:txBody>
-          <a:bodyPr rtlCol="0" anchor="ctr"/>
-          <a:lstStyle/>
-          <a:p>
-            <a:pPr algn="ctr"/>
-          </a:p>
-        </p:txBody>
-      </p:sp>
-      <p:sp>
-        <p:nvSpPr>
-          <p:cNvPr id="13" name="TextBox 12"/>
-          <p:cNvSpPr txBox="1"/>
-          <p:nvPr/>
-        </p:nvSpPr>
-        <p:spPr>
-          <a:xfrm>
-            <a:off x="8540496" y="2148840"/>
-            <a:ext cx="3154680" cy="1325880"/>
-          </a:xfrm>
-          <a:prstGeom prst="rect">
-            <a:avLst/>
-          </a:prstGeom>
-          <a:noFill/>
-        </p:spPr>
-        <p:txBody>
-          <a:bodyPr wrap="square" anchor="t">
-            <a:spAutoFit/>
-          </a:bodyPr>
-          <a:lstStyle/>
-          <a:p>
-            <a:pPr algn="l">
-              <a:spcAft>
-                <a:spcPts val="800"/>
-              </a:spcAft>
-            </a:pPr>
-            <a:r>
-              <a:rPr sz="1600" b="1">
-                <a:solidFill>
-                  <a:srgbClr val="0F172A"/>
-                </a:solidFill>
-                <a:latin typeface="PingFang TC"/>
-                <a:ea typeface="PingFang TC"/>
-              </a:rPr>
-              <a:t>[Auth &amp; Isolation]</a:t>
-            </a:r>
-          </a:p>
-          <a:p>
-            <a:pPr algn="l">
-              <a:spcAft>
-                <a:spcPts val="400"/>
-              </a:spcAft>
-            </a:pPr>
-            <a:r>
-              <a:rPr sz="1300" b="0">
-                <a:solidFill>
-                  <a:srgbClr val="64748B"/>
-                </a:solidFill>
-                <a:latin typeface="PingFang TC"/>
-                <a:ea typeface="PingFang TC"/>
-              </a:rPr>
-              <a:t>缺乏多租戶概念，資料全公開。</a:t>
-            </a:r>
-          </a:p>
-        </p:txBody>
-      </p:sp>
-      <p:sp>
-        <p:nvSpPr>
-          <p:cNvPr id="14" name="Rounded Rectangle 13"/>
-          <p:cNvSpPr/>
-          <p:nvPr/>
-        </p:nvSpPr>
-        <p:spPr>
-          <a:xfrm>
-            <a:off x="548640" y="3840480"/>
-            <a:ext cx="3611880" cy="1600200"/>
-          </a:xfrm>
-          <a:prstGeom prst="roundRect">
-            <a:avLst/>
-          </a:prstGeom>
-          <a:solidFill>
-            <a:srgbClr val="F1F5F9"/>
-          </a:solidFill>
-          <a:ln>
-            <a:solidFill>
-              <a:srgbClr val="F1F5F9"/>
-            </a:solidFill>
-          </a:ln>
-          <a:effectLst/>
-        </p:spPr>
-        <p:style>
-          <a:lnRef idx="1">
-            <a:schemeClr val="accent1"/>
-          </a:lnRef>
-          <a:fillRef idx="3">
-            <a:schemeClr val="accent1"/>
-          </a:fillRef>
-          <a:effectRef idx="2">
-            <a:schemeClr val="accent1"/>
-          </a:effectRef>
-          <a:fontRef idx="minor">
-            <a:schemeClr val="lt1"/>
-          </a:fontRef>
-        </p:style>
-        <p:txBody>
-          <a:bodyPr rtlCol="0" anchor="ctr"/>
-          <a:lstStyle/>
-          <a:p>
-            <a:pPr algn="ctr"/>
-          </a:p>
-        </p:txBody>
-      </p:sp>
-      <p:sp>
-        <p:nvSpPr>
-          <p:cNvPr id="15" name="Rectangle 14"/>
-          <p:cNvSpPr/>
-          <p:nvPr/>
-        </p:nvSpPr>
-        <p:spPr>
-          <a:xfrm>
-            <a:off x="548640" y="3840480"/>
-            <a:ext cx="82296" cy="1600200"/>
-          </a:xfrm>
-          <a:prstGeom prst="rect">
-            <a:avLst/>
-          </a:prstGeom>
-          <a:solidFill>
-            <a:srgbClr val="0EA5E9"/>
-          </a:solidFill>
-          <a:ln>
-            <a:noFill/>
-          </a:ln>
-          <a:effectLst/>
-        </p:spPr>
-        <p:style>
-          <a:lnRef idx="1">
-            <a:schemeClr val="accent1"/>
-          </a:lnRef>
-          <a:fillRef idx="3">
-            <a:schemeClr val="accent1"/>
-          </a:fillRef>
-          <a:effectRef idx="2">
-            <a:schemeClr val="accent1"/>
-          </a:effectRef>
-          <a:fontRef idx="minor">
-            <a:schemeClr val="lt1"/>
-          </a:fontRef>
-        </p:style>
-        <p:txBody>
-          <a:bodyPr rtlCol="0" anchor="ctr"/>
-          <a:lstStyle/>
-          <a:p>
-            <a:pPr algn="ctr"/>
-          </a:p>
-        </p:txBody>
-      </p:sp>
-      <p:sp>
-        <p:nvSpPr>
-          <p:cNvPr id="16" name="TextBox 15"/>
-          <p:cNvSpPr txBox="1"/>
-          <p:nvPr/>
-        </p:nvSpPr>
-        <p:spPr>
-          <a:xfrm>
-            <a:off x="822960" y="4023360"/>
-            <a:ext cx="3154680" cy="1325880"/>
-          </a:xfrm>
-          <a:prstGeom prst="rect">
-            <a:avLst/>
-          </a:prstGeom>
-          <a:noFill/>
-        </p:spPr>
-        <p:txBody>
-          <a:bodyPr wrap="square" anchor="t">
-            <a:spAutoFit/>
-          </a:bodyPr>
-          <a:lstStyle/>
-          <a:p>
-            <a:pPr algn="l">
-              <a:spcAft>
-                <a:spcPts val="800"/>
-              </a:spcAft>
-            </a:pPr>
-            <a:r>
-              <a:rPr sz="1600" b="1">
-                <a:solidFill>
-                  <a:srgbClr val="0F172A"/>
-                </a:solidFill>
-                <a:latin typeface="PingFang TC"/>
-                <a:ea typeface="PingFang TC"/>
-              </a:rPr>
-              <a:t>[Monitoring]</a:t>
-            </a:r>
-          </a:p>
-          <a:p>
-            <a:pPr algn="l">
-              <a:spcAft>
-                <a:spcPts val="400"/>
-              </a:spcAft>
-            </a:pPr>
-            <a:r>
-              <a:rPr sz="1300" b="0">
-                <a:solidFill>
-                  <a:srgbClr val="64748B"/>
-                </a:solidFill>
-                <a:latin typeface="PingFang TC"/>
-                <a:ea typeface="PingFang TC"/>
-              </a:rPr>
-              <a:t>服務掛了完全沒有 Alerting，處於盲飛狀態。</a:t>
-            </a:r>
-          </a:p>
-        </p:txBody>
-      </p:sp>
-      <p:sp>
-        <p:nvSpPr>
-          <p:cNvPr id="17" name="Rounded Rectangle 16"/>
-          <p:cNvSpPr/>
-          <p:nvPr/>
-        </p:nvSpPr>
-        <p:spPr>
-          <a:xfrm>
-            <a:off x="4407408" y="3840480"/>
-            <a:ext cx="3611880" cy="1600200"/>
-          </a:xfrm>
-          <a:prstGeom prst="roundRect">
-            <a:avLst/>
-          </a:prstGeom>
-          <a:solidFill>
-            <a:srgbClr val="F1F5F9"/>
-          </a:solidFill>
-          <a:ln>
-            <a:solidFill>
-              <a:srgbClr val="F1F5F9"/>
-            </a:solidFill>
-          </a:ln>
-          <a:effectLst/>
-        </p:spPr>
-        <p:style>
-          <a:lnRef idx="1">
-            <a:schemeClr val="accent1"/>
-          </a:lnRef>
-          <a:fillRef idx="3">
-            <a:schemeClr val="accent1"/>
-          </a:fillRef>
-          <a:effectRef idx="2">
-            <a:schemeClr val="accent1"/>
-          </a:effectRef>
-          <a:fontRef idx="minor">
-            <a:schemeClr val="lt1"/>
-          </a:fontRef>
-        </p:style>
-        <p:txBody>
-          <a:bodyPr rtlCol="0" anchor="ctr"/>
-          <a:lstStyle/>
-          <a:p>
-            <a:pPr algn="ctr"/>
-          </a:p>
-        </p:txBody>
-      </p:sp>
-      <p:sp>
-        <p:nvSpPr>
-          <p:cNvPr id="18" name="Rectangle 17"/>
-          <p:cNvSpPr/>
-          <p:nvPr/>
-        </p:nvSpPr>
-        <p:spPr>
-          <a:xfrm>
-            <a:off x="4407408" y="3840480"/>
-            <a:ext cx="82296" cy="1600200"/>
-          </a:xfrm>
-          <a:prstGeom prst="rect">
-            <a:avLst/>
-          </a:prstGeom>
-          <a:solidFill>
-            <a:srgbClr val="0EA5E9"/>
-          </a:solidFill>
-          <a:ln>
-            <a:noFill/>
-          </a:ln>
-          <a:effectLst/>
-        </p:spPr>
-        <p:style>
-          <a:lnRef idx="1">
-            <a:schemeClr val="accent1"/>
-          </a:lnRef>
-          <a:fillRef idx="3">
-            <a:schemeClr val="accent1"/>
-          </a:fillRef>
-          <a:effectRef idx="2">
-            <a:schemeClr val="accent1"/>
-          </a:effectRef>
-          <a:fontRef idx="minor">
-            <a:schemeClr val="lt1"/>
-          </a:fontRef>
-        </p:style>
-        <p:txBody>
-          <a:bodyPr rtlCol="0" anchor="ctr"/>
-          <a:lstStyle/>
-          <a:p>
-            <a:pPr algn="ctr"/>
-          </a:p>
-        </p:txBody>
-      </p:sp>
-      <p:sp>
-        <p:nvSpPr>
-          <p:cNvPr id="19" name="TextBox 18"/>
-          <p:cNvSpPr txBox="1"/>
-          <p:nvPr/>
-        </p:nvSpPr>
-        <p:spPr>
-          <a:xfrm>
-            <a:off x="4681728" y="4023360"/>
-            <a:ext cx="3154680" cy="1325880"/>
-          </a:xfrm>
-          <a:prstGeom prst="rect">
-            <a:avLst/>
-          </a:prstGeom>
-          <a:noFill/>
-        </p:spPr>
-        <p:txBody>
-          <a:bodyPr wrap="square" anchor="t">
-            <a:spAutoFit/>
-          </a:bodyPr>
-          <a:lstStyle/>
-          <a:p>
-            <a:pPr algn="l">
-              <a:spcAft>
-                <a:spcPts val="800"/>
-              </a:spcAft>
-            </a:pPr>
-            <a:r>
-              <a:rPr sz="1600" b="1">
-                <a:solidFill>
-                  <a:srgbClr val="0F172A"/>
-                </a:solidFill>
-                <a:latin typeface="PingFang TC"/>
-                <a:ea typeface="PingFang TC"/>
-              </a:rPr>
-              <a:t>[Data Cleanup]</a:t>
-            </a:r>
-          </a:p>
-          <a:p>
-            <a:pPr algn="l">
-              <a:spcAft>
-                <a:spcPts val="400"/>
-              </a:spcAft>
-            </a:pPr>
-            <a:r>
-              <a:rPr sz="1300" b="0">
-                <a:solidFill>
-                  <a:srgbClr val="64748B"/>
-                </a:solidFill>
-                <a:latin typeface="PingFang TC"/>
-                <a:ea typeface="PingFang TC"/>
-              </a:rPr>
-              <a:t>過期資料永不刪除，一年後 DB 將面臨嚴重 Bloat。</a:t>
-            </a:r>
-          </a:p>
-        </p:txBody>
-      </p:sp>
-      <p:sp>
-        <p:nvSpPr>
-          <p:cNvPr id="20" name="Rounded Rectangle 19"/>
-          <p:cNvSpPr/>
-          <p:nvPr/>
-        </p:nvSpPr>
-        <p:spPr>
-          <a:xfrm>
-            <a:off x="8266176" y="3840480"/>
-            <a:ext cx="3611880" cy="1600200"/>
-          </a:xfrm>
-          <a:prstGeom prst="roundRect">
-            <a:avLst/>
-          </a:prstGeom>
-          <a:solidFill>
-            <a:srgbClr val="F1F5F9"/>
-          </a:solidFill>
-          <a:ln>
-            <a:solidFill>
-              <a:srgbClr val="F1F5F9"/>
-            </a:solidFill>
-          </a:ln>
-          <a:effectLst/>
-        </p:spPr>
-        <p:style>
-          <a:lnRef idx="1">
-            <a:schemeClr val="accent1"/>
-          </a:lnRef>
-          <a:fillRef idx="3">
-            <a:schemeClr val="accent1"/>
-          </a:fillRef>
-          <a:effectRef idx="2">
-            <a:schemeClr val="accent1"/>
-          </a:effectRef>
-          <a:fontRef idx="minor">
-            <a:schemeClr val="lt1"/>
-          </a:fontRef>
-        </p:style>
-        <p:txBody>
-          <a:bodyPr rtlCol="0" anchor="ctr"/>
-          <a:lstStyle/>
-          <a:p>
-            <a:pPr algn="ctr"/>
-          </a:p>
-        </p:txBody>
-      </p:sp>
-      <p:sp>
-        <p:nvSpPr>
-          <p:cNvPr id="21" name="Rectangle 20"/>
-          <p:cNvSpPr/>
-          <p:nvPr/>
-        </p:nvSpPr>
-        <p:spPr>
-          <a:xfrm>
-            <a:off x="8266176" y="3840480"/>
-            <a:ext cx="82296" cy="1600200"/>
-          </a:xfrm>
-          <a:prstGeom prst="rect">
-            <a:avLst/>
-          </a:prstGeom>
-          <a:solidFill>
-            <a:srgbClr val="0EA5E9"/>
-          </a:solidFill>
-          <a:ln>
-            <a:noFill/>
-          </a:ln>
-          <a:effectLst/>
-        </p:spPr>
-        <p:style>
-          <a:lnRef idx="1">
-            <a:schemeClr val="accent1"/>
-          </a:lnRef>
-          <a:fillRef idx="3">
-            <a:schemeClr val="accent1"/>
-          </a:fillRef>
-          <a:effectRef idx="2">
-            <a:schemeClr val="accent1"/>
-          </a:effectRef>
-          <a:fontRef idx="minor">
-            <a:schemeClr val="lt1"/>
-          </a:fontRef>
-        </p:style>
-        <p:txBody>
-          <a:bodyPr rtlCol="0" anchor="ctr"/>
-          <a:lstStyle/>
-          <a:p>
-            <a:pPr algn="ctr"/>
-          </a:p>
-        </p:txBody>
-      </p:sp>
-      <p:sp>
-        <p:nvSpPr>
-          <p:cNvPr id="22" name="TextBox 21"/>
-          <p:cNvSpPr txBox="1"/>
-          <p:nvPr/>
-        </p:nvSpPr>
-        <p:spPr>
-          <a:xfrm>
-            <a:off x="8540496" y="4023360"/>
-            <a:ext cx="3154680" cy="1325880"/>
-          </a:xfrm>
-          <a:prstGeom prst="rect">
-            <a:avLst/>
-          </a:prstGeom>
-          <a:noFill/>
-        </p:spPr>
-        <p:txBody>
-          <a:bodyPr wrap="square" anchor="t">
-            <a:spAutoFit/>
-          </a:bodyPr>
-          <a:lstStyle/>
-          <a:p>
-            <a:pPr algn="l">
-              <a:spcAft>
-                <a:spcPts val="800"/>
-              </a:spcAft>
-            </a:pPr>
-            <a:r>
-              <a:rPr sz="1600" b="1">
-                <a:solidFill>
-                  <a:srgbClr val="0F172A"/>
-                </a:solidFill>
-                <a:latin typeface="PingFang TC"/>
-                <a:ea typeface="PingFang TC"/>
-              </a:rPr>
-              <a:t>[Caching / CDN]</a:t>
-            </a:r>
-          </a:p>
-          <a:p>
-            <a:pPr algn="l">
-              <a:spcAft>
-                <a:spcPts val="400"/>
-              </a:spcAft>
-            </a:pPr>
-            <a:r>
-              <a:rPr sz="1300" b="0">
-                <a:solidFill>
-                  <a:srgbClr val="64748B"/>
-                </a:solidFill>
-                <a:latin typeface="PingFang TC"/>
-                <a:ea typeface="PingFang TC"/>
-              </a:rPr>
-              <a:t>每次轉址都直擊 DB，流量一來直接癱瘓。
-→ 下週 Deep Dive 展開</a:t>
+              <a:rPr sz="1600" b="0">
+                <a:solidFill>
+                  <a:srgbClr val="E2E8F0"/>
+                </a:solidFill>
+                <a:latin typeface="PingFang TC"/>
+                <a:ea typeface="PingFang TC"/>
+              </a:rPr>
+              <a:t>✓  設計依據：DESIGN.md（16 題決策 + 優劣分析）</a:t>
             </a:r>
           </a:p>
         </p:txBody>
@@ -19938,6 +19649,1048 @@
                 <a:latin typeface="PingFang TC"/>
                 <a:ea typeface="PingFang TC"/>
               </a:rPr>
+              <a:t>下週預告 · NEXT WEEK</a:t>
+            </a:r>
+          </a:p>
+          <a:p>
+            <a:pPr algn="l">
+              <a:spcAft>
+                <a:spcPts val="400"/>
+              </a:spcAft>
+            </a:pPr>
+            <a:r>
+              <a:rPr sz="3000" b="1">
+                <a:solidFill>
+                  <a:srgbClr val="0F172A"/>
+                </a:solidFill>
+                <a:latin typeface="PingFang TC"/>
+                <a:ea typeface="PingFang TC"/>
+              </a:rPr>
+              <a:t>從 Prototype 到 Production 的巨大鴻溝</a:t>
+            </a:r>
+          </a:p>
+        </p:txBody>
+      </p:sp>
+      <p:sp>
+        <p:nvSpPr>
+          <p:cNvPr id="4" name="TextBox 3"/>
+          <p:cNvSpPr txBox="1"/>
+          <p:nvPr/>
+        </p:nvSpPr>
+        <p:spPr>
+          <a:xfrm>
+            <a:off x="548640" y="1371600"/>
+            <a:ext cx="10972800" cy="365760"/>
+          </a:xfrm>
+          <a:prstGeom prst="rect">
+            <a:avLst/>
+          </a:prstGeom>
+          <a:noFill/>
+        </p:spPr>
+        <p:txBody>
+          <a:bodyPr wrap="square" anchor="t">
+            <a:spAutoFit/>
+          </a:bodyPr>
+          <a:lstStyle/>
+          <a:p>
+            <a:pPr algn="l">
+              <a:spcAft>
+                <a:spcPts val="400"/>
+              </a:spcAft>
+            </a:pPr>
+            <a:r>
+              <a:rPr sz="1400" b="0">
+                <a:solidFill>
+                  <a:srgbClr val="64748B"/>
+                </a:solidFill>
+                <a:latin typeface="PingFang TC"/>
+                <a:ea typeface="PingFang TC"/>
+              </a:rPr>
+              <a:t>快速掃過，建立全貌 — 下週 Deep Dive 才是主菜</a:t>
+            </a:r>
+          </a:p>
+        </p:txBody>
+      </p:sp>
+      <p:sp>
+        <p:nvSpPr>
+          <p:cNvPr id="5" name="Rounded Rectangle 4"/>
+          <p:cNvSpPr/>
+          <p:nvPr/>
+        </p:nvSpPr>
+        <p:spPr>
+          <a:xfrm>
+            <a:off x="548640" y="1965960"/>
+            <a:ext cx="3611880" cy="1600200"/>
+          </a:xfrm>
+          <a:prstGeom prst="roundRect">
+            <a:avLst/>
+          </a:prstGeom>
+          <a:solidFill>
+            <a:srgbClr val="F1F5F9"/>
+          </a:solidFill>
+          <a:ln>
+            <a:solidFill>
+              <a:srgbClr val="F1F5F9"/>
+            </a:solidFill>
+          </a:ln>
+          <a:effectLst/>
+        </p:spPr>
+        <p:style>
+          <a:lnRef idx="1">
+            <a:schemeClr val="accent1"/>
+          </a:lnRef>
+          <a:fillRef idx="3">
+            <a:schemeClr val="accent1"/>
+          </a:fillRef>
+          <a:effectRef idx="2">
+            <a:schemeClr val="accent1"/>
+          </a:effectRef>
+          <a:fontRef idx="minor">
+            <a:schemeClr val="lt1"/>
+          </a:fontRef>
+        </p:style>
+        <p:txBody>
+          <a:bodyPr rtlCol="0" anchor="ctr"/>
+          <a:lstStyle/>
+          <a:p>
+            <a:pPr algn="ctr"/>
+          </a:p>
+        </p:txBody>
+      </p:sp>
+      <p:sp>
+        <p:nvSpPr>
+          <p:cNvPr id="6" name="Rectangle 5"/>
+          <p:cNvSpPr/>
+          <p:nvPr/>
+        </p:nvSpPr>
+        <p:spPr>
+          <a:xfrm>
+            <a:off x="548640" y="1965960"/>
+            <a:ext cx="82296" cy="1600200"/>
+          </a:xfrm>
+          <a:prstGeom prst="rect">
+            <a:avLst/>
+          </a:prstGeom>
+          <a:solidFill>
+            <a:srgbClr val="D97706"/>
+          </a:solidFill>
+          <a:ln>
+            <a:noFill/>
+          </a:ln>
+          <a:effectLst/>
+        </p:spPr>
+        <p:style>
+          <a:lnRef idx="1">
+            <a:schemeClr val="accent1"/>
+          </a:lnRef>
+          <a:fillRef idx="3">
+            <a:schemeClr val="accent1"/>
+          </a:fillRef>
+          <a:effectRef idx="2">
+            <a:schemeClr val="accent1"/>
+          </a:effectRef>
+          <a:fontRef idx="minor">
+            <a:schemeClr val="lt1"/>
+          </a:fontRef>
+        </p:style>
+        <p:txBody>
+          <a:bodyPr rtlCol="0" anchor="ctr"/>
+          <a:lstStyle/>
+          <a:p>
+            <a:pPr algn="ctr"/>
+          </a:p>
+        </p:txBody>
+      </p:sp>
+      <p:sp>
+        <p:nvSpPr>
+          <p:cNvPr id="7" name="TextBox 6"/>
+          <p:cNvSpPr txBox="1"/>
+          <p:nvPr/>
+        </p:nvSpPr>
+        <p:spPr>
+          <a:xfrm>
+            <a:off x="822960" y="2148840"/>
+            <a:ext cx="3154680" cy="1325880"/>
+          </a:xfrm>
+          <a:prstGeom prst="rect">
+            <a:avLst/>
+          </a:prstGeom>
+          <a:noFill/>
+        </p:spPr>
+        <p:txBody>
+          <a:bodyPr wrap="square" anchor="t">
+            <a:spAutoFit/>
+          </a:bodyPr>
+          <a:lstStyle/>
+          <a:p>
+            <a:pPr algn="l">
+              <a:spcAft>
+                <a:spcPts val="800"/>
+              </a:spcAft>
+            </a:pPr>
+            <a:r>
+              <a:rPr sz="1600" b="1">
+                <a:solidFill>
+                  <a:srgbClr val="0F172A"/>
+                </a:solidFill>
+                <a:latin typeface="PingFang TC"/>
+                <a:ea typeface="PingFang TC"/>
+              </a:rPr>
+              <a:t>[Error Handling]</a:t>
+            </a:r>
+          </a:p>
+          <a:p>
+            <a:pPr algn="l">
+              <a:spcAft>
+                <a:spcPts val="400"/>
+              </a:spcAft>
+            </a:pPr>
+            <a:r>
+              <a:rPr sz="1300" b="0">
+                <a:solidFill>
+                  <a:srgbClr val="64748B"/>
+                </a:solidFill>
+                <a:latin typeface="PingFang TC"/>
+                <a:ea typeface="PingFang TC"/>
+              </a:rPr>
+              <a:t>遇到不合法輸入直接 Crash。</a:t>
+            </a:r>
+          </a:p>
+        </p:txBody>
+      </p:sp>
+      <p:sp>
+        <p:nvSpPr>
+          <p:cNvPr id="8" name="Rounded Rectangle 7"/>
+          <p:cNvSpPr/>
+          <p:nvPr/>
+        </p:nvSpPr>
+        <p:spPr>
+          <a:xfrm>
+            <a:off x="4407408" y="1965960"/>
+            <a:ext cx="3611880" cy="1600200"/>
+          </a:xfrm>
+          <a:prstGeom prst="roundRect">
+            <a:avLst/>
+          </a:prstGeom>
+          <a:solidFill>
+            <a:srgbClr val="F1F5F9"/>
+          </a:solidFill>
+          <a:ln>
+            <a:solidFill>
+              <a:srgbClr val="F1F5F9"/>
+            </a:solidFill>
+          </a:ln>
+          <a:effectLst/>
+        </p:spPr>
+        <p:style>
+          <a:lnRef idx="1">
+            <a:schemeClr val="accent1"/>
+          </a:lnRef>
+          <a:fillRef idx="3">
+            <a:schemeClr val="accent1"/>
+          </a:fillRef>
+          <a:effectRef idx="2">
+            <a:schemeClr val="accent1"/>
+          </a:effectRef>
+          <a:fontRef idx="minor">
+            <a:schemeClr val="lt1"/>
+          </a:fontRef>
+        </p:style>
+        <p:txBody>
+          <a:bodyPr rtlCol="0" anchor="ctr"/>
+          <a:lstStyle/>
+          <a:p>
+            <a:pPr algn="ctr"/>
+          </a:p>
+        </p:txBody>
+      </p:sp>
+      <p:sp>
+        <p:nvSpPr>
+          <p:cNvPr id="9" name="Rectangle 8"/>
+          <p:cNvSpPr/>
+          <p:nvPr/>
+        </p:nvSpPr>
+        <p:spPr>
+          <a:xfrm>
+            <a:off x="4407408" y="1965960"/>
+            <a:ext cx="82296" cy="1600200"/>
+          </a:xfrm>
+          <a:prstGeom prst="rect">
+            <a:avLst/>
+          </a:prstGeom>
+          <a:solidFill>
+            <a:srgbClr val="D97706"/>
+          </a:solidFill>
+          <a:ln>
+            <a:noFill/>
+          </a:ln>
+          <a:effectLst/>
+        </p:spPr>
+        <p:style>
+          <a:lnRef idx="1">
+            <a:schemeClr val="accent1"/>
+          </a:lnRef>
+          <a:fillRef idx="3">
+            <a:schemeClr val="accent1"/>
+          </a:fillRef>
+          <a:effectRef idx="2">
+            <a:schemeClr val="accent1"/>
+          </a:effectRef>
+          <a:fontRef idx="minor">
+            <a:schemeClr val="lt1"/>
+          </a:fontRef>
+        </p:style>
+        <p:txBody>
+          <a:bodyPr rtlCol="0" anchor="ctr"/>
+          <a:lstStyle/>
+          <a:p>
+            <a:pPr algn="ctr"/>
+          </a:p>
+        </p:txBody>
+      </p:sp>
+      <p:sp>
+        <p:nvSpPr>
+          <p:cNvPr id="10" name="TextBox 9"/>
+          <p:cNvSpPr txBox="1"/>
+          <p:nvPr/>
+        </p:nvSpPr>
+        <p:spPr>
+          <a:xfrm>
+            <a:off x="4681728" y="2148840"/>
+            <a:ext cx="3154680" cy="1325880"/>
+          </a:xfrm>
+          <a:prstGeom prst="rect">
+            <a:avLst/>
+          </a:prstGeom>
+          <a:noFill/>
+        </p:spPr>
+        <p:txBody>
+          <a:bodyPr wrap="square" anchor="t">
+            <a:spAutoFit/>
+          </a:bodyPr>
+          <a:lstStyle/>
+          <a:p>
+            <a:pPr algn="l">
+              <a:spcAft>
+                <a:spcPts val="800"/>
+              </a:spcAft>
+            </a:pPr>
+            <a:r>
+              <a:rPr sz="1600" b="1">
+                <a:solidFill>
+                  <a:srgbClr val="0F172A"/>
+                </a:solidFill>
+                <a:latin typeface="PingFang TC"/>
+                <a:ea typeface="PingFang TC"/>
+              </a:rPr>
+              <a:t>[Rate Limiting]</a:t>
+            </a:r>
+          </a:p>
+          <a:p>
+            <a:pPr algn="l">
+              <a:spcAft>
+                <a:spcPts val="400"/>
+              </a:spcAft>
+            </a:pPr>
+            <a:r>
+              <a:rPr sz="1300" b="0">
+                <a:solidFill>
+                  <a:srgbClr val="64748B"/>
+                </a:solidFill>
+                <a:latin typeface="PingFang TC"/>
+                <a:ea typeface="PingFang TC"/>
+              </a:rPr>
+              <a:t>毫無防護，極易被 Script 惡意灌爆 API。</a:t>
+            </a:r>
+          </a:p>
+        </p:txBody>
+      </p:sp>
+      <p:sp>
+        <p:nvSpPr>
+          <p:cNvPr id="11" name="Rounded Rectangle 10"/>
+          <p:cNvSpPr/>
+          <p:nvPr/>
+        </p:nvSpPr>
+        <p:spPr>
+          <a:xfrm>
+            <a:off x="8266176" y="1965960"/>
+            <a:ext cx="3611880" cy="1600200"/>
+          </a:xfrm>
+          <a:prstGeom prst="roundRect">
+            <a:avLst/>
+          </a:prstGeom>
+          <a:solidFill>
+            <a:srgbClr val="F1F5F9"/>
+          </a:solidFill>
+          <a:ln>
+            <a:solidFill>
+              <a:srgbClr val="F1F5F9"/>
+            </a:solidFill>
+          </a:ln>
+          <a:effectLst/>
+        </p:spPr>
+        <p:style>
+          <a:lnRef idx="1">
+            <a:schemeClr val="accent1"/>
+          </a:lnRef>
+          <a:fillRef idx="3">
+            <a:schemeClr val="accent1"/>
+          </a:fillRef>
+          <a:effectRef idx="2">
+            <a:schemeClr val="accent1"/>
+          </a:effectRef>
+          <a:fontRef idx="minor">
+            <a:schemeClr val="lt1"/>
+          </a:fontRef>
+        </p:style>
+        <p:txBody>
+          <a:bodyPr rtlCol="0" anchor="ctr"/>
+          <a:lstStyle/>
+          <a:p>
+            <a:pPr algn="ctr"/>
+          </a:p>
+        </p:txBody>
+      </p:sp>
+      <p:sp>
+        <p:nvSpPr>
+          <p:cNvPr id="12" name="Rectangle 11"/>
+          <p:cNvSpPr/>
+          <p:nvPr/>
+        </p:nvSpPr>
+        <p:spPr>
+          <a:xfrm>
+            <a:off x="8266176" y="1965960"/>
+            <a:ext cx="82296" cy="1600200"/>
+          </a:xfrm>
+          <a:prstGeom prst="rect">
+            <a:avLst/>
+          </a:prstGeom>
+          <a:solidFill>
+            <a:srgbClr val="D97706"/>
+          </a:solidFill>
+          <a:ln>
+            <a:noFill/>
+          </a:ln>
+          <a:effectLst/>
+        </p:spPr>
+        <p:style>
+          <a:lnRef idx="1">
+            <a:schemeClr val="accent1"/>
+          </a:lnRef>
+          <a:fillRef idx="3">
+            <a:schemeClr val="accent1"/>
+          </a:fillRef>
+          <a:effectRef idx="2">
+            <a:schemeClr val="accent1"/>
+          </a:effectRef>
+          <a:fontRef idx="minor">
+            <a:schemeClr val="lt1"/>
+          </a:fontRef>
+        </p:style>
+        <p:txBody>
+          <a:bodyPr rtlCol="0" anchor="ctr"/>
+          <a:lstStyle/>
+          <a:p>
+            <a:pPr algn="ctr"/>
+          </a:p>
+        </p:txBody>
+      </p:sp>
+      <p:sp>
+        <p:nvSpPr>
+          <p:cNvPr id="13" name="TextBox 12"/>
+          <p:cNvSpPr txBox="1"/>
+          <p:nvPr/>
+        </p:nvSpPr>
+        <p:spPr>
+          <a:xfrm>
+            <a:off x="8540496" y="2148840"/>
+            <a:ext cx="3154680" cy="1325880"/>
+          </a:xfrm>
+          <a:prstGeom prst="rect">
+            <a:avLst/>
+          </a:prstGeom>
+          <a:noFill/>
+        </p:spPr>
+        <p:txBody>
+          <a:bodyPr wrap="square" anchor="t">
+            <a:spAutoFit/>
+          </a:bodyPr>
+          <a:lstStyle/>
+          <a:p>
+            <a:pPr algn="l">
+              <a:spcAft>
+                <a:spcPts val="800"/>
+              </a:spcAft>
+            </a:pPr>
+            <a:r>
+              <a:rPr sz="1600" b="1">
+                <a:solidFill>
+                  <a:srgbClr val="0F172A"/>
+                </a:solidFill>
+                <a:latin typeface="PingFang TC"/>
+                <a:ea typeface="PingFang TC"/>
+              </a:rPr>
+              <a:t>[Auth &amp; Isolation]</a:t>
+            </a:r>
+          </a:p>
+          <a:p>
+            <a:pPr algn="l">
+              <a:spcAft>
+                <a:spcPts val="400"/>
+              </a:spcAft>
+            </a:pPr>
+            <a:r>
+              <a:rPr sz="1300" b="0">
+                <a:solidFill>
+                  <a:srgbClr val="64748B"/>
+                </a:solidFill>
+                <a:latin typeface="PingFang TC"/>
+                <a:ea typeface="PingFang TC"/>
+              </a:rPr>
+              <a:t>缺乏多租戶概念，資料全公開。</a:t>
+            </a:r>
+          </a:p>
+        </p:txBody>
+      </p:sp>
+      <p:sp>
+        <p:nvSpPr>
+          <p:cNvPr id="14" name="Rounded Rectangle 13"/>
+          <p:cNvSpPr/>
+          <p:nvPr/>
+        </p:nvSpPr>
+        <p:spPr>
+          <a:xfrm>
+            <a:off x="548640" y="3840480"/>
+            <a:ext cx="3611880" cy="1600200"/>
+          </a:xfrm>
+          <a:prstGeom prst="roundRect">
+            <a:avLst/>
+          </a:prstGeom>
+          <a:solidFill>
+            <a:srgbClr val="F1F5F9"/>
+          </a:solidFill>
+          <a:ln>
+            <a:solidFill>
+              <a:srgbClr val="F1F5F9"/>
+            </a:solidFill>
+          </a:ln>
+          <a:effectLst/>
+        </p:spPr>
+        <p:style>
+          <a:lnRef idx="1">
+            <a:schemeClr val="accent1"/>
+          </a:lnRef>
+          <a:fillRef idx="3">
+            <a:schemeClr val="accent1"/>
+          </a:fillRef>
+          <a:effectRef idx="2">
+            <a:schemeClr val="accent1"/>
+          </a:effectRef>
+          <a:fontRef idx="minor">
+            <a:schemeClr val="lt1"/>
+          </a:fontRef>
+        </p:style>
+        <p:txBody>
+          <a:bodyPr rtlCol="0" anchor="ctr"/>
+          <a:lstStyle/>
+          <a:p>
+            <a:pPr algn="ctr"/>
+          </a:p>
+        </p:txBody>
+      </p:sp>
+      <p:sp>
+        <p:nvSpPr>
+          <p:cNvPr id="15" name="Rectangle 14"/>
+          <p:cNvSpPr/>
+          <p:nvPr/>
+        </p:nvSpPr>
+        <p:spPr>
+          <a:xfrm>
+            <a:off x="548640" y="3840480"/>
+            <a:ext cx="82296" cy="1600200"/>
+          </a:xfrm>
+          <a:prstGeom prst="rect">
+            <a:avLst/>
+          </a:prstGeom>
+          <a:solidFill>
+            <a:srgbClr val="0EA5E9"/>
+          </a:solidFill>
+          <a:ln>
+            <a:noFill/>
+          </a:ln>
+          <a:effectLst/>
+        </p:spPr>
+        <p:style>
+          <a:lnRef idx="1">
+            <a:schemeClr val="accent1"/>
+          </a:lnRef>
+          <a:fillRef idx="3">
+            <a:schemeClr val="accent1"/>
+          </a:fillRef>
+          <a:effectRef idx="2">
+            <a:schemeClr val="accent1"/>
+          </a:effectRef>
+          <a:fontRef idx="minor">
+            <a:schemeClr val="lt1"/>
+          </a:fontRef>
+        </p:style>
+        <p:txBody>
+          <a:bodyPr rtlCol="0" anchor="ctr"/>
+          <a:lstStyle/>
+          <a:p>
+            <a:pPr algn="ctr"/>
+          </a:p>
+        </p:txBody>
+      </p:sp>
+      <p:sp>
+        <p:nvSpPr>
+          <p:cNvPr id="16" name="TextBox 15"/>
+          <p:cNvSpPr txBox="1"/>
+          <p:nvPr/>
+        </p:nvSpPr>
+        <p:spPr>
+          <a:xfrm>
+            <a:off x="822960" y="4023360"/>
+            <a:ext cx="3154680" cy="1325880"/>
+          </a:xfrm>
+          <a:prstGeom prst="rect">
+            <a:avLst/>
+          </a:prstGeom>
+          <a:noFill/>
+        </p:spPr>
+        <p:txBody>
+          <a:bodyPr wrap="square" anchor="t">
+            <a:spAutoFit/>
+          </a:bodyPr>
+          <a:lstStyle/>
+          <a:p>
+            <a:pPr algn="l">
+              <a:spcAft>
+                <a:spcPts val="800"/>
+              </a:spcAft>
+            </a:pPr>
+            <a:r>
+              <a:rPr sz="1600" b="1">
+                <a:solidFill>
+                  <a:srgbClr val="0F172A"/>
+                </a:solidFill>
+                <a:latin typeface="PingFang TC"/>
+                <a:ea typeface="PingFang TC"/>
+              </a:rPr>
+              <a:t>[Monitoring]</a:t>
+            </a:r>
+          </a:p>
+          <a:p>
+            <a:pPr algn="l">
+              <a:spcAft>
+                <a:spcPts val="400"/>
+              </a:spcAft>
+            </a:pPr>
+            <a:r>
+              <a:rPr sz="1300" b="0">
+                <a:solidFill>
+                  <a:srgbClr val="64748B"/>
+                </a:solidFill>
+                <a:latin typeface="PingFang TC"/>
+                <a:ea typeface="PingFang TC"/>
+              </a:rPr>
+              <a:t>服務掛了完全沒有 Alerting，處於盲飛狀態。</a:t>
+            </a:r>
+          </a:p>
+        </p:txBody>
+      </p:sp>
+      <p:sp>
+        <p:nvSpPr>
+          <p:cNvPr id="17" name="Rounded Rectangle 16"/>
+          <p:cNvSpPr/>
+          <p:nvPr/>
+        </p:nvSpPr>
+        <p:spPr>
+          <a:xfrm>
+            <a:off x="4407408" y="3840480"/>
+            <a:ext cx="3611880" cy="1600200"/>
+          </a:xfrm>
+          <a:prstGeom prst="roundRect">
+            <a:avLst/>
+          </a:prstGeom>
+          <a:solidFill>
+            <a:srgbClr val="F1F5F9"/>
+          </a:solidFill>
+          <a:ln>
+            <a:solidFill>
+              <a:srgbClr val="F1F5F9"/>
+            </a:solidFill>
+          </a:ln>
+          <a:effectLst/>
+        </p:spPr>
+        <p:style>
+          <a:lnRef idx="1">
+            <a:schemeClr val="accent1"/>
+          </a:lnRef>
+          <a:fillRef idx="3">
+            <a:schemeClr val="accent1"/>
+          </a:fillRef>
+          <a:effectRef idx="2">
+            <a:schemeClr val="accent1"/>
+          </a:effectRef>
+          <a:fontRef idx="minor">
+            <a:schemeClr val="lt1"/>
+          </a:fontRef>
+        </p:style>
+        <p:txBody>
+          <a:bodyPr rtlCol="0" anchor="ctr"/>
+          <a:lstStyle/>
+          <a:p>
+            <a:pPr algn="ctr"/>
+          </a:p>
+        </p:txBody>
+      </p:sp>
+      <p:sp>
+        <p:nvSpPr>
+          <p:cNvPr id="18" name="Rectangle 17"/>
+          <p:cNvSpPr/>
+          <p:nvPr/>
+        </p:nvSpPr>
+        <p:spPr>
+          <a:xfrm>
+            <a:off x="4407408" y="3840480"/>
+            <a:ext cx="82296" cy="1600200"/>
+          </a:xfrm>
+          <a:prstGeom prst="rect">
+            <a:avLst/>
+          </a:prstGeom>
+          <a:solidFill>
+            <a:srgbClr val="0EA5E9"/>
+          </a:solidFill>
+          <a:ln>
+            <a:noFill/>
+          </a:ln>
+          <a:effectLst/>
+        </p:spPr>
+        <p:style>
+          <a:lnRef idx="1">
+            <a:schemeClr val="accent1"/>
+          </a:lnRef>
+          <a:fillRef idx="3">
+            <a:schemeClr val="accent1"/>
+          </a:fillRef>
+          <a:effectRef idx="2">
+            <a:schemeClr val="accent1"/>
+          </a:effectRef>
+          <a:fontRef idx="minor">
+            <a:schemeClr val="lt1"/>
+          </a:fontRef>
+        </p:style>
+        <p:txBody>
+          <a:bodyPr rtlCol="0" anchor="ctr"/>
+          <a:lstStyle/>
+          <a:p>
+            <a:pPr algn="ctr"/>
+          </a:p>
+        </p:txBody>
+      </p:sp>
+      <p:sp>
+        <p:nvSpPr>
+          <p:cNvPr id="19" name="TextBox 18"/>
+          <p:cNvSpPr txBox="1"/>
+          <p:nvPr/>
+        </p:nvSpPr>
+        <p:spPr>
+          <a:xfrm>
+            <a:off x="4681728" y="4023360"/>
+            <a:ext cx="3154680" cy="1325880"/>
+          </a:xfrm>
+          <a:prstGeom prst="rect">
+            <a:avLst/>
+          </a:prstGeom>
+          <a:noFill/>
+        </p:spPr>
+        <p:txBody>
+          <a:bodyPr wrap="square" anchor="t">
+            <a:spAutoFit/>
+          </a:bodyPr>
+          <a:lstStyle/>
+          <a:p>
+            <a:pPr algn="l">
+              <a:spcAft>
+                <a:spcPts val="800"/>
+              </a:spcAft>
+            </a:pPr>
+            <a:r>
+              <a:rPr sz="1600" b="1">
+                <a:solidFill>
+                  <a:srgbClr val="0F172A"/>
+                </a:solidFill>
+                <a:latin typeface="PingFang TC"/>
+                <a:ea typeface="PingFang TC"/>
+              </a:rPr>
+              <a:t>[Data Cleanup]</a:t>
+            </a:r>
+          </a:p>
+          <a:p>
+            <a:pPr algn="l">
+              <a:spcAft>
+                <a:spcPts val="400"/>
+              </a:spcAft>
+            </a:pPr>
+            <a:r>
+              <a:rPr sz="1300" b="0">
+                <a:solidFill>
+                  <a:srgbClr val="64748B"/>
+                </a:solidFill>
+                <a:latin typeface="PingFang TC"/>
+                <a:ea typeface="PingFang TC"/>
+              </a:rPr>
+              <a:t>過期資料永不刪除，一年後 DB 將面臨嚴重 Bloat。</a:t>
+            </a:r>
+          </a:p>
+        </p:txBody>
+      </p:sp>
+      <p:sp>
+        <p:nvSpPr>
+          <p:cNvPr id="20" name="Rounded Rectangle 19"/>
+          <p:cNvSpPr/>
+          <p:nvPr/>
+        </p:nvSpPr>
+        <p:spPr>
+          <a:xfrm>
+            <a:off x="8266176" y="3840480"/>
+            <a:ext cx="3611880" cy="1600200"/>
+          </a:xfrm>
+          <a:prstGeom prst="roundRect">
+            <a:avLst/>
+          </a:prstGeom>
+          <a:solidFill>
+            <a:srgbClr val="F1F5F9"/>
+          </a:solidFill>
+          <a:ln>
+            <a:solidFill>
+              <a:srgbClr val="F1F5F9"/>
+            </a:solidFill>
+          </a:ln>
+          <a:effectLst/>
+        </p:spPr>
+        <p:style>
+          <a:lnRef idx="1">
+            <a:schemeClr val="accent1"/>
+          </a:lnRef>
+          <a:fillRef idx="3">
+            <a:schemeClr val="accent1"/>
+          </a:fillRef>
+          <a:effectRef idx="2">
+            <a:schemeClr val="accent1"/>
+          </a:effectRef>
+          <a:fontRef idx="minor">
+            <a:schemeClr val="lt1"/>
+          </a:fontRef>
+        </p:style>
+        <p:txBody>
+          <a:bodyPr rtlCol="0" anchor="ctr"/>
+          <a:lstStyle/>
+          <a:p>
+            <a:pPr algn="ctr"/>
+          </a:p>
+        </p:txBody>
+      </p:sp>
+      <p:sp>
+        <p:nvSpPr>
+          <p:cNvPr id="21" name="Rectangle 20"/>
+          <p:cNvSpPr/>
+          <p:nvPr/>
+        </p:nvSpPr>
+        <p:spPr>
+          <a:xfrm>
+            <a:off x="8266176" y="3840480"/>
+            <a:ext cx="82296" cy="1600200"/>
+          </a:xfrm>
+          <a:prstGeom prst="rect">
+            <a:avLst/>
+          </a:prstGeom>
+          <a:solidFill>
+            <a:srgbClr val="0EA5E9"/>
+          </a:solidFill>
+          <a:ln>
+            <a:noFill/>
+          </a:ln>
+          <a:effectLst/>
+        </p:spPr>
+        <p:style>
+          <a:lnRef idx="1">
+            <a:schemeClr val="accent1"/>
+          </a:lnRef>
+          <a:fillRef idx="3">
+            <a:schemeClr val="accent1"/>
+          </a:fillRef>
+          <a:effectRef idx="2">
+            <a:schemeClr val="accent1"/>
+          </a:effectRef>
+          <a:fontRef idx="minor">
+            <a:schemeClr val="lt1"/>
+          </a:fontRef>
+        </p:style>
+        <p:txBody>
+          <a:bodyPr rtlCol="0" anchor="ctr"/>
+          <a:lstStyle/>
+          <a:p>
+            <a:pPr algn="ctr"/>
+          </a:p>
+        </p:txBody>
+      </p:sp>
+      <p:sp>
+        <p:nvSpPr>
+          <p:cNvPr id="22" name="TextBox 21"/>
+          <p:cNvSpPr txBox="1"/>
+          <p:nvPr/>
+        </p:nvSpPr>
+        <p:spPr>
+          <a:xfrm>
+            <a:off x="8540496" y="4023360"/>
+            <a:ext cx="3154680" cy="1325880"/>
+          </a:xfrm>
+          <a:prstGeom prst="rect">
+            <a:avLst/>
+          </a:prstGeom>
+          <a:noFill/>
+        </p:spPr>
+        <p:txBody>
+          <a:bodyPr wrap="square" anchor="t">
+            <a:spAutoFit/>
+          </a:bodyPr>
+          <a:lstStyle/>
+          <a:p>
+            <a:pPr algn="l">
+              <a:spcAft>
+                <a:spcPts val="800"/>
+              </a:spcAft>
+            </a:pPr>
+            <a:r>
+              <a:rPr sz="1600" b="1">
+                <a:solidFill>
+                  <a:srgbClr val="0F172A"/>
+                </a:solidFill>
+                <a:latin typeface="PingFang TC"/>
+                <a:ea typeface="PingFang TC"/>
+              </a:rPr>
+              <a:t>[Caching / CDN]</a:t>
+            </a:r>
+          </a:p>
+          <a:p>
+            <a:pPr algn="l">
+              <a:spcAft>
+                <a:spcPts val="400"/>
+              </a:spcAft>
+            </a:pPr>
+            <a:r>
+              <a:rPr sz="1300" b="0">
+                <a:solidFill>
+                  <a:srgbClr val="64748B"/>
+                </a:solidFill>
+                <a:latin typeface="PingFang TC"/>
+                <a:ea typeface="PingFang TC"/>
+              </a:rPr>
+              <a:t>每次轉址都直擊 DB，流量一來直接癱瘓。
+→ 下週 Deep Dive 展開</a:t>
+            </a:r>
+          </a:p>
+        </p:txBody>
+      </p:sp>
+    </p:spTree>
+  </p:cSld>
+  <p:clrMapOvr>
+    <a:masterClrMapping/>
+  </p:clrMapOvr>
+</p:sld>
+</file>
+
+<file path=ppt/slides/slide31.xml><?xml version="1.0" encoding="utf-8"?>
+<p:sld xmlns:a="http://schemas.openxmlformats.org/drawingml/2006/main" xmlns:p="http://schemas.openxmlformats.org/presentationml/2006/main" xmlns:r="http://schemas.openxmlformats.org/officeDocument/2006/relationships">
+  <p:cSld>
+    <p:spTree>
+      <p:nvGrpSpPr>
+        <p:cNvPr id="1" name=""/>
+        <p:cNvGrpSpPr/>
+        <p:nvPr/>
+      </p:nvGrpSpPr>
+      <p:grpSpPr/>
+      <p:sp>
+        <p:nvSpPr>
+          <p:cNvPr id="2" name="Rectangle 1"/>
+          <p:cNvSpPr/>
+          <p:nvPr/>
+        </p:nvSpPr>
+        <p:spPr>
+          <a:xfrm>
+            <a:off x="0" y="0"/>
+            <a:ext cx="164592" cy="6858000"/>
+          </a:xfrm>
+          <a:prstGeom prst="rect">
+            <a:avLst/>
+          </a:prstGeom>
+          <a:solidFill>
+            <a:srgbClr val="2563EB"/>
+          </a:solidFill>
+          <a:ln>
+            <a:noFill/>
+          </a:ln>
+          <a:effectLst/>
+        </p:spPr>
+        <p:style>
+          <a:lnRef idx="1">
+            <a:schemeClr val="accent1"/>
+          </a:lnRef>
+          <a:fillRef idx="3">
+            <a:schemeClr val="accent1"/>
+          </a:fillRef>
+          <a:effectRef idx="2">
+            <a:schemeClr val="accent1"/>
+          </a:effectRef>
+          <a:fontRef idx="minor">
+            <a:schemeClr val="lt1"/>
+          </a:fontRef>
+        </p:style>
+        <p:txBody>
+          <a:bodyPr rtlCol="0" anchor="ctr"/>
+          <a:lstStyle/>
+          <a:p>
+            <a:pPr algn="ctr"/>
+          </a:p>
+        </p:txBody>
+      </p:sp>
+      <p:sp>
+        <p:nvSpPr>
+          <p:cNvPr id="3" name="TextBox 2"/>
+          <p:cNvSpPr txBox="1"/>
+          <p:nvPr/>
+        </p:nvSpPr>
+        <p:spPr>
+          <a:xfrm>
+            <a:off x="502920" y="320040"/>
+            <a:ext cx="10972800" cy="1005840"/>
+          </a:xfrm>
+          <a:prstGeom prst="rect">
+            <a:avLst/>
+          </a:prstGeom>
+          <a:noFill/>
+        </p:spPr>
+        <p:txBody>
+          <a:bodyPr wrap="square" anchor="t">
+            <a:spAutoFit/>
+          </a:bodyPr>
+          <a:lstStyle/>
+          <a:p>
+            <a:pPr algn="l">
+              <a:spcAft>
+                <a:spcPts val="200"/>
+              </a:spcAft>
+            </a:pPr>
+            <a:r>
+              <a:rPr sz="1300" b="1">
+                <a:solidFill>
+                  <a:srgbClr val="2563EB"/>
+                </a:solidFill>
+                <a:latin typeface="PingFang TC"/>
+                <a:ea typeface="PingFang TC"/>
+              </a:rPr>
               <a:t>下週預告 · DEEP DIVE</a:t>
             </a:r>
           </a:p>

</xml_diff>

<commit_message>
DESIGN/slides: add scaling deep-dive (50x QPS bottleneck analysis + event-driven analytics pipeline)
- DESIGN appendix J: 1k->50k QPS failure-order (DB scan-write breaks first) + Kinesis/SQS
  buffered, batch-aggregated analytics pipeline + ASG/Redis/RDS/edge scaling fixes
- PPT: replace stress-test teaser with two formal slides (50x analysis + pipeline), 33 pages

Co-Authored-By: Claude Opus 4.8 <noreply@anthropic.com>
</commit_message>
<xml_diff>
--- a/QR Code Generator/QR_Code_Generator.pptx
+++ b/QR Code Generator/QR_Code_Generator.pptx
@@ -37,6 +37,7 @@
     <p:sldId id="285" r:id="rId36"/>
     <p:sldId id="286" r:id="rId37"/>
     <p:sldId id="287" r:id="rId38"/>
+    <p:sldId id="288" r:id="rId39"/>
   </p:sldIdLst>
   <p:sldSz cx="12191695" cy="6858000" type="screen4x3"/>
   <p:notesSz cx="6858000" cy="9144000"/>
@@ -21151,7 +21152,7 @@
                 <a:latin typeface="PingFang TC"/>
                 <a:ea typeface="PingFang TC"/>
               </a:rPr>
-              <a:t>下週預告 · DEEP DIVE</a:t>
+              <a:t>極限擴展 · 50× 推演</a:t>
             </a:r>
           </a:p>
           <a:p>
@@ -21168,7 +21169,7 @@
                 <a:latin typeface="PingFang TC"/>
                 <a:ea typeface="PingFang TC"/>
               </a:rPr>
-              <a:t>壓力測試與極限擴展 (Deep Dive)</a:t>
+              <a:t>1k → 50k QPS：這套架構哪裡先崩？</a:t>
             </a:r>
           </a:p>
         </p:txBody>
@@ -21181,8 +21182,8 @@
         </p:nvSpPr>
         <p:spPr>
           <a:xfrm>
-            <a:off x="548640" y="2011680"/>
-            <a:ext cx="5486400" cy="2926080"/>
+            <a:off x="548640" y="1417320"/>
+            <a:ext cx="10972800" cy="548640"/>
           </a:xfrm>
           <a:prstGeom prst="rect">
             <a:avLst/>
@@ -21194,23 +21195,6 @@
             <a:spAutoFit/>
           </a:bodyPr>
           <a:lstStyle/>
-          <a:p>
-            <a:pPr algn="l">
-              <a:spcAft>
-                <a:spcPts val="1600"/>
-              </a:spcAft>
-            </a:pPr>
-            <a:r>
-              <a:rPr sz="2600" b="1">
-                <a:solidFill>
-                  <a:srgbClr val="2563EB"/>
-                </a:solidFill>
-                <a:latin typeface="PingFang TC"/>
-                <a:ea typeface="PingFang TC"/>
-              </a:rPr>
-              <a:t>1,000 QPS  →  50,000 QPS</a:t>
-            </a:r>
-          </a:p>
           <a:p>
             <a:pPr algn="l">
               <a:spcAft>
@@ -21218,14 +21202,609 @@
               </a:spcAft>
             </a:pPr>
             <a:r>
-              <a:rPr sz="1900" b="1">
+              <a:rPr sz="1800" b="1">
+                <a:solidFill>
+                  <a:srgbClr val="2563EB"/>
+                </a:solidFill>
+                <a:latin typeface="PingFang TC"/>
+                <a:ea typeface="PingFang TC"/>
+              </a:rPr>
+              <a:t>1,000 QPS  →  50,000 QPS（大型客戶上線,流量瞬間 50×）</a:t>
+            </a:r>
+          </a:p>
+        </p:txBody>
+      </p:sp>
+      <p:graphicFrame>
+        <p:nvGraphicFramePr>
+          <p:cNvPr id="5" name="Table 4"/>
+          <p:cNvGraphicFramePr>
+            <a:graphicFrameLocks noGrp="1"/>
+          </p:cNvGraphicFramePr>
+          <p:nvPr/>
+        </p:nvGraphicFramePr>
+        <p:xfrm>
+          <a:off x="548640" y="2103120"/>
+          <a:ext cx="11109960" cy="3108960"/>
+        </p:xfrm>
+        <a:graphic>
+          <a:graphicData uri="http://schemas.openxmlformats.org/drawingml/2006/table">
+            <a:tbl>
+              <a:tblPr firstRow="1" bandRow="1">
+                <a:tableStyleId>{5C22544A-7EE6-4342-B048-85BDC9FD1C3A}</a:tableStyleId>
+              </a:tblPr>
+              <a:tblGrid>
+                <a:gridCol w="640080"/>
+                <a:gridCol w="3017520"/>
+                <a:gridCol w="7452360"/>
+              </a:tblGrid>
+              <a:tr h="518160">
+                <a:tc>
+                  <a:txBody>
+                    <a:bodyPr/>
+                    <a:lstStyle/>
+                    <a:p>
+                      <a:r>
+                        <a:rPr sz="1200" b="1">
+                          <a:solidFill>
+                            <a:srgbClr val="FFFFFF"/>
+                          </a:solidFill>
+                          <a:latin typeface="PingFang TC"/>
+                          <a:ea typeface="PingFang TC"/>
+                        </a:rPr>
+                        <a:t>#</a:t>
+                      </a:r>
+                    </a:p>
+                  </a:txBody>
+                  <a:tcPr marT="25400" marB="25400" marL="101600" anchor="ctr">
+                    <a:solidFill>
+                      <a:srgbClr val="2563EB"/>
+                    </a:solidFill>
+                  </a:tcPr>
+                </a:tc>
+                <a:tc>
+                  <a:txBody>
+                    <a:bodyPr/>
+                    <a:lstStyle/>
+                    <a:p>
+                      <a:r>
+                        <a:rPr sz="1200" b="1">
+                          <a:solidFill>
+                            <a:srgbClr val="FFFFFF"/>
+                          </a:solidFill>
+                          <a:latin typeface="PingFang TC"/>
+                          <a:ea typeface="PingFang TC"/>
+                        </a:rPr>
+                        <a:t>元件</a:t>
+                      </a:r>
+                    </a:p>
+                  </a:txBody>
+                  <a:tcPr marT="25400" marB="25400" marL="101600" anchor="ctr">
+                    <a:solidFill>
+                      <a:srgbClr val="2563EB"/>
+                    </a:solidFill>
+                  </a:tcPr>
+                </a:tc>
+                <a:tc>
+                  <a:txBody>
+                    <a:bodyPr/>
+                    <a:lstStyle/>
+                    <a:p>
+                      <a:r>
+                        <a:rPr sz="1200" b="1">
+                          <a:solidFill>
+                            <a:srgbClr val="FFFFFF"/>
+                          </a:solidFill>
+                          <a:latin typeface="PingFang TC"/>
+                          <a:ea typeface="PingFang TC"/>
+                        </a:rPr>
+                        <a:t>為何崩（先 → 後）</a:t>
+                      </a:r>
+                    </a:p>
+                  </a:txBody>
+                  <a:tcPr marT="25400" marB="25400" marL="101600" anchor="ctr">
+                    <a:solidFill>
+                      <a:srgbClr val="2563EB"/>
+                    </a:solidFill>
+                  </a:tcPr>
+                </a:tc>
+              </a:tr>
+              <a:tr h="518160">
+                <a:tc>
+                  <a:txBody>
+                    <a:bodyPr/>
+                    <a:lstStyle/>
+                    <a:p>
+                      <a:r>
+                        <a:rPr sz="1200" b="1">
+                          <a:solidFill>
+                            <a:srgbClr val="0F172A"/>
+                          </a:solidFill>
+                          <a:latin typeface="PingFang TC"/>
+                          <a:ea typeface="PingFang TC"/>
+                        </a:rPr>
+                        <a:t>1</a:t>
+                      </a:r>
+                    </a:p>
+                  </a:txBody>
+                  <a:tcPr marT="25400" marB="25400" marL="101600" anchor="ctr">
+                    <a:solidFill>
+                      <a:srgbClr val="FEE2E2"/>
+                    </a:solidFill>
+                  </a:tcPr>
+                </a:tc>
+                <a:tc>
+                  <a:txBody>
+                    <a:bodyPr/>
+                    <a:lstStyle/>
+                    <a:p>
+                      <a:r>
+                        <a:rPr sz="1200" b="1">
+                          <a:solidFill>
+                            <a:srgbClr val="0F172A"/>
+                          </a:solidFill>
+                          <a:latin typeface="PingFang TC"/>
+                          <a:ea typeface="PingFang TC"/>
+                        </a:rPr>
+                        <a:t>DB 寫入 (scan_events)</a:t>
+                      </a:r>
+                    </a:p>
+                  </a:txBody>
+                  <a:tcPr marT="25400" marB="25400" marL="101600" anchor="ctr">
+                    <a:solidFill>
+                      <a:srgbClr val="FEE2E2"/>
+                    </a:solidFill>
+                  </a:tcPr>
+                </a:tc>
+                <a:tc>
+                  <a:txBody>
+                    <a:bodyPr/>
+                    <a:lstStyle/>
+                    <a:p>
+                      <a:r>
+                        <a:rPr sz="1200" b="0">
+                          <a:solidFill>
+                            <a:srgbClr val="0F172A"/>
+                          </a:solidFill>
+                          <a:latin typeface="PingFang TC"/>
+                          <a:ea typeface="PingFang TC"/>
+                        </a:rPr>
+                        <a:t>每次 redirect 一筆 INSERT → 50k writes/s 打單一 RDS（單 AZ、無 replica）→ 最先爆</a:t>
+                      </a:r>
+                    </a:p>
+                  </a:txBody>
+                  <a:tcPr marT="25400" marB="25400" marL="101600" anchor="ctr">
+                    <a:solidFill>
+                      <a:srgbClr val="FEE2E2"/>
+                    </a:solidFill>
+                  </a:tcPr>
+                </a:tc>
+              </a:tr>
+              <a:tr h="518160">
+                <a:tc>
+                  <a:txBody>
+                    <a:bodyPr/>
+                    <a:lstStyle/>
+                    <a:p>
+                      <a:r>
+                        <a:rPr sz="1200" b="1">
+                          <a:solidFill>
+                            <a:srgbClr val="0F172A"/>
+                          </a:solidFill>
+                          <a:latin typeface="PingFang TC"/>
+                          <a:ea typeface="PingFang TC"/>
+                        </a:rPr>
+                        <a:t>2</a:t>
+                      </a:r>
+                    </a:p>
+                  </a:txBody>
+                  <a:tcPr marT="25400" marB="25400" marL="101600" anchor="ctr">
+                    <a:solidFill>
+                      <a:srgbClr val="F1F5F9"/>
+                    </a:solidFill>
+                  </a:tcPr>
+                </a:tc>
+                <a:tc>
+                  <a:txBody>
+                    <a:bodyPr/>
+                    <a:lstStyle/>
+                    <a:p>
+                      <a:r>
+                        <a:rPr sz="1200" b="1">
+                          <a:solidFill>
+                            <a:srgbClr val="0F172A"/>
+                          </a:solidFill>
+                          <a:latin typeface="PingFang TC"/>
+                          <a:ea typeface="PingFang TC"/>
+                        </a:rPr>
+                        <a:t>EC2 ASG</a:t>
+                      </a:r>
+                    </a:p>
+                  </a:txBody>
+                  <a:tcPr marT="25400" marB="25400" marL="101600" anchor="ctr">
+                    <a:solidFill>
+                      <a:srgbClr val="F1F5F9"/>
+                    </a:solidFill>
+                  </a:tcPr>
+                </a:tc>
+                <a:tc>
+                  <a:txBody>
+                    <a:bodyPr/>
+                    <a:lstStyle/>
+                    <a:p>
+                      <a:r>
+                        <a:rPr sz="1200" b="0">
+                          <a:solidFill>
+                            <a:srgbClr val="0F172A"/>
+                          </a:solidFill>
+                          <a:latin typeface="PingFang TC"/>
+                          <a:ea typeface="PingFang TC"/>
+                        </a:rPr>
+                        <a:t>max_size=2 且無 scaling policy（固定 desired）→ 扛不住 50k 連線/CPU</a:t>
+                      </a:r>
+                    </a:p>
+                  </a:txBody>
+                  <a:tcPr marT="25400" marB="25400" marL="101600" anchor="ctr">
+                    <a:solidFill>
+                      <a:srgbClr val="F1F5F9"/>
+                    </a:solidFill>
+                  </a:tcPr>
+                </a:tc>
+              </a:tr>
+              <a:tr h="518160">
+                <a:tc>
+                  <a:txBody>
+                    <a:bodyPr/>
+                    <a:lstStyle/>
+                    <a:p>
+                      <a:r>
+                        <a:rPr sz="1200" b="1">
+                          <a:solidFill>
+                            <a:srgbClr val="0F172A"/>
+                          </a:solidFill>
+                          <a:latin typeface="PingFang TC"/>
+                          <a:ea typeface="PingFang TC"/>
+                        </a:rPr>
+                        <a:t>3</a:t>
+                      </a:r>
+                    </a:p>
+                  </a:txBody>
+                  <a:tcPr marT="25400" marB="25400" marL="101600" anchor="ctr">
+                    <a:solidFill>
+                      <a:srgbClr val="FFFFFF"/>
+                    </a:solidFill>
+                  </a:tcPr>
+                </a:tc>
+                <a:tc>
+                  <a:txBody>
+                    <a:bodyPr/>
+                    <a:lstStyle/>
+                    <a:p>
+                      <a:r>
+                        <a:rPr sz="1200" b="1">
+                          <a:solidFill>
+                            <a:srgbClr val="0F172A"/>
+                          </a:solidFill>
+                          <a:latin typeface="PingFang TC"/>
+                          <a:ea typeface="PingFang TC"/>
+                        </a:rPr>
+                        <a:t>API Gateway</a:t>
+                      </a:r>
+                    </a:p>
+                  </a:txBody>
+                  <a:tcPr marT="25400" marB="25400" marL="101600" anchor="ctr">
+                    <a:solidFill>
+                      <a:srgbClr val="FFFFFF"/>
+                    </a:solidFill>
+                  </a:tcPr>
+                </a:tc>
+                <a:tc>
+                  <a:txBody>
+                    <a:bodyPr/>
+                    <a:lstStyle/>
+                    <a:p>
+                      <a:r>
+                        <a:rPr sz="1200" b="0">
+                          <a:solidFill>
+                            <a:srgbClr val="0F172A"/>
+                          </a:solidFill>
+                          <a:latin typeface="PingFang TC"/>
+                          <a:ea typeface="PingFang TC"/>
+                        </a:rPr>
+                        <a:t>stage rate=1000 + 帳號預設 ~10k RPS → 大量 429</a:t>
+                      </a:r>
+                    </a:p>
+                  </a:txBody>
+                  <a:tcPr marT="25400" marB="25400" marL="101600" anchor="ctr">
+                    <a:solidFill>
+                      <a:srgbClr val="FFFFFF"/>
+                    </a:solidFill>
+                  </a:tcPr>
+                </a:tc>
+              </a:tr>
+              <a:tr h="518160">
+                <a:tc>
+                  <a:txBody>
+                    <a:bodyPr/>
+                    <a:lstStyle/>
+                    <a:p>
+                      <a:r>
+                        <a:rPr sz="1200" b="1">
+                          <a:solidFill>
+                            <a:srgbClr val="0F172A"/>
+                          </a:solidFill>
+                          <a:latin typeface="PingFang TC"/>
+                          <a:ea typeface="PingFang TC"/>
+                        </a:rPr>
+                        <a:t>4</a:t>
+                      </a:r>
+                    </a:p>
+                  </a:txBody>
+                  <a:tcPr marT="25400" marB="25400" marL="101600" anchor="ctr">
+                    <a:solidFill>
+                      <a:srgbClr val="F1F5F9"/>
+                    </a:solidFill>
+                  </a:tcPr>
+                </a:tc>
+                <a:tc>
+                  <a:txBody>
+                    <a:bodyPr/>
+                    <a:lstStyle/>
+                    <a:p>
+                      <a:r>
+                        <a:rPr sz="1200" b="1">
+                          <a:solidFill>
+                            <a:srgbClr val="0F172A"/>
+                          </a:solidFill>
+                          <a:latin typeface="PingFang TC"/>
+                          <a:ea typeface="PingFang TC"/>
+                        </a:rPr>
+                        <a:t>Redis 單節點</a:t>
+                      </a:r>
+                    </a:p>
+                  </a:txBody>
+                  <a:tcPr marT="25400" marB="25400" marL="101600" anchor="ctr">
+                    <a:solidFill>
+                      <a:srgbClr val="F1F5F9"/>
+                    </a:solidFill>
+                  </a:tcPr>
+                </a:tc>
+                <a:tc>
+                  <a:txBody>
+                    <a:bodyPr/>
+                    <a:lstStyle/>
+                    <a:p>
+                      <a:r>
+                        <a:rPr sz="1200" b="0">
+                          <a:solidFill>
+                            <a:srgbClr val="0F172A"/>
+                          </a:solidFill>
+                          <a:latin typeface="PingFang TC"/>
+                          <a:ea typeface="PingFang TC"/>
+                        </a:rPr>
+                        <a:t>cache.t4g.micro 50k GET/s 高 CPU/網路、無讀擴展</a:t>
+                      </a:r>
+                    </a:p>
+                  </a:txBody>
+                  <a:tcPr marT="25400" marB="25400" marL="101600" anchor="ctr">
+                    <a:solidFill>
+                      <a:srgbClr val="F1F5F9"/>
+                    </a:solidFill>
+                  </a:tcPr>
+                </a:tc>
+              </a:tr>
+              <a:tr h="518160">
+                <a:tc>
+                  <a:txBody>
+                    <a:bodyPr/>
+                    <a:lstStyle/>
+                    <a:p>
+                      <a:r>
+                        <a:rPr sz="1200" b="1">
+                          <a:solidFill>
+                            <a:srgbClr val="0F172A"/>
+                          </a:solidFill>
+                          <a:latin typeface="PingFang TC"/>
+                          <a:ea typeface="PingFang TC"/>
+                        </a:rPr>
+                        <a:t>5</a:t>
+                      </a:r>
+                    </a:p>
+                  </a:txBody>
+                  <a:tcPr marT="25400" marB="25400" marL="101600" anchor="ctr">
+                    <a:solidFill>
+                      <a:srgbClr val="FFFFFF"/>
+                    </a:solidFill>
+                  </a:tcPr>
+                </a:tc>
+                <a:tc>
+                  <a:txBody>
+                    <a:bodyPr/>
+                    <a:lstStyle/>
+                    <a:p>
+                      <a:r>
+                        <a:rPr sz="1200" b="1">
+                          <a:solidFill>
+                            <a:srgbClr val="0F172A"/>
+                          </a:solidFill>
+                          <a:latin typeface="PingFang TC"/>
+                          <a:ea typeface="PingFang TC"/>
+                        </a:rPr>
+                        <a:t>Edge</a:t>
+                      </a:r>
+                    </a:p>
+                  </a:txBody>
+                  <a:tcPr marT="25400" marB="25400" marL="101600" anchor="ctr">
+                    <a:solidFill>
+                      <a:srgbClr val="FFFFFF"/>
+                    </a:solidFill>
+                  </a:tcPr>
+                </a:tc>
+                <a:tc>
+                  <a:txBody>
+                    <a:bodyPr/>
+                    <a:lstStyle/>
+                    <a:p>
+                      <a:r>
+                        <a:rPr sz="1200" b="0">
+                          <a:solidFill>
+                            <a:srgbClr val="0F172A"/>
+                          </a:solidFill>
+                          <a:latin typeface="PingFang TC"/>
+                          <a:ea typeface="PingFang TC"/>
+                        </a:rPr>
+                        <a:t>CloudFront/ALB 可擴(LCU 成本↑);但 redirect 不快取 → 全額回源放大下游</a:t>
+                      </a:r>
+                    </a:p>
+                  </a:txBody>
+                  <a:tcPr marT="25400" marB="25400" marL="101600" anchor="ctr">
+                    <a:solidFill>
+                      <a:srgbClr val="FFFFFF"/>
+                    </a:solidFill>
+                  </a:tcPr>
+                </a:tc>
+              </a:tr>
+            </a:tbl>
+          </a:graphicData>
+        </a:graphic>
+      </p:graphicFrame>
+      <p:sp>
+        <p:nvSpPr>
+          <p:cNvPr id="6" name="TextBox 5"/>
+          <p:cNvSpPr txBox="1"/>
+          <p:nvPr/>
+        </p:nvSpPr>
+        <p:spPr>
+          <a:xfrm>
+            <a:off x="548640" y="5394960"/>
+            <a:ext cx="11247120" cy="1097280"/>
+          </a:xfrm>
+          <a:prstGeom prst="rect">
+            <a:avLst/>
+          </a:prstGeom>
+          <a:noFill/>
+        </p:spPr>
+        <p:txBody>
+          <a:bodyPr wrap="square">
+            <a:spAutoFit/>
+          </a:bodyPr>
+          <a:lstStyle/>
+          <a:p>
+            <a:pPr>
+              <a:spcAft>
+                <a:spcPts val="400"/>
+              </a:spcAft>
+            </a:pPr>
+            <a:r>
+              <a:rPr sz="1400" b="0">
                 <a:solidFill>
                   <a:srgbClr val="0F172A"/>
                 </a:solidFill>
                 <a:latin typeface="PingFang TC"/>
                 <a:ea typeface="PingFang TC"/>
               </a:rPr>
-              <a:t>當大型客戶上線，</a:t>
+              <a:t>•  結論：DB 的 scan 寫入最先崩——分析寫入沒和 redirect 解耦(唯一線性暴增又集中單點的寫入)。</a:t>
+            </a:r>
+          </a:p>
+        </p:txBody>
+      </p:sp>
+    </p:spTree>
+  </p:cSld>
+  <p:clrMapOvr>
+    <a:masterClrMapping/>
+  </p:clrMapOvr>
+</p:sld>
+</file>
+
+<file path=ppt/slides/slide33.xml><?xml version="1.0" encoding="utf-8"?>
+<p:sld xmlns:a="http://schemas.openxmlformats.org/drawingml/2006/main" xmlns:p="http://schemas.openxmlformats.org/presentationml/2006/main" xmlns:r="http://schemas.openxmlformats.org/officeDocument/2006/relationships">
+  <p:cSld>
+    <p:spTree>
+      <p:nvGrpSpPr>
+        <p:cNvPr id="1" name=""/>
+        <p:cNvGrpSpPr/>
+        <p:nvPr/>
+      </p:nvGrpSpPr>
+      <p:grpSpPr/>
+      <p:sp>
+        <p:nvSpPr>
+          <p:cNvPr id="2" name="Rectangle 1"/>
+          <p:cNvSpPr/>
+          <p:nvPr/>
+        </p:nvSpPr>
+        <p:spPr>
+          <a:xfrm>
+            <a:off x="0" y="0"/>
+            <a:ext cx="164592" cy="6858000"/>
+          </a:xfrm>
+          <a:prstGeom prst="rect">
+            <a:avLst/>
+          </a:prstGeom>
+          <a:solidFill>
+            <a:srgbClr val="2563EB"/>
+          </a:solidFill>
+          <a:ln>
+            <a:noFill/>
+          </a:ln>
+          <a:effectLst/>
+        </p:spPr>
+        <p:style>
+          <a:lnRef idx="1">
+            <a:schemeClr val="accent1"/>
+          </a:lnRef>
+          <a:fillRef idx="3">
+            <a:schemeClr val="accent1"/>
+          </a:fillRef>
+          <a:effectRef idx="2">
+            <a:schemeClr val="accent1"/>
+          </a:effectRef>
+          <a:fontRef idx="minor">
+            <a:schemeClr val="lt1"/>
+          </a:fontRef>
+        </p:style>
+        <p:txBody>
+          <a:bodyPr rtlCol="0" anchor="ctr"/>
+          <a:lstStyle/>
+          <a:p>
+            <a:pPr algn="ctr"/>
+          </a:p>
+        </p:txBody>
+      </p:sp>
+      <p:sp>
+        <p:nvSpPr>
+          <p:cNvPr id="3" name="TextBox 2"/>
+          <p:cNvSpPr txBox="1"/>
+          <p:nvPr/>
+        </p:nvSpPr>
+        <p:spPr>
+          <a:xfrm>
+            <a:off x="502920" y="320040"/>
+            <a:ext cx="10972800" cy="1005840"/>
+          </a:xfrm>
+          <a:prstGeom prst="rect">
+            <a:avLst/>
+          </a:prstGeom>
+          <a:noFill/>
+        </p:spPr>
+        <p:txBody>
+          <a:bodyPr wrap="square" anchor="t">
+            <a:spAutoFit/>
+          </a:bodyPr>
+          <a:lstStyle/>
+          <a:p>
+            <a:pPr algn="l">
+              <a:spcAft>
+                <a:spcPts val="200"/>
+              </a:spcAft>
+            </a:pPr>
+            <a:r>
+              <a:rPr sz="1300" b="1">
+                <a:solidFill>
+                  <a:srgbClr val="2563EB"/>
+                </a:solidFill>
+                <a:latin typeface="PingFang TC"/>
+                <a:ea typeface="PingFang TC"/>
+              </a:rPr>
+              <a:t>極限擴展 · ANALYTICS PIPELINE</a:t>
             </a:r>
           </a:p>
           <a:p>
@@ -21235,129 +21814,38 @@
               </a:spcAft>
             </a:pPr>
             <a:r>
-              <a:rPr sz="1900" b="1">
+              <a:rPr sz="3000" b="1">
                 <a:solidFill>
                   <a:srgbClr val="0F172A"/>
                 </a:solidFill>
                 <a:latin typeface="PingFang TC"/>
                 <a:ea typeface="PingFang TC"/>
               </a:rPr>
-              <a:t>流量瞬間暴增 50 倍，</a:t>
-            </a:r>
-          </a:p>
-          <a:p>
-            <a:pPr algn="l">
-              <a:spcAft>
-                <a:spcPts val="400"/>
-              </a:spcAft>
-            </a:pPr>
-            <a:r>
-              <a:rPr sz="1900" b="1">
-                <a:solidFill>
-                  <a:srgbClr val="0F172A"/>
-                </a:solidFill>
-                <a:latin typeface="PingFang TC"/>
-                <a:ea typeface="PingFang TC"/>
-              </a:rPr>
-              <a:t>這個架構哪會先崩潰？</a:t>
-            </a:r>
-          </a:p>
-        </p:txBody>
-      </p:sp>
-      <p:sp>
-        <p:nvSpPr>
-          <p:cNvPr id="5" name="TextBox 4"/>
-          <p:cNvSpPr txBox="1"/>
-          <p:nvPr/>
-        </p:nvSpPr>
-        <p:spPr>
-          <a:xfrm>
-            <a:off x="6400800" y="2057400"/>
-            <a:ext cx="5303520" cy="2194560"/>
-          </a:xfrm>
-          <a:prstGeom prst="rect">
-            <a:avLst/>
-          </a:prstGeom>
-          <a:noFill/>
-        </p:spPr>
-        <p:txBody>
-          <a:bodyPr wrap="square">
-            <a:spAutoFit/>
-          </a:bodyPr>
-          <a:lstStyle/>
-          <a:p>
-            <a:pPr>
-              <a:spcAft>
-                <a:spcPts val="1400"/>
-              </a:spcAft>
-            </a:pPr>
-            <a:r>
-              <a:rPr sz="1600" b="0">
-                <a:solidFill>
-                  <a:srgbClr val="0F172A"/>
-                </a:solidFill>
-                <a:latin typeface="PingFang TC"/>
-                <a:ea typeface="PingFang TC"/>
-              </a:rPr>
-              <a:t>•  流量暴增 Scenario 推演（Server vs DB vs Network）</a:t>
-            </a:r>
-          </a:p>
-          <a:p>
-            <a:pPr>
-              <a:spcAft>
-                <a:spcPts val="1400"/>
-              </a:spcAft>
-            </a:pPr>
-            <a:r>
-              <a:rPr sz="1600" b="0">
-                <a:solidFill>
-                  <a:srgbClr val="0F172A"/>
-                </a:solidFill>
-                <a:latin typeface="PingFang TC"/>
-                <a:ea typeface="PingFang TC"/>
-              </a:rPr>
-              <a:t>•  Event-Driven Analytics Pipeline 架構</a:t>
-            </a:r>
-          </a:p>
-          <a:p>
-            <a:pPr>
-              <a:spcAft>
-                <a:spcPts val="1400"/>
-              </a:spcAft>
-            </a:pPr>
-            <a:r>
-              <a:rPr sz="1600" b="0">
-                <a:solidFill>
-                  <a:srgbClr val="0F172A"/>
-                </a:solidFill>
-                <a:latin typeface="PingFang TC"/>
-                <a:ea typeface="PingFang TC"/>
-              </a:rPr>
-              <a:t>•  System Design 面試實戰答題框架</a:t>
-            </a:r>
-          </a:p>
-        </p:txBody>
-      </p:sp>
-      <p:sp>
-        <p:nvSpPr>
-          <p:cNvPr id="6" name="Rounded Rectangle 5"/>
+              <a:t>解法:緩衝 + 批次聚合（解 DB 寫入瓶頸）</a:t>
+            </a:r>
+          </a:p>
+        </p:txBody>
+      </p:sp>
+      <p:sp>
+        <p:nvSpPr>
+          <p:cNvPr id="4" name="Rounded Rectangle 3"/>
           <p:cNvSpPr/>
           <p:nvPr/>
         </p:nvSpPr>
         <p:spPr>
           <a:xfrm>
-            <a:off x="6400800" y="4343400"/>
-            <a:ext cx="5303520" cy="1051560"/>
+            <a:off x="457200" y="1920240"/>
+            <a:ext cx="1920240" cy="822960"/>
           </a:xfrm>
           <a:prstGeom prst="roundRect">
             <a:avLst/>
           </a:prstGeom>
           <a:solidFill>
-            <a:srgbClr val="F1F5F9"/>
+            <a:srgbClr val="64748B"/>
           </a:solidFill>
           <a:ln>
             <a:solidFill>
-              <a:srgbClr val="F1F5F9"/>
+              <a:srgbClr val="64748B"/>
             </a:solidFill>
           </a:ln>
           <a:effectLst/>
@@ -21377,32 +21865,57 @@
           </a:fontRef>
         </p:style>
         <p:txBody>
-          <a:bodyPr rtlCol="0" anchor="ctr"/>
+          <a:bodyPr rtlCol="0" anchor="ctr" wrap="square" tIns="25400" bIns="25400"/>
           <a:lstStyle/>
           <a:p>
             <a:pPr algn="ctr"/>
-          </a:p>
-        </p:txBody>
-      </p:sp>
-      <p:sp>
-        <p:nvSpPr>
-          <p:cNvPr id="7" name="Rectangle 6"/>
+            <a:r>
+              <a:rPr sz="1200" b="1">
+                <a:solidFill>
+                  <a:srgbClr val="FFFFFF"/>
+                </a:solidFill>
+                <a:latin typeface="PingFang TC"/>
+                <a:ea typeface="PingFang TC"/>
+              </a:rPr>
+              <a:t>redirect</a:t>
+            </a:r>
+          </a:p>
+          <a:p>
+            <a:pPr algn="ctr"/>
+            <a:r>
+              <a:rPr sz="1200" b="0">
+                <a:solidFill>
+                  <a:srgbClr val="FFFFFF"/>
+                </a:solidFill>
+                <a:latin typeface="PingFang TC"/>
+                <a:ea typeface="PingFang TC"/>
+              </a:rPr>
+              <a:t>put 1 event</a:t>
+            </a:r>
+          </a:p>
+        </p:txBody>
+      </p:sp>
+      <p:sp>
+        <p:nvSpPr>
+          <p:cNvPr id="5" name="Rounded Rectangle 4"/>
           <p:cNvSpPr/>
           <p:nvPr/>
         </p:nvSpPr>
         <p:spPr>
           <a:xfrm>
-            <a:off x="6400800" y="4343400"/>
-            <a:ext cx="82296" cy="1051560"/>
-          </a:xfrm>
-          <a:prstGeom prst="rect">
+            <a:off x="2743200" y="1920240"/>
+            <a:ext cx="2468880" cy="822960"/>
+          </a:xfrm>
+          <a:prstGeom prst="roundRect">
             <a:avLst/>
           </a:prstGeom>
           <a:solidFill>
-            <a:srgbClr val="0EA5E9"/>
+            <a:srgbClr val="D97706"/>
           </a:solidFill>
           <a:ln>
-            <a:noFill/>
+            <a:solidFill>
+              <a:srgbClr val="D97706"/>
+            </a:solidFill>
           </a:ln>
           <a:effectLst/>
         </p:spPr>
@@ -21421,23 +21934,502 @@
           </a:fontRef>
         </p:style>
         <p:txBody>
-          <a:bodyPr rtlCol="0" anchor="ctr"/>
+          <a:bodyPr rtlCol="0" anchor="ctr" wrap="square" tIns="25400" bIns="25400"/>
           <a:lstStyle/>
           <a:p>
             <a:pPr algn="ctr"/>
-          </a:p>
-        </p:txBody>
-      </p:sp>
-      <p:sp>
-        <p:nvSpPr>
-          <p:cNvPr id="8" name="TextBox 7"/>
+            <a:r>
+              <a:rPr sz="1100" b="1">
+                <a:solidFill>
+                  <a:srgbClr val="FFFFFF"/>
+                </a:solidFill>
+                <a:latin typeface="PingFang TC"/>
+                <a:ea typeface="PingFang TC"/>
+              </a:rPr>
+              <a:t>Kinesis / SQS</a:t>
+            </a:r>
+          </a:p>
+          <a:p>
+            <a:pPr algn="ctr"/>
+            <a:r>
+              <a:rPr sz="1100" b="0">
+                <a:solidFill>
+                  <a:srgbClr val="FFFFFF"/>
+                </a:solidFill>
+                <a:latin typeface="PingFang TC"/>
+                <a:ea typeface="PingFang TC"/>
+              </a:rPr>
+              <a:t>高吞吐緩衝(吸尖峰)</a:t>
+            </a:r>
+          </a:p>
+        </p:txBody>
+      </p:sp>
+      <p:sp>
+        <p:nvSpPr>
+          <p:cNvPr id="6" name="Rounded Rectangle 5"/>
+          <p:cNvSpPr/>
+          <p:nvPr/>
+        </p:nvSpPr>
+        <p:spPr>
+          <a:xfrm>
+            <a:off x="5577840" y="1920240"/>
+            <a:ext cx="2468880" cy="822960"/>
+          </a:xfrm>
+          <a:prstGeom prst="roundRect">
+            <a:avLst/>
+          </a:prstGeom>
+          <a:solidFill>
+            <a:srgbClr val="2563EB"/>
+          </a:solidFill>
+          <a:ln>
+            <a:solidFill>
+              <a:srgbClr val="2563EB"/>
+            </a:solidFill>
+          </a:ln>
+          <a:effectLst/>
+        </p:spPr>
+        <p:style>
+          <a:lnRef idx="1">
+            <a:schemeClr val="accent1"/>
+          </a:lnRef>
+          <a:fillRef idx="3">
+            <a:schemeClr val="accent1"/>
+          </a:fillRef>
+          <a:effectRef idx="2">
+            <a:schemeClr val="accent1"/>
+          </a:effectRef>
+          <a:fontRef idx="minor">
+            <a:schemeClr val="lt1"/>
+          </a:fontRef>
+        </p:style>
+        <p:txBody>
+          <a:bodyPr rtlCol="0" anchor="ctr" wrap="square" tIns="25400" bIns="25400"/>
+          <a:lstStyle/>
+          <a:p>
+            <a:pPr algn="ctr"/>
+            <a:r>
+              <a:rPr sz="1100" b="1">
+                <a:solidFill>
+                  <a:srgbClr val="FFFFFF"/>
+                </a:solidFill>
+                <a:latin typeface="PingFang TC"/>
+                <a:ea typeface="PingFang TC"/>
+              </a:rPr>
+              <a:t>消費者</a:t>
+            </a:r>
+          </a:p>
+          <a:p>
+            <a:pPr algn="ctr"/>
+            <a:r>
+              <a:rPr sz="1100" b="0">
+                <a:solidFill>
+                  <a:srgbClr val="FFFFFF"/>
+                </a:solidFill>
+                <a:latin typeface="PingFang TC"/>
+                <a:ea typeface="PingFang TC"/>
+              </a:rPr>
+              <a:t>Lambda/KCL 批次聚合</a:t>
+            </a:r>
+          </a:p>
+        </p:txBody>
+      </p:sp>
+      <p:sp>
+        <p:nvSpPr>
+          <p:cNvPr id="7" name="Rounded Rectangle 6"/>
+          <p:cNvSpPr/>
+          <p:nvPr/>
+        </p:nvSpPr>
+        <p:spPr>
+          <a:xfrm>
+            <a:off x="8412480" y="1280160"/>
+            <a:ext cx="3017520" cy="640080"/>
+          </a:xfrm>
+          <a:prstGeom prst="roundRect">
+            <a:avLst/>
+          </a:prstGeom>
+          <a:solidFill>
+            <a:srgbClr val="059669"/>
+          </a:solidFill>
+          <a:ln>
+            <a:solidFill>
+              <a:srgbClr val="059669"/>
+            </a:solidFill>
+          </a:ln>
+          <a:effectLst/>
+        </p:spPr>
+        <p:style>
+          <a:lnRef idx="1">
+            <a:schemeClr val="accent1"/>
+          </a:lnRef>
+          <a:fillRef idx="3">
+            <a:schemeClr val="accent1"/>
+          </a:fillRef>
+          <a:effectRef idx="2">
+            <a:schemeClr val="accent1"/>
+          </a:effectRef>
+          <a:fontRef idx="minor">
+            <a:schemeClr val="lt1"/>
+          </a:fontRef>
+        </p:style>
+        <p:txBody>
+          <a:bodyPr rtlCol="0" anchor="ctr" wrap="square" tIns="25400" bIns="25400"/>
+          <a:lstStyle/>
+          <a:p>
+            <a:pPr algn="ctr"/>
+            <a:r>
+              <a:rPr sz="1000" b="1">
+                <a:solidFill>
+                  <a:srgbClr val="FFFFFF"/>
+                </a:solidFill>
+                <a:latin typeface="PingFang TC"/>
+                <a:ea typeface="PingFang TC"/>
+              </a:rPr>
+              <a:t>每日計數 rollup</a:t>
+            </a:r>
+          </a:p>
+          <a:p>
+            <a:pPr algn="ctr"/>
+            <a:r>
+              <a:rPr sz="1000" b="0">
+                <a:solidFill>
+                  <a:srgbClr val="FFFFFF"/>
+                </a:solidFill>
+                <a:latin typeface="PingFang TC"/>
+                <a:ea typeface="PingFang TC"/>
+              </a:rPr>
+              <a:t>(DynamoDB/RDS)</a:t>
+            </a:r>
+          </a:p>
+        </p:txBody>
+      </p:sp>
+      <p:sp>
+        <p:nvSpPr>
+          <p:cNvPr id="8" name="Rounded Rectangle 7"/>
+          <p:cNvSpPr/>
+          <p:nvPr/>
+        </p:nvSpPr>
+        <p:spPr>
+          <a:xfrm>
+            <a:off x="8412480" y="2057400"/>
+            <a:ext cx="3017520" cy="640080"/>
+          </a:xfrm>
+          <a:prstGeom prst="roundRect">
+            <a:avLst/>
+          </a:prstGeom>
+          <a:solidFill>
+            <a:srgbClr val="059669"/>
+          </a:solidFill>
+          <a:ln>
+            <a:solidFill>
+              <a:srgbClr val="059669"/>
+            </a:solidFill>
+          </a:ln>
+          <a:effectLst/>
+        </p:spPr>
+        <p:style>
+          <a:lnRef idx="1">
+            <a:schemeClr val="accent1"/>
+          </a:lnRef>
+          <a:fillRef idx="3">
+            <a:schemeClr val="accent1"/>
+          </a:fillRef>
+          <a:effectRef idx="2">
+            <a:schemeClr val="accent1"/>
+          </a:effectRef>
+          <a:fontRef idx="minor">
+            <a:schemeClr val="lt1"/>
+          </a:fontRef>
+        </p:style>
+        <p:txBody>
+          <a:bodyPr rtlCol="0" anchor="ctr" wrap="square" tIns="25400" bIns="25400"/>
+          <a:lstStyle/>
+          <a:p>
+            <a:pPr algn="ctr"/>
+            <a:r>
+              <a:rPr sz="1000" b="1">
+                <a:solidFill>
+                  <a:srgbClr val="FFFFFF"/>
+                </a:solidFill>
+                <a:latin typeface="PingFang TC"/>
+                <a:ea typeface="PingFang TC"/>
+              </a:rPr>
+              <a:t>原始明細歸檔</a:t>
+            </a:r>
+          </a:p>
+          <a:p>
+            <a:pPr algn="ctr"/>
+            <a:r>
+              <a:rPr sz="1000" b="0">
+                <a:solidFill>
+                  <a:srgbClr val="FFFFFF"/>
+                </a:solidFill>
+                <a:latin typeface="PingFang TC"/>
+                <a:ea typeface="PingFang TC"/>
+              </a:rPr>
+              <a:t>(S3 + Athena)</a:t>
+            </a:r>
+          </a:p>
+        </p:txBody>
+      </p:sp>
+      <p:sp>
+        <p:nvSpPr>
+          <p:cNvPr id="9" name="Rounded Rectangle 8"/>
+          <p:cNvSpPr/>
+          <p:nvPr/>
+        </p:nvSpPr>
+        <p:spPr>
+          <a:xfrm>
+            <a:off x="8412480" y="2834640"/>
+            <a:ext cx="3017520" cy="640080"/>
+          </a:xfrm>
+          <a:prstGeom prst="roundRect">
+            <a:avLst/>
+          </a:prstGeom>
+          <a:solidFill>
+            <a:srgbClr val="059669"/>
+          </a:solidFill>
+          <a:ln>
+            <a:solidFill>
+              <a:srgbClr val="059669"/>
+            </a:solidFill>
+          </a:ln>
+          <a:effectLst/>
+        </p:spPr>
+        <p:style>
+          <a:lnRef idx="1">
+            <a:schemeClr val="accent1"/>
+          </a:lnRef>
+          <a:fillRef idx="3">
+            <a:schemeClr val="accent1"/>
+          </a:fillRef>
+          <a:effectRef idx="2">
+            <a:schemeClr val="accent1"/>
+          </a:effectRef>
+          <a:fontRef idx="minor">
+            <a:schemeClr val="lt1"/>
+          </a:fontRef>
+        </p:style>
+        <p:txBody>
+          <a:bodyPr rtlCol="0" anchor="ctr" wrap="square" tIns="25400" bIns="25400"/>
+          <a:lstStyle/>
+          <a:p>
+            <a:pPr algn="ctr"/>
+            <a:r>
+              <a:rPr sz="1000" b="1">
+                <a:solidFill>
+                  <a:srgbClr val="FFFFFF"/>
+                </a:solidFill>
+                <a:latin typeface="PingFang TC"/>
+                <a:ea typeface="PingFang TC"/>
+              </a:rPr>
+              <a:t>即時分析(選)</a:t>
+            </a:r>
+          </a:p>
+          <a:p>
+            <a:pPr algn="ctr"/>
+            <a:r>
+              <a:rPr sz="1000" b="0">
+                <a:solidFill>
+                  <a:srgbClr val="FFFFFF"/>
+                </a:solidFill>
+                <a:latin typeface="PingFang TC"/>
+                <a:ea typeface="PingFang TC"/>
+              </a:rPr>
+              <a:t>OpenSearch</a:t>
+            </a:r>
+          </a:p>
+        </p:txBody>
+      </p:sp>
+      <p:cxnSp>
+        <p:nvCxnSpPr>
+          <p:cNvPr id="10" name="Connector 9"/>
+          <p:cNvCxnSpPr/>
+          <p:nvPr/>
+        </p:nvCxnSpPr>
+        <p:spPr>
+          <a:xfrm>
+            <a:off x="2377440" y="2331720"/>
+            <a:ext cx="365760" cy="0"/>
+          </a:xfrm>
+          <a:prstGeom prst="line">
+            <a:avLst/>
+          </a:prstGeom>
+          <a:ln w="22225">
+            <a:solidFill>
+              <a:srgbClr val="64748B"/>
+            </a:solidFill>
+            <a:tailEnd type="triangle" w="med" len="med"/>
+          </a:ln>
+        </p:spPr>
+        <p:style>
+          <a:lnRef idx="2">
+            <a:schemeClr val="accent1"/>
+          </a:lnRef>
+          <a:fillRef idx="0">
+            <a:schemeClr val="accent1"/>
+          </a:fillRef>
+          <a:effectRef idx="1">
+            <a:schemeClr val="accent1"/>
+          </a:effectRef>
+          <a:fontRef idx="minor">
+            <a:schemeClr val="tx1"/>
+          </a:fontRef>
+        </p:style>
+      </p:cxnSp>
+      <p:cxnSp>
+        <p:nvCxnSpPr>
+          <p:cNvPr id="11" name="Connector 10"/>
+          <p:cNvCxnSpPr/>
+          <p:nvPr/>
+        </p:nvCxnSpPr>
+        <p:spPr>
+          <a:xfrm>
+            <a:off x="5212080" y="2331720"/>
+            <a:ext cx="365760" cy="0"/>
+          </a:xfrm>
+          <a:prstGeom prst="line">
+            <a:avLst/>
+          </a:prstGeom>
+          <a:ln w="22225">
+            <a:solidFill>
+              <a:srgbClr val="64748B"/>
+            </a:solidFill>
+            <a:tailEnd type="triangle" w="med" len="med"/>
+          </a:ln>
+        </p:spPr>
+        <p:style>
+          <a:lnRef idx="2">
+            <a:schemeClr val="accent1"/>
+          </a:lnRef>
+          <a:fillRef idx="0">
+            <a:schemeClr val="accent1"/>
+          </a:fillRef>
+          <a:effectRef idx="1">
+            <a:schemeClr val="accent1"/>
+          </a:effectRef>
+          <a:fontRef idx="minor">
+            <a:schemeClr val="tx1"/>
+          </a:fontRef>
+        </p:style>
+      </p:cxnSp>
+      <p:cxnSp>
+        <p:nvCxnSpPr>
+          <p:cNvPr id="12" name="Connector 11"/>
+          <p:cNvCxnSpPr/>
+          <p:nvPr/>
+        </p:nvCxnSpPr>
+        <p:spPr>
+          <a:xfrm flipV="1">
+            <a:off x="8046720" y="1600200"/>
+            <a:ext cx="365760" cy="731520"/>
+          </a:xfrm>
+          <a:prstGeom prst="line">
+            <a:avLst/>
+          </a:prstGeom>
+          <a:ln w="13970">
+            <a:solidFill>
+              <a:srgbClr val="64748B"/>
+            </a:solidFill>
+            <a:tailEnd type="triangle" w="med" len="med"/>
+          </a:ln>
+        </p:spPr>
+        <p:style>
+          <a:lnRef idx="2">
+            <a:schemeClr val="accent1"/>
+          </a:lnRef>
+          <a:fillRef idx="0">
+            <a:schemeClr val="accent1"/>
+          </a:fillRef>
+          <a:effectRef idx="1">
+            <a:schemeClr val="accent1"/>
+          </a:effectRef>
+          <a:fontRef idx="minor">
+            <a:schemeClr val="tx1"/>
+          </a:fontRef>
+        </p:style>
+      </p:cxnSp>
+      <p:cxnSp>
+        <p:nvCxnSpPr>
+          <p:cNvPr id="13" name="Connector 12"/>
+          <p:cNvCxnSpPr/>
+          <p:nvPr/>
+        </p:nvCxnSpPr>
+        <p:spPr>
+          <a:xfrm>
+            <a:off x="8046720" y="2331720"/>
+            <a:ext cx="365760" cy="45720"/>
+          </a:xfrm>
+          <a:prstGeom prst="line">
+            <a:avLst/>
+          </a:prstGeom>
+          <a:ln w="13970">
+            <a:solidFill>
+              <a:srgbClr val="64748B"/>
+            </a:solidFill>
+            <a:tailEnd type="triangle" w="med" len="med"/>
+          </a:ln>
+        </p:spPr>
+        <p:style>
+          <a:lnRef idx="2">
+            <a:schemeClr val="accent1"/>
+          </a:lnRef>
+          <a:fillRef idx="0">
+            <a:schemeClr val="accent1"/>
+          </a:fillRef>
+          <a:effectRef idx="1">
+            <a:schemeClr val="accent1"/>
+          </a:effectRef>
+          <a:fontRef idx="minor">
+            <a:schemeClr val="tx1"/>
+          </a:fontRef>
+        </p:style>
+      </p:cxnSp>
+      <p:cxnSp>
+        <p:nvCxnSpPr>
+          <p:cNvPr id="14" name="Connector 13"/>
+          <p:cNvCxnSpPr/>
+          <p:nvPr/>
+        </p:nvCxnSpPr>
+        <p:spPr>
+          <a:xfrm>
+            <a:off x="8046720" y="2331720"/>
+            <a:ext cx="365760" cy="822960"/>
+          </a:xfrm>
+          <a:prstGeom prst="line">
+            <a:avLst/>
+          </a:prstGeom>
+          <a:ln w="13970">
+            <a:solidFill>
+              <a:srgbClr val="64748B"/>
+            </a:solidFill>
+            <a:tailEnd type="triangle" w="med" len="med"/>
+          </a:ln>
+        </p:spPr>
+        <p:style>
+          <a:lnRef idx="2">
+            <a:schemeClr val="accent1"/>
+          </a:lnRef>
+          <a:fillRef idx="0">
+            <a:schemeClr val="accent1"/>
+          </a:fillRef>
+          <a:effectRef idx="1">
+            <a:schemeClr val="accent1"/>
+          </a:effectRef>
+          <a:fontRef idx="minor">
+            <a:schemeClr val="tx1"/>
+          </a:fontRef>
+        </p:style>
+      </p:cxnSp>
+      <p:sp>
+        <p:nvSpPr>
+          <p:cNvPr id="15" name="TextBox 14"/>
           <p:cNvSpPr txBox="1"/>
           <p:nvPr/>
         </p:nvSpPr>
         <p:spPr>
           <a:xfrm>
-            <a:off x="6675120" y="4526280"/>
-            <a:ext cx="4846320" cy="822960"/>
+            <a:off x="548640" y="4023360"/>
+            <a:ext cx="11247120" cy="2377440"/>
           </a:xfrm>
           <a:prstGeom prst="rect">
             <a:avLst/>
@@ -21445,42 +22437,76 @@
           <a:noFill/>
         </p:spPr>
         <p:txBody>
-          <a:bodyPr wrap="square" anchor="t">
+          <a:bodyPr wrap="square">
             <a:spAutoFit/>
           </a:bodyPr>
           <a:lstStyle/>
           <a:p>
-            <a:pPr algn="l">
+            <a:pPr>
               <a:spcAft>
-                <a:spcPts val="600"/>
+                <a:spcPts val="800"/>
               </a:spcAft>
             </a:pPr>
             <a:r>
-              <a:rPr sz="1500" b="1">
+              <a:rPr sz="1300" b="0">
                 <a:solidFill>
                   <a:srgbClr val="0F172A"/>
                 </a:solidFill>
                 <a:latin typeface="PingFang TC"/>
                 <a:ea typeface="PingFang TC"/>
               </a:rPr>
-              <a:t>課前準備</a:t>
-            </a:r>
-          </a:p>
-          <a:p>
-            <a:pPr algn="l">
+              <a:t>•  redirect 只丟事件進 stream(極快、緩衝吸 50k/s 尖峰),不再每次同步寫 RDS → 寫入降到批次級(對應第 14 題)</a:t>
+            </a:r>
+          </a:p>
+          <a:p>
+            <a:pPr>
               <a:spcAft>
-                <a:spcPts val="400"/>
+                <a:spcPts val="800"/>
               </a:spcAft>
             </a:pPr>
             <a:r>
-              <a:rPr sz="1400" b="0">
-                <a:solidFill>
-                  <a:srgbClr val="64748B"/>
-                </a:solidFill>
-                <a:latin typeface="PingFang TC"/>
-                <a:ea typeface="PingFang TC"/>
-              </a:rPr>
-              <a:t>複習教材 Deep Dive 章節</a:t>
+              <a:rPr sz="1300" b="0">
+                <a:solidFill>
+                  <a:srgbClr val="0F172A"/>
+                </a:solidFill>
+                <a:latin typeface="PingFang TC"/>
+                <a:ea typeface="PingFang TC"/>
+              </a:rPr>
+              <a:t>•  ASG：target-tracking autoscaling + 提高 max(或 Fargate/Lambda)</a:t>
+            </a:r>
+          </a:p>
+          <a:p>
+            <a:pPr>
+              <a:spcAft>
+                <a:spcPts val="800"/>
+              </a:spcAft>
+            </a:pPr>
+            <a:r>
+              <a:rPr sz="1300" b="0">
+                <a:solidFill>
+                  <a:srgbClr val="0F172A"/>
+                </a:solidFill>
+                <a:latin typeface="PingFang TC"/>
+                <a:ea typeface="PingFang TC"/>
+              </a:rPr>
+              <a:t>•  讀路徑：Redis cluster/多節點 + 拉高熱門命中;RDS read replica 分攤 cache-miss 讀(第 16 題)</a:t>
+            </a:r>
+          </a:p>
+          <a:p>
+            <a:pPr>
+              <a:spcAft>
+                <a:spcPts val="800"/>
+              </a:spcAft>
+            </a:pPr>
+            <a:r>
+              <a:rPr sz="1300" b="0">
+                <a:solidFill>
+                  <a:srgbClr val="0F172A"/>
+                </a:solidFill>
+                <a:latin typeface="PingFang TC"/>
+                <a:ea typeface="PingFang TC"/>
+              </a:rPr>
+              <a:t>•  edge：熱門 token 用 CloudFront 短 TTL 邊緣 redirect(附錄 B)在邊緣消化大半流量;API GW 調高 throttle</a:t>
             </a:r>
           </a:p>
         </p:txBody>

</xml_diff>